<commit_message>
Updated pptx template for use in quarto. Semi-populated quarto template and current render.
</commit_message>
<xml_diff>
--- a/NHP_SBR impacts_2024.pptx
+++ b/NHP_SBR impacts_2024.pptx
@@ -7,6 +7,18 @@
   <p:sldIdLst>
     <p:sldId id="256" r:id="rId5"/>
     <p:sldId id="257" r:id="rId6"/>
+    <p:sldId id="258" r:id="rId7"/>
+    <p:sldId id="259" r:id="rId8"/>
+    <p:sldId id="260" r:id="rId9"/>
+    <p:sldId id="261" r:id="rId10"/>
+    <p:sldId id="262" r:id="rId11"/>
+    <p:sldId id="263" r:id="rId12"/>
+    <p:sldId id="264" r:id="rId13"/>
+    <p:sldId id="265" r:id="rId14"/>
+    <p:sldId id="266" r:id="rId15"/>
+    <p:sldId id="267" r:id="rId16"/>
+    <p:sldId id="268" r:id="rId17"/>
+    <p:sldId id="269" r:id="rId18"/>
   </p:sldIdLst>
   <p:sldSz cx="12192000" cy="6858000"/>
   <p:notesSz cx="6858000" cy="9144000"/>
@@ -190,7 +202,7 @@
           </a:bodyPr>
           <a:lstStyle>
             <a:lvl1pPr algn="l">
-              <a:defRPr sz="4400" spc="200" baseline="0"/>
+              <a:defRPr sz="3600" spc="200" baseline="0"/>
             </a:lvl1pPr>
           </a:lstStyle>
           <a:p>
@@ -217,6 +229,9 @@
             <a:off x="457199" y="6020353"/>
             <a:ext cx="8406374" cy="674129"/>
           </a:xfrm>
+          <a:prstGeom prst="rect">
+            <a:avLst/>
+          </a:prstGeom>
         </p:spPr>
         <p:txBody>
           <a:bodyPr lIns="91440" rIns="91440" anchor="ctr">
@@ -825,7 +840,7 @@
           </a:bodyPr>
           <a:lstStyle>
             <a:lvl1pPr algn="l">
-              <a:defRPr sz="4400" spc="200" baseline="0"/>
+              <a:defRPr sz="3600" spc="200" baseline="0"/>
             </a:lvl1pPr>
           </a:lstStyle>
           <a:p>
@@ -852,6 +867,9 @@
             <a:off x="457199" y="6020353"/>
             <a:ext cx="7772399" cy="674129"/>
           </a:xfrm>
+          <a:prstGeom prst="rect">
+            <a:avLst/>
+          </a:prstGeom>
         </p:spPr>
         <p:txBody>
           <a:bodyPr lIns="91440" rIns="91440" anchor="ctr">
@@ -1002,7 +1020,7 @@
 </file>
 
 <file path=ppt/slideLayouts/slideLayout3.xml><?xml version="1.0" encoding="utf-8"?>
-<p:sldLayout xmlns:a="http://schemas.openxmlformats.org/drawingml/2006/main" xmlns:r="http://schemas.openxmlformats.org/officeDocument/2006/relationships" xmlns:p="http://schemas.openxmlformats.org/presentationml/2006/main" type="twoObj" preserve="1">
+<p:sldLayout xmlns:a="http://schemas.openxmlformats.org/drawingml/2006/main" xmlns:r="http://schemas.openxmlformats.org/officeDocument/2006/relationships" xmlns:p="http://schemas.openxmlformats.org/presentationml/2006/main" preserve="1" userDrawn="1">
   <p:cSld name="Two Content">
     <p:spTree>
       <p:nvGrpSpPr>
@@ -1030,131 +1048,23 @@
         </p:nvSpPr>
         <p:spPr>
           <a:xfrm>
-            <a:off x="1024127" y="192984"/>
-            <a:ext cx="9720072" cy="1499616"/>
+            <a:off x="919352" y="419100"/>
+            <a:ext cx="9720072" cy="933450"/>
           </a:xfrm>
         </p:spPr>
         <p:txBody>
-          <a:bodyPr/>
-          <a:lstStyle/>
+          <a:bodyPr>
+            <a:normAutofit/>
+          </a:bodyPr>
+          <a:lstStyle>
+            <a:lvl1pPr>
+              <a:defRPr sz="3600"/>
+            </a:lvl1pPr>
+          </a:lstStyle>
           <a:p>
             <a:r>
               <a:rPr lang="en-GB" dirty="0"/>
               <a:t>Click to edit Master title style</a:t>
-            </a:r>
-            <a:endParaRPr lang="en-US" dirty="0"/>
-          </a:p>
-        </p:txBody>
-      </p:sp>
-      <p:sp>
-        <p:nvSpPr>
-          <p:cNvPr id="3" name="Content Placeholder 2"/>
-          <p:cNvSpPr>
-            <a:spLocks noGrp="1"/>
-          </p:cNvSpPr>
-          <p:nvPr>
-            <p:ph sz="half" idx="1"/>
-          </p:nvPr>
-        </p:nvSpPr>
-        <p:spPr>
-          <a:xfrm>
-            <a:off x="1024127" y="1998070"/>
-            <a:ext cx="4754880" cy="3871102"/>
-          </a:xfrm>
-        </p:spPr>
-        <p:txBody>
-          <a:bodyPr/>
-          <a:lstStyle/>
-          <a:p>
-            <a:pPr lvl="0"/>
-            <a:r>
-              <a:rPr lang="en-GB" dirty="0"/>
-              <a:t>Click to edit Master text styles</a:t>
-            </a:r>
-          </a:p>
-          <a:p>
-            <a:pPr lvl="1"/>
-            <a:r>
-              <a:rPr lang="en-GB" dirty="0"/>
-              <a:t>Second level</a:t>
-            </a:r>
-          </a:p>
-          <a:p>
-            <a:pPr lvl="2"/>
-            <a:r>
-              <a:rPr lang="en-GB" dirty="0"/>
-              <a:t>Third level</a:t>
-            </a:r>
-          </a:p>
-          <a:p>
-            <a:pPr lvl="3"/>
-            <a:r>
-              <a:rPr lang="en-GB" dirty="0"/>
-              <a:t>Fourth level</a:t>
-            </a:r>
-          </a:p>
-          <a:p>
-            <a:pPr lvl="4"/>
-            <a:r>
-              <a:rPr lang="en-GB" dirty="0"/>
-              <a:t>Fifth level</a:t>
-            </a:r>
-            <a:endParaRPr lang="en-US" dirty="0"/>
-          </a:p>
-        </p:txBody>
-      </p:sp>
-      <p:sp>
-        <p:nvSpPr>
-          <p:cNvPr id="4" name="Content Placeholder 3"/>
-          <p:cNvSpPr>
-            <a:spLocks noGrp="1"/>
-          </p:cNvSpPr>
-          <p:nvPr>
-            <p:ph sz="half" idx="2"/>
-          </p:nvPr>
-        </p:nvSpPr>
-        <p:spPr>
-          <a:xfrm>
-            <a:off x="5989319" y="1998070"/>
-            <a:ext cx="4754880" cy="3871102"/>
-          </a:xfrm>
-        </p:spPr>
-        <p:txBody>
-          <a:bodyPr/>
-          <a:lstStyle/>
-          <a:p>
-            <a:pPr lvl="0"/>
-            <a:r>
-              <a:rPr lang="en-GB"/>
-              <a:t>Click to edit Master text styles</a:t>
-            </a:r>
-          </a:p>
-          <a:p>
-            <a:pPr lvl="1"/>
-            <a:r>
-              <a:rPr lang="en-GB"/>
-              <a:t>Second level</a:t>
-            </a:r>
-          </a:p>
-          <a:p>
-            <a:pPr lvl="2"/>
-            <a:r>
-              <a:rPr lang="en-GB"/>
-              <a:t>Third level</a:t>
-            </a:r>
-          </a:p>
-          <a:p>
-            <a:pPr lvl="3"/>
-            <a:r>
-              <a:rPr lang="en-GB"/>
-              <a:t>Fourth level</a:t>
-            </a:r>
-          </a:p>
-          <a:p>
-            <a:pPr lvl="4"/>
-            <a:r>
-              <a:rPr lang="en-GB"/>
-              <a:t>Fifth level</a:t>
             </a:r>
             <a:endParaRPr lang="en-US" dirty="0"/>
           </a:p>
@@ -1299,51 +1209,30 @@
           </a:p>
         </p:txBody>
       </p:sp>
-    </p:spTree>
-    <p:extLst>
-      <p:ext uri="{BB962C8B-B14F-4D97-AF65-F5344CB8AC3E}">
-        <p14:creationId xmlns:p14="http://schemas.microsoft.com/office/powerpoint/2010/main" val="2385444012"/>
-      </p:ext>
-    </p:extLst>
-  </p:cSld>
-  <p:clrMapOvr>
-    <a:masterClrMapping/>
-  </p:clrMapOvr>
-</p:sldLayout>
-</file>
-
-<file path=ppt/slideLayouts/slideLayout4.xml><?xml version="1.0" encoding="utf-8"?>
-<p:sldLayout xmlns:a="http://schemas.openxmlformats.org/drawingml/2006/main" xmlns:r="http://schemas.openxmlformats.org/officeDocument/2006/relationships" xmlns:p="http://schemas.openxmlformats.org/presentationml/2006/main" preserve="1" userDrawn="1">
-  <p:cSld name="Comparison">
-    <p:spTree>
-      <p:nvGrpSpPr>
-        <p:cNvPr id="1" name=""/>
-        <p:cNvGrpSpPr/>
-        <p:nvPr/>
-      </p:nvGrpSpPr>
-      <p:grpSpPr>
-        <a:xfrm>
-          <a:off x="0" y="0"/>
-          <a:ext cx="0" cy="0"/>
-          <a:chOff x="0" y="0"/>
-          <a:chExt cx="0" cy="0"/>
-        </a:xfrm>
-      </p:grpSpPr>
-      <p:sp>
-        <p:nvSpPr>
-          <p:cNvPr id="3" name="Content Placeholder 2"/>
+      <p:sp>
+        <p:nvSpPr>
+          <p:cNvPr id="3" name="Content Placeholder 2">
+            <a:extLst>
+              <a:ext uri="{FF2B5EF4-FFF2-40B4-BE49-F238E27FC236}">
+                <a16:creationId xmlns:a16="http://schemas.microsoft.com/office/drawing/2014/main" id="{D2592819-5C80-B996-F823-F8B9F9EAD6C9}"/>
+              </a:ext>
+            </a:extLst>
+          </p:cNvPr>
           <p:cNvSpPr>
             <a:spLocks noGrp="1"/>
           </p:cNvSpPr>
           <p:nvPr>
-            <p:ph idx="1"/>
+            <p:ph idx="10"/>
           </p:nvPr>
         </p:nvSpPr>
         <p:spPr>
           <a:xfrm>
-            <a:off x="5603747" y="2053950"/>
-            <a:ext cx="5678424" cy="3798739"/>
+            <a:off x="909829" y="1619249"/>
+            <a:ext cx="5046518" cy="4233439"/>
           </a:xfrm>
+          <a:prstGeom prst="rect">
+            <a:avLst/>
+          </a:prstGeom>
         </p:spPr>
         <p:txBody>
           <a:bodyPr>
@@ -1418,66 +1307,60 @@
       </p:sp>
       <p:sp>
         <p:nvSpPr>
-          <p:cNvPr id="4" name="Text Placeholder 3"/>
+          <p:cNvPr id="4" name="Content Placeholder 2">
+            <a:extLst>
+              <a:ext uri="{FF2B5EF4-FFF2-40B4-BE49-F238E27FC236}">
+                <a16:creationId xmlns:a16="http://schemas.microsoft.com/office/drawing/2014/main" id="{D1BAB7DA-EC53-0103-E362-83F86BDB6BC4}"/>
+              </a:ext>
+            </a:extLst>
+          </p:cNvPr>
           <p:cNvSpPr>
             <a:spLocks noGrp="1"/>
           </p:cNvSpPr>
           <p:nvPr>
-            <p:ph type="body" sz="half" idx="2"/>
+            <p:ph idx="11"/>
           </p:nvPr>
         </p:nvSpPr>
         <p:spPr>
           <a:xfrm>
-            <a:off x="909829" y="2053950"/>
-            <a:ext cx="4389120" cy="3762294"/>
+            <a:off x="6235653" y="1619248"/>
+            <a:ext cx="5046518" cy="4233439"/>
           </a:xfrm>
+          <a:prstGeom prst="rect">
+            <a:avLst/>
+          </a:prstGeom>
         </p:spPr>
         <p:txBody>
-          <a:bodyPr lIns="91440" rIns="91440">
+          <a:bodyPr>
             <a:normAutofit/>
           </a:bodyPr>
           <a:lstStyle>
-            <a:lvl1pPr marL="0" indent="0">
-              <a:lnSpc>
-                <a:spcPct val="108000"/>
-              </a:lnSpc>
-              <a:spcBef>
-                <a:spcPts val="600"/>
-              </a:spcBef>
-              <a:buNone/>
+            <a:lvl1pPr>
               <a:defRPr sz="1800"/>
             </a:lvl1pPr>
-            <a:lvl2pPr marL="457200" indent="0">
-              <a:buNone/>
-              <a:defRPr sz="1200"/>
+            <a:lvl2pPr>
+              <a:defRPr sz="1800"/>
             </a:lvl2pPr>
-            <a:lvl3pPr marL="914400" indent="0">
-              <a:buNone/>
-              <a:defRPr sz="1000"/>
+            <a:lvl3pPr>
+              <a:defRPr sz="1800"/>
             </a:lvl3pPr>
-            <a:lvl4pPr marL="1371600" indent="0">
-              <a:buNone/>
-              <a:defRPr sz="900"/>
+            <a:lvl4pPr>
+              <a:defRPr sz="1800"/>
             </a:lvl4pPr>
-            <a:lvl5pPr marL="1828800" indent="0">
-              <a:buNone/>
-              <a:defRPr sz="900"/>
+            <a:lvl5pPr>
+              <a:defRPr sz="1800"/>
             </a:lvl5pPr>
-            <a:lvl6pPr marL="2286000" indent="0">
-              <a:buNone/>
-              <a:defRPr sz="900"/>
+            <a:lvl6pPr>
+              <a:defRPr sz="1600"/>
             </a:lvl6pPr>
-            <a:lvl7pPr marL="2743200" indent="0">
-              <a:buNone/>
-              <a:defRPr sz="900"/>
+            <a:lvl7pPr>
+              <a:defRPr sz="1600"/>
             </a:lvl7pPr>
-            <a:lvl8pPr marL="3200400" indent="0">
-              <a:buNone/>
-              <a:defRPr sz="900"/>
+            <a:lvl8pPr>
+              <a:defRPr sz="1600"/>
             </a:lvl8pPr>
-            <a:lvl9pPr marL="3657600" indent="0">
-              <a:buNone/>
-              <a:defRPr sz="900"/>
+            <a:lvl9pPr>
+              <a:defRPr sz="1600"/>
             </a:lvl9pPr>
           </a:lstStyle>
           <a:p>
@@ -1486,6 +1369,155 @@
               <a:rPr lang="en-GB" dirty="0"/>
               <a:t>Click to edit Master text styles</a:t>
             </a:r>
+          </a:p>
+          <a:p>
+            <a:pPr lvl="1"/>
+            <a:r>
+              <a:rPr lang="en-GB" dirty="0"/>
+              <a:t>Second level</a:t>
+            </a:r>
+          </a:p>
+          <a:p>
+            <a:pPr lvl="2"/>
+            <a:r>
+              <a:rPr lang="en-GB" dirty="0"/>
+              <a:t>Third level</a:t>
+            </a:r>
+          </a:p>
+          <a:p>
+            <a:pPr lvl="3"/>
+            <a:r>
+              <a:rPr lang="en-GB" dirty="0"/>
+              <a:t>Fourth level</a:t>
+            </a:r>
+          </a:p>
+          <a:p>
+            <a:pPr lvl="4"/>
+            <a:r>
+              <a:rPr lang="en-GB" dirty="0"/>
+              <a:t>Fifth level</a:t>
+            </a:r>
+            <a:endParaRPr lang="en-US" dirty="0"/>
+          </a:p>
+        </p:txBody>
+      </p:sp>
+    </p:spTree>
+    <p:extLst>
+      <p:ext uri="{BB962C8B-B14F-4D97-AF65-F5344CB8AC3E}">
+        <p14:creationId xmlns:p14="http://schemas.microsoft.com/office/powerpoint/2010/main" val="2385444012"/>
+      </p:ext>
+    </p:extLst>
+  </p:cSld>
+  <p:clrMapOvr>
+    <a:masterClrMapping/>
+  </p:clrMapOvr>
+</p:sldLayout>
+</file>
+
+<file path=ppt/slideLayouts/slideLayout4.xml><?xml version="1.0" encoding="utf-8"?>
+<p:sldLayout xmlns:a="http://schemas.openxmlformats.org/drawingml/2006/main" xmlns:r="http://schemas.openxmlformats.org/officeDocument/2006/relationships" xmlns:p="http://schemas.openxmlformats.org/presentationml/2006/main" preserve="1" userDrawn="1">
+  <p:cSld name="Comparison">
+    <p:spTree>
+      <p:nvGrpSpPr>
+        <p:cNvPr id="1" name=""/>
+        <p:cNvGrpSpPr/>
+        <p:nvPr/>
+      </p:nvGrpSpPr>
+      <p:grpSpPr>
+        <a:xfrm>
+          <a:off x="0" y="0"/>
+          <a:ext cx="0" cy="0"/>
+          <a:chOff x="0" y="0"/>
+          <a:chExt cx="0" cy="0"/>
+        </a:xfrm>
+      </p:grpSpPr>
+      <p:sp>
+        <p:nvSpPr>
+          <p:cNvPr id="3" name="Content Placeholder 2"/>
+          <p:cNvSpPr>
+            <a:spLocks noGrp="1"/>
+          </p:cNvSpPr>
+          <p:nvPr>
+            <p:ph idx="1"/>
+          </p:nvPr>
+        </p:nvSpPr>
+        <p:spPr>
+          <a:xfrm>
+            <a:off x="5603747" y="1619250"/>
+            <a:ext cx="5678424" cy="4233439"/>
+          </a:xfrm>
+          <a:prstGeom prst="rect">
+            <a:avLst/>
+          </a:prstGeom>
+        </p:spPr>
+        <p:txBody>
+          <a:bodyPr>
+            <a:normAutofit/>
+          </a:bodyPr>
+          <a:lstStyle>
+            <a:lvl1pPr>
+              <a:defRPr sz="1800"/>
+            </a:lvl1pPr>
+            <a:lvl2pPr>
+              <a:defRPr sz="1800"/>
+            </a:lvl2pPr>
+            <a:lvl3pPr>
+              <a:defRPr sz="1800"/>
+            </a:lvl3pPr>
+            <a:lvl4pPr>
+              <a:defRPr sz="1800"/>
+            </a:lvl4pPr>
+            <a:lvl5pPr>
+              <a:defRPr sz="1800"/>
+            </a:lvl5pPr>
+            <a:lvl6pPr>
+              <a:defRPr sz="1600"/>
+            </a:lvl6pPr>
+            <a:lvl7pPr>
+              <a:defRPr sz="1600"/>
+            </a:lvl7pPr>
+            <a:lvl8pPr>
+              <a:defRPr sz="1600"/>
+            </a:lvl8pPr>
+            <a:lvl9pPr>
+              <a:defRPr sz="1600"/>
+            </a:lvl9pPr>
+          </a:lstStyle>
+          <a:p>
+            <a:pPr lvl="0"/>
+            <a:r>
+              <a:rPr lang="en-GB" dirty="0"/>
+              <a:t>Click to edit Master text styles</a:t>
+            </a:r>
+          </a:p>
+          <a:p>
+            <a:pPr lvl="1"/>
+            <a:r>
+              <a:rPr lang="en-GB" dirty="0"/>
+              <a:t>Second level</a:t>
+            </a:r>
+          </a:p>
+          <a:p>
+            <a:pPr lvl="2"/>
+            <a:r>
+              <a:rPr lang="en-GB" dirty="0"/>
+              <a:t>Third level</a:t>
+            </a:r>
+          </a:p>
+          <a:p>
+            <a:pPr lvl="3"/>
+            <a:r>
+              <a:rPr lang="en-GB" dirty="0"/>
+              <a:t>Fourth level</a:t>
+            </a:r>
+          </a:p>
+          <a:p>
+            <a:pPr lvl="4"/>
+            <a:r>
+              <a:rPr lang="en-GB" dirty="0"/>
+              <a:t>Fifth level</a:t>
+            </a:r>
+            <a:endParaRPr lang="en-US" dirty="0"/>
           </a:p>
         </p:txBody>
       </p:sp>
@@ -1507,13 +1539,19 @@
         </p:nvSpPr>
         <p:spPr>
           <a:xfrm>
-            <a:off x="909829" y="237744"/>
-            <a:ext cx="8434196" cy="1499616"/>
+            <a:off x="909829" y="428624"/>
+            <a:ext cx="8434196" cy="914401"/>
           </a:xfrm>
         </p:spPr>
         <p:txBody>
-          <a:bodyPr/>
-          <a:lstStyle/>
+          <a:bodyPr>
+            <a:normAutofit/>
+          </a:bodyPr>
+          <a:lstStyle>
+            <a:lvl1pPr>
+              <a:defRPr sz="3600"/>
+            </a:lvl1pPr>
+          </a:lstStyle>
           <a:p>
             <a:r>
               <a:rPr lang="en-GB" dirty="0"/>
@@ -1662,6 +1700,102 @@
           </a:p>
         </p:txBody>
       </p:sp>
+      <p:sp>
+        <p:nvSpPr>
+          <p:cNvPr id="4" name="Content Placeholder 2">
+            <a:extLst>
+              <a:ext uri="{FF2B5EF4-FFF2-40B4-BE49-F238E27FC236}">
+                <a16:creationId xmlns:a16="http://schemas.microsoft.com/office/drawing/2014/main" id="{DF61A5FC-3684-1BAC-1114-63C491ABAD76}"/>
+              </a:ext>
+            </a:extLst>
+          </p:cNvPr>
+          <p:cNvSpPr>
+            <a:spLocks noGrp="1"/>
+          </p:cNvSpPr>
+          <p:nvPr>
+            <p:ph idx="10"/>
+          </p:nvPr>
+        </p:nvSpPr>
+        <p:spPr>
+          <a:xfrm>
+            <a:off x="909829" y="1619249"/>
+            <a:ext cx="4405121" cy="4233439"/>
+          </a:xfrm>
+          <a:prstGeom prst="rect">
+            <a:avLst/>
+          </a:prstGeom>
+        </p:spPr>
+        <p:txBody>
+          <a:bodyPr>
+            <a:normAutofit/>
+          </a:bodyPr>
+          <a:lstStyle>
+            <a:lvl1pPr>
+              <a:defRPr sz="1800"/>
+            </a:lvl1pPr>
+            <a:lvl2pPr>
+              <a:defRPr sz="1800"/>
+            </a:lvl2pPr>
+            <a:lvl3pPr>
+              <a:defRPr sz="1800"/>
+            </a:lvl3pPr>
+            <a:lvl4pPr>
+              <a:defRPr sz="1800"/>
+            </a:lvl4pPr>
+            <a:lvl5pPr>
+              <a:defRPr sz="1800"/>
+            </a:lvl5pPr>
+            <a:lvl6pPr>
+              <a:defRPr sz="1600"/>
+            </a:lvl6pPr>
+            <a:lvl7pPr>
+              <a:defRPr sz="1600"/>
+            </a:lvl7pPr>
+            <a:lvl8pPr>
+              <a:defRPr sz="1600"/>
+            </a:lvl8pPr>
+            <a:lvl9pPr>
+              <a:defRPr sz="1600"/>
+            </a:lvl9pPr>
+          </a:lstStyle>
+          <a:p>
+            <a:pPr lvl="0"/>
+            <a:r>
+              <a:rPr lang="en-GB" dirty="0"/>
+              <a:t>Click to edit Master text styles</a:t>
+            </a:r>
+          </a:p>
+          <a:p>
+            <a:pPr lvl="1"/>
+            <a:r>
+              <a:rPr lang="en-GB" dirty="0"/>
+              <a:t>Second level</a:t>
+            </a:r>
+          </a:p>
+          <a:p>
+            <a:pPr lvl="2"/>
+            <a:r>
+              <a:rPr lang="en-GB" dirty="0"/>
+              <a:t>Third level</a:t>
+            </a:r>
+          </a:p>
+          <a:p>
+            <a:pPr lvl="3"/>
+            <a:r>
+              <a:rPr lang="en-GB" dirty="0"/>
+              <a:t>Fourth level</a:t>
+            </a:r>
+          </a:p>
+          <a:p>
+            <a:pPr lvl="4"/>
+            <a:r>
+              <a:rPr lang="en-GB" dirty="0"/>
+              <a:t>Fifth level</a:t>
+            </a:r>
+            <a:endParaRPr lang="en-US" dirty="0"/>
+          </a:p>
+        </p:txBody>
+      </p:sp>
     </p:spTree>
     <p:extLst>
       <p:ext uri="{BB962C8B-B14F-4D97-AF65-F5344CB8AC3E}">
@@ -1702,10 +1836,21 @@
             <p:ph type="title" hasCustomPrompt="1"/>
           </p:nvPr>
         </p:nvSpPr>
-        <p:spPr/>
-        <p:txBody>
-          <a:bodyPr/>
-          <a:lstStyle/>
+        <p:spPr>
+          <a:xfrm>
+            <a:off x="909829" y="438150"/>
+            <a:ext cx="8434196" cy="914400"/>
+          </a:xfrm>
+        </p:spPr>
+        <p:txBody>
+          <a:bodyPr>
+            <a:normAutofit/>
+          </a:bodyPr>
+          <a:lstStyle>
+            <a:lvl1pPr>
+              <a:defRPr sz="3600"/>
+            </a:lvl1pPr>
+          </a:lstStyle>
           <a:p>
             <a:r>
               <a:rPr lang="en-GB" dirty="0"/>
@@ -1727,9 +1872,12 @@
         </p:nvSpPr>
         <p:spPr>
           <a:xfrm>
-            <a:off x="909828" y="1911308"/>
-            <a:ext cx="11083698" cy="460417"/>
+            <a:off x="909829" y="1550608"/>
+            <a:ext cx="10243946" cy="460417"/>
           </a:xfrm>
+          <a:prstGeom prst="rect">
+            <a:avLst/>
+          </a:prstGeom>
         </p:spPr>
         <p:txBody>
           <a:bodyPr anchor="ctr"/>
@@ -1773,80 +1921,6 @@
               <a:rPr lang="en-US" dirty="0"/>
               <a:t>Add sensitivity if needed</a:t>
             </a:r>
-          </a:p>
-        </p:txBody>
-      </p:sp>
-      <p:sp>
-        <p:nvSpPr>
-          <p:cNvPr id="4" name="Picture Placeholder 2">
-            <a:extLst>
-              <a:ext uri="{FF2B5EF4-FFF2-40B4-BE49-F238E27FC236}">
-                <a16:creationId xmlns:a16="http://schemas.microsoft.com/office/drawing/2014/main" id="{3624C560-4E3C-7F23-9A71-5ECD5129CBDE}"/>
-              </a:ext>
-            </a:extLst>
-          </p:cNvPr>
-          <p:cNvSpPr>
-            <a:spLocks noGrp="1" noChangeAspect="1"/>
-          </p:cNvSpPr>
-          <p:nvPr>
-            <p:ph type="pic" idx="12"/>
-          </p:nvPr>
-        </p:nvSpPr>
-        <p:spPr>
-          <a:xfrm>
-            <a:off x="884301" y="2411684"/>
-            <a:ext cx="5041792" cy="3518177"/>
-          </a:xfrm>
-          <a:solidFill>
-            <a:srgbClr val="046AAA"/>
-          </a:solidFill>
-        </p:spPr>
-        <p:txBody>
-          <a:bodyPr lIns="457200" tIns="365760" rIns="45720" bIns="45720" anchor="t"/>
-          <a:lstStyle>
-            <a:lvl1pPr marL="0" indent="0">
-              <a:buNone/>
-              <a:defRPr sz="3200"/>
-            </a:lvl1pPr>
-            <a:lvl2pPr marL="457200" indent="0">
-              <a:buNone/>
-              <a:defRPr sz="2800"/>
-            </a:lvl2pPr>
-            <a:lvl3pPr marL="914400" indent="0">
-              <a:buNone/>
-              <a:defRPr sz="2400"/>
-            </a:lvl3pPr>
-            <a:lvl4pPr marL="1371600" indent="0">
-              <a:buNone/>
-              <a:defRPr sz="2000"/>
-            </a:lvl4pPr>
-            <a:lvl5pPr marL="1828800" indent="0">
-              <a:buNone/>
-              <a:defRPr sz="2000"/>
-            </a:lvl5pPr>
-            <a:lvl6pPr marL="2286000" indent="0">
-              <a:buNone/>
-              <a:defRPr sz="2000"/>
-            </a:lvl6pPr>
-            <a:lvl7pPr marL="2743200" indent="0">
-              <a:buNone/>
-              <a:defRPr sz="2000"/>
-            </a:lvl7pPr>
-            <a:lvl8pPr marL="3200400" indent="0">
-              <a:buNone/>
-              <a:defRPr sz="2000"/>
-            </a:lvl8pPr>
-            <a:lvl9pPr marL="3657600" indent="0">
-              <a:buNone/>
-              <a:defRPr sz="2000"/>
-            </a:lvl9pPr>
-          </a:lstStyle>
-          <a:p>
-            <a:r>
-              <a:rPr lang="en-GB" dirty="0"/>
-              <a:t>Click icon to add picture</a:t>
-            </a:r>
-            <a:endParaRPr lang="en-US" dirty="0"/>
           </a:p>
         </p:txBody>
       </p:sp>
@@ -1983,6 +2057,72 @@
           </a:p>
         </p:txBody>
       </p:sp>
+      <p:sp>
+        <p:nvSpPr>
+          <p:cNvPr id="8" name="Content Placeholder 7">
+            <a:extLst>
+              <a:ext uri="{FF2B5EF4-FFF2-40B4-BE49-F238E27FC236}">
+                <a16:creationId xmlns:a16="http://schemas.microsoft.com/office/drawing/2014/main" id="{E661F691-68A2-ACF8-5D27-3F5571B6FD79}"/>
+              </a:ext>
+            </a:extLst>
+          </p:cNvPr>
+          <p:cNvSpPr>
+            <a:spLocks noGrp="1"/>
+          </p:cNvSpPr>
+          <p:nvPr>
+            <p:ph sz="quarter" idx="12"/>
+          </p:nvPr>
+        </p:nvSpPr>
+        <p:spPr>
+          <a:xfrm>
+            <a:off x="909638" y="2228850"/>
+            <a:ext cx="7015162" cy="3695700"/>
+          </a:xfrm>
+          <a:prstGeom prst="rect">
+            <a:avLst/>
+          </a:prstGeom>
+        </p:spPr>
+        <p:txBody>
+          <a:bodyPr/>
+          <a:lstStyle/>
+          <a:p>
+            <a:pPr lvl="0"/>
+            <a:r>
+              <a:rPr lang="en-US"/>
+              <a:t>Click to edit Master text styles</a:t>
+            </a:r>
+          </a:p>
+          <a:p>
+            <a:pPr lvl="1"/>
+            <a:r>
+              <a:rPr lang="en-US"/>
+              <a:t>Second level</a:t>
+            </a:r>
+          </a:p>
+          <a:p>
+            <a:pPr lvl="2"/>
+            <a:r>
+              <a:rPr lang="en-US"/>
+              <a:t>Third level</a:t>
+            </a:r>
+          </a:p>
+          <a:p>
+            <a:pPr lvl="3"/>
+            <a:r>
+              <a:rPr lang="en-US"/>
+              <a:t>Fourth level</a:t>
+            </a:r>
+          </a:p>
+          <a:p>
+            <a:pPr lvl="4"/>
+            <a:r>
+              <a:rPr lang="en-US"/>
+              <a:t>Fifth level</a:t>
+            </a:r>
+            <a:endParaRPr lang="en-GB"/>
+          </a:p>
+        </p:txBody>
+      </p:sp>
     </p:spTree>
     <p:extLst>
       <p:ext uri="{BB962C8B-B14F-4D97-AF65-F5344CB8AC3E}">
@@ -2036,7 +2176,7 @@
           <a:p>
             <a:fld id="{0EB35C0E-E263-0848-A698-EE526CA39358}" type="datetimeFigureOut">
               <a:rPr lang="en-US" smtClean="0"/>
-              <a:t>5/14/2024</a:t>
+              <a:t>5/20/2024</a:t>
             </a:fld>
             <a:endParaRPr lang="en-US" dirty="0"/>
           </a:p>
@@ -2136,10 +2276,21 @@
             <p:ph type="title" hasCustomPrompt="1"/>
           </p:nvPr>
         </p:nvSpPr>
-        <p:spPr/>
-        <p:txBody>
-          <a:bodyPr/>
-          <a:lstStyle/>
+        <p:spPr>
+          <a:xfrm>
+            <a:off x="909829" y="403765"/>
+            <a:ext cx="8434196" cy="976056"/>
+          </a:xfrm>
+        </p:spPr>
+        <p:txBody>
+          <a:bodyPr>
+            <a:normAutofit/>
+          </a:bodyPr>
+          <a:lstStyle>
+            <a:lvl1pPr>
+              <a:defRPr sz="3600"/>
+            </a:lvl1pPr>
+          </a:lstStyle>
           <a:p>
             <a:r>
               <a:rPr lang="en-GB" dirty="0"/>
@@ -2161,9 +2312,12 @@
         </p:nvSpPr>
         <p:spPr>
           <a:xfrm>
-            <a:off x="909828" y="1911308"/>
-            <a:ext cx="10420160" cy="3915333"/>
+            <a:off x="909828" y="1737360"/>
+            <a:ext cx="10420160" cy="4089281"/>
           </a:xfrm>
+          <a:prstGeom prst="rect">
+            <a:avLst/>
+          </a:prstGeom>
         </p:spPr>
         <p:txBody>
           <a:bodyPr/>
@@ -2997,6 +3151,289 @@
           <a:chExt cx="0" cy="0"/>
         </a:xfrm>
       </p:grpSpPr>
+      <p:sp>
+        <p:nvSpPr>
+          <p:cNvPr id="4" name="Content Placeholder 2">
+            <a:extLst>
+              <a:ext uri="{FF2B5EF4-FFF2-40B4-BE49-F238E27FC236}">
+                <a16:creationId xmlns:a16="http://schemas.microsoft.com/office/drawing/2014/main" id="{456AE61C-CB53-A51B-2E3D-419A782B4757}"/>
+              </a:ext>
+            </a:extLst>
+          </p:cNvPr>
+          <p:cNvSpPr txBox="1">
+            <a:spLocks/>
+          </p:cNvSpPr>
+          <p:nvPr userDrawn="1"/>
+        </p:nvSpPr>
+        <p:spPr>
+          <a:xfrm>
+            <a:off x="909828" y="1619249"/>
+            <a:ext cx="10420159" cy="4233439"/>
+          </a:xfrm>
+          <a:prstGeom prst="rect">
+            <a:avLst/>
+          </a:prstGeom>
+        </p:spPr>
+        <p:txBody>
+          <a:bodyPr>
+            <a:normAutofit/>
+          </a:bodyPr>
+          <a:lstStyle>
+            <a:lvl1pPr algn="l" defTabSz="914400" eaLnBrk="1" hangingPunct="1" indent="-91440" latinLnBrk="0" marL="91440" rtl="0">
+              <a:lnSpc>
+                <a:spcPct val="90000"/>
+              </a:lnSpc>
+              <a:spcBef>
+                <a:spcPts val="1200"/>
+              </a:spcBef>
+              <a:spcAft>
+                <a:spcPts val="200"/>
+              </a:spcAft>
+              <a:buClr>
+                <a:schemeClr val="accent1"/>
+              </a:buClr>
+              <a:buSzPct val="100000"/>
+              <a:buFont charset="0" panose="020B0602020104020603" pitchFamily="34" typeface="Tw Cen MT"/>
+              <a:buChar char=" "/>
+              <a:defRPr kern="1200" sz="1800">
+                <a:solidFill>
+                  <a:schemeClr val="tx1"/>
+                </a:solidFill>
+                <a:latin charset="0" panose="020B0004020202020204" pitchFamily="34" typeface="Aptos"/>
+                <a:ea typeface="+mn-ea"/>
+                <a:cs charset="0" panose="020B0604020202020204" pitchFamily="34" typeface="Arial"/>
+              </a:defRPr>
+            </a:lvl1pPr>
+            <a:lvl2pPr algn="l" defTabSz="914400" eaLnBrk="1" hangingPunct="1" indent="-137160" latinLnBrk="0" marL="265176" rtl="0">
+              <a:lnSpc>
+                <a:spcPct val="90000"/>
+              </a:lnSpc>
+              <a:spcBef>
+                <a:spcPts val="200"/>
+              </a:spcBef>
+              <a:spcAft>
+                <a:spcPts val="400"/>
+              </a:spcAft>
+              <a:buClr>
+                <a:schemeClr val="accent1"/>
+              </a:buClr>
+              <a:buFont charset="2" pitchFamily="18" typeface="Wingdings 3"/>
+              <a:buChar char=""/>
+              <a:defRPr kern="1200" sz="1800">
+                <a:solidFill>
+                  <a:schemeClr val="tx1"/>
+                </a:solidFill>
+                <a:latin charset="0" panose="020B0004020202020204" pitchFamily="34" typeface="Aptos"/>
+                <a:ea typeface="+mn-ea"/>
+                <a:cs charset="0" panose="020B0604020202020204" pitchFamily="34" typeface="Arial"/>
+              </a:defRPr>
+            </a:lvl2pPr>
+            <a:lvl3pPr algn="l" defTabSz="914400" eaLnBrk="1" hangingPunct="1" indent="-137160" latinLnBrk="0" marL="448056" rtl="0">
+              <a:lnSpc>
+                <a:spcPct val="90000"/>
+              </a:lnSpc>
+              <a:spcBef>
+                <a:spcPts val="200"/>
+              </a:spcBef>
+              <a:spcAft>
+                <a:spcPts val="400"/>
+              </a:spcAft>
+              <a:buClr>
+                <a:schemeClr val="accent1"/>
+              </a:buClr>
+              <a:buFont charset="2" pitchFamily="18" typeface="Wingdings 3"/>
+              <a:buChar char=""/>
+              <a:defRPr kern="1200" sz="1800">
+                <a:solidFill>
+                  <a:schemeClr val="tx1"/>
+                </a:solidFill>
+                <a:latin charset="0" panose="020B0004020202020204" pitchFamily="34" typeface="Aptos"/>
+                <a:ea typeface="+mn-ea"/>
+                <a:cs charset="0" panose="020B0604020202020204" pitchFamily="34" typeface="Arial"/>
+              </a:defRPr>
+            </a:lvl3pPr>
+            <a:lvl4pPr algn="l" defTabSz="914400" eaLnBrk="1" hangingPunct="1" indent="-137160" latinLnBrk="0" marL="594360" rtl="0">
+              <a:lnSpc>
+                <a:spcPct val="90000"/>
+              </a:lnSpc>
+              <a:spcBef>
+                <a:spcPts val="200"/>
+              </a:spcBef>
+              <a:spcAft>
+                <a:spcPts val="400"/>
+              </a:spcAft>
+              <a:buClr>
+                <a:schemeClr val="accent1"/>
+              </a:buClr>
+              <a:buFont charset="2" pitchFamily="18" typeface="Wingdings 3"/>
+              <a:buChar char=""/>
+              <a:defRPr kern="1200" sz="1800">
+                <a:solidFill>
+                  <a:schemeClr val="tx1"/>
+                </a:solidFill>
+                <a:latin charset="0" panose="020B0004020202020204" pitchFamily="34" typeface="Aptos"/>
+                <a:ea typeface="+mn-ea"/>
+                <a:cs charset="0" panose="020B0604020202020204" pitchFamily="34" typeface="Arial"/>
+              </a:defRPr>
+            </a:lvl4pPr>
+            <a:lvl5pPr algn="l" defTabSz="914400" eaLnBrk="1" hangingPunct="1" indent="-137160" latinLnBrk="0" marL="777240" rtl="0">
+              <a:lnSpc>
+                <a:spcPct val="90000"/>
+              </a:lnSpc>
+              <a:spcBef>
+                <a:spcPts val="200"/>
+              </a:spcBef>
+              <a:spcAft>
+                <a:spcPts val="400"/>
+              </a:spcAft>
+              <a:buClr>
+                <a:schemeClr val="accent1"/>
+              </a:buClr>
+              <a:buFont charset="2" pitchFamily="18" typeface="Wingdings 3"/>
+              <a:buChar char=""/>
+              <a:defRPr kern="1200" sz="1800">
+                <a:solidFill>
+                  <a:schemeClr val="tx1"/>
+                </a:solidFill>
+                <a:latin charset="0" panose="020B0004020202020204" pitchFamily="34" typeface="Aptos"/>
+                <a:ea typeface="+mn-ea"/>
+                <a:cs charset="0" panose="020B0604020202020204" pitchFamily="34" typeface="Arial"/>
+              </a:defRPr>
+            </a:lvl5pPr>
+            <a:lvl6pPr algn="l" defTabSz="914400" eaLnBrk="1" hangingPunct="1" indent="-137160" latinLnBrk="0" marL="914400" rtl="0">
+              <a:lnSpc>
+                <a:spcPct val="90000"/>
+              </a:lnSpc>
+              <a:spcBef>
+                <a:spcPts val="200"/>
+              </a:spcBef>
+              <a:spcAft>
+                <a:spcPts val="400"/>
+              </a:spcAft>
+              <a:buClr>
+                <a:schemeClr val="accent1"/>
+              </a:buClr>
+              <a:buFont charset="2" pitchFamily="18" typeface="Wingdings 3"/>
+              <a:buChar char=""/>
+              <a:defRPr kern="1200" sz="1600">
+                <a:solidFill>
+                  <a:schemeClr val="tx1"/>
+                </a:solidFill>
+                <a:latin typeface="+mn-lt"/>
+                <a:ea typeface="+mn-ea"/>
+                <a:cs typeface="+mn-cs"/>
+              </a:defRPr>
+            </a:lvl6pPr>
+            <a:lvl7pPr algn="l" defTabSz="914400" eaLnBrk="1" hangingPunct="1" indent="-137160" latinLnBrk="0" marL="1060704" rtl="0">
+              <a:lnSpc>
+                <a:spcPct val="90000"/>
+              </a:lnSpc>
+              <a:spcBef>
+                <a:spcPts val="200"/>
+              </a:spcBef>
+              <a:spcAft>
+                <a:spcPts val="400"/>
+              </a:spcAft>
+              <a:buClr>
+                <a:schemeClr val="accent1"/>
+              </a:buClr>
+              <a:buFont charset="2" pitchFamily="18" typeface="Wingdings 3"/>
+              <a:buChar char=""/>
+              <a:defRPr kern="1200" sz="1600">
+                <a:solidFill>
+                  <a:schemeClr val="tx1"/>
+                </a:solidFill>
+                <a:latin typeface="+mn-lt"/>
+                <a:ea typeface="+mn-ea"/>
+                <a:cs typeface="+mn-cs"/>
+              </a:defRPr>
+            </a:lvl7pPr>
+            <a:lvl8pPr algn="l" defTabSz="914400" eaLnBrk="1" hangingPunct="1" indent="-137160" latinLnBrk="0" marL="1216152" rtl="0">
+              <a:lnSpc>
+                <a:spcPct val="90000"/>
+              </a:lnSpc>
+              <a:spcBef>
+                <a:spcPts val="200"/>
+              </a:spcBef>
+              <a:spcAft>
+                <a:spcPts val="400"/>
+              </a:spcAft>
+              <a:buClr>
+                <a:schemeClr val="accent1"/>
+              </a:buClr>
+              <a:buFont charset="2" pitchFamily="18" typeface="Wingdings 3"/>
+              <a:buChar char=""/>
+              <a:defRPr kern="1200" sz="1600">
+                <a:solidFill>
+                  <a:schemeClr val="tx1"/>
+                </a:solidFill>
+                <a:latin typeface="+mn-lt"/>
+                <a:ea typeface="+mn-ea"/>
+                <a:cs typeface="+mn-cs"/>
+              </a:defRPr>
+            </a:lvl8pPr>
+            <a:lvl9pPr algn="l" defTabSz="914400" eaLnBrk="1" hangingPunct="1" indent="-137160" latinLnBrk="0" marL="1362456" rtl="0">
+              <a:lnSpc>
+                <a:spcPct val="90000"/>
+              </a:lnSpc>
+              <a:spcBef>
+                <a:spcPts val="200"/>
+              </a:spcBef>
+              <a:spcAft>
+                <a:spcPts val="400"/>
+              </a:spcAft>
+              <a:buClr>
+                <a:schemeClr val="accent1"/>
+              </a:buClr>
+              <a:buFont charset="2" pitchFamily="18" typeface="Wingdings 3"/>
+              <a:buChar char=""/>
+              <a:defRPr kern="1200" sz="1600">
+                <a:solidFill>
+                  <a:schemeClr val="tx1"/>
+                </a:solidFill>
+                <a:latin typeface="+mn-lt"/>
+                <a:ea typeface="+mn-ea"/>
+                <a:cs typeface="+mn-cs"/>
+              </a:defRPr>
+            </a:lvl9pPr>
+          </a:lstStyle>
+          <a:p>
+            <a:r>
+              <a:rPr lang="en-GB"/>
+              <a:t>Click to edit Master text styles</a:t>
+            </a:r>
+          </a:p>
+          <a:p>
+            <a:pPr lvl="1"/>
+            <a:r>
+              <a:rPr lang="en-GB"/>
+              <a:t>Second level</a:t>
+            </a:r>
+          </a:p>
+          <a:p>
+            <a:pPr lvl="2"/>
+            <a:r>
+              <a:rPr lang="en-GB"/>
+              <a:t>Third level</a:t>
+            </a:r>
+          </a:p>
+          <a:p>
+            <a:pPr lvl="3"/>
+            <a:r>
+              <a:rPr lang="en-GB"/>
+              <a:t>Fourth level</a:t>
+            </a:r>
+          </a:p>
+          <a:p>
+            <a:pPr lvl="4"/>
+            <a:r>
+              <a:rPr lang="en-GB"/>
+              <a:t>Fifth level</a:t>
+            </a:r>
+            <a:endParaRPr dirty="0" lang="en-US"/>
+          </a:p>
+        </p:txBody>
+      </p:sp>
       <p:pic>
         <p:nvPicPr>
           <p:cNvPr descr="A blue line with a white background" id="8" name="Picture 7">
@@ -3038,8 +3475,8 @@
         </p:nvSpPr>
         <p:spPr>
           <a:xfrm>
-            <a:off x="909829" y="237744"/>
-            <a:ext cx="8434196" cy="1499616"/>
+            <a:off x="909829" y="429900"/>
+            <a:ext cx="8434196" cy="914400"/>
           </a:xfrm>
           <a:prstGeom prst="rect">
             <a:avLst/>
@@ -3071,8 +3508,8 @@
         </p:nvSpPr>
         <p:spPr>
           <a:xfrm>
-            <a:off x="909828" y="1975104"/>
-            <a:ext cx="10420160" cy="3754184"/>
+            <a:off x="909828" y="1695450"/>
+            <a:ext cx="10420160" cy="4033838"/>
           </a:xfrm>
           <a:prstGeom prst="rect">
             <a:avLst/>
@@ -3268,7 +3705,7 @@
           <a:spcPct val="0"/>
         </a:spcBef>
         <a:buNone/>
-        <a:defRPr b="1" baseline="0" cap="none" kern="1200" spc="100" sz="4400">
+        <a:defRPr b="1" baseline="0" cap="none" kern="1200" spc="100" sz="3600">
           <a:solidFill>
             <a:schemeClr val="tx1">
               <a:lumMod val="95000"/>
@@ -3641,7 +4078,7 @@
             </a:pPr>
             <a:r>
               <a:rPr/>
-              <a:t>Quantifying the impacts of single bed room changes</a:t>
+              <a:t>Quantifying the impacts of hospitals increasing single bed room provision</a:t>
             </a:r>
           </a:p>
         </p:txBody>
@@ -3661,6 +4098,9 @@
             <a:off x="457199" y="6020353"/>
             <a:ext cx="8406374" cy="674129"/>
           </a:xfrm>
+          <a:prstGeom prst="rect">
+            <a:avLst/>
+          </a:prstGeom>
         </p:spPr>
         <p:txBody>
           <a:bodyPr/>
@@ -3674,6 +4114,702 @@
             <a:r>
               <a:rPr/>
               <a:t>Andy Hood | Analytics Manager | Strategy Unit | 14th May 2024</a:t>
+            </a:r>
+          </a:p>
+        </p:txBody>
+      </p:sp>
+    </p:spTree>
+  </p:cSld>
+</p:sld>
+</file>
+
+<file path=ppt/slides/slide10.xml><?xml version="1.0" encoding="utf-8"?>
+<p:sld xmlns:a="http://schemas.openxmlformats.org/drawingml/2006/main" xmlns:r="http://schemas.openxmlformats.org/officeDocument/2006/relationships" xmlns:p="http://schemas.openxmlformats.org/presentationml/2006/main">
+  <p:cSld>
+    <p:spTree>
+      <p:nvGrpSpPr>
+        <p:cNvPr id="1" name=""/>
+        <p:cNvGrpSpPr/>
+        <p:nvPr/>
+      </p:nvGrpSpPr>
+      <p:grpSpPr>
+        <a:xfrm>
+          <a:off x="0" y="0"/>
+          <a:ext cx="0" cy="0"/>
+          <a:chOff x="0" y="0"/>
+          <a:chExt cx="0" cy="0"/>
+        </a:xfrm>
+      </p:grpSpPr>
+      <p:sp>
+        <p:nvSpPr>
+          <p:cNvPr id="2" name="Title 1"/>
+          <p:cNvSpPr>
+            <a:spLocks noGrp="1"/>
+          </p:cNvSpPr>
+          <p:nvPr>
+            <p:ph hasCustomPrompt="1" type="ctrTitle"/>
+          </p:nvPr>
+        </p:nvSpPr>
+        <p:spPr>
+          <a:xfrm>
+            <a:off x="457199" y="4755350"/>
+            <a:ext cx="7772400" cy="1218369"/>
+          </a:xfrm>
+        </p:spPr>
+        <p:txBody>
+          <a:bodyPr/>
+          <a:lstStyle/>
+          <a:p>
+            <a:pPr lvl="0" indent="0" marL="0">
+              <a:buNone/>
+            </a:pPr>
+            <a:r>
+              <a:rPr/>
+              <a:t>Summary of methods</a:t>
+            </a:r>
+          </a:p>
+        </p:txBody>
+      </p:sp>
+    </p:spTree>
+  </p:cSld>
+</p:sld>
+</file>
+
+<file path=ppt/slides/slide11.xml><?xml version="1.0" encoding="utf-8"?>
+<p:sld xmlns:a="http://schemas.openxmlformats.org/drawingml/2006/main" xmlns:r="http://schemas.openxmlformats.org/officeDocument/2006/relationships" xmlns:p="http://schemas.openxmlformats.org/presentationml/2006/main">
+  <p:cSld>
+    <p:spTree>
+      <p:nvGrpSpPr>
+        <p:cNvPr id="1" name=""/>
+        <p:cNvGrpSpPr/>
+        <p:nvPr/>
+      </p:nvGrpSpPr>
+      <p:grpSpPr>
+        <a:xfrm>
+          <a:off x="0" y="0"/>
+          <a:ext cx="0" cy="0"/>
+          <a:chOff x="0" y="0"/>
+          <a:chExt cx="0" cy="0"/>
+        </a:xfrm>
+      </p:grpSpPr>
+      <p:sp>
+        <p:nvSpPr>
+          <p:cNvPr id="2" name="Title 1"/>
+          <p:cNvSpPr>
+            <a:spLocks noGrp="1"/>
+          </p:cNvSpPr>
+          <p:nvPr>
+            <p:ph type="title"/>
+          </p:nvPr>
+        </p:nvSpPr>
+        <p:spPr>
+          <a:xfrm>
+            <a:off x="919352" y="419100"/>
+            <a:ext cx="9720072" cy="933450"/>
+          </a:xfrm>
+        </p:spPr>
+        <p:txBody>
+          <a:bodyPr/>
+          <a:lstStyle/>
+          <a:p>
+            <a:pPr lvl="0" indent="0" marL="0">
+              <a:buNone/>
+            </a:pPr>
+            <a:r>
+              <a:rPr/>
+              <a:t>Selecting control sites</a:t>
+            </a:r>
+          </a:p>
+        </p:txBody>
+      </p:sp>
+      <p:sp>
+        <p:nvSpPr>
+          <p:cNvPr id="3" name="Content Placeholder 2">
+            <a:extLst>
+              <a:ext uri="{FF2B5EF4-FFF2-40B4-BE49-F238E27FC236}">
+                <a16:creationId xmlns:a16="http://schemas.microsoft.com/office/drawing/2014/main" id="{D2592819-5C80-B996-F823-F8B9F9EAD6C9}"/>
+              </a:ext>
+            </a:extLst>
+          </p:cNvPr>
+          <p:cNvSpPr>
+            <a:spLocks noGrp="1"/>
+          </p:cNvSpPr>
+          <p:nvPr>
+            <p:ph idx="10"/>
+          </p:nvPr>
+        </p:nvSpPr>
+        <p:spPr/>
+        <p:txBody>
+          <a:bodyPr/>
+          <a:lstStyle/>
+          <a:p>
+            <a:pPr lvl="0" indent="0" marL="0">
+              <a:buNone/>
+            </a:pPr>
+            <a:r>
+              <a:rPr/>
+              <a:t>Before including control sites into the calculation of the post-intervention counterfactual, we must ensure they’re similar to the site under study. We do this in several consecutive steps:</a:t>
+            </a:r>
+          </a:p>
+          <a:p>
+            <a:pPr lvl="0" indent="-457200" marL="457200">
+              <a:buAutoNum type="arabicPeriod"/>
+            </a:pPr>
+            <a:r>
+              <a:rPr/>
+              <a:t>Filter on similar site types e.g. General Acute, Tertiary Centre</a:t>
+            </a:r>
+          </a:p>
+          <a:p>
+            <a:pPr lvl="0" indent="-457200" marL="457200">
+              <a:buAutoNum type="arabicPeriod"/>
+            </a:pPr>
+            <a:r>
+              <a:rPr/>
+              <a:t>Exclude those with dissimilar single bed %’s at the point of intervention</a:t>
+            </a:r>
+          </a:p>
+          <a:p>
+            <a:pPr lvl="0" indent="-457200" marL="457200">
+              <a:buAutoNum type="arabicPeriod"/>
+            </a:pPr>
+            <a:r>
+              <a:rPr/>
+              <a:t>Match on (the closest 20) according to the following variables:</a:t>
+            </a:r>
+          </a:p>
+          <a:p>
+            <a:pPr lvl="0"/>
+            <a:r>
+              <a:rPr/>
+              <a:t>Hospital size (m2)</a:t>
+            </a:r>
+          </a:p>
+          <a:p>
+            <a:pPr lvl="0"/>
+            <a:r>
+              <a:rPr/>
+              <a:t>Patient case-mix (median age)</a:t>
+            </a:r>
+          </a:p>
+          <a:p>
+            <a:pPr lvl="0"/>
+            <a:r>
+              <a:rPr/>
+              <a:t>Elective:Non-elective spell ratio</a:t>
+            </a:r>
+          </a:p>
+        </p:txBody>
+      </p:sp>
+      <p:pic>
+        <p:nvPicPr>
+          <p:cNvPr descr="images/control_flowchart.png" id="0" name="Picture 1"/>
+          <p:cNvPicPr>
+            <a:picLocks noGrp="1" noChangeAspect="1"/>
+          </p:cNvPicPr>
+          <p:nvPr/>
+        </p:nvPicPr>
+        <p:blipFill>
+          <a:blip r:embed="rId2"/>
+          <a:stretch>
+            <a:fillRect/>
+          </a:stretch>
+        </p:blipFill>
+        <p:spPr bwMode="auto">
+          <a:xfrm>
+            <a:off x="6223000" y="1663700"/>
+            <a:ext cx="5041900" cy="4114800"/>
+          </a:xfrm>
+          <a:prstGeom prst="rect">
+            <a:avLst/>
+          </a:prstGeom>
+          <a:noFill/>
+          <a:ln w="9525">
+            <a:noFill/>
+            <a:headEnd/>
+            <a:tailEnd/>
+          </a:ln>
+        </p:spPr>
+      </p:pic>
+    </p:spTree>
+  </p:cSld>
+  <p:timing>
+    <p:tnLst>
+      <p:par>
+        <p:cTn id="1" dur="indefinite" restart="never" nodeType="tmRoot">
+          <p:childTnLst>
+            <p:seq concurrent="1" nextAc="seek">
+              <p:cTn id="2" dur="indefinite" nodeType="mainSeq">
+                <p:childTnLst>
+                  <p:par>
+                    <p:cTn id="3" fill="hold">
+                      <p:stCondLst>
+                        <p:cond delay="indefinite"/>
+                      </p:stCondLst>
+                      <p:childTnLst>
+                        <p:par>
+                          <p:cTn id="4" fill="hold">
+                            <p:stCondLst>
+                              <p:cond delay="0"/>
+                            </p:stCondLst>
+                            <p:childTnLst>
+                              <p:par>
+                                <p:cTn id="5" presetID="1" presetClass="entr" presetSubtype="0" fill="hold" grpId="0" nodeType="clickEffect">
+                                  <p:stCondLst>
+                                    <p:cond delay="0"/>
+                                  </p:stCondLst>
+                                  <p:childTnLst>
+                                    <p:set>
+                                      <p:cBhvr>
+                                        <p:cTn id="6" dur="1" fill="hold">
+                                          <p:stCondLst>
+                                            <p:cond delay="0"/>
+                                          </p:stCondLst>
+                                        </p:cTn>
+                                        <p:tgtEl>
+                                          <p:spTgt spid="3">
+                                            <p:txEl>
+                                              <p:pRg st="1" end="1"/>
+                                            </p:txEl>
+                                          </p:spTgt>
+                                        </p:tgtEl>
+                                        <p:attrNameLst>
+                                          <p:attrName>style.visibility</p:attrName>
+                                        </p:attrNameLst>
+                                      </p:cBhvr>
+                                      <p:to>
+                                        <p:strVal val="visible"/>
+                                      </p:to>
+                                    </p:set>
+                                  </p:childTnLst>
+                                </p:cTn>
+                              </p:par>
+                            </p:childTnLst>
+                          </p:cTn>
+                        </p:par>
+                      </p:childTnLst>
+                    </p:cTn>
+                  </p:par>
+                  <p:par>
+                    <p:cTn id="7" fill="hold">
+                      <p:stCondLst>
+                        <p:cond delay="indefinite"/>
+                      </p:stCondLst>
+                      <p:childTnLst>
+                        <p:par>
+                          <p:cTn id="8" fill="hold">
+                            <p:stCondLst>
+                              <p:cond delay="0"/>
+                            </p:stCondLst>
+                            <p:childTnLst>
+                              <p:par>
+                                <p:cTn id="9" presetID="1" presetClass="entr" presetSubtype="0" fill="hold" grpId="0" nodeType="clickEffect">
+                                  <p:stCondLst>
+                                    <p:cond delay="0"/>
+                                  </p:stCondLst>
+                                  <p:childTnLst>
+                                    <p:set>
+                                      <p:cBhvr>
+                                        <p:cTn id="10" dur="1" fill="hold">
+                                          <p:stCondLst>
+                                            <p:cond delay="0"/>
+                                          </p:stCondLst>
+                                        </p:cTn>
+                                        <p:tgtEl>
+                                          <p:spTgt spid="3">
+                                            <p:txEl>
+                                              <p:pRg st="2" end="2"/>
+                                            </p:txEl>
+                                          </p:spTgt>
+                                        </p:tgtEl>
+                                        <p:attrNameLst>
+                                          <p:attrName>style.visibility</p:attrName>
+                                        </p:attrNameLst>
+                                      </p:cBhvr>
+                                      <p:to>
+                                        <p:strVal val="visible"/>
+                                      </p:to>
+                                    </p:set>
+                                  </p:childTnLst>
+                                </p:cTn>
+                              </p:par>
+                            </p:childTnLst>
+                          </p:cTn>
+                        </p:par>
+                      </p:childTnLst>
+                    </p:cTn>
+                  </p:par>
+                  <p:par>
+                    <p:cTn id="11" fill="hold">
+                      <p:stCondLst>
+                        <p:cond delay="indefinite"/>
+                      </p:stCondLst>
+                      <p:childTnLst>
+                        <p:par>
+                          <p:cTn id="12" fill="hold">
+                            <p:stCondLst>
+                              <p:cond delay="0"/>
+                            </p:stCondLst>
+                            <p:childTnLst>
+                              <p:par>
+                                <p:cTn id="13" presetID="1" presetClass="entr" presetSubtype="0" fill="hold" grpId="0" nodeType="clickEffect">
+                                  <p:stCondLst>
+                                    <p:cond delay="0"/>
+                                  </p:stCondLst>
+                                  <p:childTnLst>
+                                    <p:set>
+                                      <p:cBhvr>
+                                        <p:cTn id="14" dur="1" fill="hold">
+                                          <p:stCondLst>
+                                            <p:cond delay="0"/>
+                                          </p:stCondLst>
+                                        </p:cTn>
+                                        <p:tgtEl>
+                                          <p:spTgt spid="3">
+                                            <p:txEl>
+                                              <p:pRg st="3" end="3"/>
+                                            </p:txEl>
+                                          </p:spTgt>
+                                        </p:tgtEl>
+                                        <p:attrNameLst>
+                                          <p:attrName>style.visibility</p:attrName>
+                                        </p:attrNameLst>
+                                      </p:cBhvr>
+                                      <p:to>
+                                        <p:strVal val="visible"/>
+                                      </p:to>
+                                    </p:set>
+                                  </p:childTnLst>
+                                </p:cTn>
+                              </p:par>
+                            </p:childTnLst>
+                          </p:cTn>
+                        </p:par>
+                      </p:childTnLst>
+                    </p:cTn>
+                  </p:par>
+                  <p:par>
+                    <p:cTn id="15" fill="hold">
+                      <p:stCondLst>
+                        <p:cond delay="indefinite"/>
+                      </p:stCondLst>
+                      <p:childTnLst>
+                        <p:par>
+                          <p:cTn id="16" fill="hold">
+                            <p:stCondLst>
+                              <p:cond delay="0"/>
+                            </p:stCondLst>
+                            <p:childTnLst>
+                              <p:par>
+                                <p:cTn id="17" presetID="1" presetClass="entr" presetSubtype="0" fill="hold" grpId="0" nodeType="clickEffect">
+                                  <p:stCondLst>
+                                    <p:cond delay="0"/>
+                                  </p:stCondLst>
+                                  <p:childTnLst>
+                                    <p:set>
+                                      <p:cBhvr>
+                                        <p:cTn id="18" dur="1" fill="hold">
+                                          <p:stCondLst>
+                                            <p:cond delay="0"/>
+                                          </p:stCondLst>
+                                        </p:cTn>
+                                        <p:tgtEl>
+                                          <p:spTgt spid="3">
+                                            <p:txEl>
+                                              <p:pRg st="4" end="4"/>
+                                            </p:txEl>
+                                          </p:spTgt>
+                                        </p:tgtEl>
+                                        <p:attrNameLst>
+                                          <p:attrName>style.visibility</p:attrName>
+                                        </p:attrNameLst>
+                                      </p:cBhvr>
+                                      <p:to>
+                                        <p:strVal val="visible"/>
+                                      </p:to>
+                                    </p:set>
+                                  </p:childTnLst>
+                                </p:cTn>
+                              </p:par>
+                            </p:childTnLst>
+                          </p:cTn>
+                        </p:par>
+                      </p:childTnLst>
+                    </p:cTn>
+                  </p:par>
+                  <p:par>
+                    <p:cTn id="19" fill="hold">
+                      <p:stCondLst>
+                        <p:cond delay="indefinite"/>
+                      </p:stCondLst>
+                      <p:childTnLst>
+                        <p:par>
+                          <p:cTn id="20" fill="hold">
+                            <p:stCondLst>
+                              <p:cond delay="0"/>
+                            </p:stCondLst>
+                            <p:childTnLst>
+                              <p:par>
+                                <p:cTn id="21" presetID="1" presetClass="entr" presetSubtype="0" fill="hold" grpId="0" nodeType="clickEffect">
+                                  <p:stCondLst>
+                                    <p:cond delay="0"/>
+                                  </p:stCondLst>
+                                  <p:childTnLst>
+                                    <p:set>
+                                      <p:cBhvr>
+                                        <p:cTn id="22" dur="1" fill="hold">
+                                          <p:stCondLst>
+                                            <p:cond delay="0"/>
+                                          </p:stCondLst>
+                                        </p:cTn>
+                                        <p:tgtEl>
+                                          <p:spTgt spid="3">
+                                            <p:txEl>
+                                              <p:pRg st="5" end="5"/>
+                                            </p:txEl>
+                                          </p:spTgt>
+                                        </p:tgtEl>
+                                        <p:attrNameLst>
+                                          <p:attrName>style.visibility</p:attrName>
+                                        </p:attrNameLst>
+                                      </p:cBhvr>
+                                      <p:to>
+                                        <p:strVal val="visible"/>
+                                      </p:to>
+                                    </p:set>
+                                  </p:childTnLst>
+                                </p:cTn>
+                              </p:par>
+                            </p:childTnLst>
+                          </p:cTn>
+                        </p:par>
+                      </p:childTnLst>
+                    </p:cTn>
+                  </p:par>
+                  <p:par>
+                    <p:cTn id="23" fill="hold">
+                      <p:stCondLst>
+                        <p:cond delay="indefinite"/>
+                      </p:stCondLst>
+                      <p:childTnLst>
+                        <p:par>
+                          <p:cTn id="24" fill="hold">
+                            <p:stCondLst>
+                              <p:cond delay="0"/>
+                            </p:stCondLst>
+                            <p:childTnLst>
+                              <p:par>
+                                <p:cTn id="25" presetID="1" presetClass="entr" presetSubtype="0" fill="hold" grpId="0" nodeType="clickEffect">
+                                  <p:stCondLst>
+                                    <p:cond delay="0"/>
+                                  </p:stCondLst>
+                                  <p:childTnLst>
+                                    <p:set>
+                                      <p:cBhvr>
+                                        <p:cTn id="26" dur="1" fill="hold">
+                                          <p:stCondLst>
+                                            <p:cond delay="0"/>
+                                          </p:stCondLst>
+                                        </p:cTn>
+                                        <p:tgtEl>
+                                          <p:spTgt spid="3">
+                                            <p:txEl>
+                                              <p:pRg st="6" end="6"/>
+                                            </p:txEl>
+                                          </p:spTgt>
+                                        </p:tgtEl>
+                                        <p:attrNameLst>
+                                          <p:attrName>style.visibility</p:attrName>
+                                        </p:attrNameLst>
+                                      </p:cBhvr>
+                                      <p:to>
+                                        <p:strVal val="visible"/>
+                                      </p:to>
+                                    </p:set>
+                                  </p:childTnLst>
+                                </p:cTn>
+                              </p:par>
+                            </p:childTnLst>
+                          </p:cTn>
+                        </p:par>
+                      </p:childTnLst>
+                    </p:cTn>
+                  </p:par>
+                </p:childTnLst>
+              </p:cTn>
+              <p:prevCondLst>
+                <p:cond evt="onPrev" delay="0">
+                  <p:tgtEl>
+                    <p:sldTgt/>
+                  </p:tgtEl>
+                </p:cond>
+              </p:prevCondLst>
+              <p:nextCondLst>
+                <p:cond evt="onNext" delay="0">
+                  <p:tgtEl>
+                    <p:sldTgt/>
+                  </p:tgtEl>
+                </p:cond>
+              </p:nextCondLst>
+            </p:seq>
+          </p:childTnLst>
+        </p:cTn>
+      </p:par>
+    </p:tnLst>
+    <p:bldLst>
+      <p:bldP spid="3" grpId="0" uiExpand="1" build="p"/>
+    </p:bldLst>
+  </p:timing>
+</p:sld>
+</file>
+
+<file path=ppt/slides/slide12.xml><?xml version="1.0" encoding="utf-8"?>
+<p:sld xmlns:a="http://schemas.openxmlformats.org/drawingml/2006/main" xmlns:r="http://schemas.openxmlformats.org/officeDocument/2006/relationships" xmlns:p="http://schemas.openxmlformats.org/presentationml/2006/main">
+  <p:cSld>
+    <p:spTree>
+      <p:nvGrpSpPr>
+        <p:cNvPr id="1" name=""/>
+        <p:cNvGrpSpPr/>
+        <p:nvPr/>
+      </p:nvGrpSpPr>
+      <p:grpSpPr>
+        <a:xfrm>
+          <a:off x="0" y="0"/>
+          <a:ext cx="0" cy="0"/>
+          <a:chOff x="0" y="0"/>
+          <a:chExt cx="0" cy="0"/>
+        </a:xfrm>
+      </p:grpSpPr>
+      <p:sp>
+        <p:nvSpPr>
+          <p:cNvPr id="2" name="Title 1"/>
+          <p:cNvSpPr>
+            <a:spLocks noGrp="1"/>
+          </p:cNvSpPr>
+          <p:nvPr>
+            <p:ph hasCustomPrompt="1" type="title"/>
+          </p:nvPr>
+        </p:nvSpPr>
+        <p:spPr>
+          <a:xfrm>
+            <a:off x="909829" y="403765"/>
+            <a:ext cx="8434196" cy="976056"/>
+          </a:xfrm>
+        </p:spPr>
+        <p:txBody>
+          <a:bodyPr/>
+          <a:lstStyle/>
+          <a:p>
+            <a:pPr lvl="0" indent="0" marL="0">
+              <a:buNone/>
+            </a:pPr>
+            <a:r>
+              <a:rPr/>
+              <a:t>Causal Impact Analysis</a:t>
+            </a:r>
+          </a:p>
+        </p:txBody>
+      </p:sp>
+    </p:spTree>
+  </p:cSld>
+</p:sld>
+</file>
+
+<file path=ppt/slides/slide13.xml><?xml version="1.0" encoding="utf-8"?>
+<p:sld xmlns:a="http://schemas.openxmlformats.org/drawingml/2006/main" xmlns:r="http://schemas.openxmlformats.org/officeDocument/2006/relationships" xmlns:p="http://schemas.openxmlformats.org/presentationml/2006/main">
+  <p:cSld>
+    <p:spTree>
+      <p:nvGrpSpPr>
+        <p:cNvPr id="1" name=""/>
+        <p:cNvGrpSpPr/>
+        <p:nvPr/>
+      </p:nvGrpSpPr>
+      <p:grpSpPr>
+        <a:xfrm>
+          <a:off x="0" y="0"/>
+          <a:ext cx="0" cy="0"/>
+          <a:chOff x="0" y="0"/>
+          <a:chExt cx="0" cy="0"/>
+        </a:xfrm>
+      </p:grpSpPr>
+      <p:sp>
+        <p:nvSpPr>
+          <p:cNvPr id="2" name="Title 1"/>
+          <p:cNvSpPr>
+            <a:spLocks noGrp="1"/>
+          </p:cNvSpPr>
+          <p:nvPr>
+            <p:ph hasCustomPrompt="1" type="title"/>
+          </p:nvPr>
+        </p:nvSpPr>
+        <p:spPr>
+          <a:xfrm>
+            <a:off x="909829" y="403765"/>
+            <a:ext cx="8434196" cy="976056"/>
+          </a:xfrm>
+        </p:spPr>
+        <p:txBody>
+          <a:bodyPr/>
+          <a:lstStyle/>
+          <a:p>
+            <a:pPr lvl="0" indent="0" marL="0">
+              <a:buNone/>
+            </a:pPr>
+            <a:r>
+              <a:rPr/>
+              <a:t>Aggregating impacts</a:t>
+            </a:r>
+          </a:p>
+        </p:txBody>
+      </p:sp>
+    </p:spTree>
+  </p:cSld>
+</p:sld>
+</file>
+
+<file path=ppt/slides/slide14.xml><?xml version="1.0" encoding="utf-8"?>
+<p:sld xmlns:a="http://schemas.openxmlformats.org/drawingml/2006/main" xmlns:r="http://schemas.openxmlformats.org/officeDocument/2006/relationships" xmlns:p="http://schemas.openxmlformats.org/presentationml/2006/main">
+  <p:cSld>
+    <p:spTree>
+      <p:nvGrpSpPr>
+        <p:cNvPr id="1" name=""/>
+        <p:cNvGrpSpPr/>
+        <p:nvPr/>
+      </p:nvGrpSpPr>
+      <p:grpSpPr>
+        <a:xfrm>
+          <a:off x="0" y="0"/>
+          <a:ext cx="0" cy="0"/>
+          <a:chOff x="0" y="0"/>
+          <a:chExt cx="0" cy="0"/>
+        </a:xfrm>
+      </p:grpSpPr>
+      <p:sp>
+        <p:nvSpPr>
+          <p:cNvPr id="2" name="Title 1"/>
+          <p:cNvSpPr>
+            <a:spLocks noGrp="1"/>
+          </p:cNvSpPr>
+          <p:nvPr>
+            <p:ph hasCustomPrompt="1" type="ctrTitle"/>
+          </p:nvPr>
+        </p:nvSpPr>
+        <p:spPr>
+          <a:xfrm>
+            <a:off x="457199" y="4755350"/>
+            <a:ext cx="7772400" cy="1218369"/>
+          </a:xfrm>
+        </p:spPr>
+        <p:txBody>
+          <a:bodyPr/>
+          <a:lstStyle/>
+          <a:p>
+            <a:pPr lvl="0" indent="0" marL="0">
+              <a:buNone/>
+            </a:pPr>
+            <a:r>
+              <a:rPr/>
+              <a:t>Main results</a:t>
             </a:r>
           </a:p>
         </p:txBody>
@@ -3707,10 +4843,15 @@
             <a:spLocks noGrp="1"/>
           </p:cNvSpPr>
           <p:nvPr>
-            <p:ph hasCustomPrompt="1" type="title"/>
+            <p:ph hasCustomPrompt="1" type="ctrTitle"/>
           </p:nvPr>
         </p:nvSpPr>
-        <p:spPr/>
+        <p:spPr>
+          <a:xfrm>
+            <a:off x="457199" y="4755350"/>
+            <a:ext cx="7772400" cy="1218369"/>
+          </a:xfrm>
+        </p:spPr>
         <p:txBody>
           <a:bodyPr/>
           <a:lstStyle/>
@@ -3720,7 +4861,760 @@
             </a:pPr>
             <a:r>
               <a:rPr/>
-              <a:t>Quarto</a:t>
+              <a:t>Introduction, approach and summary</a:t>
+            </a:r>
+          </a:p>
+        </p:txBody>
+      </p:sp>
+    </p:spTree>
+  </p:cSld>
+</p:sld>
+</file>
+
+<file path=ppt/slides/slide3.xml><?xml version="1.0" encoding="utf-8"?>
+<p:sld xmlns:a="http://schemas.openxmlformats.org/drawingml/2006/main" xmlns:r="http://schemas.openxmlformats.org/officeDocument/2006/relationships" xmlns:p="http://schemas.openxmlformats.org/presentationml/2006/main">
+  <p:cSld>
+    <p:spTree>
+      <p:nvGrpSpPr>
+        <p:cNvPr id="1" name=""/>
+        <p:cNvGrpSpPr/>
+        <p:nvPr/>
+      </p:nvGrpSpPr>
+      <p:grpSpPr>
+        <a:xfrm>
+          <a:off x="0" y="0"/>
+          <a:ext cx="0" cy="0"/>
+          <a:chOff x="0" y="0"/>
+          <a:chExt cx="0" cy="0"/>
+        </a:xfrm>
+      </p:grpSpPr>
+      <p:sp>
+        <p:nvSpPr>
+          <p:cNvPr id="2" name="Title 1"/>
+          <p:cNvSpPr>
+            <a:spLocks noGrp="1"/>
+          </p:cNvSpPr>
+          <p:nvPr>
+            <p:ph type="title"/>
+          </p:nvPr>
+        </p:nvSpPr>
+        <p:spPr>
+          <a:xfrm>
+            <a:off x="919352" y="419100"/>
+            <a:ext cx="9720072" cy="933450"/>
+          </a:xfrm>
+        </p:spPr>
+        <p:txBody>
+          <a:bodyPr/>
+          <a:lstStyle/>
+          <a:p>
+            <a:pPr lvl="0" indent="0" marL="0">
+              <a:buNone/>
+            </a:pPr>
+            <a:r>
+              <a:rPr/>
+              <a:t>Introduction</a:t>
+            </a:r>
+          </a:p>
+        </p:txBody>
+      </p:sp>
+      <p:sp>
+        <p:nvSpPr>
+          <p:cNvPr id="3" name="Content Placeholder 2">
+            <a:extLst>
+              <a:ext uri="{FF2B5EF4-FFF2-40B4-BE49-F238E27FC236}">
+                <a16:creationId xmlns:a16="http://schemas.microsoft.com/office/drawing/2014/main" id="{D2592819-5C80-B996-F823-F8B9F9EAD6C9}"/>
+              </a:ext>
+            </a:extLst>
+          </p:cNvPr>
+          <p:cNvSpPr>
+            <a:spLocks noGrp="1"/>
+          </p:cNvSpPr>
+          <p:nvPr>
+            <p:ph idx="10"/>
+          </p:nvPr>
+        </p:nvSpPr>
+        <p:spPr/>
+        <p:txBody>
+          <a:bodyPr/>
+          <a:lstStyle/>
+          <a:p>
+            <a:pPr lvl="0" indent="0" marL="0">
+              <a:buNone/>
+            </a:pPr>
+            <a:r>
+              <a:rPr/>
+              <a:t>Since it’s inception, the New Hospital Programme (NHP) has advocated for single bed rooms (SBR). The grounds for this are based on a range of guidance, evidence and previous policy statements of intent. Whilst that position is unequivocal, there is uncertainty around the quantification of impacts of such a change and thus the assumptions that feed into demand and capacity models and economic business cases for current and future new hospital developments.</a:t>
+            </a:r>
+          </a:p>
+        </p:txBody>
+      </p:sp>
+      <p:sp>
+        <p:nvSpPr>
+          <p:cNvPr id="4" name="Content Placeholder 2">
+            <a:extLst>
+              <a:ext uri="{FF2B5EF4-FFF2-40B4-BE49-F238E27FC236}">
+                <a16:creationId xmlns:a16="http://schemas.microsoft.com/office/drawing/2014/main" id="{D1BAB7DA-EC53-0103-E362-83F86BDB6BC4}"/>
+              </a:ext>
+            </a:extLst>
+          </p:cNvPr>
+          <p:cNvSpPr>
+            <a:spLocks noGrp="1"/>
+          </p:cNvSpPr>
+          <p:nvPr>
+            <p:ph idx="11"/>
+          </p:nvPr>
+        </p:nvSpPr>
+        <p:spPr/>
+        <p:txBody>
+          <a:bodyPr/>
+          <a:lstStyle/>
+          <a:p>
+            <a:pPr lvl="0" indent="0" marL="0">
+              <a:buNone/>
+            </a:pPr>
+            <a:r>
+              <a:rPr/>
+              <a:t>Specifically, a starting assumption was that a length of stay reduction of 12% was likely for all new SBR facilities compared to prior trends. This assumption was criticised by the national audit office (NAO) (Office 2023) in the face of a mixed evidence base.</a:t>
+            </a:r>
+          </a:p>
+          <a:p>
+            <a:pPr lvl="0" indent="0" marL="0">
+              <a:buNone/>
+            </a:pPr>
+            <a:r>
+              <a:rPr/>
+              <a:t>It is the express aim of this analysis therefore to quantify the range of likely impacts for length of stay and a basket of other measures across patient &amp; staff experience, productivity and health &amp; safety.</a:t>
+            </a:r>
+          </a:p>
+        </p:txBody>
+      </p:sp>
+    </p:spTree>
+  </p:cSld>
+</p:sld>
+</file>
+
+<file path=ppt/slides/slide4.xml><?xml version="1.0" encoding="utf-8"?>
+<p:sld xmlns:a="http://schemas.openxmlformats.org/drawingml/2006/main" xmlns:r="http://schemas.openxmlformats.org/officeDocument/2006/relationships" xmlns:p="http://schemas.openxmlformats.org/presentationml/2006/main">
+  <p:cSld>
+    <p:spTree>
+      <p:nvGrpSpPr>
+        <p:cNvPr id="1" name=""/>
+        <p:cNvGrpSpPr/>
+        <p:nvPr/>
+      </p:nvGrpSpPr>
+      <p:grpSpPr>
+        <a:xfrm>
+          <a:off x="0" y="0"/>
+          <a:ext cx="0" cy="0"/>
+          <a:chOff x="0" y="0"/>
+          <a:chExt cx="0" cy="0"/>
+        </a:xfrm>
+      </p:grpSpPr>
+      <p:sp>
+        <p:nvSpPr>
+          <p:cNvPr id="2" name="Title 1"/>
+          <p:cNvSpPr>
+            <a:spLocks noGrp="1"/>
+          </p:cNvSpPr>
+          <p:nvPr>
+            <p:ph type="title"/>
+          </p:nvPr>
+        </p:nvSpPr>
+        <p:spPr>
+          <a:xfrm>
+            <a:off x="919352" y="419100"/>
+            <a:ext cx="9720072" cy="933450"/>
+          </a:xfrm>
+        </p:spPr>
+        <p:txBody>
+          <a:bodyPr/>
+          <a:lstStyle/>
+          <a:p>
+            <a:pPr lvl="0" indent="0" marL="0">
+              <a:buNone/>
+            </a:pPr>
+            <a:r>
+              <a:rPr/>
+              <a:t>Approach</a:t>
+            </a:r>
+          </a:p>
+        </p:txBody>
+      </p:sp>
+      <p:sp>
+        <p:nvSpPr>
+          <p:cNvPr id="3" name="Content Placeholder 2">
+            <a:extLst>
+              <a:ext uri="{FF2B5EF4-FFF2-40B4-BE49-F238E27FC236}">
+                <a16:creationId xmlns:a16="http://schemas.microsoft.com/office/drawing/2014/main" id="{D2592819-5C80-B996-F823-F8B9F9EAD6C9}"/>
+              </a:ext>
+            </a:extLst>
+          </p:cNvPr>
+          <p:cNvSpPr>
+            <a:spLocks noGrp="1"/>
+          </p:cNvSpPr>
+          <p:nvPr>
+            <p:ph idx="10"/>
+          </p:nvPr>
+        </p:nvSpPr>
+        <p:spPr/>
+        <p:txBody>
+          <a:bodyPr/>
+          <a:lstStyle/>
+          <a:p>
+            <a:pPr lvl="0"/>
+            <a:r>
+              <a:rPr/>
+              <a:t>Previous literature reviews and general searches were undertaken to identify potential impact factors.</a:t>
+            </a:r>
+          </a:p>
+          <a:p>
+            <a:pPr lvl="0"/>
+            <a:r>
+              <a:rPr/>
+              <a:t>Identified relevant measures or proxy measures from publicly available data and routine data sources.</a:t>
+            </a:r>
+          </a:p>
+          <a:p>
+            <a:pPr lvl="0"/>
+            <a:r>
+              <a:rPr/>
+              <a:t>Included only those with sufficient time series and of acceptable data quality into final impact framework.</a:t>
+            </a:r>
+          </a:p>
+          <a:p>
+            <a:pPr lvl="0"/>
+            <a:r>
+              <a:rPr/>
+              <a:t>Cleansed and compiled all the data into time series format.</a:t>
+            </a:r>
+          </a:p>
+        </p:txBody>
+      </p:sp>
+      <p:sp>
+        <p:nvSpPr>
+          <p:cNvPr id="4" name="Content Placeholder 2">
+            <a:extLst>
+              <a:ext uri="{FF2B5EF4-FFF2-40B4-BE49-F238E27FC236}">
+                <a16:creationId xmlns:a16="http://schemas.microsoft.com/office/drawing/2014/main" id="{D1BAB7DA-EC53-0103-E362-83F86BDB6BC4}"/>
+              </a:ext>
+            </a:extLst>
+          </p:cNvPr>
+          <p:cNvSpPr>
+            <a:spLocks noGrp="1"/>
+          </p:cNvSpPr>
+          <p:nvPr>
+            <p:ph idx="11"/>
+          </p:nvPr>
+        </p:nvSpPr>
+        <p:spPr/>
+        <p:txBody>
+          <a:bodyPr/>
+          <a:lstStyle/>
+          <a:p>
+            <a:pPr lvl="0"/>
+            <a:r>
+              <a:rPr/>
+              <a:t>Identified ‘control’ sites and providers to compare to our natural experiment sites.</a:t>
+            </a:r>
+          </a:p>
+          <a:p>
+            <a:pPr lvl="0"/>
+            <a:r>
+              <a:rPr/>
+              <a:t>Several stages of this matching according to hospital function, size, case-mix and admission ratio’s.</a:t>
+            </a:r>
+          </a:p>
+          <a:p>
+            <a:pPr lvl="0"/>
+            <a:r>
+              <a:rPr/>
+              <a:t>Performed causal impact analysis on the pre and post intervention periods to detect the nature and scale of impacts for each natural experiment.</a:t>
+            </a:r>
+          </a:p>
+          <a:p>
+            <a:pPr lvl="0"/>
+            <a:r>
+              <a:rPr/>
+              <a:t>Aggregated findings for the non-specialist hospitals.</a:t>
+            </a:r>
+          </a:p>
+        </p:txBody>
+      </p:sp>
+    </p:spTree>
+  </p:cSld>
+  <p:timing>
+    <p:tnLst>
+      <p:par>
+        <p:cTn id="1" dur="indefinite" restart="never" nodeType="tmRoot">
+          <p:childTnLst>
+            <p:seq concurrent="1" nextAc="seek">
+              <p:cTn id="2" dur="indefinite" nodeType="mainSeq">
+                <p:childTnLst>
+                  <p:par>
+                    <p:cTn id="3" fill="hold">
+                      <p:stCondLst>
+                        <p:cond delay="indefinite"/>
+                      </p:stCondLst>
+                      <p:childTnLst>
+                        <p:par>
+                          <p:cTn id="4" fill="hold">
+                            <p:stCondLst>
+                              <p:cond delay="0"/>
+                            </p:stCondLst>
+                            <p:childTnLst>
+                              <p:par>
+                                <p:cTn id="5" presetID="1" presetClass="entr" presetSubtype="0" fill="hold" grpId="0" nodeType="clickEffect">
+                                  <p:stCondLst>
+                                    <p:cond delay="0"/>
+                                  </p:stCondLst>
+                                  <p:childTnLst>
+                                    <p:set>
+                                      <p:cBhvr>
+                                        <p:cTn id="6" dur="1" fill="hold">
+                                          <p:stCondLst>
+                                            <p:cond delay="0"/>
+                                          </p:stCondLst>
+                                        </p:cTn>
+                                        <p:tgtEl>
+                                          <p:spTgt spid="3">
+                                            <p:txEl>
+                                              <p:pRg st="0" end="0"/>
+                                            </p:txEl>
+                                          </p:spTgt>
+                                        </p:tgtEl>
+                                        <p:attrNameLst>
+                                          <p:attrName>style.visibility</p:attrName>
+                                        </p:attrNameLst>
+                                      </p:cBhvr>
+                                      <p:to>
+                                        <p:strVal val="visible"/>
+                                      </p:to>
+                                    </p:set>
+                                  </p:childTnLst>
+                                </p:cTn>
+                              </p:par>
+                            </p:childTnLst>
+                          </p:cTn>
+                        </p:par>
+                      </p:childTnLst>
+                    </p:cTn>
+                  </p:par>
+                  <p:par>
+                    <p:cTn id="7" fill="hold">
+                      <p:stCondLst>
+                        <p:cond delay="indefinite"/>
+                      </p:stCondLst>
+                      <p:childTnLst>
+                        <p:par>
+                          <p:cTn id="8" fill="hold">
+                            <p:stCondLst>
+                              <p:cond delay="0"/>
+                            </p:stCondLst>
+                            <p:childTnLst>
+                              <p:par>
+                                <p:cTn id="9" presetID="1" presetClass="entr" presetSubtype="0" fill="hold" grpId="0" nodeType="clickEffect">
+                                  <p:stCondLst>
+                                    <p:cond delay="0"/>
+                                  </p:stCondLst>
+                                  <p:childTnLst>
+                                    <p:set>
+                                      <p:cBhvr>
+                                        <p:cTn id="10" dur="1" fill="hold">
+                                          <p:stCondLst>
+                                            <p:cond delay="0"/>
+                                          </p:stCondLst>
+                                        </p:cTn>
+                                        <p:tgtEl>
+                                          <p:spTgt spid="3">
+                                            <p:txEl>
+                                              <p:pRg st="1" end="1"/>
+                                            </p:txEl>
+                                          </p:spTgt>
+                                        </p:tgtEl>
+                                        <p:attrNameLst>
+                                          <p:attrName>style.visibility</p:attrName>
+                                        </p:attrNameLst>
+                                      </p:cBhvr>
+                                      <p:to>
+                                        <p:strVal val="visible"/>
+                                      </p:to>
+                                    </p:set>
+                                  </p:childTnLst>
+                                </p:cTn>
+                              </p:par>
+                            </p:childTnLst>
+                          </p:cTn>
+                        </p:par>
+                      </p:childTnLst>
+                    </p:cTn>
+                  </p:par>
+                  <p:par>
+                    <p:cTn id="11" fill="hold">
+                      <p:stCondLst>
+                        <p:cond delay="indefinite"/>
+                      </p:stCondLst>
+                      <p:childTnLst>
+                        <p:par>
+                          <p:cTn id="12" fill="hold">
+                            <p:stCondLst>
+                              <p:cond delay="0"/>
+                            </p:stCondLst>
+                            <p:childTnLst>
+                              <p:par>
+                                <p:cTn id="13" presetID="1" presetClass="entr" presetSubtype="0" fill="hold" grpId="0" nodeType="clickEffect">
+                                  <p:stCondLst>
+                                    <p:cond delay="0"/>
+                                  </p:stCondLst>
+                                  <p:childTnLst>
+                                    <p:set>
+                                      <p:cBhvr>
+                                        <p:cTn id="14" dur="1" fill="hold">
+                                          <p:stCondLst>
+                                            <p:cond delay="0"/>
+                                          </p:stCondLst>
+                                        </p:cTn>
+                                        <p:tgtEl>
+                                          <p:spTgt spid="3">
+                                            <p:txEl>
+                                              <p:pRg st="2" end="2"/>
+                                            </p:txEl>
+                                          </p:spTgt>
+                                        </p:tgtEl>
+                                        <p:attrNameLst>
+                                          <p:attrName>style.visibility</p:attrName>
+                                        </p:attrNameLst>
+                                      </p:cBhvr>
+                                      <p:to>
+                                        <p:strVal val="visible"/>
+                                      </p:to>
+                                    </p:set>
+                                  </p:childTnLst>
+                                </p:cTn>
+                              </p:par>
+                            </p:childTnLst>
+                          </p:cTn>
+                        </p:par>
+                      </p:childTnLst>
+                    </p:cTn>
+                  </p:par>
+                  <p:par>
+                    <p:cTn id="15" fill="hold">
+                      <p:stCondLst>
+                        <p:cond delay="indefinite"/>
+                      </p:stCondLst>
+                      <p:childTnLst>
+                        <p:par>
+                          <p:cTn id="16" fill="hold">
+                            <p:stCondLst>
+                              <p:cond delay="0"/>
+                            </p:stCondLst>
+                            <p:childTnLst>
+                              <p:par>
+                                <p:cTn id="17" presetID="1" presetClass="entr" presetSubtype="0" fill="hold" grpId="0" nodeType="clickEffect">
+                                  <p:stCondLst>
+                                    <p:cond delay="0"/>
+                                  </p:stCondLst>
+                                  <p:childTnLst>
+                                    <p:set>
+                                      <p:cBhvr>
+                                        <p:cTn id="18" dur="1" fill="hold">
+                                          <p:stCondLst>
+                                            <p:cond delay="0"/>
+                                          </p:stCondLst>
+                                        </p:cTn>
+                                        <p:tgtEl>
+                                          <p:spTgt spid="3">
+                                            <p:txEl>
+                                              <p:pRg st="3" end="3"/>
+                                            </p:txEl>
+                                          </p:spTgt>
+                                        </p:tgtEl>
+                                        <p:attrNameLst>
+                                          <p:attrName>style.visibility</p:attrName>
+                                        </p:attrNameLst>
+                                      </p:cBhvr>
+                                      <p:to>
+                                        <p:strVal val="visible"/>
+                                      </p:to>
+                                    </p:set>
+                                  </p:childTnLst>
+                                </p:cTn>
+                              </p:par>
+                            </p:childTnLst>
+                          </p:cTn>
+                        </p:par>
+                      </p:childTnLst>
+                    </p:cTn>
+                  </p:par>
+                  <p:par>
+                    <p:cTn id="19" fill="hold">
+                      <p:stCondLst>
+                        <p:cond delay="indefinite"/>
+                      </p:stCondLst>
+                      <p:childTnLst>
+                        <p:par>
+                          <p:cTn id="20" fill="hold">
+                            <p:stCondLst>
+                              <p:cond delay="0"/>
+                            </p:stCondLst>
+                            <p:childTnLst>
+                              <p:par>
+                                <p:cTn id="21" presetID="1" presetClass="entr" presetSubtype="0" fill="hold" grpId="0" nodeType="clickEffect">
+                                  <p:stCondLst>
+                                    <p:cond delay="0"/>
+                                  </p:stCondLst>
+                                  <p:childTnLst>
+                                    <p:set>
+                                      <p:cBhvr>
+                                        <p:cTn id="22" dur="1" fill="hold">
+                                          <p:stCondLst>
+                                            <p:cond delay="0"/>
+                                          </p:stCondLst>
+                                        </p:cTn>
+                                        <p:tgtEl>
+                                          <p:spTgt spid="4">
+                                            <p:txEl>
+                                              <p:pRg st="0" end="0"/>
+                                            </p:txEl>
+                                          </p:spTgt>
+                                        </p:tgtEl>
+                                        <p:attrNameLst>
+                                          <p:attrName>style.visibility</p:attrName>
+                                        </p:attrNameLst>
+                                      </p:cBhvr>
+                                      <p:to>
+                                        <p:strVal val="visible"/>
+                                      </p:to>
+                                    </p:set>
+                                  </p:childTnLst>
+                                </p:cTn>
+                              </p:par>
+                            </p:childTnLst>
+                          </p:cTn>
+                        </p:par>
+                      </p:childTnLst>
+                    </p:cTn>
+                  </p:par>
+                  <p:par>
+                    <p:cTn id="23" fill="hold">
+                      <p:stCondLst>
+                        <p:cond delay="indefinite"/>
+                      </p:stCondLst>
+                      <p:childTnLst>
+                        <p:par>
+                          <p:cTn id="24" fill="hold">
+                            <p:stCondLst>
+                              <p:cond delay="0"/>
+                            </p:stCondLst>
+                            <p:childTnLst>
+                              <p:par>
+                                <p:cTn id="25" presetID="1" presetClass="entr" presetSubtype="0" fill="hold" grpId="0" nodeType="clickEffect">
+                                  <p:stCondLst>
+                                    <p:cond delay="0"/>
+                                  </p:stCondLst>
+                                  <p:childTnLst>
+                                    <p:set>
+                                      <p:cBhvr>
+                                        <p:cTn id="26" dur="1" fill="hold">
+                                          <p:stCondLst>
+                                            <p:cond delay="0"/>
+                                          </p:stCondLst>
+                                        </p:cTn>
+                                        <p:tgtEl>
+                                          <p:spTgt spid="4">
+                                            <p:txEl>
+                                              <p:pRg st="1" end="1"/>
+                                            </p:txEl>
+                                          </p:spTgt>
+                                        </p:tgtEl>
+                                        <p:attrNameLst>
+                                          <p:attrName>style.visibility</p:attrName>
+                                        </p:attrNameLst>
+                                      </p:cBhvr>
+                                      <p:to>
+                                        <p:strVal val="visible"/>
+                                      </p:to>
+                                    </p:set>
+                                  </p:childTnLst>
+                                </p:cTn>
+                              </p:par>
+                            </p:childTnLst>
+                          </p:cTn>
+                        </p:par>
+                      </p:childTnLst>
+                    </p:cTn>
+                  </p:par>
+                  <p:par>
+                    <p:cTn id="27" fill="hold">
+                      <p:stCondLst>
+                        <p:cond delay="indefinite"/>
+                      </p:stCondLst>
+                      <p:childTnLst>
+                        <p:par>
+                          <p:cTn id="28" fill="hold">
+                            <p:stCondLst>
+                              <p:cond delay="0"/>
+                            </p:stCondLst>
+                            <p:childTnLst>
+                              <p:par>
+                                <p:cTn id="29" presetID="1" presetClass="entr" presetSubtype="0" fill="hold" grpId="0" nodeType="clickEffect">
+                                  <p:stCondLst>
+                                    <p:cond delay="0"/>
+                                  </p:stCondLst>
+                                  <p:childTnLst>
+                                    <p:set>
+                                      <p:cBhvr>
+                                        <p:cTn id="30" dur="1" fill="hold">
+                                          <p:stCondLst>
+                                            <p:cond delay="0"/>
+                                          </p:stCondLst>
+                                        </p:cTn>
+                                        <p:tgtEl>
+                                          <p:spTgt spid="4">
+                                            <p:txEl>
+                                              <p:pRg st="2" end="2"/>
+                                            </p:txEl>
+                                          </p:spTgt>
+                                        </p:tgtEl>
+                                        <p:attrNameLst>
+                                          <p:attrName>style.visibility</p:attrName>
+                                        </p:attrNameLst>
+                                      </p:cBhvr>
+                                      <p:to>
+                                        <p:strVal val="visible"/>
+                                      </p:to>
+                                    </p:set>
+                                  </p:childTnLst>
+                                </p:cTn>
+                              </p:par>
+                            </p:childTnLst>
+                          </p:cTn>
+                        </p:par>
+                      </p:childTnLst>
+                    </p:cTn>
+                  </p:par>
+                  <p:par>
+                    <p:cTn id="31" fill="hold">
+                      <p:stCondLst>
+                        <p:cond delay="indefinite"/>
+                      </p:stCondLst>
+                      <p:childTnLst>
+                        <p:par>
+                          <p:cTn id="32" fill="hold">
+                            <p:stCondLst>
+                              <p:cond delay="0"/>
+                            </p:stCondLst>
+                            <p:childTnLst>
+                              <p:par>
+                                <p:cTn id="33" presetID="1" presetClass="entr" presetSubtype="0" fill="hold" grpId="0" nodeType="clickEffect">
+                                  <p:stCondLst>
+                                    <p:cond delay="0"/>
+                                  </p:stCondLst>
+                                  <p:childTnLst>
+                                    <p:set>
+                                      <p:cBhvr>
+                                        <p:cTn id="34" dur="1" fill="hold">
+                                          <p:stCondLst>
+                                            <p:cond delay="0"/>
+                                          </p:stCondLst>
+                                        </p:cTn>
+                                        <p:tgtEl>
+                                          <p:spTgt spid="4">
+                                            <p:txEl>
+                                              <p:pRg st="3" end="3"/>
+                                            </p:txEl>
+                                          </p:spTgt>
+                                        </p:tgtEl>
+                                        <p:attrNameLst>
+                                          <p:attrName>style.visibility</p:attrName>
+                                        </p:attrNameLst>
+                                      </p:cBhvr>
+                                      <p:to>
+                                        <p:strVal val="visible"/>
+                                      </p:to>
+                                    </p:set>
+                                  </p:childTnLst>
+                                </p:cTn>
+                              </p:par>
+                            </p:childTnLst>
+                          </p:cTn>
+                        </p:par>
+                      </p:childTnLst>
+                    </p:cTn>
+                  </p:par>
+                </p:childTnLst>
+              </p:cTn>
+              <p:prevCondLst>
+                <p:cond evt="onPrev" delay="0">
+                  <p:tgtEl>
+                    <p:sldTgt/>
+                  </p:tgtEl>
+                </p:cond>
+              </p:prevCondLst>
+              <p:nextCondLst>
+                <p:cond evt="onNext" delay="0">
+                  <p:tgtEl>
+                    <p:sldTgt/>
+                  </p:tgtEl>
+                </p:cond>
+              </p:nextCondLst>
+            </p:seq>
+          </p:childTnLst>
+        </p:cTn>
+      </p:par>
+    </p:tnLst>
+    <p:bldLst>
+      <p:bldP spid="3" grpId="0" uiExpand="1" build="p"/>
+      <p:bldP spid="4" grpId="0" uiExpand="1" build="p"/>
+    </p:bldLst>
+  </p:timing>
+</p:sld>
+</file>
+
+<file path=ppt/slides/slide5.xml><?xml version="1.0" encoding="utf-8"?>
+<p:sld xmlns:a="http://schemas.openxmlformats.org/drawingml/2006/main" xmlns:r="http://schemas.openxmlformats.org/officeDocument/2006/relationships" xmlns:p="http://schemas.openxmlformats.org/presentationml/2006/main">
+  <p:cSld>
+    <p:spTree>
+      <p:nvGrpSpPr>
+        <p:cNvPr id="1" name=""/>
+        <p:cNvGrpSpPr/>
+        <p:nvPr/>
+      </p:nvGrpSpPr>
+      <p:grpSpPr>
+        <a:xfrm>
+          <a:off x="0" y="0"/>
+          <a:ext cx="0" cy="0"/>
+          <a:chOff x="0" y="0"/>
+          <a:chExt cx="0" cy="0"/>
+        </a:xfrm>
+      </p:grpSpPr>
+      <p:sp>
+        <p:nvSpPr>
+          <p:cNvPr id="2" name="Title 1"/>
+          <p:cNvSpPr>
+            <a:spLocks noGrp="1"/>
+          </p:cNvSpPr>
+          <p:nvPr>
+            <p:ph hasCustomPrompt="1" type="title"/>
+          </p:nvPr>
+        </p:nvSpPr>
+        <p:spPr>
+          <a:xfrm>
+            <a:off x="909829" y="403765"/>
+            <a:ext cx="8434196" cy="976056"/>
+          </a:xfrm>
+        </p:spPr>
+        <p:txBody>
+          <a:bodyPr/>
+          <a:lstStyle/>
+          <a:p>
+            <a:pPr lvl="0" indent="0" marL="0">
+              <a:buNone/>
+            </a:pPr>
+            <a:r>
+              <a:rPr/>
+              <a:t>Summary of key findings</a:t>
             </a:r>
           </a:p>
         </p:txBody>
@@ -3745,106 +5639,728 @@
             </a:pPr>
             <a:r>
               <a:rPr/>
-              <a:t>Quarto enables you to weave together content and executable code into a finished presentation. To learn more about Quarto presentations see </a:t>
-            </a:r>
-            <a:r>
-              <a:rPr>
-                <a:hlinkClick r:id="rId2"/>
-              </a:rPr>
-              <a:t>https://quarto.org/docs/presentations/</a:t>
-            </a:r>
-            <a:r>
-              <a:rPr/>
-              <a:t>.</a:t>
-            </a:r>
-          </a:p>
-          <a:p>
-            <a:pPr lvl="0" indent="0" marL="0">
-              <a:spcBef>
-                <a:spcPts val="3000"/>
-              </a:spcBef>
-              <a:buNone/>
-            </a:pPr>
-            <a:r>
-              <a:rPr b="1"/>
-              <a:t>Bullets</a:t>
-            </a:r>
-          </a:p>
+              <a:t>Regardless of direction of impact, our results are not consistent across hospital sites. This suggests that there are a number of other factors in the hospital design, systems, policies and procedures that are important. Switching to single bedroom hospitals without considering the other factors would not necessarily have a positive effect on outcomes nor mitigate any likely risks. This inconsistency is reflective of the findings from published literature.</a:t>
+            </a:r>
+          </a:p>
+        </p:txBody>
+      </p:sp>
+    </p:spTree>
+  </p:cSld>
+</p:sld>
+</file>
+
+<file path=ppt/slides/slide6.xml><?xml version="1.0" encoding="utf-8"?>
+<p:sld xmlns:a="http://schemas.openxmlformats.org/drawingml/2006/main" xmlns:r="http://schemas.openxmlformats.org/officeDocument/2006/relationships" xmlns:p="http://schemas.openxmlformats.org/presentationml/2006/main">
+  <p:cSld>
+    <p:spTree>
+      <p:nvGrpSpPr>
+        <p:cNvPr id="1" name=""/>
+        <p:cNvGrpSpPr/>
+        <p:nvPr/>
+      </p:nvGrpSpPr>
+      <p:grpSpPr>
+        <a:xfrm>
+          <a:off x="0" y="0"/>
+          <a:ext cx="0" cy="0"/>
+          <a:chOff x="0" y="0"/>
+          <a:chExt cx="0" cy="0"/>
+        </a:xfrm>
+      </p:grpSpPr>
+      <p:sp>
+        <p:nvSpPr>
+          <p:cNvPr id="2" name="Title 1"/>
+          <p:cNvSpPr>
+            <a:spLocks noGrp="1"/>
+          </p:cNvSpPr>
+          <p:nvPr>
+            <p:ph hasCustomPrompt="1" type="ctrTitle"/>
+          </p:nvPr>
+        </p:nvSpPr>
+        <p:spPr>
+          <a:xfrm>
+            <a:off x="457199" y="4755350"/>
+            <a:ext cx="7772400" cy="1218369"/>
+          </a:xfrm>
+        </p:spPr>
+        <p:txBody>
+          <a:bodyPr/>
+          <a:lstStyle/>
           <a:p>
             <a:pPr lvl="0" indent="0" marL="0">
               <a:buNone/>
             </a:pPr>
             <a:r>
               <a:rPr/>
-              <a:t>When you click the </a:t>
-            </a:r>
-            <a:r>
-              <a:rPr b="1"/>
-              <a:t>Render</a:t>
-            </a:r>
-            <a:r>
-              <a:rPr/>
-              <a:t> button a document will be generated that includes:</a:t>
-            </a:r>
-          </a:p>
-          <a:p>
-            <a:pPr lvl="0"/>
-            <a:r>
-              <a:rPr/>
-              <a:t>Content authored with markdown</a:t>
-            </a:r>
-          </a:p>
-          <a:p>
-            <a:pPr lvl="0"/>
-            <a:r>
-              <a:rPr/>
-              <a:t>Output from executable code</a:t>
-            </a:r>
-          </a:p>
-          <a:p>
-            <a:pPr lvl="0" indent="0" marL="0">
-              <a:spcBef>
-                <a:spcPts val="3000"/>
-              </a:spcBef>
-              <a:buNone/>
-            </a:pPr>
-            <a:r>
-              <a:rPr b="1"/>
-              <a:t>Code</a:t>
-            </a:r>
-          </a:p>
+              <a:t>The impact framework</a:t>
+            </a:r>
+          </a:p>
+        </p:txBody>
+      </p:sp>
+    </p:spTree>
+  </p:cSld>
+</p:sld>
+</file>
+
+<file path=ppt/slides/slide7.xml><?xml version="1.0" encoding="utf-8"?>
+<p:sld xmlns:a="http://schemas.openxmlformats.org/drawingml/2006/main" xmlns:r="http://schemas.openxmlformats.org/officeDocument/2006/relationships" xmlns:p="http://schemas.openxmlformats.org/presentationml/2006/main">
+  <p:cSld>
+    <p:spTree>
+      <p:nvGrpSpPr>
+        <p:cNvPr id="1" name=""/>
+        <p:cNvGrpSpPr/>
+        <p:nvPr/>
+      </p:nvGrpSpPr>
+      <p:grpSpPr>
+        <a:xfrm>
+          <a:off x="0" y="0"/>
+          <a:ext cx="0" cy="0"/>
+          <a:chOff x="0" y="0"/>
+          <a:chExt cx="0" cy="0"/>
+        </a:xfrm>
+      </p:grpSpPr>
+      <p:sp>
+        <p:nvSpPr>
+          <p:cNvPr id="2" name="Title 1"/>
+          <p:cNvSpPr>
+            <a:spLocks noGrp="1"/>
+          </p:cNvSpPr>
+          <p:nvPr>
+            <p:ph hasCustomPrompt="1" type="title"/>
+          </p:nvPr>
+        </p:nvSpPr>
+        <p:spPr>
+          <a:xfrm>
+            <a:off x="909829" y="403765"/>
+            <a:ext cx="8434196" cy="976056"/>
+          </a:xfrm>
+        </p:spPr>
+        <p:txBody>
+          <a:bodyPr/>
+          <a:lstStyle/>
           <a:p>
             <a:pPr lvl="0" indent="0" marL="0">
               <a:buNone/>
             </a:pPr>
             <a:r>
               <a:rPr/>
-              <a:t>When you click the </a:t>
-            </a:r>
-            <a:r>
-              <a:rPr b="1"/>
-              <a:t>Render</a:t>
-            </a:r>
-            <a:r>
-              <a:rPr/>
-              <a:t> button a presentation will be generated that includes both content and the output of embedded code. You can embed code like this:</a:t>
-            </a:r>
-          </a:p>
-          <a:p>
-            <a:pPr lvl="0" indent="0">
+              <a:t>Overview</a:t>
+            </a:r>
+          </a:p>
+        </p:txBody>
+      </p:sp>
+      <p:pic>
+        <p:nvPicPr>
+          <p:cNvPr descr="images/indicators.jpeg" id="0" name="Picture 1"/>
+          <p:cNvPicPr>
+            <a:picLocks noGrp="1" noChangeAspect="1"/>
+          </p:cNvPicPr>
+          <p:nvPr/>
+        </p:nvPicPr>
+        <p:blipFill>
+          <a:blip r:embed="rId2"/>
+          <a:stretch>
+            <a:fillRect/>
+          </a:stretch>
+        </p:blipFill>
+        <p:spPr bwMode="auto">
+          <a:xfrm>
+            <a:off x="901700" y="2032000"/>
+            <a:ext cx="10414000" cy="3467100"/>
+          </a:xfrm>
+          <a:prstGeom prst="rect">
+            <a:avLst/>
+          </a:prstGeom>
+          <a:noFill/>
+          <a:ln w="9525">
+            <a:noFill/>
+            <a:headEnd/>
+            <a:tailEnd/>
+          </a:ln>
+        </p:spPr>
+      </p:pic>
+    </p:spTree>
+  </p:cSld>
+</p:sld>
+</file>
+
+<file path=ppt/slides/slide8.xml><?xml version="1.0" encoding="utf-8"?>
+<p:sld xmlns:a="http://schemas.openxmlformats.org/drawingml/2006/main" xmlns:r="http://schemas.openxmlformats.org/officeDocument/2006/relationships" xmlns:p="http://schemas.openxmlformats.org/presentationml/2006/main">
+  <p:cSld>
+    <p:spTree>
+      <p:nvGrpSpPr>
+        <p:cNvPr id="1" name=""/>
+        <p:cNvGrpSpPr/>
+        <p:nvPr/>
+      </p:nvGrpSpPr>
+      <p:grpSpPr>
+        <a:xfrm>
+          <a:off x="0" y="0"/>
+          <a:ext cx="0" cy="0"/>
+          <a:chOff x="0" y="0"/>
+          <a:chExt cx="0" cy="0"/>
+        </a:xfrm>
+      </p:grpSpPr>
+      <p:sp>
+        <p:nvSpPr>
+          <p:cNvPr id="2" name="Title 1"/>
+          <p:cNvSpPr>
+            <a:spLocks noGrp="1"/>
+          </p:cNvSpPr>
+          <p:nvPr>
+            <p:ph hasCustomPrompt="1" type="ctrTitle"/>
+          </p:nvPr>
+        </p:nvSpPr>
+        <p:spPr>
+          <a:xfrm>
+            <a:off x="457199" y="4755350"/>
+            <a:ext cx="7772400" cy="1218369"/>
+          </a:xfrm>
+        </p:spPr>
+        <p:txBody>
+          <a:bodyPr/>
+          <a:lstStyle/>
+          <a:p>
+            <a:pPr lvl="0" indent="0" marL="0">
               <a:buNone/>
             </a:pPr>
             <a:r>
-              <a:rPr>
-                <a:latin typeface="Courier"/>
-              </a:rPr>
-              <a:t>[1] 2</a:t>
+              <a:rPr/>
+              <a:t>The hospitals</a:t>
             </a:r>
           </a:p>
         </p:txBody>
       </p:sp>
     </p:spTree>
   </p:cSld>
+</p:sld>
+</file>
+
+<file path=ppt/slides/slide9.xml><?xml version="1.0" encoding="utf-8"?>
+<p:sld xmlns:a="http://schemas.openxmlformats.org/drawingml/2006/main" xmlns:r="http://schemas.openxmlformats.org/officeDocument/2006/relationships" xmlns:p="http://schemas.openxmlformats.org/presentationml/2006/main">
+  <p:cSld>
+    <p:spTree>
+      <p:nvGrpSpPr>
+        <p:cNvPr id="1" name=""/>
+        <p:cNvGrpSpPr/>
+        <p:nvPr/>
+      </p:nvGrpSpPr>
+      <p:grpSpPr>
+        <a:xfrm>
+          <a:off x="0" y="0"/>
+          <a:ext cx="0" cy="0"/>
+          <a:chOff x="0" y="0"/>
+          <a:chExt cx="0" cy="0"/>
+        </a:xfrm>
+      </p:grpSpPr>
+      <p:sp>
+        <p:nvSpPr>
+          <p:cNvPr id="2" name="Title 1"/>
+          <p:cNvSpPr>
+            <a:spLocks noGrp="1"/>
+          </p:cNvSpPr>
+          <p:nvPr>
+            <p:ph type="title"/>
+          </p:nvPr>
+        </p:nvSpPr>
+        <p:spPr>
+          <a:xfrm>
+            <a:off x="919352" y="419100"/>
+            <a:ext cx="9720072" cy="933450"/>
+          </a:xfrm>
+        </p:spPr>
+        <p:txBody>
+          <a:bodyPr/>
+          <a:lstStyle/>
+          <a:p>
+            <a:pPr lvl="0" indent="0" marL="0">
+              <a:buNone/>
+            </a:pPr>
+            <a:r>
+              <a:rPr/>
+              <a:t>7 natural experiments</a:t>
+            </a:r>
+          </a:p>
+        </p:txBody>
+      </p:sp>
+      <p:sp>
+        <p:nvSpPr>
+          <p:cNvPr id="3" name="Content Placeholder 2">
+            <a:extLst>
+              <a:ext uri="{FF2B5EF4-FFF2-40B4-BE49-F238E27FC236}">
+                <a16:creationId xmlns:a16="http://schemas.microsoft.com/office/drawing/2014/main" id="{D2592819-5C80-B996-F823-F8B9F9EAD6C9}"/>
+              </a:ext>
+            </a:extLst>
+          </p:cNvPr>
+          <p:cNvSpPr>
+            <a:spLocks noGrp="1"/>
+          </p:cNvSpPr>
+          <p:nvPr>
+            <p:ph idx="10"/>
+          </p:nvPr>
+        </p:nvSpPr>
+        <p:spPr/>
+        <p:txBody>
+          <a:bodyPr/>
+          <a:lstStyle/>
+          <a:p>
+            <a:pPr lvl="0"/>
+            <a:r>
+              <a:rPr/>
+              <a:t>Royal Liverpool (Oct 2022)</a:t>
+            </a:r>
+          </a:p>
+          <a:p>
+            <a:pPr lvl="0"/>
+            <a:r>
+              <a:rPr/>
+              <a:t>Clatterbridge Cancer Centre (June 2020)</a:t>
+            </a:r>
+          </a:p>
+          <a:p>
+            <a:pPr lvl="0"/>
+            <a:r>
+              <a:rPr/>
+              <a:t>Royal Papworth Hospital (May 2019)</a:t>
+            </a:r>
+          </a:p>
+          <a:p>
+            <a:pPr lvl="0"/>
+            <a:r>
+              <a:rPr/>
+              <a:t>Chase Farm Hospital (Sept 2018)</a:t>
+            </a:r>
+          </a:p>
+          <a:p>
+            <a:pPr lvl="0"/>
+            <a:r>
+              <a:rPr/>
+              <a:t>Southmead Hospital (May 2014)</a:t>
+            </a:r>
+          </a:p>
+          <a:p>
+            <a:pPr lvl="0"/>
+            <a:r>
+              <a:rPr/>
+              <a:t>Tunbridge Wells (Jan/Sept 2011)</a:t>
+            </a:r>
+          </a:p>
+          <a:p>
+            <a:pPr lvl="0"/>
+            <a:r>
+              <a:rPr/>
+              <a:t>Peterborough Hospital (Nov 2010)</a:t>
+            </a:r>
+          </a:p>
+        </p:txBody>
+      </p:sp>
+      <p:pic>
+        <p:nvPicPr>
+          <p:cNvPr descr="images/hospitals_map.png" id="0" name="Picture 1"/>
+          <p:cNvPicPr>
+            <a:picLocks noGrp="1" noChangeAspect="1"/>
+          </p:cNvPicPr>
+          <p:nvPr/>
+        </p:nvPicPr>
+        <p:blipFill>
+          <a:blip r:embed="rId2"/>
+          <a:stretch>
+            <a:fillRect/>
+          </a:stretch>
+        </p:blipFill>
+        <p:spPr bwMode="auto">
+          <a:xfrm>
+            <a:off x="6223000" y="2057400"/>
+            <a:ext cx="5041900" cy="3327400"/>
+          </a:xfrm>
+          <a:prstGeom prst="rect">
+            <a:avLst/>
+          </a:prstGeom>
+          <a:noFill/>
+          <a:ln w="9525">
+            <a:noFill/>
+            <a:headEnd/>
+            <a:tailEnd/>
+          </a:ln>
+        </p:spPr>
+      </p:pic>
+    </p:spTree>
+  </p:cSld>
+  <p:timing>
+    <p:tnLst>
+      <p:par>
+        <p:cTn id="1" dur="indefinite" restart="never" nodeType="tmRoot">
+          <p:childTnLst>
+            <p:seq concurrent="1" nextAc="seek">
+              <p:cTn id="2" dur="indefinite" nodeType="mainSeq">
+                <p:childTnLst>
+                  <p:par>
+                    <p:cTn id="3" fill="hold">
+                      <p:stCondLst>
+                        <p:cond delay="indefinite"/>
+                      </p:stCondLst>
+                      <p:childTnLst>
+                        <p:par>
+                          <p:cTn id="4" fill="hold">
+                            <p:stCondLst>
+                              <p:cond delay="0"/>
+                            </p:stCondLst>
+                            <p:childTnLst>
+                              <p:par>
+                                <p:cTn id="5" presetID="1" presetClass="entr" presetSubtype="0" fill="hold" grpId="0" nodeType="clickEffect">
+                                  <p:stCondLst>
+                                    <p:cond delay="0"/>
+                                  </p:stCondLst>
+                                  <p:childTnLst>
+                                    <p:set>
+                                      <p:cBhvr>
+                                        <p:cTn id="6" dur="1" fill="hold">
+                                          <p:stCondLst>
+                                            <p:cond delay="0"/>
+                                          </p:stCondLst>
+                                        </p:cTn>
+                                        <p:tgtEl>
+                                          <p:spTgt spid="3">
+                                            <p:txEl>
+                                              <p:pRg st="0" end="0"/>
+                                            </p:txEl>
+                                          </p:spTgt>
+                                        </p:tgtEl>
+                                        <p:attrNameLst>
+                                          <p:attrName>style.visibility</p:attrName>
+                                        </p:attrNameLst>
+                                      </p:cBhvr>
+                                      <p:to>
+                                        <p:strVal val="visible"/>
+                                      </p:to>
+                                    </p:set>
+                                  </p:childTnLst>
+                                </p:cTn>
+                              </p:par>
+                            </p:childTnLst>
+                          </p:cTn>
+                        </p:par>
+                      </p:childTnLst>
+                    </p:cTn>
+                  </p:par>
+                  <p:par>
+                    <p:cTn id="7" fill="hold">
+                      <p:stCondLst>
+                        <p:cond delay="indefinite"/>
+                      </p:stCondLst>
+                      <p:childTnLst>
+                        <p:par>
+                          <p:cTn id="8" fill="hold">
+                            <p:stCondLst>
+                              <p:cond delay="0"/>
+                            </p:stCondLst>
+                            <p:childTnLst>
+                              <p:par>
+                                <p:cTn id="9" presetID="1" presetClass="entr" presetSubtype="0" fill="hold" grpId="0" nodeType="clickEffect">
+                                  <p:stCondLst>
+                                    <p:cond delay="0"/>
+                                  </p:stCondLst>
+                                  <p:childTnLst>
+                                    <p:set>
+                                      <p:cBhvr>
+                                        <p:cTn id="10" dur="1" fill="hold">
+                                          <p:stCondLst>
+                                            <p:cond delay="0"/>
+                                          </p:stCondLst>
+                                        </p:cTn>
+                                        <p:tgtEl>
+                                          <p:spTgt spid="3">
+                                            <p:txEl>
+                                              <p:pRg st="1" end="1"/>
+                                            </p:txEl>
+                                          </p:spTgt>
+                                        </p:tgtEl>
+                                        <p:attrNameLst>
+                                          <p:attrName>style.visibility</p:attrName>
+                                        </p:attrNameLst>
+                                      </p:cBhvr>
+                                      <p:to>
+                                        <p:strVal val="visible"/>
+                                      </p:to>
+                                    </p:set>
+                                  </p:childTnLst>
+                                </p:cTn>
+                              </p:par>
+                            </p:childTnLst>
+                          </p:cTn>
+                        </p:par>
+                      </p:childTnLst>
+                    </p:cTn>
+                  </p:par>
+                  <p:par>
+                    <p:cTn id="11" fill="hold">
+                      <p:stCondLst>
+                        <p:cond delay="indefinite"/>
+                      </p:stCondLst>
+                      <p:childTnLst>
+                        <p:par>
+                          <p:cTn id="12" fill="hold">
+                            <p:stCondLst>
+                              <p:cond delay="0"/>
+                            </p:stCondLst>
+                            <p:childTnLst>
+                              <p:par>
+                                <p:cTn id="13" presetID="1" presetClass="entr" presetSubtype="0" fill="hold" grpId="0" nodeType="clickEffect">
+                                  <p:stCondLst>
+                                    <p:cond delay="0"/>
+                                  </p:stCondLst>
+                                  <p:childTnLst>
+                                    <p:set>
+                                      <p:cBhvr>
+                                        <p:cTn id="14" dur="1" fill="hold">
+                                          <p:stCondLst>
+                                            <p:cond delay="0"/>
+                                          </p:stCondLst>
+                                        </p:cTn>
+                                        <p:tgtEl>
+                                          <p:spTgt spid="3">
+                                            <p:txEl>
+                                              <p:pRg st="2" end="2"/>
+                                            </p:txEl>
+                                          </p:spTgt>
+                                        </p:tgtEl>
+                                        <p:attrNameLst>
+                                          <p:attrName>style.visibility</p:attrName>
+                                        </p:attrNameLst>
+                                      </p:cBhvr>
+                                      <p:to>
+                                        <p:strVal val="visible"/>
+                                      </p:to>
+                                    </p:set>
+                                  </p:childTnLst>
+                                </p:cTn>
+                              </p:par>
+                            </p:childTnLst>
+                          </p:cTn>
+                        </p:par>
+                      </p:childTnLst>
+                    </p:cTn>
+                  </p:par>
+                  <p:par>
+                    <p:cTn id="15" fill="hold">
+                      <p:stCondLst>
+                        <p:cond delay="indefinite"/>
+                      </p:stCondLst>
+                      <p:childTnLst>
+                        <p:par>
+                          <p:cTn id="16" fill="hold">
+                            <p:stCondLst>
+                              <p:cond delay="0"/>
+                            </p:stCondLst>
+                            <p:childTnLst>
+                              <p:par>
+                                <p:cTn id="17" presetID="1" presetClass="entr" presetSubtype="0" fill="hold" grpId="0" nodeType="clickEffect">
+                                  <p:stCondLst>
+                                    <p:cond delay="0"/>
+                                  </p:stCondLst>
+                                  <p:childTnLst>
+                                    <p:set>
+                                      <p:cBhvr>
+                                        <p:cTn id="18" dur="1" fill="hold">
+                                          <p:stCondLst>
+                                            <p:cond delay="0"/>
+                                          </p:stCondLst>
+                                        </p:cTn>
+                                        <p:tgtEl>
+                                          <p:spTgt spid="3">
+                                            <p:txEl>
+                                              <p:pRg st="3" end="3"/>
+                                            </p:txEl>
+                                          </p:spTgt>
+                                        </p:tgtEl>
+                                        <p:attrNameLst>
+                                          <p:attrName>style.visibility</p:attrName>
+                                        </p:attrNameLst>
+                                      </p:cBhvr>
+                                      <p:to>
+                                        <p:strVal val="visible"/>
+                                      </p:to>
+                                    </p:set>
+                                  </p:childTnLst>
+                                </p:cTn>
+                              </p:par>
+                            </p:childTnLst>
+                          </p:cTn>
+                        </p:par>
+                      </p:childTnLst>
+                    </p:cTn>
+                  </p:par>
+                  <p:par>
+                    <p:cTn id="19" fill="hold">
+                      <p:stCondLst>
+                        <p:cond delay="indefinite"/>
+                      </p:stCondLst>
+                      <p:childTnLst>
+                        <p:par>
+                          <p:cTn id="20" fill="hold">
+                            <p:stCondLst>
+                              <p:cond delay="0"/>
+                            </p:stCondLst>
+                            <p:childTnLst>
+                              <p:par>
+                                <p:cTn id="21" presetID="1" presetClass="entr" presetSubtype="0" fill="hold" grpId="0" nodeType="clickEffect">
+                                  <p:stCondLst>
+                                    <p:cond delay="0"/>
+                                  </p:stCondLst>
+                                  <p:childTnLst>
+                                    <p:set>
+                                      <p:cBhvr>
+                                        <p:cTn id="22" dur="1" fill="hold">
+                                          <p:stCondLst>
+                                            <p:cond delay="0"/>
+                                          </p:stCondLst>
+                                        </p:cTn>
+                                        <p:tgtEl>
+                                          <p:spTgt spid="3">
+                                            <p:txEl>
+                                              <p:pRg st="4" end="4"/>
+                                            </p:txEl>
+                                          </p:spTgt>
+                                        </p:tgtEl>
+                                        <p:attrNameLst>
+                                          <p:attrName>style.visibility</p:attrName>
+                                        </p:attrNameLst>
+                                      </p:cBhvr>
+                                      <p:to>
+                                        <p:strVal val="visible"/>
+                                      </p:to>
+                                    </p:set>
+                                  </p:childTnLst>
+                                </p:cTn>
+                              </p:par>
+                            </p:childTnLst>
+                          </p:cTn>
+                        </p:par>
+                      </p:childTnLst>
+                    </p:cTn>
+                  </p:par>
+                  <p:par>
+                    <p:cTn id="23" fill="hold">
+                      <p:stCondLst>
+                        <p:cond delay="indefinite"/>
+                      </p:stCondLst>
+                      <p:childTnLst>
+                        <p:par>
+                          <p:cTn id="24" fill="hold">
+                            <p:stCondLst>
+                              <p:cond delay="0"/>
+                            </p:stCondLst>
+                            <p:childTnLst>
+                              <p:par>
+                                <p:cTn id="25" presetID="1" presetClass="entr" presetSubtype="0" fill="hold" grpId="0" nodeType="clickEffect">
+                                  <p:stCondLst>
+                                    <p:cond delay="0"/>
+                                  </p:stCondLst>
+                                  <p:childTnLst>
+                                    <p:set>
+                                      <p:cBhvr>
+                                        <p:cTn id="26" dur="1" fill="hold">
+                                          <p:stCondLst>
+                                            <p:cond delay="0"/>
+                                          </p:stCondLst>
+                                        </p:cTn>
+                                        <p:tgtEl>
+                                          <p:spTgt spid="3">
+                                            <p:txEl>
+                                              <p:pRg st="5" end="5"/>
+                                            </p:txEl>
+                                          </p:spTgt>
+                                        </p:tgtEl>
+                                        <p:attrNameLst>
+                                          <p:attrName>style.visibility</p:attrName>
+                                        </p:attrNameLst>
+                                      </p:cBhvr>
+                                      <p:to>
+                                        <p:strVal val="visible"/>
+                                      </p:to>
+                                    </p:set>
+                                  </p:childTnLst>
+                                </p:cTn>
+                              </p:par>
+                            </p:childTnLst>
+                          </p:cTn>
+                        </p:par>
+                      </p:childTnLst>
+                    </p:cTn>
+                  </p:par>
+                  <p:par>
+                    <p:cTn id="27" fill="hold">
+                      <p:stCondLst>
+                        <p:cond delay="indefinite"/>
+                      </p:stCondLst>
+                      <p:childTnLst>
+                        <p:par>
+                          <p:cTn id="28" fill="hold">
+                            <p:stCondLst>
+                              <p:cond delay="0"/>
+                            </p:stCondLst>
+                            <p:childTnLst>
+                              <p:par>
+                                <p:cTn id="29" presetID="1" presetClass="entr" presetSubtype="0" fill="hold" grpId="0" nodeType="clickEffect">
+                                  <p:stCondLst>
+                                    <p:cond delay="0"/>
+                                  </p:stCondLst>
+                                  <p:childTnLst>
+                                    <p:set>
+                                      <p:cBhvr>
+                                        <p:cTn id="30" dur="1" fill="hold">
+                                          <p:stCondLst>
+                                            <p:cond delay="0"/>
+                                          </p:stCondLst>
+                                        </p:cTn>
+                                        <p:tgtEl>
+                                          <p:spTgt spid="3">
+                                            <p:txEl>
+                                              <p:pRg st="6" end="6"/>
+                                            </p:txEl>
+                                          </p:spTgt>
+                                        </p:tgtEl>
+                                        <p:attrNameLst>
+                                          <p:attrName>style.visibility</p:attrName>
+                                        </p:attrNameLst>
+                                      </p:cBhvr>
+                                      <p:to>
+                                        <p:strVal val="visible"/>
+                                      </p:to>
+                                    </p:set>
+                                  </p:childTnLst>
+                                </p:cTn>
+                              </p:par>
+                            </p:childTnLst>
+                          </p:cTn>
+                        </p:par>
+                      </p:childTnLst>
+                    </p:cTn>
+                  </p:par>
+                </p:childTnLst>
+              </p:cTn>
+              <p:prevCondLst>
+                <p:cond evt="onPrev" delay="0">
+                  <p:tgtEl>
+                    <p:sldTgt/>
+                  </p:tgtEl>
+                </p:cond>
+              </p:prevCondLst>
+              <p:nextCondLst>
+                <p:cond evt="onNext" delay="0">
+                  <p:tgtEl>
+                    <p:sldTgt/>
+                  </p:tgtEl>
+                </p:cond>
+              </p:nextCondLst>
+            </p:seq>
+          </p:childTnLst>
+        </p:cTn>
+      </p:par>
+    </p:tnLst>
+    <p:bldLst>
+      <p:bldP spid="3" grpId="0" uiExpand="1" build="p"/>
+    </p:bldLst>
+  </p:timing>
 </p:sld>
 </file>
 

</xml_diff>

<commit_message>
Completed sections up to key results. Latest ppt render included.
</commit_message>
<xml_diff>
--- a/NHP_SBR impacts_2024.pptx
+++ b/NHP_SBR impacts_2024.pptx
@@ -4317,8 +4317,8 @@
         </p:blipFill>
         <p:spPr bwMode="auto">
           <a:xfrm>
-            <a:off x="6223000" y="1663700"/>
-            <a:ext cx="5041900" cy="4114800"/>
+            <a:off x="6223000" y="1993900"/>
+            <a:ext cx="5041900" cy="3467100"/>
           </a:xfrm>
           <a:prstGeom prst="rect">
             <a:avLst/>
@@ -4687,13 +4687,13 @@
             <a:spLocks noGrp="1"/>
           </p:cNvSpPr>
           <p:nvPr>
-            <p:ph hasCustomPrompt="1" type="title"/>
+            <p:ph type="title"/>
           </p:nvPr>
         </p:nvSpPr>
         <p:spPr>
           <a:xfrm>
-            <a:off x="909829" y="403765"/>
-            <a:ext cx="8434196" cy="976056"/>
+            <a:off x="919352" y="419100"/>
+            <a:ext cx="9720072" cy="933450"/>
           </a:xfrm>
         </p:spPr>
         <p:txBody>
@@ -4706,6 +4706,106 @@
             <a:r>
               <a:rPr/>
               <a:t>Causal Impact Analysis</a:t>
+            </a:r>
+          </a:p>
+        </p:txBody>
+      </p:sp>
+      <p:sp>
+        <p:nvSpPr>
+          <p:cNvPr id="3" name="Content Placeholder 2">
+            <a:extLst>
+              <a:ext uri="{FF2B5EF4-FFF2-40B4-BE49-F238E27FC236}">
+                <a16:creationId xmlns:a16="http://schemas.microsoft.com/office/drawing/2014/main" id="{D2592819-5C80-B996-F823-F8B9F9EAD6C9}"/>
+              </a:ext>
+            </a:extLst>
+          </p:cNvPr>
+          <p:cNvSpPr>
+            <a:spLocks noGrp="1"/>
+          </p:cNvSpPr>
+          <p:nvPr>
+            <p:ph idx="10"/>
+          </p:nvPr>
+        </p:nvSpPr>
+        <p:spPr/>
+        <p:txBody>
+          <a:bodyPr/>
+          <a:lstStyle/>
+          <a:p>
+            <a:pPr lvl="0" indent="0" marL="0">
+              <a:buNone/>
+            </a:pPr>
+            <a:r>
+              <a:rPr/>
+              <a:t>Causal Impact Analysis (CIA), developed by K. Broderson in 2014, explicitly uses prior trends and ‘market-matched’ control analysis to predict a time series. The observed values for the study site are compared to this to determine the direction, magnitude and significance of impacts as a result of the intervention.</a:t>
+            </a:r>
+          </a:p>
+          <a:p>
+            <a:pPr lvl="0" indent="0" marL="0">
+              <a:buNone/>
+            </a:pPr>
+            <a:r>
+              <a:rPr/>
+              <a:t>All analysis has been performed in R software (v4.3.2+) with the following packages - CausalImpact, MarketMatching, dtw, metafor.</a:t>
+            </a:r>
+          </a:p>
+        </p:txBody>
+      </p:sp>
+      <p:pic>
+        <p:nvPicPr>
+          <p:cNvPr descr="fig:  images/cia_example.png" id="0" name="Picture 1"/>
+          <p:cNvPicPr>
+            <a:picLocks noGrp="1" noChangeAspect="1"/>
+          </p:cNvPicPr>
+          <p:nvPr/>
+        </p:nvPicPr>
+        <p:blipFill>
+          <a:blip r:embed="rId2"/>
+          <a:stretch>
+            <a:fillRect/>
+          </a:stretch>
+        </p:blipFill>
+        <p:spPr bwMode="auto">
+          <a:xfrm>
+            <a:off x="7188200" y="1612900"/>
+            <a:ext cx="3098800" cy="3721100"/>
+          </a:xfrm>
+          <a:prstGeom prst="rect">
+            <a:avLst/>
+          </a:prstGeom>
+          <a:noFill/>
+          <a:ln w="9525">
+            <a:noFill/>
+            <a:headEnd/>
+            <a:tailEnd/>
+          </a:ln>
+        </p:spPr>
+      </p:pic>
+      <p:sp>
+        <p:nvSpPr>
+          <p:cNvPr id="1" name="TextBox 3"/>
+          <p:cNvSpPr txBox="1"/>
+          <p:nvPr/>
+        </p:nvSpPr>
+        <p:spPr>
+          <a:xfrm>
+            <a:off x="6223000" y="5334000"/>
+            <a:ext cx="5041900" cy="508000"/>
+          </a:xfrm>
+          <a:prstGeom prst="rect">
+            <a:avLst/>
+          </a:prstGeom>
+          <a:noFill/>
+        </p:spPr>
+        <p:txBody>
+          <a:bodyPr/>
+          <a:lstStyle/>
+          <a:p>
+            <a:pPr lvl="0" indent="0" marL="0" algn="ctr">
+              <a:buNone/>
+            </a:pPr>
+            <a:r>
+              <a:rPr/>
+              <a:t>Example of CIA analysis</a:t>
             </a:r>
           </a:p>
         </p:txBody>
@@ -4739,13 +4839,13 @@
             <a:spLocks noGrp="1"/>
           </p:cNvSpPr>
           <p:nvPr>
-            <p:ph hasCustomPrompt="1" type="title"/>
+            <p:ph type="title"/>
           </p:nvPr>
         </p:nvSpPr>
         <p:spPr>
           <a:xfrm>
-            <a:off x="909829" y="403765"/>
-            <a:ext cx="8434196" cy="976056"/>
+            <a:off x="919352" y="419100"/>
+            <a:ext cx="9720072" cy="933450"/>
           </a:xfrm>
         </p:spPr>
         <p:txBody>
@@ -4758,6 +4858,106 @@
             <a:r>
               <a:rPr/>
               <a:t>Aggregating impacts</a:t>
+            </a:r>
+          </a:p>
+        </p:txBody>
+      </p:sp>
+      <p:sp>
+        <p:nvSpPr>
+          <p:cNvPr id="3" name="Content Placeholder 2">
+            <a:extLst>
+              <a:ext uri="{FF2B5EF4-FFF2-40B4-BE49-F238E27FC236}">
+                <a16:creationId xmlns:a16="http://schemas.microsoft.com/office/drawing/2014/main" id="{D2592819-5C80-B996-F823-F8B9F9EAD6C9}"/>
+              </a:ext>
+            </a:extLst>
+          </p:cNvPr>
+          <p:cNvSpPr>
+            <a:spLocks noGrp="1"/>
+          </p:cNvSpPr>
+          <p:nvPr>
+            <p:ph idx="10"/>
+          </p:nvPr>
+        </p:nvSpPr>
+        <p:spPr/>
+        <p:txBody>
+          <a:bodyPr/>
+          <a:lstStyle/>
+          <a:p>
+            <a:pPr lvl="0" indent="0" marL="0">
+              <a:buNone/>
+            </a:pPr>
+            <a:r>
+              <a:rPr/>
+              <a:t>Where for each impact measure there were 2 or more general and acute hospitals, a meta-analysis was conducted. The specialist hospital sites were excluded from this analysis as it is felt the effects at these sites may not be generalisable when considering future building of general acute hospitals.</a:t>
+            </a:r>
+          </a:p>
+          <a:p>
+            <a:pPr lvl="0" indent="0" marL="0">
+              <a:buNone/>
+            </a:pPr>
+            <a:r>
+              <a:rPr/>
+              <a:t>A random-effects meta-analysis was conducted using the metafor R package (Viechtbauer 2024) and with the relative effects for each site weighted using the inverse variance, as used for meta-analysis of causal impact models by Schmitt et al. (Schmitt, Tull, and Atwater 2017).</a:t>
+            </a:r>
+          </a:p>
+        </p:txBody>
+      </p:sp>
+      <p:pic>
+        <p:nvPicPr>
+          <p:cNvPr descr="fig:  images/meta_example.png" id="0" name="Picture 1"/>
+          <p:cNvPicPr>
+            <a:picLocks noGrp="1" noChangeAspect="1"/>
+          </p:cNvPicPr>
+          <p:nvPr/>
+        </p:nvPicPr>
+        <p:blipFill>
+          <a:blip r:embed="rId2"/>
+          <a:stretch>
+            <a:fillRect/>
+          </a:stretch>
+        </p:blipFill>
+        <p:spPr bwMode="auto">
+          <a:xfrm>
+            <a:off x="6223000" y="2743200"/>
+            <a:ext cx="5041900" cy="1447800"/>
+          </a:xfrm>
+          <a:prstGeom prst="rect">
+            <a:avLst/>
+          </a:prstGeom>
+          <a:noFill/>
+          <a:ln w="9525">
+            <a:noFill/>
+            <a:headEnd/>
+            <a:tailEnd/>
+          </a:ln>
+        </p:spPr>
+      </p:pic>
+      <p:sp>
+        <p:nvSpPr>
+          <p:cNvPr id="1" name="TextBox 3"/>
+          <p:cNvSpPr txBox="1"/>
+          <p:nvPr/>
+        </p:nvSpPr>
+        <p:spPr>
+          <a:xfrm>
+            <a:off x="6223000" y="5334000"/>
+            <a:ext cx="5041900" cy="508000"/>
+          </a:xfrm>
+          <a:prstGeom prst="rect">
+            <a:avLst/>
+          </a:prstGeom>
+          <a:noFill/>
+        </p:spPr>
+        <p:txBody>
+          <a:bodyPr/>
+          <a:lstStyle/>
+          <a:p>
+            <a:pPr lvl="0" indent="0" marL="0" algn="ctr">
+              <a:buNone/>
+            </a:pPr>
+            <a:r>
+              <a:rPr/>
+              <a:t>Example of meta-analysis</a:t>
             </a:r>
           </a:p>
         </p:txBody>

</xml_diff>

<commit_message>
Added summary results sections to qmd/pptx output. Minor tweaks to template layout. Latest render aded.
Unknown changes (accidental space?) to causal impact script :-).
</commit_message>
<xml_diff>
--- a/NHP_SBR impacts_2024.pptx
+++ b/NHP_SBR impacts_2024.pptx
@@ -19,6 +19,23 @@
     <p:sldId id="267" r:id="rId16"/>
     <p:sldId id="268" r:id="rId17"/>
     <p:sldId id="269" r:id="rId18"/>
+    <p:sldId id="270" r:id="rId19"/>
+    <p:sldId id="271" r:id="rId20"/>
+    <p:sldId id="272" r:id="rId21"/>
+    <p:sldId id="273" r:id="rId22"/>
+    <p:sldId id="274" r:id="rId23"/>
+    <p:sldId id="275" r:id="rId24"/>
+    <p:sldId id="276" r:id="rId25"/>
+    <p:sldId id="277" r:id="rId26"/>
+    <p:sldId id="278" r:id="rId27"/>
+    <p:sldId id="279" r:id="rId28"/>
+    <p:sldId id="280" r:id="rId29"/>
+    <p:sldId id="281" r:id="rId30"/>
+    <p:sldId id="282" r:id="rId31"/>
+    <p:sldId id="283" r:id="rId32"/>
+    <p:sldId id="284" r:id="rId33"/>
+    <p:sldId id="285" r:id="rId34"/>
+    <p:sldId id="286" r:id="rId35"/>
   </p:sldIdLst>
   <p:sldSz cx="12192000" cy="6858000"/>
   <p:notesSz cx="6858000" cy="9144000"/>
@@ -192,8 +209,8 @@
         </p:nvSpPr>
         <p:spPr>
           <a:xfrm>
-            <a:off x="457198" y="4755350"/>
-            <a:ext cx="8406375" cy="1218369"/>
+            <a:off x="457198" y="4624736"/>
+            <a:ext cx="8406375" cy="1348983"/>
           </a:xfrm>
         </p:spPr>
         <p:txBody>
@@ -830,8 +847,8 @@
         </p:nvSpPr>
         <p:spPr>
           <a:xfrm>
-            <a:off x="457199" y="4755350"/>
-            <a:ext cx="7772400" cy="1218369"/>
+            <a:off x="457199" y="4665306"/>
+            <a:ext cx="7772400" cy="1308413"/>
           </a:xfrm>
         </p:spPr>
         <p:txBody>
@@ -1451,7 +1468,7 @@
           </a:prstGeom>
         </p:spPr>
         <p:txBody>
-          <a:bodyPr>
+          <a:bodyPr anchor="ctr">
             <a:normAutofit/>
           </a:bodyPr>
           <a:lstStyle>
@@ -1726,7 +1743,7 @@
           </a:prstGeom>
         </p:spPr>
         <p:txBody>
-          <a:bodyPr>
+          <a:bodyPr anchor="ctr">
             <a:normAutofit/>
           </a:bodyPr>
           <a:lstStyle>
@@ -1855,43 +1872,6 @@
             <a:r>
               <a:rPr lang="en-GB" dirty="0"/>
               <a:t>Click to edit title</a:t>
-            </a:r>
-            <a:endParaRPr lang="en-US" dirty="0"/>
-          </a:p>
-        </p:txBody>
-      </p:sp>
-      <p:sp>
-        <p:nvSpPr>
-          <p:cNvPr id="3" name="Content Placeholder 2"/>
-          <p:cNvSpPr>
-            <a:spLocks noGrp="1"/>
-          </p:cNvSpPr>
-          <p:nvPr>
-            <p:ph idx="1" hasCustomPrompt="1"/>
-          </p:nvPr>
-        </p:nvSpPr>
-        <p:spPr>
-          <a:xfrm>
-            <a:off x="909829" y="1550608"/>
-            <a:ext cx="10243946" cy="460417"/>
-          </a:xfrm>
-          <a:prstGeom prst="rect">
-            <a:avLst/>
-          </a:prstGeom>
-        </p:spPr>
-        <p:txBody>
-          <a:bodyPr anchor="ctr"/>
-          <a:lstStyle>
-            <a:lvl1pPr marL="0" indent="0">
-              <a:buNone/>
-              <a:defRPr/>
-            </a:lvl1pPr>
-          </a:lstStyle>
-          <a:p>
-            <a:pPr lvl="0"/>
-            <a:r>
-              <a:rPr lang="en-GB" dirty="0"/>
-              <a:t>Click to edit text</a:t>
             </a:r>
             <a:endParaRPr lang="en-US" dirty="0"/>
           </a:p>
@@ -2075,16 +2055,115 @@
         </p:nvSpPr>
         <p:spPr>
           <a:xfrm>
-            <a:off x="909638" y="2228850"/>
-            <a:ext cx="7015162" cy="3695700"/>
+            <a:off x="4138613" y="1550608"/>
+            <a:ext cx="7015162" cy="4263106"/>
           </a:xfrm>
           <a:prstGeom prst="rect">
             <a:avLst/>
           </a:prstGeom>
         </p:spPr>
         <p:txBody>
-          <a:bodyPr/>
-          <a:lstStyle/>
+          <a:bodyPr anchor="ctr">
+            <a:normAutofit/>
+          </a:bodyPr>
+          <a:lstStyle>
+            <a:lvl1pPr>
+              <a:defRPr sz="1800"/>
+            </a:lvl1pPr>
+            <a:lvl2pPr>
+              <a:defRPr sz="1800"/>
+            </a:lvl2pPr>
+            <a:lvl3pPr>
+              <a:defRPr sz="1800"/>
+            </a:lvl3pPr>
+            <a:lvl4pPr>
+              <a:defRPr sz="1800"/>
+            </a:lvl4pPr>
+            <a:lvl5pPr>
+              <a:defRPr sz="1800"/>
+            </a:lvl5pPr>
+          </a:lstStyle>
+          <a:p>
+            <a:pPr lvl="0"/>
+            <a:r>
+              <a:rPr lang="en-US"/>
+              <a:t>Click to edit Master text styles</a:t>
+            </a:r>
+          </a:p>
+          <a:p>
+            <a:pPr lvl="1"/>
+            <a:r>
+              <a:rPr lang="en-US"/>
+              <a:t>Second level</a:t>
+            </a:r>
+          </a:p>
+          <a:p>
+            <a:pPr lvl="2"/>
+            <a:r>
+              <a:rPr lang="en-US"/>
+              <a:t>Third level</a:t>
+            </a:r>
+          </a:p>
+          <a:p>
+            <a:pPr lvl="3"/>
+            <a:r>
+              <a:rPr lang="en-US"/>
+              <a:t>Fourth level</a:t>
+            </a:r>
+          </a:p>
+          <a:p>
+            <a:pPr lvl="4"/>
+            <a:r>
+              <a:rPr lang="en-US"/>
+              <a:t>Fifth level</a:t>
+            </a:r>
+            <a:endParaRPr lang="en-GB"/>
+          </a:p>
+        </p:txBody>
+      </p:sp>
+      <p:sp>
+        <p:nvSpPr>
+          <p:cNvPr id="7" name="Text Placeholder 6">
+            <a:extLst>
+              <a:ext uri="{FF2B5EF4-FFF2-40B4-BE49-F238E27FC236}">
+                <a16:creationId xmlns:a16="http://schemas.microsoft.com/office/drawing/2014/main" id="{DE622849-4EA7-24AE-DD96-E693EAA81594}"/>
+              </a:ext>
+            </a:extLst>
+          </p:cNvPr>
+          <p:cNvSpPr>
+            <a:spLocks noGrp="1"/>
+          </p:cNvSpPr>
+          <p:nvPr>
+            <p:ph type="body" sz="quarter" idx="13"/>
+          </p:nvPr>
+        </p:nvSpPr>
+        <p:spPr>
+          <a:xfrm>
+            <a:off x="909638" y="1550988"/>
+            <a:ext cx="2997200" cy="4262437"/>
+          </a:xfrm>
+        </p:spPr>
+        <p:txBody>
+          <a:bodyPr anchor="ctr">
+            <a:normAutofit/>
+          </a:bodyPr>
+          <a:lstStyle>
+            <a:lvl1pPr>
+              <a:defRPr sz="1800"/>
+            </a:lvl1pPr>
+            <a:lvl2pPr>
+              <a:defRPr sz="1800"/>
+            </a:lvl2pPr>
+            <a:lvl3pPr>
+              <a:defRPr sz="1800"/>
+            </a:lvl3pPr>
+            <a:lvl4pPr>
+              <a:defRPr sz="1800"/>
+            </a:lvl4pPr>
+            <a:lvl5pPr>
+              <a:defRPr sz="1800"/>
+            </a:lvl5pPr>
+          </a:lstStyle>
           <a:p>
             <a:pPr lvl="0"/>
             <a:r>
@@ -2176,7 +2255,7 @@
           <a:p>
             <a:fld id="{0EB35C0E-E263-0848-A698-EE526CA39358}" type="datetimeFigureOut">
               <a:rPr lang="en-US" smtClean="0"/>
-              <a:t>5/20/2024</a:t>
+              <a:t>5/21/2024</a:t>
             </a:fld>
             <a:endParaRPr lang="en-US" dirty="0"/>
           </a:p>
@@ -2320,8 +2399,26 @@
           </a:prstGeom>
         </p:spPr>
         <p:txBody>
-          <a:bodyPr/>
-          <a:lstStyle/>
+          <a:bodyPr>
+            <a:normAutofit/>
+          </a:bodyPr>
+          <a:lstStyle>
+            <a:lvl1pPr>
+              <a:defRPr sz="1800"/>
+            </a:lvl1pPr>
+            <a:lvl2pPr>
+              <a:defRPr sz="1800"/>
+            </a:lvl2pPr>
+            <a:lvl3pPr>
+              <a:defRPr sz="1800"/>
+            </a:lvl3pPr>
+            <a:lvl4pPr>
+              <a:defRPr sz="1800"/>
+            </a:lvl4pPr>
+            <a:lvl5pPr>
+              <a:defRPr sz="1800"/>
+            </a:lvl5pPr>
+          </a:lstStyle>
           <a:p>
             <a:pPr lvl="0"/>
             <a:r>
@@ -4065,8 +4162,8 @@
         </p:nvSpPr>
         <p:spPr>
           <a:xfrm>
-            <a:off x="457198" y="4755350"/>
-            <a:ext cx="8406375" cy="1218369"/>
+            <a:off x="457198" y="4624736"/>
+            <a:ext cx="8406375" cy="1348983"/>
           </a:xfrm>
         </p:spPr>
         <p:txBody>
@@ -4152,8 +4249,8 @@
         </p:nvSpPr>
         <p:spPr>
           <a:xfrm>
-            <a:off x="457199" y="4755350"/>
-            <a:ext cx="7772400" cy="1218369"/>
+            <a:off x="457199" y="4665306"/>
+            <a:ext cx="7772400" cy="1308413"/>
           </a:xfrm>
         </p:spPr>
         <p:txBody>
@@ -4165,7 +4262,7 @@
             </a:pPr>
             <a:r>
               <a:rPr/>
-              <a:t>Summary of methods</a:t>
+              <a:t>3. The hospitals</a:t>
             </a:r>
           </a:p>
         </p:txBody>
@@ -4199,13 +4296,13 @@
             <a:spLocks noGrp="1"/>
           </p:cNvSpPr>
           <p:nvPr>
-            <p:ph type="title"/>
+            <p:ph hasCustomPrompt="1" type="title"/>
           </p:nvPr>
         </p:nvSpPr>
         <p:spPr>
           <a:xfrm>
-            <a:off x="919352" y="419100"/>
-            <a:ext cx="9720072" cy="933450"/>
+            <a:off x="909829" y="438150"/>
+            <a:ext cx="8434196" cy="914400"/>
           </a:xfrm>
         </p:spPr>
         <p:txBody>
@@ -4217,17 +4314,17 @@
             </a:pPr>
             <a:r>
               <a:rPr/>
-              <a:t>Selecting control sites</a:t>
-            </a:r>
-          </a:p>
-        </p:txBody>
-      </p:sp>
-      <p:sp>
-        <p:nvSpPr>
-          <p:cNvPr id="3" name="Content Placeholder 2">
+              <a:t>3.1 Seven natural experiments</a:t>
+            </a:r>
+          </a:p>
+        </p:txBody>
+      </p:sp>
+      <p:sp>
+        <p:nvSpPr>
+          <p:cNvPr id="7" name="Text Placeholder 6">
             <a:extLst>
               <a:ext uri="{FF2B5EF4-FFF2-40B4-BE49-F238E27FC236}">
-                <a16:creationId xmlns:a16="http://schemas.microsoft.com/office/drawing/2014/main" id="{D2592819-5C80-B996-F823-F8B9F9EAD6C9}"/>
+                <a16:creationId xmlns:a16="http://schemas.microsoft.com/office/drawing/2014/main" id="{DE622849-4EA7-24AE-DD96-E693EAA81594}"/>
               </a:ext>
             </a:extLst>
           </p:cNvPr>
@@ -4235,7 +4332,7 @@
             <a:spLocks noGrp="1"/>
           </p:cNvSpPr>
           <p:nvPr>
-            <p:ph idx="10"/>
+            <p:ph idx="13" sz="quarter" type="body"/>
           </p:nvPr>
         </p:nvSpPr>
         <p:spPr/>
@@ -4243,67 +4340,59 @@
           <a:bodyPr/>
           <a:lstStyle/>
           <a:p>
-            <a:pPr lvl="0" indent="0" marL="0">
-              <a:buNone/>
-            </a:pPr>
-            <a:r>
-              <a:rPr/>
-              <a:t>Before including control sites into the calculation of the post-intervention counterfactual, we must ensure they’re similar to the site under study. We do this in several consecutive steps:</a:t>
-            </a:r>
-          </a:p>
-          <a:p>
-            <a:pPr lvl="0" indent="-457200" marL="457200">
-              <a:buAutoNum type="arabicPeriod"/>
-            </a:pPr>
-            <a:r>
-              <a:rPr/>
-              <a:t>Filter on similar site types e.g. General Acute, Tertiary Centre</a:t>
-            </a:r>
-          </a:p>
-          <a:p>
-            <a:pPr lvl="0" indent="-457200" marL="457200">
-              <a:buAutoNum type="arabicPeriod"/>
-            </a:pPr>
-            <a:r>
-              <a:rPr/>
-              <a:t>Exclude those with dissimilar single bed %’s at the point of intervention</a:t>
-            </a:r>
-          </a:p>
-          <a:p>
-            <a:pPr lvl="0" indent="-457200" marL="457200">
-              <a:buAutoNum type="arabicPeriod"/>
-            </a:pPr>
-            <a:r>
-              <a:rPr/>
-              <a:t>Match on (the closest 20) according to the following variables:</a:t>
-            </a:r>
-          </a:p>
-          <a:p>
             <a:pPr lvl="0"/>
             <a:r>
               <a:rPr/>
-              <a:t>Hospital size (m2)</a:t>
+              <a:t>Royal Liverpool (Oct 2022)</a:t>
             </a:r>
           </a:p>
           <a:p>
             <a:pPr lvl="0"/>
             <a:r>
               <a:rPr/>
-              <a:t>Patient case-mix (median age)</a:t>
+              <a:t>Clatterbridge Cancer Centre (June 2020)</a:t>
             </a:r>
           </a:p>
           <a:p>
             <a:pPr lvl="0"/>
             <a:r>
               <a:rPr/>
-              <a:t>Elective:Non-elective spell ratio</a:t>
+              <a:t>Royal Papworth Hospital (May 2019)</a:t>
+            </a:r>
+          </a:p>
+          <a:p>
+            <a:pPr lvl="0"/>
+            <a:r>
+              <a:rPr/>
+              <a:t>Chase Farm Hospital (Sept 2018)</a:t>
+            </a:r>
+          </a:p>
+          <a:p>
+            <a:pPr lvl="0"/>
+            <a:r>
+              <a:rPr/>
+              <a:t>Southmead Hospital (May 2014)</a:t>
+            </a:r>
+          </a:p>
+          <a:p>
+            <a:pPr lvl="0"/>
+            <a:r>
+              <a:rPr/>
+              <a:t>Tunbridge Wells (Jan/Sept 2011)</a:t>
+            </a:r>
+          </a:p>
+          <a:p>
+            <a:pPr lvl="0"/>
+            <a:r>
+              <a:rPr/>
+              <a:t>Peterborough Hospital (Nov 2010)</a:t>
             </a:r>
           </a:p>
         </p:txBody>
       </p:sp>
       <p:pic>
         <p:nvPicPr>
-          <p:cNvPr descr="images/control_flowchart.png" id="0" name="Picture 1"/>
+          <p:cNvPr descr="images/hospitals_map.png" id="0" name="Picture 1"/>
           <p:cNvPicPr>
             <a:picLocks noGrp="1" noChangeAspect="1"/>
           </p:cNvPicPr>
@@ -4317,8 +4406,8 @@
         </p:blipFill>
         <p:spPr bwMode="auto">
           <a:xfrm>
-            <a:off x="6223000" y="1993900"/>
-            <a:ext cx="5041900" cy="3467100"/>
+            <a:off x="4406900" y="1549400"/>
+            <a:ext cx="6438900" cy="4254500"/>
           </a:xfrm>
           <a:prstGeom prst="rect">
             <a:avLst/>
@@ -4333,333 +4422,6 @@
       </p:pic>
     </p:spTree>
   </p:cSld>
-  <p:timing>
-    <p:tnLst>
-      <p:par>
-        <p:cTn id="1" dur="indefinite" restart="never" nodeType="tmRoot">
-          <p:childTnLst>
-            <p:seq concurrent="1" nextAc="seek">
-              <p:cTn id="2" dur="indefinite" nodeType="mainSeq">
-                <p:childTnLst>
-                  <p:par>
-                    <p:cTn id="3" fill="hold">
-                      <p:stCondLst>
-                        <p:cond delay="indefinite"/>
-                      </p:stCondLst>
-                      <p:childTnLst>
-                        <p:par>
-                          <p:cTn id="4" fill="hold">
-                            <p:stCondLst>
-                              <p:cond delay="0"/>
-                            </p:stCondLst>
-                            <p:childTnLst>
-                              <p:par>
-                                <p:cTn id="5" presetID="1" presetClass="entr" presetSubtype="0" fill="hold" grpId="0" nodeType="clickEffect">
-                                  <p:stCondLst>
-                                    <p:cond delay="0"/>
-                                  </p:stCondLst>
-                                  <p:childTnLst>
-                                    <p:set>
-                                      <p:cBhvr>
-                                        <p:cTn id="6" dur="1" fill="hold">
-                                          <p:stCondLst>
-                                            <p:cond delay="0"/>
-                                          </p:stCondLst>
-                                        </p:cTn>
-                                        <p:tgtEl>
-                                          <p:spTgt spid="3">
-                                            <p:txEl>
-                                              <p:pRg st="1" end="1"/>
-                                            </p:txEl>
-                                          </p:spTgt>
-                                        </p:tgtEl>
-                                        <p:attrNameLst>
-                                          <p:attrName>style.visibility</p:attrName>
-                                        </p:attrNameLst>
-                                      </p:cBhvr>
-                                      <p:to>
-                                        <p:strVal val="visible"/>
-                                      </p:to>
-                                    </p:set>
-                                  </p:childTnLst>
-                                </p:cTn>
-                              </p:par>
-                            </p:childTnLst>
-                          </p:cTn>
-                        </p:par>
-                      </p:childTnLst>
-                    </p:cTn>
-                  </p:par>
-                  <p:par>
-                    <p:cTn id="7" fill="hold">
-                      <p:stCondLst>
-                        <p:cond delay="indefinite"/>
-                      </p:stCondLst>
-                      <p:childTnLst>
-                        <p:par>
-                          <p:cTn id="8" fill="hold">
-                            <p:stCondLst>
-                              <p:cond delay="0"/>
-                            </p:stCondLst>
-                            <p:childTnLst>
-                              <p:par>
-                                <p:cTn id="9" presetID="1" presetClass="entr" presetSubtype="0" fill="hold" grpId="0" nodeType="clickEffect">
-                                  <p:stCondLst>
-                                    <p:cond delay="0"/>
-                                  </p:stCondLst>
-                                  <p:childTnLst>
-                                    <p:set>
-                                      <p:cBhvr>
-                                        <p:cTn id="10" dur="1" fill="hold">
-                                          <p:stCondLst>
-                                            <p:cond delay="0"/>
-                                          </p:stCondLst>
-                                        </p:cTn>
-                                        <p:tgtEl>
-                                          <p:spTgt spid="3">
-                                            <p:txEl>
-                                              <p:pRg st="2" end="2"/>
-                                            </p:txEl>
-                                          </p:spTgt>
-                                        </p:tgtEl>
-                                        <p:attrNameLst>
-                                          <p:attrName>style.visibility</p:attrName>
-                                        </p:attrNameLst>
-                                      </p:cBhvr>
-                                      <p:to>
-                                        <p:strVal val="visible"/>
-                                      </p:to>
-                                    </p:set>
-                                  </p:childTnLst>
-                                </p:cTn>
-                              </p:par>
-                            </p:childTnLst>
-                          </p:cTn>
-                        </p:par>
-                      </p:childTnLst>
-                    </p:cTn>
-                  </p:par>
-                  <p:par>
-                    <p:cTn id="11" fill="hold">
-                      <p:stCondLst>
-                        <p:cond delay="indefinite"/>
-                      </p:stCondLst>
-                      <p:childTnLst>
-                        <p:par>
-                          <p:cTn id="12" fill="hold">
-                            <p:stCondLst>
-                              <p:cond delay="0"/>
-                            </p:stCondLst>
-                            <p:childTnLst>
-                              <p:par>
-                                <p:cTn id="13" presetID="1" presetClass="entr" presetSubtype="0" fill="hold" grpId="0" nodeType="clickEffect">
-                                  <p:stCondLst>
-                                    <p:cond delay="0"/>
-                                  </p:stCondLst>
-                                  <p:childTnLst>
-                                    <p:set>
-                                      <p:cBhvr>
-                                        <p:cTn id="14" dur="1" fill="hold">
-                                          <p:stCondLst>
-                                            <p:cond delay="0"/>
-                                          </p:stCondLst>
-                                        </p:cTn>
-                                        <p:tgtEl>
-                                          <p:spTgt spid="3">
-                                            <p:txEl>
-                                              <p:pRg st="3" end="3"/>
-                                            </p:txEl>
-                                          </p:spTgt>
-                                        </p:tgtEl>
-                                        <p:attrNameLst>
-                                          <p:attrName>style.visibility</p:attrName>
-                                        </p:attrNameLst>
-                                      </p:cBhvr>
-                                      <p:to>
-                                        <p:strVal val="visible"/>
-                                      </p:to>
-                                    </p:set>
-                                  </p:childTnLst>
-                                </p:cTn>
-                              </p:par>
-                            </p:childTnLst>
-                          </p:cTn>
-                        </p:par>
-                      </p:childTnLst>
-                    </p:cTn>
-                  </p:par>
-                  <p:par>
-                    <p:cTn id="15" fill="hold">
-                      <p:stCondLst>
-                        <p:cond delay="indefinite"/>
-                      </p:stCondLst>
-                      <p:childTnLst>
-                        <p:par>
-                          <p:cTn id="16" fill="hold">
-                            <p:stCondLst>
-                              <p:cond delay="0"/>
-                            </p:stCondLst>
-                            <p:childTnLst>
-                              <p:par>
-                                <p:cTn id="17" presetID="1" presetClass="entr" presetSubtype="0" fill="hold" grpId="0" nodeType="clickEffect">
-                                  <p:stCondLst>
-                                    <p:cond delay="0"/>
-                                  </p:stCondLst>
-                                  <p:childTnLst>
-                                    <p:set>
-                                      <p:cBhvr>
-                                        <p:cTn id="18" dur="1" fill="hold">
-                                          <p:stCondLst>
-                                            <p:cond delay="0"/>
-                                          </p:stCondLst>
-                                        </p:cTn>
-                                        <p:tgtEl>
-                                          <p:spTgt spid="3">
-                                            <p:txEl>
-                                              <p:pRg st="4" end="4"/>
-                                            </p:txEl>
-                                          </p:spTgt>
-                                        </p:tgtEl>
-                                        <p:attrNameLst>
-                                          <p:attrName>style.visibility</p:attrName>
-                                        </p:attrNameLst>
-                                      </p:cBhvr>
-                                      <p:to>
-                                        <p:strVal val="visible"/>
-                                      </p:to>
-                                    </p:set>
-                                  </p:childTnLst>
-                                </p:cTn>
-                              </p:par>
-                            </p:childTnLst>
-                          </p:cTn>
-                        </p:par>
-                      </p:childTnLst>
-                    </p:cTn>
-                  </p:par>
-                  <p:par>
-                    <p:cTn id="19" fill="hold">
-                      <p:stCondLst>
-                        <p:cond delay="indefinite"/>
-                      </p:stCondLst>
-                      <p:childTnLst>
-                        <p:par>
-                          <p:cTn id="20" fill="hold">
-                            <p:stCondLst>
-                              <p:cond delay="0"/>
-                            </p:stCondLst>
-                            <p:childTnLst>
-                              <p:par>
-                                <p:cTn id="21" presetID="1" presetClass="entr" presetSubtype="0" fill="hold" grpId="0" nodeType="clickEffect">
-                                  <p:stCondLst>
-                                    <p:cond delay="0"/>
-                                  </p:stCondLst>
-                                  <p:childTnLst>
-                                    <p:set>
-                                      <p:cBhvr>
-                                        <p:cTn id="22" dur="1" fill="hold">
-                                          <p:stCondLst>
-                                            <p:cond delay="0"/>
-                                          </p:stCondLst>
-                                        </p:cTn>
-                                        <p:tgtEl>
-                                          <p:spTgt spid="3">
-                                            <p:txEl>
-                                              <p:pRg st="5" end="5"/>
-                                            </p:txEl>
-                                          </p:spTgt>
-                                        </p:tgtEl>
-                                        <p:attrNameLst>
-                                          <p:attrName>style.visibility</p:attrName>
-                                        </p:attrNameLst>
-                                      </p:cBhvr>
-                                      <p:to>
-                                        <p:strVal val="visible"/>
-                                      </p:to>
-                                    </p:set>
-                                  </p:childTnLst>
-                                </p:cTn>
-                              </p:par>
-                            </p:childTnLst>
-                          </p:cTn>
-                        </p:par>
-                      </p:childTnLst>
-                    </p:cTn>
-                  </p:par>
-                  <p:par>
-                    <p:cTn id="23" fill="hold">
-                      <p:stCondLst>
-                        <p:cond delay="indefinite"/>
-                      </p:stCondLst>
-                      <p:childTnLst>
-                        <p:par>
-                          <p:cTn id="24" fill="hold">
-                            <p:stCondLst>
-                              <p:cond delay="0"/>
-                            </p:stCondLst>
-                            <p:childTnLst>
-                              <p:par>
-                                <p:cTn id="25" presetID="1" presetClass="entr" presetSubtype="0" fill="hold" grpId="0" nodeType="clickEffect">
-                                  <p:stCondLst>
-                                    <p:cond delay="0"/>
-                                  </p:stCondLst>
-                                  <p:childTnLst>
-                                    <p:set>
-                                      <p:cBhvr>
-                                        <p:cTn id="26" dur="1" fill="hold">
-                                          <p:stCondLst>
-                                            <p:cond delay="0"/>
-                                          </p:stCondLst>
-                                        </p:cTn>
-                                        <p:tgtEl>
-                                          <p:spTgt spid="3">
-                                            <p:txEl>
-                                              <p:pRg st="6" end="6"/>
-                                            </p:txEl>
-                                          </p:spTgt>
-                                        </p:tgtEl>
-                                        <p:attrNameLst>
-                                          <p:attrName>style.visibility</p:attrName>
-                                        </p:attrNameLst>
-                                      </p:cBhvr>
-                                      <p:to>
-                                        <p:strVal val="visible"/>
-                                      </p:to>
-                                    </p:set>
-                                  </p:childTnLst>
-                                </p:cTn>
-                              </p:par>
-                            </p:childTnLst>
-                          </p:cTn>
-                        </p:par>
-                      </p:childTnLst>
-                    </p:cTn>
-                  </p:par>
-                </p:childTnLst>
-              </p:cTn>
-              <p:prevCondLst>
-                <p:cond evt="onPrev" delay="0">
-                  <p:tgtEl>
-                    <p:sldTgt/>
-                  </p:tgtEl>
-                </p:cond>
-              </p:prevCondLst>
-              <p:nextCondLst>
-                <p:cond evt="onNext" delay="0">
-                  <p:tgtEl>
-                    <p:sldTgt/>
-                  </p:tgtEl>
-                </p:cond>
-              </p:nextCondLst>
-            </p:seq>
-          </p:childTnLst>
-        </p:cTn>
-      </p:par>
-    </p:tnLst>
-    <p:bldLst>
-      <p:bldP spid="3" grpId="0" uiExpand="1" build="p"/>
-    </p:bldLst>
-  </p:timing>
 </p:sld>
 </file>
 
@@ -4687,13 +4449,13 @@
             <a:spLocks noGrp="1"/>
           </p:cNvSpPr>
           <p:nvPr>
-            <p:ph type="title"/>
+            <p:ph hasCustomPrompt="1" type="title"/>
           </p:nvPr>
         </p:nvSpPr>
         <p:spPr>
           <a:xfrm>
-            <a:off x="919352" y="419100"/>
-            <a:ext cx="9720072" cy="933450"/>
+            <a:off x="909829" y="403765"/>
+            <a:ext cx="8434196" cy="976056"/>
           </a:xfrm>
         </p:spPr>
         <p:txBody>
@@ -4705,25 +4467,19 @@
             </a:pPr>
             <a:r>
               <a:rPr/>
-              <a:t>Causal Impact Analysis</a:t>
-            </a:r>
-          </a:p>
-        </p:txBody>
-      </p:sp>
-      <p:sp>
-        <p:nvSpPr>
-          <p:cNvPr id="3" name="Content Placeholder 2">
-            <a:extLst>
-              <a:ext uri="{FF2B5EF4-FFF2-40B4-BE49-F238E27FC236}">
-                <a16:creationId xmlns:a16="http://schemas.microsoft.com/office/drawing/2014/main" id="{D2592819-5C80-B996-F823-F8B9F9EAD6C9}"/>
-              </a:ext>
-            </a:extLst>
-          </p:cNvPr>
-          <p:cNvSpPr>
-            <a:spLocks noGrp="1"/>
-          </p:cNvSpPr>
-          <p:nvPr>
-            <p:ph idx="10"/>
+              <a:t>3.2 Heterogeneity</a:t>
+            </a:r>
+          </a:p>
+        </p:txBody>
+      </p:sp>
+      <p:sp>
+        <p:nvSpPr>
+          <p:cNvPr id="3" name="Content Placeholder 2"/>
+          <p:cNvSpPr>
+            <a:spLocks noGrp="1"/>
+          </p:cNvSpPr>
+          <p:nvPr>
+            <p:ph idx="1"/>
           </p:nvPr>
         </p:nvSpPr>
         <p:spPr/>
@@ -4736,7 +4492,7 @@
             </a:pPr>
             <a:r>
               <a:rPr/>
-              <a:t>Causal Impact Analysis (CIA), developed by K. Broderson in 2014, explicitly uses prior trends and ‘market-matched’ control analysis to predict a time series. The observed values for the study site are compared to this to determine the direction, magnitude and significance of impacts as a result of the intervention.</a:t>
+              <a:t>No hospital site is the same as another. This is no more true than for our 7 natural experiments. The sites are a mixture of general acute hospitals and specialist ones. They vary in size and function and there are many possible confounding factors in the input-output logic model for our impacts that we can not identify nor account for.</a:t>
             </a:r>
           </a:p>
           <a:p>
@@ -4745,67 +4501,7 @@
             </a:pPr>
             <a:r>
               <a:rPr/>
-              <a:t>All analysis has been performed in R software (v4.3.2+) with the following packages - CausalImpact, MarketMatching, dtw, metafor.</a:t>
-            </a:r>
-          </a:p>
-        </p:txBody>
-      </p:sp>
-      <p:pic>
-        <p:nvPicPr>
-          <p:cNvPr descr="fig:  images/cia_example.png" id="0" name="Picture 1"/>
-          <p:cNvPicPr>
-            <a:picLocks noGrp="1" noChangeAspect="1"/>
-          </p:cNvPicPr>
-          <p:nvPr/>
-        </p:nvPicPr>
-        <p:blipFill>
-          <a:blip r:embed="rId2"/>
-          <a:stretch>
-            <a:fillRect/>
-          </a:stretch>
-        </p:blipFill>
-        <p:spPr bwMode="auto">
-          <a:xfrm>
-            <a:off x="7188200" y="1612900"/>
-            <a:ext cx="3098800" cy="3721100"/>
-          </a:xfrm>
-          <a:prstGeom prst="rect">
-            <a:avLst/>
-          </a:prstGeom>
-          <a:noFill/>
-          <a:ln w="9525">
-            <a:noFill/>
-            <a:headEnd/>
-            <a:tailEnd/>
-          </a:ln>
-        </p:spPr>
-      </p:pic>
-      <p:sp>
-        <p:nvSpPr>
-          <p:cNvPr id="1" name="TextBox 3"/>
-          <p:cNvSpPr txBox="1"/>
-          <p:nvPr/>
-        </p:nvSpPr>
-        <p:spPr>
-          <a:xfrm>
-            <a:off x="6223000" y="5334000"/>
-            <a:ext cx="5041900" cy="508000"/>
-          </a:xfrm>
-          <a:prstGeom prst="rect">
-            <a:avLst/>
-          </a:prstGeom>
-          <a:noFill/>
-        </p:spPr>
-        <p:txBody>
-          <a:bodyPr/>
-          <a:lstStyle/>
-          <a:p>
-            <a:pPr lvl="0" indent="0" marL="0" algn="ctr">
-              <a:buNone/>
-            </a:pPr>
-            <a:r>
-              <a:rPr/>
-              <a:t>Example of CIA analysis</a:t>
+              <a:t>In aggregating some of the findings in this analysis, we have grouped the general acute sites together for indicative purposes. However; the nature of those hospital systems and the social and cultural circumstance should be considerations when both interpreting our findings and also in considering single-bed provision within hospital developments</a:t>
             </a:r>
           </a:p>
         </p:txBody>
@@ -4839,13 +4535,13 @@
             <a:spLocks noGrp="1"/>
           </p:cNvSpPr>
           <p:nvPr>
-            <p:ph type="title"/>
+            <p:ph hasCustomPrompt="1" type="ctrTitle"/>
           </p:nvPr>
         </p:nvSpPr>
         <p:spPr>
           <a:xfrm>
-            <a:off x="919352" y="419100"/>
-            <a:ext cx="9720072" cy="933450"/>
+            <a:off x="457199" y="4665306"/>
+            <a:ext cx="7772400" cy="1308413"/>
           </a:xfrm>
         </p:spPr>
         <p:txBody>
@@ -4857,107 +4553,7 @@
             </a:pPr>
             <a:r>
               <a:rPr/>
-              <a:t>Aggregating impacts</a:t>
-            </a:r>
-          </a:p>
-        </p:txBody>
-      </p:sp>
-      <p:sp>
-        <p:nvSpPr>
-          <p:cNvPr id="3" name="Content Placeholder 2">
-            <a:extLst>
-              <a:ext uri="{FF2B5EF4-FFF2-40B4-BE49-F238E27FC236}">
-                <a16:creationId xmlns:a16="http://schemas.microsoft.com/office/drawing/2014/main" id="{D2592819-5C80-B996-F823-F8B9F9EAD6C9}"/>
-              </a:ext>
-            </a:extLst>
-          </p:cNvPr>
-          <p:cNvSpPr>
-            <a:spLocks noGrp="1"/>
-          </p:cNvSpPr>
-          <p:nvPr>
-            <p:ph idx="10"/>
-          </p:nvPr>
-        </p:nvSpPr>
-        <p:spPr/>
-        <p:txBody>
-          <a:bodyPr/>
-          <a:lstStyle/>
-          <a:p>
-            <a:pPr lvl="0" indent="0" marL="0">
-              <a:buNone/>
-            </a:pPr>
-            <a:r>
-              <a:rPr/>
-              <a:t>Where for each impact measure there were 2 or more general and acute hospitals, a meta-analysis was conducted. The specialist hospital sites were excluded from this analysis as it is felt the effects at these sites may not be generalisable when considering future building of general acute hospitals.</a:t>
-            </a:r>
-          </a:p>
-          <a:p>
-            <a:pPr lvl="0" indent="0" marL="0">
-              <a:buNone/>
-            </a:pPr>
-            <a:r>
-              <a:rPr/>
-              <a:t>A random-effects meta-analysis was conducted using the metafor R package (Viechtbauer 2024) and with the relative effects for each site weighted using the inverse variance, as used for meta-analysis of causal impact models by Schmitt et al. (Schmitt, Tull, and Atwater 2017).</a:t>
-            </a:r>
-          </a:p>
-        </p:txBody>
-      </p:sp>
-      <p:pic>
-        <p:nvPicPr>
-          <p:cNvPr descr="fig:  images/meta_example.png" id="0" name="Picture 1"/>
-          <p:cNvPicPr>
-            <a:picLocks noGrp="1" noChangeAspect="1"/>
-          </p:cNvPicPr>
-          <p:nvPr/>
-        </p:nvPicPr>
-        <p:blipFill>
-          <a:blip r:embed="rId2"/>
-          <a:stretch>
-            <a:fillRect/>
-          </a:stretch>
-        </p:blipFill>
-        <p:spPr bwMode="auto">
-          <a:xfrm>
-            <a:off x="6223000" y="2743200"/>
-            <a:ext cx="5041900" cy="1447800"/>
-          </a:xfrm>
-          <a:prstGeom prst="rect">
-            <a:avLst/>
-          </a:prstGeom>
-          <a:noFill/>
-          <a:ln w="9525">
-            <a:noFill/>
-            <a:headEnd/>
-            <a:tailEnd/>
-          </a:ln>
-        </p:spPr>
-      </p:pic>
-      <p:sp>
-        <p:nvSpPr>
-          <p:cNvPr id="1" name="TextBox 3"/>
-          <p:cNvSpPr txBox="1"/>
-          <p:nvPr/>
-        </p:nvSpPr>
-        <p:spPr>
-          <a:xfrm>
-            <a:off x="6223000" y="5334000"/>
-            <a:ext cx="5041900" cy="508000"/>
-          </a:xfrm>
-          <a:prstGeom prst="rect">
-            <a:avLst/>
-          </a:prstGeom>
-          <a:noFill/>
-        </p:spPr>
-        <p:txBody>
-          <a:bodyPr/>
-          <a:lstStyle/>
-          <a:p>
-            <a:pPr lvl="0" indent="0" marL="0" algn="ctr">
-              <a:buNone/>
-            </a:pPr>
-            <a:r>
-              <a:rPr/>
-              <a:t>Example of meta-analysis</a:t>
+              <a:t>4. Summary of methods</a:t>
             </a:r>
           </a:p>
         </p:txBody>
@@ -4991,13 +4587,13 @@
             <a:spLocks noGrp="1"/>
           </p:cNvSpPr>
           <p:nvPr>
-            <p:ph hasCustomPrompt="1" type="ctrTitle"/>
+            <p:ph type="title"/>
           </p:nvPr>
         </p:nvSpPr>
         <p:spPr>
           <a:xfrm>
-            <a:off x="457199" y="4755350"/>
-            <a:ext cx="7772400" cy="1218369"/>
+            <a:off x="919352" y="419100"/>
+            <a:ext cx="9720072" cy="933450"/>
           </a:xfrm>
         </p:spPr>
         <p:txBody>
@@ -5009,11 +4605,752 @@
             </a:pPr>
             <a:r>
               <a:rPr/>
-              <a:t>Main results</a:t>
-            </a:r>
-          </a:p>
-        </p:txBody>
-      </p:sp>
+              <a:t>4.1 Selecting control sites</a:t>
+            </a:r>
+          </a:p>
+        </p:txBody>
+      </p:sp>
+      <p:sp>
+        <p:nvSpPr>
+          <p:cNvPr id="3" name="Content Placeholder 2">
+            <a:extLst>
+              <a:ext uri="{FF2B5EF4-FFF2-40B4-BE49-F238E27FC236}">
+                <a16:creationId xmlns:a16="http://schemas.microsoft.com/office/drawing/2014/main" id="{D2592819-5C80-B996-F823-F8B9F9EAD6C9}"/>
+              </a:ext>
+            </a:extLst>
+          </p:cNvPr>
+          <p:cNvSpPr>
+            <a:spLocks noGrp="1"/>
+          </p:cNvSpPr>
+          <p:nvPr>
+            <p:ph idx="10"/>
+          </p:nvPr>
+        </p:nvSpPr>
+        <p:spPr/>
+        <p:txBody>
+          <a:bodyPr/>
+          <a:lstStyle/>
+          <a:p>
+            <a:pPr lvl="0" indent="0" marL="0">
+              <a:buNone/>
+            </a:pPr>
+            <a:r>
+              <a:rPr/>
+              <a:t>Before including control sites into the calculation of the post-intervention counterfactual, we must ensure they’re similar to the site under study. We do this in several consecutive steps:</a:t>
+            </a:r>
+          </a:p>
+          <a:p>
+            <a:pPr lvl="0" indent="-457200" marL="457200">
+              <a:buAutoNum type="arabicPeriod"/>
+            </a:pPr>
+            <a:r>
+              <a:rPr/>
+              <a:t>Filter on similar site types e.g. General Acute, Tertiary Centre</a:t>
+            </a:r>
+          </a:p>
+          <a:p>
+            <a:pPr lvl="0" indent="-457200" marL="457200">
+              <a:buAutoNum type="arabicPeriod"/>
+            </a:pPr>
+            <a:r>
+              <a:rPr/>
+              <a:t>Exclude those with dissimilar single bed %’s at the point of intervention</a:t>
+            </a:r>
+          </a:p>
+          <a:p>
+            <a:pPr lvl="0" indent="-457200" marL="457200">
+              <a:buAutoNum type="arabicPeriod"/>
+            </a:pPr>
+            <a:r>
+              <a:rPr/>
+              <a:t>Match on (the closest 20) according to the following variables:</a:t>
+            </a:r>
+          </a:p>
+          <a:p>
+            <a:pPr lvl="0"/>
+            <a:r>
+              <a:rPr/>
+              <a:t>Hospital size (m2)</a:t>
+            </a:r>
+          </a:p>
+          <a:p>
+            <a:pPr lvl="0"/>
+            <a:r>
+              <a:rPr/>
+              <a:t>Patient case-mix (median age)</a:t>
+            </a:r>
+          </a:p>
+          <a:p>
+            <a:pPr lvl="0"/>
+            <a:r>
+              <a:rPr/>
+              <a:t>Elective:Non-elective spell ratio</a:t>
+            </a:r>
+          </a:p>
+        </p:txBody>
+      </p:sp>
+      <p:pic>
+        <p:nvPicPr>
+          <p:cNvPr descr="images/control_flowchart.png" id="0" name="Picture 1"/>
+          <p:cNvPicPr>
+            <a:picLocks noGrp="1" noChangeAspect="1"/>
+          </p:cNvPicPr>
+          <p:nvPr/>
+        </p:nvPicPr>
+        <p:blipFill>
+          <a:blip r:embed="rId2"/>
+          <a:stretch>
+            <a:fillRect/>
+          </a:stretch>
+        </p:blipFill>
+        <p:spPr bwMode="auto">
+          <a:xfrm>
+            <a:off x="6223000" y="1993900"/>
+            <a:ext cx="5041900" cy="3467100"/>
+          </a:xfrm>
+          <a:prstGeom prst="rect">
+            <a:avLst/>
+          </a:prstGeom>
+          <a:noFill/>
+          <a:ln w="9525">
+            <a:noFill/>
+            <a:headEnd/>
+            <a:tailEnd/>
+          </a:ln>
+        </p:spPr>
+      </p:pic>
+    </p:spTree>
+  </p:cSld>
+</p:sld>
+</file>
+
+<file path=ppt/slides/slide15.xml><?xml version="1.0" encoding="utf-8"?>
+<p:sld xmlns:a="http://schemas.openxmlformats.org/drawingml/2006/main" xmlns:r="http://schemas.openxmlformats.org/officeDocument/2006/relationships" xmlns:p="http://schemas.openxmlformats.org/presentationml/2006/main">
+  <p:cSld>
+    <p:spTree>
+      <p:nvGrpSpPr>
+        <p:cNvPr id="1" name=""/>
+        <p:cNvGrpSpPr/>
+        <p:nvPr/>
+      </p:nvGrpSpPr>
+      <p:grpSpPr>
+        <a:xfrm>
+          <a:off x="0" y="0"/>
+          <a:ext cx="0" cy="0"/>
+          <a:chOff x="0" y="0"/>
+          <a:chExt cx="0" cy="0"/>
+        </a:xfrm>
+      </p:grpSpPr>
+      <p:sp>
+        <p:nvSpPr>
+          <p:cNvPr id="2" name="Title 1"/>
+          <p:cNvSpPr>
+            <a:spLocks noGrp="1"/>
+          </p:cNvSpPr>
+          <p:nvPr>
+            <p:ph type="title"/>
+          </p:nvPr>
+        </p:nvSpPr>
+        <p:spPr>
+          <a:xfrm>
+            <a:off x="919352" y="419100"/>
+            <a:ext cx="9720072" cy="933450"/>
+          </a:xfrm>
+        </p:spPr>
+        <p:txBody>
+          <a:bodyPr/>
+          <a:lstStyle/>
+          <a:p>
+            <a:pPr lvl="0" indent="0" marL="0">
+              <a:buNone/>
+            </a:pPr>
+            <a:r>
+              <a:rPr/>
+              <a:t>4.2 Causal Impact Analysis</a:t>
+            </a:r>
+          </a:p>
+        </p:txBody>
+      </p:sp>
+      <p:sp>
+        <p:nvSpPr>
+          <p:cNvPr id="3" name="Content Placeholder 2">
+            <a:extLst>
+              <a:ext uri="{FF2B5EF4-FFF2-40B4-BE49-F238E27FC236}">
+                <a16:creationId xmlns:a16="http://schemas.microsoft.com/office/drawing/2014/main" id="{D2592819-5C80-B996-F823-F8B9F9EAD6C9}"/>
+              </a:ext>
+            </a:extLst>
+          </p:cNvPr>
+          <p:cNvSpPr>
+            <a:spLocks noGrp="1"/>
+          </p:cNvSpPr>
+          <p:nvPr>
+            <p:ph idx="10"/>
+          </p:nvPr>
+        </p:nvSpPr>
+        <p:spPr/>
+        <p:txBody>
+          <a:bodyPr/>
+          <a:lstStyle/>
+          <a:p>
+            <a:pPr lvl="0" indent="0" marL="0">
+              <a:buNone/>
+            </a:pPr>
+            <a:r>
+              <a:rPr/>
+              <a:t>Causal Impact Analysis (CIA), developed by K. Broderson in 2014, explicitly uses prior trends and ‘market-matched’ control analysis to predict a time series. The observed values for the study site are compared to this to determine the direction, magnitude and significance of impacts as a result of the intervention.</a:t>
+            </a:r>
+          </a:p>
+          <a:p>
+            <a:pPr lvl="0" indent="0" marL="0">
+              <a:buNone/>
+            </a:pPr>
+            <a:r>
+              <a:rPr/>
+              <a:t>All analysis has been performed in R software (v4.3.2+) with the following packages - CausalImpact, MarketMatching, dtw, metafor.</a:t>
+            </a:r>
+          </a:p>
+        </p:txBody>
+      </p:sp>
+      <p:pic>
+        <p:nvPicPr>
+          <p:cNvPr descr="fig:  images/cia_example.png" id="0" name="Picture 1"/>
+          <p:cNvPicPr>
+            <a:picLocks noGrp="1" noChangeAspect="1"/>
+          </p:cNvPicPr>
+          <p:nvPr/>
+        </p:nvPicPr>
+        <p:blipFill>
+          <a:blip r:embed="rId2"/>
+          <a:stretch>
+            <a:fillRect/>
+          </a:stretch>
+        </p:blipFill>
+        <p:spPr bwMode="auto">
+          <a:xfrm>
+            <a:off x="7188200" y="1612900"/>
+            <a:ext cx="3098800" cy="3721100"/>
+          </a:xfrm>
+          <a:prstGeom prst="rect">
+            <a:avLst/>
+          </a:prstGeom>
+          <a:noFill/>
+          <a:ln w="9525">
+            <a:noFill/>
+            <a:headEnd/>
+            <a:tailEnd/>
+          </a:ln>
+        </p:spPr>
+      </p:pic>
+      <p:sp>
+        <p:nvSpPr>
+          <p:cNvPr id="1" name="TextBox 3"/>
+          <p:cNvSpPr txBox="1"/>
+          <p:nvPr/>
+        </p:nvSpPr>
+        <p:spPr>
+          <a:xfrm>
+            <a:off x="6223000" y="5334000"/>
+            <a:ext cx="5041900" cy="508000"/>
+          </a:xfrm>
+          <a:prstGeom prst="rect">
+            <a:avLst/>
+          </a:prstGeom>
+          <a:noFill/>
+        </p:spPr>
+        <p:txBody>
+          <a:bodyPr/>
+          <a:lstStyle/>
+          <a:p>
+            <a:pPr lvl="0" indent="0" marL="0" algn="ctr">
+              <a:buNone/>
+            </a:pPr>
+            <a:r>
+              <a:rPr/>
+              <a:t>Example of CIA analysis</a:t>
+            </a:r>
+          </a:p>
+        </p:txBody>
+      </p:sp>
+    </p:spTree>
+  </p:cSld>
+</p:sld>
+</file>
+
+<file path=ppt/slides/slide16.xml><?xml version="1.0" encoding="utf-8"?>
+<p:sld xmlns:a="http://schemas.openxmlformats.org/drawingml/2006/main" xmlns:r="http://schemas.openxmlformats.org/officeDocument/2006/relationships" xmlns:p="http://schemas.openxmlformats.org/presentationml/2006/main">
+  <p:cSld>
+    <p:spTree>
+      <p:nvGrpSpPr>
+        <p:cNvPr id="1" name=""/>
+        <p:cNvGrpSpPr/>
+        <p:nvPr/>
+      </p:nvGrpSpPr>
+      <p:grpSpPr>
+        <a:xfrm>
+          <a:off x="0" y="0"/>
+          <a:ext cx="0" cy="0"/>
+          <a:chOff x="0" y="0"/>
+          <a:chExt cx="0" cy="0"/>
+        </a:xfrm>
+      </p:grpSpPr>
+      <p:sp>
+        <p:nvSpPr>
+          <p:cNvPr id="2" name="Title 1"/>
+          <p:cNvSpPr>
+            <a:spLocks noGrp="1"/>
+          </p:cNvSpPr>
+          <p:nvPr>
+            <p:ph type="title"/>
+          </p:nvPr>
+        </p:nvSpPr>
+        <p:spPr>
+          <a:xfrm>
+            <a:off x="919352" y="419100"/>
+            <a:ext cx="9720072" cy="933450"/>
+          </a:xfrm>
+        </p:spPr>
+        <p:txBody>
+          <a:bodyPr/>
+          <a:lstStyle/>
+          <a:p>
+            <a:pPr lvl="0" indent="0" marL="0">
+              <a:buNone/>
+            </a:pPr>
+            <a:r>
+              <a:rPr/>
+              <a:t>4.3 Aggregating impacts</a:t>
+            </a:r>
+          </a:p>
+        </p:txBody>
+      </p:sp>
+      <p:sp>
+        <p:nvSpPr>
+          <p:cNvPr id="3" name="Content Placeholder 2">
+            <a:extLst>
+              <a:ext uri="{FF2B5EF4-FFF2-40B4-BE49-F238E27FC236}">
+                <a16:creationId xmlns:a16="http://schemas.microsoft.com/office/drawing/2014/main" id="{D2592819-5C80-B996-F823-F8B9F9EAD6C9}"/>
+              </a:ext>
+            </a:extLst>
+          </p:cNvPr>
+          <p:cNvSpPr>
+            <a:spLocks noGrp="1"/>
+          </p:cNvSpPr>
+          <p:nvPr>
+            <p:ph idx="10"/>
+          </p:nvPr>
+        </p:nvSpPr>
+        <p:spPr/>
+        <p:txBody>
+          <a:bodyPr/>
+          <a:lstStyle/>
+          <a:p>
+            <a:pPr lvl="0" indent="0" marL="0">
+              <a:buNone/>
+            </a:pPr>
+            <a:r>
+              <a:rPr/>
+              <a:t>Where for each impact measure there were 2 or more general and acute hospitals, a meta-analysis was conducted. The specialist hospital sites were excluded from this analysis as it is felt the effects at these sites may not be generalisable when considering future building of general acute hospitals.</a:t>
+            </a:r>
+          </a:p>
+          <a:p>
+            <a:pPr lvl="0" indent="0" marL="0">
+              <a:buNone/>
+            </a:pPr>
+            <a:r>
+              <a:rPr/>
+              <a:t>A random-effects meta-analysis was conducted using the metafor R package (Viechtbauer 2024) and with the relative effects for each site weighted using the inverse variance, as used for meta-analysis of causal impact models by Schmitt et al. (Schmitt, Tull, and Atwater 2017).</a:t>
+            </a:r>
+          </a:p>
+        </p:txBody>
+      </p:sp>
+      <p:pic>
+        <p:nvPicPr>
+          <p:cNvPr descr="fig:  images/meta_example.png" id="0" name="Picture 1"/>
+          <p:cNvPicPr>
+            <a:picLocks noGrp="1" noChangeAspect="1"/>
+          </p:cNvPicPr>
+          <p:nvPr/>
+        </p:nvPicPr>
+        <p:blipFill>
+          <a:blip r:embed="rId2"/>
+          <a:stretch>
+            <a:fillRect/>
+          </a:stretch>
+        </p:blipFill>
+        <p:spPr bwMode="auto">
+          <a:xfrm>
+            <a:off x="6223000" y="2743200"/>
+            <a:ext cx="5041900" cy="1447800"/>
+          </a:xfrm>
+          <a:prstGeom prst="rect">
+            <a:avLst/>
+          </a:prstGeom>
+          <a:noFill/>
+          <a:ln w="9525">
+            <a:noFill/>
+            <a:headEnd/>
+            <a:tailEnd/>
+          </a:ln>
+        </p:spPr>
+      </p:pic>
+      <p:sp>
+        <p:nvSpPr>
+          <p:cNvPr id="1" name="TextBox 3"/>
+          <p:cNvSpPr txBox="1"/>
+          <p:nvPr/>
+        </p:nvSpPr>
+        <p:spPr>
+          <a:xfrm>
+            <a:off x="6223000" y="5334000"/>
+            <a:ext cx="5041900" cy="508000"/>
+          </a:xfrm>
+          <a:prstGeom prst="rect">
+            <a:avLst/>
+          </a:prstGeom>
+          <a:noFill/>
+        </p:spPr>
+        <p:txBody>
+          <a:bodyPr/>
+          <a:lstStyle/>
+          <a:p>
+            <a:pPr lvl="0" indent="0" marL="0" algn="ctr">
+              <a:buNone/>
+            </a:pPr>
+            <a:r>
+              <a:rPr/>
+              <a:t>Example of meta-analysis</a:t>
+            </a:r>
+          </a:p>
+        </p:txBody>
+      </p:sp>
+    </p:spTree>
+  </p:cSld>
+</p:sld>
+</file>
+
+<file path=ppt/slides/slide17.xml><?xml version="1.0" encoding="utf-8"?>
+<p:sld xmlns:a="http://schemas.openxmlformats.org/drawingml/2006/main" xmlns:r="http://schemas.openxmlformats.org/officeDocument/2006/relationships" xmlns:p="http://schemas.openxmlformats.org/presentationml/2006/main">
+  <p:cSld>
+    <p:spTree>
+      <p:nvGrpSpPr>
+        <p:cNvPr id="1" name=""/>
+        <p:cNvGrpSpPr/>
+        <p:nvPr/>
+      </p:nvGrpSpPr>
+      <p:grpSpPr>
+        <a:xfrm>
+          <a:off x="0" y="0"/>
+          <a:ext cx="0" cy="0"/>
+          <a:chOff x="0" y="0"/>
+          <a:chExt cx="0" cy="0"/>
+        </a:xfrm>
+      </p:grpSpPr>
+      <p:sp>
+        <p:nvSpPr>
+          <p:cNvPr id="2" name="Title 1"/>
+          <p:cNvSpPr>
+            <a:spLocks noGrp="1"/>
+          </p:cNvSpPr>
+          <p:nvPr>
+            <p:ph hasCustomPrompt="1" type="ctrTitle"/>
+          </p:nvPr>
+        </p:nvSpPr>
+        <p:spPr>
+          <a:xfrm>
+            <a:off x="457199" y="4665306"/>
+            <a:ext cx="7772400" cy="1308413"/>
+          </a:xfrm>
+        </p:spPr>
+        <p:txBody>
+          <a:bodyPr/>
+          <a:lstStyle/>
+          <a:p>
+            <a:pPr lvl="0" indent="0" marL="0">
+              <a:buNone/>
+            </a:pPr>
+            <a:r>
+              <a:rPr/>
+              <a:t>5. Main results - Productivity and Efficiency</a:t>
+            </a:r>
+          </a:p>
+        </p:txBody>
+      </p:sp>
+    </p:spTree>
+  </p:cSld>
+</p:sld>
+</file>
+
+<file path=ppt/slides/slide18.xml><?xml version="1.0" encoding="utf-8"?>
+<p:sld xmlns:a="http://schemas.openxmlformats.org/drawingml/2006/main" xmlns:r="http://schemas.openxmlformats.org/officeDocument/2006/relationships" xmlns:p="http://schemas.openxmlformats.org/presentationml/2006/main">
+  <p:cSld>
+    <p:spTree>
+      <p:nvGrpSpPr>
+        <p:cNvPr id="1" name=""/>
+        <p:cNvGrpSpPr/>
+        <p:nvPr/>
+      </p:nvGrpSpPr>
+      <p:grpSpPr>
+        <a:xfrm>
+          <a:off x="0" y="0"/>
+          <a:ext cx="0" cy="0"/>
+          <a:chOff x="0" y="0"/>
+          <a:chExt cx="0" cy="0"/>
+        </a:xfrm>
+      </p:grpSpPr>
+      <p:sp>
+        <p:nvSpPr>
+          <p:cNvPr id="2" name="Title 1"/>
+          <p:cNvSpPr>
+            <a:spLocks noGrp="1"/>
+          </p:cNvSpPr>
+          <p:nvPr>
+            <p:ph hasCustomPrompt="1" type="title"/>
+          </p:nvPr>
+        </p:nvSpPr>
+        <p:spPr>
+          <a:xfrm>
+            <a:off x="909829" y="438150"/>
+            <a:ext cx="8434196" cy="914400"/>
+          </a:xfrm>
+        </p:spPr>
+        <p:txBody>
+          <a:bodyPr/>
+          <a:lstStyle/>
+          <a:p>
+            <a:pPr lvl="0" indent="0" marL="0">
+              <a:buNone/>
+            </a:pPr>
+            <a:r>
+              <a:rPr/>
+              <a:t>5.1 Length of stay</a:t>
+            </a:r>
+          </a:p>
+        </p:txBody>
+      </p:sp>
+      <p:sp>
+        <p:nvSpPr>
+          <p:cNvPr id="7" name="Text Placeholder 6">
+            <a:extLst>
+              <a:ext uri="{FF2B5EF4-FFF2-40B4-BE49-F238E27FC236}">
+                <a16:creationId xmlns:a16="http://schemas.microsoft.com/office/drawing/2014/main" id="{DE622849-4EA7-24AE-DD96-E693EAA81594}"/>
+              </a:ext>
+            </a:extLst>
+          </p:cNvPr>
+          <p:cNvSpPr>
+            <a:spLocks noGrp="1"/>
+          </p:cNvSpPr>
+          <p:nvPr>
+            <p:ph idx="13" sz="quarter" type="body"/>
+          </p:nvPr>
+        </p:nvSpPr>
+        <p:spPr/>
+        <p:txBody>
+          <a:bodyPr/>
+          <a:lstStyle/>
+          <a:p>
+            <a:pPr lvl="0" indent="0" marL="0">
+              <a:buNone/>
+            </a:pPr>
+            <a:r>
+              <a:rPr/>
+              <a:t>This </a:t>
+            </a:r>
+            <a:r>
+              <a:rPr b="1"/>
+              <a:t>monthly</a:t>
+            </a:r>
+            <a:r>
+              <a:rPr/>
+              <a:t> data at </a:t>
+            </a:r>
+            <a:r>
+              <a:rPr b="1"/>
+              <a:t>site level</a:t>
+            </a:r>
+            <a:r>
+              <a:rPr/>
+              <a:t> is derived from the Secondary Uses Service (SUS) admitted patients care spells.</a:t>
+            </a:r>
+          </a:p>
+          <a:p>
+            <a:pPr lvl="0" indent="0" marL="0">
+              <a:buNone/>
+            </a:pPr>
+            <a:r>
+              <a:rPr/>
+              <a:t>Mean length of stay (in days) significantly decreased at 3/6 sites (Southmead, Peterborough and Chase Farm), was unchanged at 2/6 sites (Royal Liverpool and Tunbridge Wells), but significantly increased at Clatterbridge.</a:t>
+            </a:r>
+          </a:p>
+        </p:txBody>
+      </p:sp>
+      <p:pic>
+        <p:nvPicPr>
+          <p:cNvPr descr="NHP_SBR-impacts_2024_files/figure-pptx/cia_los-1.png" id="0" name="Picture 1"/>
+          <p:cNvPicPr>
+            <a:picLocks noGrp="1" noChangeAspect="1"/>
+          </p:cNvPicPr>
+          <p:nvPr/>
+        </p:nvPicPr>
+        <p:blipFill>
+          <a:blip r:embed="rId2"/>
+          <a:stretch>
+            <a:fillRect/>
+          </a:stretch>
+        </p:blipFill>
+        <p:spPr bwMode="auto">
+          <a:xfrm>
+            <a:off x="4127500" y="1930400"/>
+            <a:ext cx="7010400" cy="3505200"/>
+          </a:xfrm>
+          <a:prstGeom prst="rect">
+            <a:avLst/>
+          </a:prstGeom>
+          <a:noFill/>
+          <a:ln w="9525">
+            <a:noFill/>
+            <a:headEnd/>
+            <a:tailEnd/>
+          </a:ln>
+        </p:spPr>
+      </p:pic>
+    </p:spTree>
+  </p:cSld>
+</p:sld>
+</file>
+
+<file path=ppt/slides/slide19.xml><?xml version="1.0" encoding="utf-8"?>
+<p:sld xmlns:a="http://schemas.openxmlformats.org/drawingml/2006/main" xmlns:r="http://schemas.openxmlformats.org/officeDocument/2006/relationships" xmlns:p="http://schemas.openxmlformats.org/presentationml/2006/main">
+  <p:cSld>
+    <p:spTree>
+      <p:nvGrpSpPr>
+        <p:cNvPr id="1" name=""/>
+        <p:cNvGrpSpPr/>
+        <p:nvPr/>
+      </p:nvGrpSpPr>
+      <p:grpSpPr>
+        <a:xfrm>
+          <a:off x="0" y="0"/>
+          <a:ext cx="0" cy="0"/>
+          <a:chOff x="0" y="0"/>
+          <a:chExt cx="0" cy="0"/>
+        </a:xfrm>
+      </p:grpSpPr>
+      <p:sp>
+        <p:nvSpPr>
+          <p:cNvPr id="2" name="Title 1"/>
+          <p:cNvSpPr>
+            <a:spLocks noGrp="1"/>
+          </p:cNvSpPr>
+          <p:nvPr>
+            <p:ph hasCustomPrompt="1" type="title"/>
+          </p:nvPr>
+        </p:nvSpPr>
+        <p:spPr>
+          <a:xfrm>
+            <a:off x="909829" y="438150"/>
+            <a:ext cx="8434196" cy="914400"/>
+          </a:xfrm>
+        </p:spPr>
+        <p:txBody>
+          <a:bodyPr/>
+          <a:lstStyle/>
+          <a:p>
+            <a:pPr lvl="0" indent="0" marL="0">
+              <a:buNone/>
+            </a:pPr>
+            <a:r>
+              <a:rPr/>
+              <a:t>5.2 Waiting time (median)</a:t>
+            </a:r>
+          </a:p>
+        </p:txBody>
+      </p:sp>
+      <p:sp>
+        <p:nvSpPr>
+          <p:cNvPr id="7" name="Text Placeholder 6">
+            <a:extLst>
+              <a:ext uri="{FF2B5EF4-FFF2-40B4-BE49-F238E27FC236}">
+                <a16:creationId xmlns:a16="http://schemas.microsoft.com/office/drawing/2014/main" id="{DE622849-4EA7-24AE-DD96-E693EAA81594}"/>
+              </a:ext>
+            </a:extLst>
+          </p:cNvPr>
+          <p:cNvSpPr>
+            <a:spLocks noGrp="1"/>
+          </p:cNvSpPr>
+          <p:nvPr>
+            <p:ph idx="13" sz="quarter" type="body"/>
+          </p:nvPr>
+        </p:nvSpPr>
+        <p:spPr/>
+        <p:txBody>
+          <a:bodyPr/>
+          <a:lstStyle/>
+          <a:p>
+            <a:pPr lvl="0" indent="0" marL="0">
+              <a:buNone/>
+            </a:pPr>
+            <a:r>
+              <a:rPr/>
+              <a:t>This </a:t>
+            </a:r>
+            <a:r>
+              <a:rPr b="1"/>
+              <a:t>monthly</a:t>
+            </a:r>
+            <a:r>
+              <a:rPr/>
+              <a:t> data at </a:t>
+            </a:r>
+            <a:r>
+              <a:rPr b="1"/>
+              <a:t>provider level</a:t>
+            </a:r>
+            <a:r>
+              <a:rPr/>
+              <a:t> is from published RTT waiting times dataset (via UDAL).</a:t>
+            </a:r>
+          </a:p>
+          <a:p>
+            <a:pPr lvl="0" indent="0" marL="0">
+              <a:buNone/>
+            </a:pPr>
+            <a:r>
+              <a:rPr/>
+              <a:t>The median referral to treatment waiting time (in weeks) significantly decreased at 2/5 sites (Royal Liverpool and Peterborough) and was unchanged at 2/5 sites (Papworth and Clatterbridge) and increased at Tunbridge Wells.</a:t>
+            </a:r>
+          </a:p>
+        </p:txBody>
+      </p:sp>
+      <p:pic>
+        <p:nvPicPr>
+          <p:cNvPr descr="NHP_SBR-impacts_2024_files/figure-pptx/cia_wait-1.png" id="0" name="Picture 1"/>
+          <p:cNvPicPr>
+            <a:picLocks noGrp="1" noChangeAspect="1"/>
+          </p:cNvPicPr>
+          <p:nvPr/>
+        </p:nvPicPr>
+        <p:blipFill>
+          <a:blip r:embed="rId2"/>
+          <a:stretch>
+            <a:fillRect/>
+          </a:stretch>
+        </p:blipFill>
+        <p:spPr bwMode="auto">
+          <a:xfrm>
+            <a:off x="4127500" y="1930400"/>
+            <a:ext cx="7010400" cy="3505200"/>
+          </a:xfrm>
+          <a:prstGeom prst="rect">
+            <a:avLst/>
+          </a:prstGeom>
+          <a:noFill/>
+          <a:ln w="9525">
+            <a:noFill/>
+            <a:headEnd/>
+            <a:tailEnd/>
+          </a:ln>
+        </p:spPr>
+      </p:pic>
     </p:spTree>
   </p:cSld>
 </p:sld>
@@ -5048,8 +5385,8 @@
         </p:nvSpPr>
         <p:spPr>
           <a:xfrm>
-            <a:off x="457199" y="4755350"/>
-            <a:ext cx="7772400" cy="1218369"/>
+            <a:off x="457199" y="4665306"/>
+            <a:ext cx="7772400" cy="1308413"/>
           </a:xfrm>
         </p:spPr>
         <p:txBody>
@@ -5061,11 +5398,1219 @@
             </a:pPr>
             <a:r>
               <a:rPr/>
-              <a:t>Introduction, approach and summary</a:t>
-            </a:r>
-          </a:p>
-        </p:txBody>
-      </p:sp>
+              <a:t>1. Introduction, approach, summary and recommendations</a:t>
+            </a:r>
+          </a:p>
+        </p:txBody>
+      </p:sp>
+    </p:spTree>
+  </p:cSld>
+</p:sld>
+</file>
+
+<file path=ppt/slides/slide20.xml><?xml version="1.0" encoding="utf-8"?>
+<p:sld xmlns:a="http://schemas.openxmlformats.org/drawingml/2006/main" xmlns:r="http://schemas.openxmlformats.org/officeDocument/2006/relationships" xmlns:p="http://schemas.openxmlformats.org/presentationml/2006/main">
+  <p:cSld>
+    <p:spTree>
+      <p:nvGrpSpPr>
+        <p:cNvPr id="1" name=""/>
+        <p:cNvGrpSpPr/>
+        <p:nvPr/>
+      </p:nvGrpSpPr>
+      <p:grpSpPr>
+        <a:xfrm>
+          <a:off x="0" y="0"/>
+          <a:ext cx="0" cy="0"/>
+          <a:chOff x="0" y="0"/>
+          <a:chExt cx="0" cy="0"/>
+        </a:xfrm>
+      </p:grpSpPr>
+      <p:sp>
+        <p:nvSpPr>
+          <p:cNvPr id="2" name="Title 1"/>
+          <p:cNvSpPr>
+            <a:spLocks noGrp="1"/>
+          </p:cNvSpPr>
+          <p:nvPr>
+            <p:ph hasCustomPrompt="1" type="title"/>
+          </p:nvPr>
+        </p:nvSpPr>
+        <p:spPr>
+          <a:xfrm>
+            <a:off x="909829" y="438150"/>
+            <a:ext cx="8434196" cy="914400"/>
+          </a:xfrm>
+        </p:spPr>
+        <p:txBody>
+          <a:bodyPr/>
+          <a:lstStyle/>
+          <a:p>
+            <a:pPr lvl="0" indent="0" marL="0">
+              <a:buNone/>
+            </a:pPr>
+            <a:r>
+              <a:rPr/>
+              <a:t>5.3 Bed Occupancy</a:t>
+            </a:r>
+          </a:p>
+        </p:txBody>
+      </p:sp>
+      <p:sp>
+        <p:nvSpPr>
+          <p:cNvPr id="7" name="Text Placeholder 6">
+            <a:extLst>
+              <a:ext uri="{FF2B5EF4-FFF2-40B4-BE49-F238E27FC236}">
+                <a16:creationId xmlns:a16="http://schemas.microsoft.com/office/drawing/2014/main" id="{DE622849-4EA7-24AE-DD96-E693EAA81594}"/>
+              </a:ext>
+            </a:extLst>
+          </p:cNvPr>
+          <p:cNvSpPr>
+            <a:spLocks noGrp="1"/>
+          </p:cNvSpPr>
+          <p:nvPr>
+            <p:ph idx="13" sz="quarter" type="body"/>
+          </p:nvPr>
+        </p:nvSpPr>
+        <p:spPr/>
+        <p:txBody>
+          <a:bodyPr/>
+          <a:lstStyle/>
+          <a:p>
+            <a:pPr lvl="0" indent="0" marL="0">
+              <a:buNone/>
+            </a:pPr>
+            <a:r>
+              <a:rPr/>
+              <a:t>This </a:t>
+            </a:r>
+            <a:r>
+              <a:rPr b="1"/>
+              <a:t>quarterly</a:t>
+            </a:r>
+            <a:r>
+              <a:rPr/>
+              <a:t> data at </a:t>
+            </a:r>
+            <a:r>
+              <a:rPr b="1"/>
+              <a:t>provider level</a:t>
+            </a:r>
+            <a:r>
+              <a:rPr/>
+              <a:t> is from published KH03 bed returns (via UDAL).</a:t>
+            </a:r>
+          </a:p>
+          <a:p>
+            <a:pPr lvl="0" indent="0" marL="0">
+              <a:buNone/>
+            </a:pPr>
+            <a:r>
+              <a:rPr/>
+              <a:t>Bed occupancy is measured quarterly and is only available at a Provider level. The percentage of available beds occupied significantly increased at 2/4 sites (Clatterbridge and Southmead) and was unchanged at 2/4 (Royal Liverpool and and Chase Farm).</a:t>
+            </a:r>
+          </a:p>
+        </p:txBody>
+      </p:sp>
+      <p:pic>
+        <p:nvPicPr>
+          <p:cNvPr descr="NHP_SBR-impacts_2024_files/figure-pptx/cia_bedocc-1.png" id="0" name="Picture 1"/>
+          <p:cNvPicPr>
+            <a:picLocks noGrp="1" noChangeAspect="1"/>
+          </p:cNvPicPr>
+          <p:nvPr/>
+        </p:nvPicPr>
+        <p:blipFill>
+          <a:blip r:embed="rId2"/>
+          <a:stretch>
+            <a:fillRect/>
+          </a:stretch>
+        </p:blipFill>
+        <p:spPr bwMode="auto">
+          <a:xfrm>
+            <a:off x="4127500" y="1930400"/>
+            <a:ext cx="7010400" cy="3505200"/>
+          </a:xfrm>
+          <a:prstGeom prst="rect">
+            <a:avLst/>
+          </a:prstGeom>
+          <a:noFill/>
+          <a:ln w="9525">
+            <a:noFill/>
+            <a:headEnd/>
+            <a:tailEnd/>
+          </a:ln>
+        </p:spPr>
+      </p:pic>
+    </p:spTree>
+  </p:cSld>
+</p:sld>
+</file>
+
+<file path=ppt/slides/slide21.xml><?xml version="1.0" encoding="utf-8"?>
+<p:sld xmlns:a="http://schemas.openxmlformats.org/drawingml/2006/main" xmlns:r="http://schemas.openxmlformats.org/officeDocument/2006/relationships" xmlns:p="http://schemas.openxmlformats.org/presentationml/2006/main">
+  <p:cSld>
+    <p:spTree>
+      <p:nvGrpSpPr>
+        <p:cNvPr id="1" name=""/>
+        <p:cNvGrpSpPr/>
+        <p:nvPr/>
+      </p:nvGrpSpPr>
+      <p:grpSpPr>
+        <a:xfrm>
+          <a:off x="0" y="0"/>
+          <a:ext cx="0" cy="0"/>
+          <a:chOff x="0" y="0"/>
+          <a:chExt cx="0" cy="0"/>
+        </a:xfrm>
+      </p:grpSpPr>
+      <p:sp>
+        <p:nvSpPr>
+          <p:cNvPr id="2" name="Title 1"/>
+          <p:cNvSpPr>
+            <a:spLocks noGrp="1"/>
+          </p:cNvSpPr>
+          <p:nvPr>
+            <p:ph hasCustomPrompt="1" type="title"/>
+          </p:nvPr>
+        </p:nvSpPr>
+        <p:spPr>
+          <a:xfrm>
+            <a:off x="909829" y="438150"/>
+            <a:ext cx="8434196" cy="914400"/>
+          </a:xfrm>
+        </p:spPr>
+        <p:txBody>
+          <a:bodyPr/>
+          <a:lstStyle/>
+          <a:p>
+            <a:pPr lvl="0" indent="0" marL="0">
+              <a:buNone/>
+            </a:pPr>
+            <a:r>
+              <a:rPr/>
+              <a:t>5.4 Emergency readmissions</a:t>
+            </a:r>
+          </a:p>
+        </p:txBody>
+      </p:sp>
+      <p:sp>
+        <p:nvSpPr>
+          <p:cNvPr id="7" name="Text Placeholder 6">
+            <a:extLst>
+              <a:ext uri="{FF2B5EF4-FFF2-40B4-BE49-F238E27FC236}">
+                <a16:creationId xmlns:a16="http://schemas.microsoft.com/office/drawing/2014/main" id="{DE622849-4EA7-24AE-DD96-E693EAA81594}"/>
+              </a:ext>
+            </a:extLst>
+          </p:cNvPr>
+          <p:cNvSpPr>
+            <a:spLocks noGrp="1"/>
+          </p:cNvSpPr>
+          <p:nvPr>
+            <p:ph idx="13" sz="quarter" type="body"/>
+          </p:nvPr>
+        </p:nvSpPr>
+        <p:spPr/>
+        <p:txBody>
+          <a:bodyPr/>
+          <a:lstStyle/>
+          <a:p>
+            <a:pPr lvl="0" indent="0" marL="0">
+              <a:buNone/>
+            </a:pPr>
+            <a:r>
+              <a:rPr/>
+              <a:t>This </a:t>
+            </a:r>
+            <a:r>
+              <a:rPr b="1"/>
+              <a:t>monthly</a:t>
+            </a:r>
+            <a:r>
+              <a:rPr/>
+              <a:t> data at </a:t>
+            </a:r>
+            <a:r>
+              <a:rPr b="1"/>
+              <a:t>site level</a:t>
+            </a:r>
+            <a:r>
+              <a:rPr/>
+              <a:t> is derived from SUS admitted patient care records.</a:t>
+            </a:r>
+          </a:p>
+          <a:p>
+            <a:pPr lvl="0" indent="0" marL="0">
+              <a:buNone/>
+            </a:pPr>
+            <a:r>
+              <a:rPr/>
+              <a:t>The percentage of admissions that are emergency readmissions &lt; 30 days of discharge significantly decreased at 3/7 sites (Tunbridge Wells, Peterborough and Clatterbridge) and was unchanged at the remaining 4/7 sites.</a:t>
+            </a:r>
+          </a:p>
+        </p:txBody>
+      </p:sp>
+      <p:pic>
+        <p:nvPicPr>
+          <p:cNvPr descr="NHP_SBR-impacts_2024_files/figure-pptx/cia_emergreadm-1.png" id="0" name="Picture 1"/>
+          <p:cNvPicPr>
+            <a:picLocks noGrp="1" noChangeAspect="1"/>
+          </p:cNvPicPr>
+          <p:nvPr/>
+        </p:nvPicPr>
+        <p:blipFill>
+          <a:blip r:embed="rId2"/>
+          <a:stretch>
+            <a:fillRect/>
+          </a:stretch>
+        </p:blipFill>
+        <p:spPr bwMode="auto">
+          <a:xfrm>
+            <a:off x="4127500" y="1930400"/>
+            <a:ext cx="7010400" cy="3505200"/>
+          </a:xfrm>
+          <a:prstGeom prst="rect">
+            <a:avLst/>
+          </a:prstGeom>
+          <a:noFill/>
+          <a:ln w="9525">
+            <a:noFill/>
+            <a:headEnd/>
+            <a:tailEnd/>
+          </a:ln>
+        </p:spPr>
+      </p:pic>
+    </p:spTree>
+  </p:cSld>
+</p:sld>
+</file>
+
+<file path=ppt/slides/slide22.xml><?xml version="1.0" encoding="utf-8"?>
+<p:sld xmlns:a="http://schemas.openxmlformats.org/drawingml/2006/main" xmlns:r="http://schemas.openxmlformats.org/officeDocument/2006/relationships" xmlns:p="http://schemas.openxmlformats.org/presentationml/2006/main">
+  <p:cSld>
+    <p:spTree>
+      <p:nvGrpSpPr>
+        <p:cNvPr id="1" name=""/>
+        <p:cNvGrpSpPr/>
+        <p:nvPr/>
+      </p:nvGrpSpPr>
+      <p:grpSpPr>
+        <a:xfrm>
+          <a:off x="0" y="0"/>
+          <a:ext cx="0" cy="0"/>
+          <a:chOff x="0" y="0"/>
+          <a:chExt cx="0" cy="0"/>
+        </a:xfrm>
+      </p:grpSpPr>
+      <p:sp>
+        <p:nvSpPr>
+          <p:cNvPr id="2" name="Title 1"/>
+          <p:cNvSpPr>
+            <a:spLocks noGrp="1"/>
+          </p:cNvSpPr>
+          <p:nvPr>
+            <p:ph hasCustomPrompt="1" type="title"/>
+          </p:nvPr>
+        </p:nvSpPr>
+        <p:spPr>
+          <a:xfrm>
+            <a:off x="909829" y="438150"/>
+            <a:ext cx="8434196" cy="914400"/>
+          </a:xfrm>
+        </p:spPr>
+        <p:txBody>
+          <a:bodyPr/>
+          <a:lstStyle/>
+          <a:p>
+            <a:pPr lvl="0" indent="0" marL="0">
+              <a:buNone/>
+            </a:pPr>
+            <a:r>
+              <a:rPr/>
+              <a:t>5.5 Cleaning costs</a:t>
+            </a:r>
+          </a:p>
+        </p:txBody>
+      </p:sp>
+      <p:sp>
+        <p:nvSpPr>
+          <p:cNvPr id="7" name="Text Placeholder 6">
+            <a:extLst>
+              <a:ext uri="{FF2B5EF4-FFF2-40B4-BE49-F238E27FC236}">
+                <a16:creationId xmlns:a16="http://schemas.microsoft.com/office/drawing/2014/main" id="{DE622849-4EA7-24AE-DD96-E693EAA81594}"/>
+              </a:ext>
+            </a:extLst>
+          </p:cNvPr>
+          <p:cNvSpPr>
+            <a:spLocks noGrp="1"/>
+          </p:cNvSpPr>
+          <p:nvPr>
+            <p:ph idx="13" sz="quarter" type="body"/>
+          </p:nvPr>
+        </p:nvSpPr>
+        <p:spPr/>
+        <p:txBody>
+          <a:bodyPr/>
+          <a:lstStyle/>
+          <a:p>
+            <a:pPr lvl="0" indent="0" marL="0">
+              <a:buNone/>
+            </a:pPr>
+            <a:r>
+              <a:rPr/>
+              <a:t>This </a:t>
+            </a:r>
+            <a:r>
+              <a:rPr b="1"/>
+              <a:t>annual</a:t>
+            </a:r>
+            <a:r>
+              <a:rPr/>
+              <a:t> data at </a:t>
+            </a:r>
+            <a:r>
+              <a:rPr b="1"/>
+              <a:t>site level</a:t>
+            </a:r>
+            <a:r>
+              <a:rPr/>
+              <a:t> is taken from published Estates Return Information Collection (ERIC) datasets.</a:t>
+            </a:r>
+          </a:p>
+          <a:p>
+            <a:pPr lvl="0" indent="0" marL="0">
+              <a:buNone/>
+            </a:pPr>
+            <a:r>
+              <a:rPr/>
+              <a:t>The cleaning costs (in £) per square metre of occupied floor space significantly increased at 1/3 sites (Royal Liverpool) but decreased at 2/3 sites (Clatterbridge and Papworth).</a:t>
+            </a:r>
+          </a:p>
+        </p:txBody>
+      </p:sp>
+      <p:pic>
+        <p:nvPicPr>
+          <p:cNvPr descr="NHP_SBR-impacts_2024_files/figure-pptx/cia_cleaning-1.png" id="0" name="Picture 1"/>
+          <p:cNvPicPr>
+            <a:picLocks noGrp="1" noChangeAspect="1"/>
+          </p:cNvPicPr>
+          <p:nvPr/>
+        </p:nvPicPr>
+        <p:blipFill>
+          <a:blip r:embed="rId2"/>
+          <a:stretch>
+            <a:fillRect/>
+          </a:stretch>
+        </p:blipFill>
+        <p:spPr bwMode="auto">
+          <a:xfrm>
+            <a:off x="4127500" y="1930400"/>
+            <a:ext cx="7010400" cy="3505200"/>
+          </a:xfrm>
+          <a:prstGeom prst="rect">
+            <a:avLst/>
+          </a:prstGeom>
+          <a:noFill/>
+          <a:ln w="9525">
+            <a:noFill/>
+            <a:headEnd/>
+            <a:tailEnd/>
+          </a:ln>
+        </p:spPr>
+      </p:pic>
+    </p:spTree>
+  </p:cSld>
+</p:sld>
+</file>
+
+<file path=ppt/slides/slide23.xml><?xml version="1.0" encoding="utf-8"?>
+<p:sld xmlns:a="http://schemas.openxmlformats.org/drawingml/2006/main" xmlns:r="http://schemas.openxmlformats.org/officeDocument/2006/relationships" xmlns:p="http://schemas.openxmlformats.org/presentationml/2006/main">
+  <p:cSld>
+    <p:spTree>
+      <p:nvGrpSpPr>
+        <p:cNvPr id="1" name=""/>
+        <p:cNvGrpSpPr/>
+        <p:nvPr/>
+      </p:nvGrpSpPr>
+      <p:grpSpPr>
+        <a:xfrm>
+          <a:off x="0" y="0"/>
+          <a:ext cx="0" cy="0"/>
+          <a:chOff x="0" y="0"/>
+          <a:chExt cx="0" cy="0"/>
+        </a:xfrm>
+      </p:grpSpPr>
+      <p:sp>
+        <p:nvSpPr>
+          <p:cNvPr id="2" name="Title 1"/>
+          <p:cNvSpPr>
+            <a:spLocks noGrp="1"/>
+          </p:cNvSpPr>
+          <p:nvPr>
+            <p:ph hasCustomPrompt="1" type="ctrTitle"/>
+          </p:nvPr>
+        </p:nvSpPr>
+        <p:spPr>
+          <a:xfrm>
+            <a:off x="457199" y="4665306"/>
+            <a:ext cx="7772400" cy="1308413"/>
+          </a:xfrm>
+        </p:spPr>
+        <p:txBody>
+          <a:bodyPr/>
+          <a:lstStyle/>
+          <a:p>
+            <a:pPr lvl="0" indent="0" marL="0">
+              <a:buNone/>
+            </a:pPr>
+            <a:r>
+              <a:rPr/>
+              <a:t>6. Main results - Health and Safety</a:t>
+            </a:r>
+          </a:p>
+        </p:txBody>
+      </p:sp>
+    </p:spTree>
+  </p:cSld>
+</p:sld>
+</file>
+
+<file path=ppt/slides/slide24.xml><?xml version="1.0" encoding="utf-8"?>
+<p:sld xmlns:a="http://schemas.openxmlformats.org/drawingml/2006/main" xmlns:r="http://schemas.openxmlformats.org/officeDocument/2006/relationships" xmlns:p="http://schemas.openxmlformats.org/presentationml/2006/main">
+  <p:cSld>
+    <p:spTree>
+      <p:nvGrpSpPr>
+        <p:cNvPr id="1" name=""/>
+        <p:cNvGrpSpPr/>
+        <p:nvPr/>
+      </p:nvGrpSpPr>
+      <p:grpSpPr>
+        <a:xfrm>
+          <a:off x="0" y="0"/>
+          <a:ext cx="0" cy="0"/>
+          <a:chOff x="0" y="0"/>
+          <a:chExt cx="0" cy="0"/>
+        </a:xfrm>
+      </p:grpSpPr>
+      <p:sp>
+        <p:nvSpPr>
+          <p:cNvPr id="2" name="Title 1"/>
+          <p:cNvSpPr>
+            <a:spLocks noGrp="1"/>
+          </p:cNvSpPr>
+          <p:nvPr>
+            <p:ph hasCustomPrompt="1" type="title"/>
+          </p:nvPr>
+        </p:nvSpPr>
+        <p:spPr>
+          <a:xfrm>
+            <a:off x="909829" y="438150"/>
+            <a:ext cx="8434196" cy="914400"/>
+          </a:xfrm>
+        </p:spPr>
+        <p:txBody>
+          <a:bodyPr/>
+          <a:lstStyle/>
+          <a:p>
+            <a:pPr lvl="0" indent="0" marL="0">
+              <a:buNone/>
+            </a:pPr>
+            <a:r>
+              <a:rPr/>
+              <a:t>6.1 In-hospital deaths</a:t>
+            </a:r>
+          </a:p>
+        </p:txBody>
+      </p:sp>
+      <p:sp>
+        <p:nvSpPr>
+          <p:cNvPr id="7" name="Text Placeholder 6">
+            <a:extLst>
+              <a:ext uri="{FF2B5EF4-FFF2-40B4-BE49-F238E27FC236}">
+                <a16:creationId xmlns:a16="http://schemas.microsoft.com/office/drawing/2014/main" id="{DE622849-4EA7-24AE-DD96-E693EAA81594}"/>
+              </a:ext>
+            </a:extLst>
+          </p:cNvPr>
+          <p:cNvSpPr>
+            <a:spLocks noGrp="1"/>
+          </p:cNvSpPr>
+          <p:nvPr>
+            <p:ph idx="13" sz="quarter" type="body"/>
+          </p:nvPr>
+        </p:nvSpPr>
+        <p:spPr/>
+        <p:txBody>
+          <a:bodyPr/>
+          <a:lstStyle/>
+          <a:p>
+            <a:pPr lvl="0" indent="0" marL="0">
+              <a:buNone/>
+            </a:pPr>
+            <a:r>
+              <a:rPr/>
+              <a:t>This </a:t>
+            </a:r>
+            <a:r>
+              <a:rPr b="1"/>
+              <a:t>monthly</a:t>
+            </a:r>
+            <a:r>
+              <a:rPr/>
+              <a:t> data at </a:t>
+            </a:r>
+            <a:r>
+              <a:rPr b="1"/>
+              <a:t>site level</a:t>
+            </a:r>
+            <a:r>
+              <a:rPr/>
+              <a:t> is derived from SUS admitted patient care records.</a:t>
+            </a:r>
+          </a:p>
+          <a:p>
+            <a:pPr lvl="0" indent="0" marL="0">
+              <a:buNone/>
+            </a:pPr>
+            <a:r>
+              <a:rPr/>
+              <a:t>The rate of in-hospital deaths (number per 1,000 discharges) significantly decreased at 1/5 sites (Peterborough), and was unchanged at 4/5 sites (Royal Liverpool, Tunbridge Wells, Clatterbridge and Southmead).</a:t>
+            </a:r>
+          </a:p>
+        </p:txBody>
+      </p:sp>
+      <p:pic>
+        <p:nvPicPr>
+          <p:cNvPr descr="NHP_SBR-impacts_2024_files/figure-pptx/cia_mort-1.png" id="0" name="Picture 1"/>
+          <p:cNvPicPr>
+            <a:picLocks noGrp="1" noChangeAspect="1"/>
+          </p:cNvPicPr>
+          <p:nvPr/>
+        </p:nvPicPr>
+        <p:blipFill>
+          <a:blip r:embed="rId2"/>
+          <a:stretch>
+            <a:fillRect/>
+          </a:stretch>
+        </p:blipFill>
+        <p:spPr bwMode="auto">
+          <a:xfrm>
+            <a:off x="4127500" y="1930400"/>
+            <a:ext cx="7010400" cy="3505200"/>
+          </a:xfrm>
+          <a:prstGeom prst="rect">
+            <a:avLst/>
+          </a:prstGeom>
+          <a:noFill/>
+          <a:ln w="9525">
+            <a:noFill/>
+            <a:headEnd/>
+            <a:tailEnd/>
+          </a:ln>
+        </p:spPr>
+      </p:pic>
+    </p:spTree>
+  </p:cSld>
+</p:sld>
+</file>
+
+<file path=ppt/slides/slide25.xml><?xml version="1.0" encoding="utf-8"?>
+<p:sld xmlns:a="http://schemas.openxmlformats.org/drawingml/2006/main" xmlns:r="http://schemas.openxmlformats.org/officeDocument/2006/relationships" xmlns:p="http://schemas.openxmlformats.org/presentationml/2006/main">
+  <p:cSld>
+    <p:spTree>
+      <p:nvGrpSpPr>
+        <p:cNvPr id="1" name=""/>
+        <p:cNvGrpSpPr/>
+        <p:nvPr/>
+      </p:nvGrpSpPr>
+      <p:grpSpPr>
+        <a:xfrm>
+          <a:off x="0" y="0"/>
+          <a:ext cx="0" cy="0"/>
+          <a:chOff x="0" y="0"/>
+          <a:chExt cx="0" cy="0"/>
+        </a:xfrm>
+      </p:grpSpPr>
+      <p:sp>
+        <p:nvSpPr>
+          <p:cNvPr id="2" name="Title 1"/>
+          <p:cNvSpPr>
+            <a:spLocks noGrp="1"/>
+          </p:cNvSpPr>
+          <p:nvPr>
+            <p:ph hasCustomPrompt="1" type="title"/>
+          </p:nvPr>
+        </p:nvSpPr>
+        <p:spPr>
+          <a:xfrm>
+            <a:off x="909829" y="438150"/>
+            <a:ext cx="8434196" cy="914400"/>
+          </a:xfrm>
+        </p:spPr>
+        <p:txBody>
+          <a:bodyPr/>
+          <a:lstStyle/>
+          <a:p>
+            <a:pPr lvl="0" indent="0" marL="0">
+              <a:buNone/>
+            </a:pPr>
+            <a:r>
+              <a:rPr/>
+              <a:t>6.2 In-hospital falls and injuries</a:t>
+            </a:r>
+          </a:p>
+        </p:txBody>
+      </p:sp>
+      <p:sp>
+        <p:nvSpPr>
+          <p:cNvPr id="7" name="Text Placeholder 6">
+            <a:extLst>
+              <a:ext uri="{FF2B5EF4-FFF2-40B4-BE49-F238E27FC236}">
+                <a16:creationId xmlns:a16="http://schemas.microsoft.com/office/drawing/2014/main" id="{DE622849-4EA7-24AE-DD96-E693EAA81594}"/>
+              </a:ext>
+            </a:extLst>
+          </p:cNvPr>
+          <p:cNvSpPr>
+            <a:spLocks noGrp="1"/>
+          </p:cNvSpPr>
+          <p:nvPr>
+            <p:ph idx="13" sz="quarter" type="body"/>
+          </p:nvPr>
+        </p:nvSpPr>
+        <p:spPr/>
+        <p:txBody>
+          <a:bodyPr/>
+          <a:lstStyle/>
+          <a:p>
+            <a:pPr lvl="0" indent="0" marL="0">
+              <a:buNone/>
+            </a:pPr>
+            <a:r>
+              <a:rPr/>
+              <a:t>This </a:t>
+            </a:r>
+            <a:r>
+              <a:rPr b="1"/>
+              <a:t>monthly</a:t>
+            </a:r>
+            <a:r>
+              <a:rPr/>
+              <a:t> data at </a:t>
+            </a:r>
+            <a:r>
+              <a:rPr b="1"/>
+              <a:t>site level</a:t>
+            </a:r>
+            <a:r>
+              <a:rPr/>
+              <a:t> is derived from SUS admitted patient care records.</a:t>
+            </a:r>
+          </a:p>
+          <a:p>
+            <a:pPr lvl="0" indent="0" marL="0">
+              <a:buNone/>
+            </a:pPr>
+            <a:r>
+              <a:rPr/>
+              <a:t>The rate of in-hospital falls and injuries (% of spells) significantly decreased at 1/4 sites (Peterborough), and was unchanged at 3/4 sites (Royal Liverpool, Tunbridge Wells and Southmead).</a:t>
+            </a:r>
+          </a:p>
+        </p:txBody>
+      </p:sp>
+      <p:pic>
+        <p:nvPicPr>
+          <p:cNvPr descr="NHP_SBR-impacts_2024_files/figure-pptx/cia_falls-1.png" id="0" name="Picture 1"/>
+          <p:cNvPicPr>
+            <a:picLocks noGrp="1" noChangeAspect="1"/>
+          </p:cNvPicPr>
+          <p:nvPr/>
+        </p:nvPicPr>
+        <p:blipFill>
+          <a:blip r:embed="rId2"/>
+          <a:stretch>
+            <a:fillRect/>
+          </a:stretch>
+        </p:blipFill>
+        <p:spPr bwMode="auto">
+          <a:xfrm>
+            <a:off x="4127500" y="1930400"/>
+            <a:ext cx="7010400" cy="3505200"/>
+          </a:xfrm>
+          <a:prstGeom prst="rect">
+            <a:avLst/>
+          </a:prstGeom>
+          <a:noFill/>
+          <a:ln w="9525">
+            <a:noFill/>
+            <a:headEnd/>
+            <a:tailEnd/>
+          </a:ln>
+        </p:spPr>
+      </p:pic>
+    </p:spTree>
+  </p:cSld>
+</p:sld>
+</file>
+
+<file path=ppt/slides/slide26.xml><?xml version="1.0" encoding="utf-8"?>
+<p:sld xmlns:a="http://schemas.openxmlformats.org/drawingml/2006/main" xmlns:r="http://schemas.openxmlformats.org/officeDocument/2006/relationships" xmlns:p="http://schemas.openxmlformats.org/presentationml/2006/main">
+  <p:cSld>
+    <p:spTree>
+      <p:nvGrpSpPr>
+        <p:cNvPr id="1" name=""/>
+        <p:cNvGrpSpPr/>
+        <p:nvPr/>
+      </p:nvGrpSpPr>
+      <p:grpSpPr>
+        <a:xfrm>
+          <a:off x="0" y="0"/>
+          <a:ext cx="0" cy="0"/>
+          <a:chOff x="0" y="0"/>
+          <a:chExt cx="0" cy="0"/>
+        </a:xfrm>
+      </p:grpSpPr>
+      <p:sp>
+        <p:nvSpPr>
+          <p:cNvPr id="2" name="Title 1"/>
+          <p:cNvSpPr>
+            <a:spLocks noGrp="1"/>
+          </p:cNvSpPr>
+          <p:nvPr>
+            <p:ph hasCustomPrompt="1" type="title"/>
+          </p:nvPr>
+        </p:nvSpPr>
+        <p:spPr>
+          <a:xfrm>
+            <a:off x="909829" y="438150"/>
+            <a:ext cx="8434196" cy="914400"/>
+          </a:xfrm>
+        </p:spPr>
+        <p:txBody>
+          <a:bodyPr/>
+          <a:lstStyle/>
+          <a:p>
+            <a:pPr lvl="0" indent="0" marL="0">
+              <a:buNone/>
+            </a:pPr>
+            <a:r>
+              <a:rPr/>
+              <a:t>6.3 Healthcare Acquired Infections (HCAI) - clostridium dificile</a:t>
+            </a:r>
+          </a:p>
+        </p:txBody>
+      </p:sp>
+      <p:sp>
+        <p:nvSpPr>
+          <p:cNvPr id="7" name="Text Placeholder 6">
+            <a:extLst>
+              <a:ext uri="{FF2B5EF4-FFF2-40B4-BE49-F238E27FC236}">
+                <a16:creationId xmlns:a16="http://schemas.microsoft.com/office/drawing/2014/main" id="{DE622849-4EA7-24AE-DD96-E693EAA81594}"/>
+              </a:ext>
+            </a:extLst>
+          </p:cNvPr>
+          <p:cNvSpPr>
+            <a:spLocks noGrp="1"/>
+          </p:cNvSpPr>
+          <p:nvPr>
+            <p:ph idx="13" sz="quarter" type="body"/>
+          </p:nvPr>
+        </p:nvSpPr>
+        <p:spPr/>
+        <p:txBody>
+          <a:bodyPr/>
+          <a:lstStyle/>
+          <a:p>
+            <a:pPr lvl="0" indent="0" marL="0">
+              <a:buNone/>
+            </a:pPr>
+            <a:r>
+              <a:rPr/>
+              <a:t>This </a:t>
+            </a:r>
+            <a:r>
+              <a:rPr b="1"/>
+              <a:t>monthly</a:t>
+            </a:r>
+            <a:r>
+              <a:rPr/>
+              <a:t> data at </a:t>
+            </a:r>
+            <a:r>
+              <a:rPr b="1"/>
+              <a:t>provider level</a:t>
+            </a:r>
+            <a:r>
+              <a:rPr/>
+              <a:t> is taken from published UKHSA surveillance data (via UDAL).</a:t>
+            </a:r>
+          </a:p>
+          <a:p>
+            <a:pPr lvl="0" indent="0" marL="0">
+              <a:buNone/>
+            </a:pPr>
+            <a:r>
+              <a:rPr/>
+              <a:t>The rate of healthcare acquired C. difficile infections (cases per 10,000 bed days) decreased at 2/3 sites (Chase Farm and Southmead) but was unchanged at Royal Liverpool.</a:t>
+            </a:r>
+          </a:p>
+        </p:txBody>
+      </p:sp>
+      <p:pic>
+        <p:nvPicPr>
+          <p:cNvPr descr="NHP_SBR-impacts_2024_files/figure-pptx/cia_hcai-1.png" id="0" name="Picture 1"/>
+          <p:cNvPicPr>
+            <a:picLocks noGrp="1" noChangeAspect="1"/>
+          </p:cNvPicPr>
+          <p:nvPr/>
+        </p:nvPicPr>
+        <p:blipFill>
+          <a:blip r:embed="rId2"/>
+          <a:stretch>
+            <a:fillRect/>
+          </a:stretch>
+        </p:blipFill>
+        <p:spPr bwMode="auto">
+          <a:xfrm>
+            <a:off x="4127500" y="1930400"/>
+            <a:ext cx="7010400" cy="3505200"/>
+          </a:xfrm>
+          <a:prstGeom prst="rect">
+            <a:avLst/>
+          </a:prstGeom>
+          <a:noFill/>
+          <a:ln w="9525">
+            <a:noFill/>
+            <a:headEnd/>
+            <a:tailEnd/>
+          </a:ln>
+        </p:spPr>
+      </p:pic>
+    </p:spTree>
+  </p:cSld>
+</p:sld>
+</file>
+
+<file path=ppt/slides/slide27.xml><?xml version="1.0" encoding="utf-8"?>
+<p:sld xmlns:a="http://schemas.openxmlformats.org/drawingml/2006/main" xmlns:r="http://schemas.openxmlformats.org/officeDocument/2006/relationships" xmlns:p="http://schemas.openxmlformats.org/presentationml/2006/main">
+  <p:cSld>
+    <p:spTree>
+      <p:nvGrpSpPr>
+        <p:cNvPr id="1" name=""/>
+        <p:cNvGrpSpPr/>
+        <p:nvPr/>
+      </p:nvGrpSpPr>
+      <p:grpSpPr>
+        <a:xfrm>
+          <a:off x="0" y="0"/>
+          <a:ext cx="0" cy="0"/>
+          <a:chOff x="0" y="0"/>
+          <a:chExt cx="0" cy="0"/>
+        </a:xfrm>
+      </p:grpSpPr>
+      <p:sp>
+        <p:nvSpPr>
+          <p:cNvPr id="2" name="Title 1"/>
+          <p:cNvSpPr>
+            <a:spLocks noGrp="1"/>
+          </p:cNvSpPr>
+          <p:nvPr>
+            <p:ph hasCustomPrompt="1" type="ctrTitle"/>
+          </p:nvPr>
+        </p:nvSpPr>
+        <p:spPr>
+          <a:xfrm>
+            <a:off x="457199" y="4665306"/>
+            <a:ext cx="7772400" cy="1308413"/>
+          </a:xfrm>
+        </p:spPr>
+        <p:txBody>
+          <a:bodyPr/>
+          <a:lstStyle/>
+          <a:p>
+            <a:pPr lvl="0" indent="0" marL="0">
+              <a:buNone/>
+            </a:pPr>
+            <a:r>
+              <a:rPr/>
+              <a:t>7. Main results - Patient and Staff Experience</a:t>
+            </a:r>
+          </a:p>
+        </p:txBody>
+      </p:sp>
+    </p:spTree>
+  </p:cSld>
+</p:sld>
+</file>
+
+<file path=ppt/slides/slide28.xml><?xml version="1.0" encoding="utf-8"?>
+<p:sld xmlns:a="http://schemas.openxmlformats.org/drawingml/2006/main" xmlns:r="http://schemas.openxmlformats.org/officeDocument/2006/relationships" xmlns:p="http://schemas.openxmlformats.org/presentationml/2006/main">
+  <p:cSld>
+    <p:spTree>
+      <p:nvGrpSpPr>
+        <p:cNvPr id="1" name=""/>
+        <p:cNvGrpSpPr/>
+        <p:nvPr/>
+      </p:nvGrpSpPr>
+      <p:grpSpPr>
+        <a:xfrm>
+          <a:off x="0" y="0"/>
+          <a:ext cx="0" cy="0"/>
+          <a:chOff x="0" y="0"/>
+          <a:chExt cx="0" cy="0"/>
+        </a:xfrm>
+      </p:grpSpPr>
+      <p:sp>
+        <p:nvSpPr>
+          <p:cNvPr id="2" name="Title 1"/>
+          <p:cNvSpPr>
+            <a:spLocks noGrp="1"/>
+          </p:cNvSpPr>
+          <p:nvPr>
+            <p:ph hasCustomPrompt="1" type="title"/>
+          </p:nvPr>
+        </p:nvSpPr>
+        <p:spPr>
+          <a:xfrm>
+            <a:off x="909829" y="438150"/>
+            <a:ext cx="8434196" cy="914400"/>
+          </a:xfrm>
+        </p:spPr>
+        <p:txBody>
+          <a:bodyPr/>
+          <a:lstStyle/>
+          <a:p>
+            <a:pPr lvl="0" indent="0" marL="0">
+              <a:buNone/>
+            </a:pPr>
+            <a:r>
+              <a:rPr/>
+              <a:t>7.1 Family and Friends test</a:t>
+            </a:r>
+          </a:p>
+        </p:txBody>
+      </p:sp>
+      <p:sp>
+        <p:nvSpPr>
+          <p:cNvPr id="7" name="Text Placeholder 6">
+            <a:extLst>
+              <a:ext uri="{FF2B5EF4-FFF2-40B4-BE49-F238E27FC236}">
+                <a16:creationId xmlns:a16="http://schemas.microsoft.com/office/drawing/2014/main" id="{DE622849-4EA7-24AE-DD96-E693EAA81594}"/>
+              </a:ext>
+            </a:extLst>
+          </p:cNvPr>
+          <p:cNvSpPr>
+            <a:spLocks noGrp="1"/>
+          </p:cNvSpPr>
+          <p:nvPr>
+            <p:ph idx="13" sz="quarter" type="body"/>
+          </p:nvPr>
+        </p:nvSpPr>
+        <p:spPr/>
+        <p:txBody>
+          <a:bodyPr/>
+          <a:lstStyle/>
+          <a:p>
+            <a:pPr lvl="0" indent="0" marL="0">
+              <a:buNone/>
+            </a:pPr>
+            <a:r>
+              <a:rPr/>
+              <a:t>This </a:t>
+            </a:r>
+            <a:r>
+              <a:rPr b="1"/>
+              <a:t>monthly</a:t>
+            </a:r>
+            <a:r>
+              <a:rPr/>
+              <a:t> data at </a:t>
+            </a:r>
+            <a:r>
+              <a:rPr b="1"/>
+              <a:t>site level</a:t>
+            </a:r>
+            <a:r>
+              <a:rPr/>
+              <a:t> is taken from published NHS England data (via UDAL).</a:t>
+            </a:r>
+          </a:p>
+          <a:p>
+            <a:pPr lvl="0" indent="0" marL="0">
+              <a:buNone/>
+            </a:pPr>
+            <a:r>
+              <a:rPr/>
+              <a:t>The percentage of positive responses significantly decreased at 1/5 sites (Clatterbridge), increased at 1/5 sites (Papworth) and was unchanged at the other 3/5 sites (Royal Liverpool, Southmead and Chase Farm).</a:t>
+            </a:r>
+          </a:p>
+        </p:txBody>
+      </p:sp>
+      <p:pic>
+        <p:nvPicPr>
+          <p:cNvPr descr="NHP_SBR-impacts_2024_files/figure-pptx/cia_famfriend-1.png" id="0" name="Picture 1"/>
+          <p:cNvPicPr>
+            <a:picLocks noGrp="1" noChangeAspect="1"/>
+          </p:cNvPicPr>
+          <p:nvPr/>
+        </p:nvPicPr>
+        <p:blipFill>
+          <a:blip r:embed="rId2"/>
+          <a:stretch>
+            <a:fillRect/>
+          </a:stretch>
+        </p:blipFill>
+        <p:spPr bwMode="auto">
+          <a:xfrm>
+            <a:off x="4127500" y="1930400"/>
+            <a:ext cx="7010400" cy="3505200"/>
+          </a:xfrm>
+          <a:prstGeom prst="rect">
+            <a:avLst/>
+          </a:prstGeom>
+          <a:noFill/>
+          <a:ln w="9525">
+            <a:noFill/>
+            <a:headEnd/>
+            <a:tailEnd/>
+          </a:ln>
+        </p:spPr>
+      </p:pic>
+    </p:spTree>
+  </p:cSld>
+</p:sld>
+</file>
+
+<file path=ppt/slides/slide29.xml><?xml version="1.0" encoding="utf-8"?>
+<p:sld xmlns:a="http://schemas.openxmlformats.org/drawingml/2006/main" xmlns:r="http://schemas.openxmlformats.org/officeDocument/2006/relationships" xmlns:p="http://schemas.openxmlformats.org/presentationml/2006/main">
+  <p:cSld>
+    <p:spTree>
+      <p:nvGrpSpPr>
+        <p:cNvPr id="1" name=""/>
+        <p:cNvGrpSpPr/>
+        <p:nvPr/>
+      </p:nvGrpSpPr>
+      <p:grpSpPr>
+        <a:xfrm>
+          <a:off x="0" y="0"/>
+          <a:ext cx="0" cy="0"/>
+          <a:chOff x="0" y="0"/>
+          <a:chExt cx="0" cy="0"/>
+        </a:xfrm>
+      </p:grpSpPr>
+      <p:sp>
+        <p:nvSpPr>
+          <p:cNvPr id="2" name="Title 1"/>
+          <p:cNvSpPr>
+            <a:spLocks noGrp="1"/>
+          </p:cNvSpPr>
+          <p:nvPr>
+            <p:ph hasCustomPrompt="1" type="title"/>
+          </p:nvPr>
+        </p:nvSpPr>
+        <p:spPr>
+          <a:xfrm>
+            <a:off x="909829" y="438150"/>
+            <a:ext cx="8434196" cy="914400"/>
+          </a:xfrm>
+        </p:spPr>
+        <p:txBody>
+          <a:bodyPr/>
+          <a:lstStyle/>
+          <a:p>
+            <a:pPr lvl="0" indent="0" marL="0">
+              <a:buNone/>
+            </a:pPr>
+            <a:r>
+              <a:rPr/>
+              <a:t>7.2 Staff sickness absence</a:t>
+            </a:r>
+          </a:p>
+        </p:txBody>
+      </p:sp>
+      <p:sp>
+        <p:nvSpPr>
+          <p:cNvPr id="7" name="Text Placeholder 6">
+            <a:extLst>
+              <a:ext uri="{FF2B5EF4-FFF2-40B4-BE49-F238E27FC236}">
+                <a16:creationId xmlns:a16="http://schemas.microsoft.com/office/drawing/2014/main" id="{DE622849-4EA7-24AE-DD96-E693EAA81594}"/>
+              </a:ext>
+            </a:extLst>
+          </p:cNvPr>
+          <p:cNvSpPr>
+            <a:spLocks noGrp="1"/>
+          </p:cNvSpPr>
+          <p:nvPr>
+            <p:ph idx="13" sz="quarter" type="body"/>
+          </p:nvPr>
+        </p:nvSpPr>
+        <p:spPr/>
+        <p:txBody>
+          <a:bodyPr/>
+          <a:lstStyle/>
+          <a:p>
+            <a:pPr lvl="0" indent="0" marL="0">
+              <a:buNone/>
+            </a:pPr>
+            <a:r>
+              <a:rPr/>
+              <a:t>This </a:t>
+            </a:r>
+            <a:r>
+              <a:rPr b="1"/>
+              <a:t>monthly</a:t>
+            </a:r>
+            <a:r>
+              <a:rPr/>
+              <a:t> data at </a:t>
+            </a:r>
+            <a:r>
+              <a:rPr b="1"/>
+              <a:t>provider level</a:t>
+            </a:r>
+            <a:r>
+              <a:rPr/>
+              <a:t> is taken from published NHS England data (via UDAL).</a:t>
+            </a:r>
+          </a:p>
+          <a:p>
+            <a:pPr lvl="0" indent="0" marL="0">
+              <a:buNone/>
+            </a:pPr>
+            <a:r>
+              <a:rPr/>
+              <a:t>The percentage of available days taken off sick by staff significantly increased at 2/7 sites (Southmead and Tunbridge Wells) and was unchanged at the remaining 5 sites.</a:t>
+            </a:r>
+          </a:p>
+        </p:txBody>
+      </p:sp>
+      <p:pic>
+        <p:nvPicPr>
+          <p:cNvPr descr="NHP_SBR-impacts_2024_files/figure-pptx/cia_sick-1.png" id="0" name="Picture 1"/>
+          <p:cNvPicPr>
+            <a:picLocks noGrp="1" noChangeAspect="1"/>
+          </p:cNvPicPr>
+          <p:nvPr/>
+        </p:nvPicPr>
+        <p:blipFill>
+          <a:blip r:embed="rId2"/>
+          <a:stretch>
+            <a:fillRect/>
+          </a:stretch>
+        </p:blipFill>
+        <p:spPr bwMode="auto">
+          <a:xfrm>
+            <a:off x="4127500" y="1930400"/>
+            <a:ext cx="7010400" cy="3505200"/>
+          </a:xfrm>
+          <a:prstGeom prst="rect">
+            <a:avLst/>
+          </a:prstGeom>
+          <a:noFill/>
+          <a:ln w="9525">
+            <a:noFill/>
+            <a:headEnd/>
+            <a:tailEnd/>
+          </a:ln>
+        </p:spPr>
+      </p:pic>
     </p:spTree>
   </p:cSld>
 </p:sld>
@@ -5113,7 +6658,7 @@
             </a:pPr>
             <a:r>
               <a:rPr/>
-              <a:t>Introduction</a:t>
+              <a:t>1.1 Introduction</a:t>
             </a:r>
           </a:p>
         </p:txBody>
@@ -5189,6 +6734,282 @@
           </a:p>
         </p:txBody>
       </p:sp>
+    </p:spTree>
+  </p:cSld>
+</p:sld>
+</file>
+
+<file path=ppt/slides/slide30.xml><?xml version="1.0" encoding="utf-8"?>
+<p:sld xmlns:a="http://schemas.openxmlformats.org/drawingml/2006/main" xmlns:r="http://schemas.openxmlformats.org/officeDocument/2006/relationships" xmlns:p="http://schemas.openxmlformats.org/presentationml/2006/main">
+  <p:cSld>
+    <p:spTree>
+      <p:nvGrpSpPr>
+        <p:cNvPr id="1" name=""/>
+        <p:cNvGrpSpPr/>
+        <p:nvPr/>
+      </p:nvGrpSpPr>
+      <p:grpSpPr>
+        <a:xfrm>
+          <a:off x="0" y="0"/>
+          <a:ext cx="0" cy="0"/>
+          <a:chOff x="0" y="0"/>
+          <a:chExt cx="0" cy="0"/>
+        </a:xfrm>
+      </p:grpSpPr>
+      <p:sp>
+        <p:nvSpPr>
+          <p:cNvPr id="2" name="Title 1"/>
+          <p:cNvSpPr>
+            <a:spLocks noGrp="1"/>
+          </p:cNvSpPr>
+          <p:nvPr>
+            <p:ph hasCustomPrompt="1" type="title"/>
+          </p:nvPr>
+        </p:nvSpPr>
+        <p:spPr>
+          <a:xfrm>
+            <a:off x="909829" y="438150"/>
+            <a:ext cx="8434196" cy="914400"/>
+          </a:xfrm>
+        </p:spPr>
+        <p:txBody>
+          <a:bodyPr/>
+          <a:lstStyle/>
+          <a:p>
+            <a:pPr lvl="0" indent="0" marL="0">
+              <a:buNone/>
+            </a:pPr>
+            <a:r>
+              <a:rPr/>
+              <a:t>7.3 Staff turnover</a:t>
+            </a:r>
+          </a:p>
+        </p:txBody>
+      </p:sp>
+      <p:sp>
+        <p:nvSpPr>
+          <p:cNvPr id="7" name="Text Placeholder 6">
+            <a:extLst>
+              <a:ext uri="{FF2B5EF4-FFF2-40B4-BE49-F238E27FC236}">
+                <a16:creationId xmlns:a16="http://schemas.microsoft.com/office/drawing/2014/main" id="{DE622849-4EA7-24AE-DD96-E693EAA81594}"/>
+              </a:ext>
+            </a:extLst>
+          </p:cNvPr>
+          <p:cNvSpPr>
+            <a:spLocks noGrp="1"/>
+          </p:cNvSpPr>
+          <p:nvPr>
+            <p:ph idx="13" sz="quarter" type="body"/>
+          </p:nvPr>
+        </p:nvSpPr>
+        <p:spPr/>
+        <p:txBody>
+          <a:bodyPr/>
+          <a:lstStyle/>
+          <a:p>
+            <a:pPr lvl="0" indent="0" marL="0">
+              <a:buNone/>
+            </a:pPr>
+            <a:r>
+              <a:rPr/>
+              <a:t>This </a:t>
+            </a:r>
+            <a:r>
+              <a:rPr b="1"/>
+              <a:t>monthly</a:t>
+            </a:r>
+            <a:r>
+              <a:rPr/>
+              <a:t> data at </a:t>
+            </a:r>
+            <a:r>
+              <a:rPr b="1"/>
+              <a:t>provider level</a:t>
+            </a:r>
+            <a:r>
+              <a:rPr/>
+              <a:t> is taken from published NHS England data (via UDAL).</a:t>
+            </a:r>
+          </a:p>
+          <a:p>
+            <a:pPr lvl="0" indent="0" marL="0">
+              <a:buNone/>
+            </a:pPr>
+            <a:r>
+              <a:rPr/>
+              <a:t>Staff turnover measured as percentage of staff leaving was not significantly changed at any of the 3 sites where data was available.</a:t>
+            </a:r>
+          </a:p>
+        </p:txBody>
+      </p:sp>
+      <p:pic>
+        <p:nvPicPr>
+          <p:cNvPr descr="NHP_SBR-impacts_2024_files/figure-pptx/cia_turnover-1.png" id="0" name="Picture 1"/>
+          <p:cNvPicPr>
+            <a:picLocks noGrp="1" noChangeAspect="1"/>
+          </p:cNvPicPr>
+          <p:nvPr/>
+        </p:nvPicPr>
+        <p:blipFill>
+          <a:blip r:embed="rId2"/>
+          <a:stretch>
+            <a:fillRect/>
+          </a:stretch>
+        </p:blipFill>
+        <p:spPr bwMode="auto">
+          <a:xfrm>
+            <a:off x="4127500" y="1930400"/>
+            <a:ext cx="7010400" cy="3505200"/>
+          </a:xfrm>
+          <a:prstGeom prst="rect">
+            <a:avLst/>
+          </a:prstGeom>
+          <a:noFill/>
+          <a:ln w="9525">
+            <a:noFill/>
+            <a:headEnd/>
+            <a:tailEnd/>
+          </a:ln>
+        </p:spPr>
+      </p:pic>
+    </p:spTree>
+  </p:cSld>
+</p:sld>
+</file>
+
+<file path=ppt/slides/slide31.xml><?xml version="1.0" encoding="utf-8"?>
+<p:sld xmlns:a="http://schemas.openxmlformats.org/drawingml/2006/main" xmlns:r="http://schemas.openxmlformats.org/officeDocument/2006/relationships" xmlns:p="http://schemas.openxmlformats.org/presentationml/2006/main">
+  <p:cSld>
+    <p:spTree>
+      <p:nvGrpSpPr>
+        <p:cNvPr id="1" name=""/>
+        <p:cNvGrpSpPr/>
+        <p:nvPr/>
+      </p:nvGrpSpPr>
+      <p:grpSpPr>
+        <a:xfrm>
+          <a:off x="0" y="0"/>
+          <a:ext cx="0" cy="0"/>
+          <a:chOff x="0" y="0"/>
+          <a:chExt cx="0" cy="0"/>
+        </a:xfrm>
+      </p:grpSpPr>
+      <p:sp>
+        <p:nvSpPr>
+          <p:cNvPr id="2" name="Title 1"/>
+          <p:cNvSpPr>
+            <a:spLocks noGrp="1"/>
+          </p:cNvSpPr>
+          <p:nvPr>
+            <p:ph hasCustomPrompt="1" type="title"/>
+          </p:nvPr>
+        </p:nvSpPr>
+        <p:spPr>
+          <a:xfrm>
+            <a:off x="909829" y="438150"/>
+            <a:ext cx="8434196" cy="914400"/>
+          </a:xfrm>
+        </p:spPr>
+        <p:txBody>
+          <a:bodyPr/>
+          <a:lstStyle/>
+          <a:p>
+            <a:pPr lvl="0" indent="0" marL="0">
+              <a:buNone/>
+            </a:pPr>
+            <a:r>
+              <a:rPr/>
+              <a:t>7.4 Staff survey - recommending place to work</a:t>
+            </a:r>
+          </a:p>
+        </p:txBody>
+      </p:sp>
+      <p:sp>
+        <p:nvSpPr>
+          <p:cNvPr id="7" name="Text Placeholder 6">
+            <a:extLst>
+              <a:ext uri="{FF2B5EF4-FFF2-40B4-BE49-F238E27FC236}">
+                <a16:creationId xmlns:a16="http://schemas.microsoft.com/office/drawing/2014/main" id="{DE622849-4EA7-24AE-DD96-E693EAA81594}"/>
+              </a:ext>
+            </a:extLst>
+          </p:cNvPr>
+          <p:cNvSpPr>
+            <a:spLocks noGrp="1"/>
+          </p:cNvSpPr>
+          <p:nvPr>
+            <p:ph idx="13" sz="quarter" type="body"/>
+          </p:nvPr>
+        </p:nvSpPr>
+        <p:spPr/>
+        <p:txBody>
+          <a:bodyPr/>
+          <a:lstStyle/>
+          <a:p>
+            <a:pPr lvl="0" indent="0" marL="0">
+              <a:buNone/>
+            </a:pPr>
+            <a:r>
+              <a:rPr/>
+              <a:t>This </a:t>
+            </a:r>
+            <a:r>
+              <a:rPr b="1"/>
+              <a:t>monthly</a:t>
+            </a:r>
+            <a:r>
+              <a:rPr/>
+              <a:t> data at </a:t>
+            </a:r>
+            <a:r>
+              <a:rPr b="1"/>
+              <a:t>provider level</a:t>
+            </a:r>
+            <a:r>
+              <a:rPr/>
+              <a:t> is taken from published NHS England data (via UDAL).</a:t>
+            </a:r>
+          </a:p>
+          <a:p>
+            <a:pPr lvl="0" indent="0" marL="0">
+              <a:buNone/>
+            </a:pPr>
+            <a:r>
+              <a:rPr/>
+              <a:t>The percentage of staff that would recommend their trust as a place to work significantly increased at 1/6 sites (Papworth), and was unchanged at 3/6 (Chase Farm, Royal Liverpool and Tunbridge Wells). At 2/6 sites (Southmead and Clatterbridge) there was a significant decrease in the percentage that would recommend their trust as a place to work.</a:t>
+            </a:r>
+          </a:p>
+        </p:txBody>
+      </p:sp>
+      <p:pic>
+        <p:nvPicPr>
+          <p:cNvPr descr="NHP_SBR-impacts_2024_files/figure-pptx/cia_survey-1.png" id="0" name="Picture 1"/>
+          <p:cNvPicPr>
+            <a:picLocks noGrp="1" noChangeAspect="1"/>
+          </p:cNvPicPr>
+          <p:nvPr/>
+        </p:nvPicPr>
+        <p:blipFill>
+          <a:blip r:embed="rId2"/>
+          <a:stretch>
+            <a:fillRect/>
+          </a:stretch>
+        </p:blipFill>
+        <p:spPr bwMode="auto">
+          <a:xfrm>
+            <a:off x="4127500" y="1930400"/>
+            <a:ext cx="7010400" cy="3505200"/>
+          </a:xfrm>
+          <a:prstGeom prst="rect">
+            <a:avLst/>
+          </a:prstGeom>
+          <a:noFill/>
+          <a:ln w="9525">
+            <a:noFill/>
+            <a:headEnd/>
+            <a:tailEnd/>
+          </a:ln>
+        </p:spPr>
+      </p:pic>
     </p:spTree>
   </p:cSld>
 </p:sld>
@@ -5236,7 +7057,7 @@
             </a:pPr>
             <a:r>
               <a:rPr/>
-              <a:t>Approach</a:t>
+              <a:t>1.2 Approach</a:t>
             </a:r>
           </a:p>
         </p:txBody>
@@ -5343,432 +7164,6 @@
       </p:sp>
     </p:spTree>
   </p:cSld>
-  <p:timing>
-    <p:tnLst>
-      <p:par>
-        <p:cTn id="1" dur="indefinite" restart="never" nodeType="tmRoot">
-          <p:childTnLst>
-            <p:seq concurrent="1" nextAc="seek">
-              <p:cTn id="2" dur="indefinite" nodeType="mainSeq">
-                <p:childTnLst>
-                  <p:par>
-                    <p:cTn id="3" fill="hold">
-                      <p:stCondLst>
-                        <p:cond delay="indefinite"/>
-                      </p:stCondLst>
-                      <p:childTnLst>
-                        <p:par>
-                          <p:cTn id="4" fill="hold">
-                            <p:stCondLst>
-                              <p:cond delay="0"/>
-                            </p:stCondLst>
-                            <p:childTnLst>
-                              <p:par>
-                                <p:cTn id="5" presetID="1" presetClass="entr" presetSubtype="0" fill="hold" grpId="0" nodeType="clickEffect">
-                                  <p:stCondLst>
-                                    <p:cond delay="0"/>
-                                  </p:stCondLst>
-                                  <p:childTnLst>
-                                    <p:set>
-                                      <p:cBhvr>
-                                        <p:cTn id="6" dur="1" fill="hold">
-                                          <p:stCondLst>
-                                            <p:cond delay="0"/>
-                                          </p:stCondLst>
-                                        </p:cTn>
-                                        <p:tgtEl>
-                                          <p:spTgt spid="3">
-                                            <p:txEl>
-                                              <p:pRg st="0" end="0"/>
-                                            </p:txEl>
-                                          </p:spTgt>
-                                        </p:tgtEl>
-                                        <p:attrNameLst>
-                                          <p:attrName>style.visibility</p:attrName>
-                                        </p:attrNameLst>
-                                      </p:cBhvr>
-                                      <p:to>
-                                        <p:strVal val="visible"/>
-                                      </p:to>
-                                    </p:set>
-                                  </p:childTnLst>
-                                </p:cTn>
-                              </p:par>
-                            </p:childTnLst>
-                          </p:cTn>
-                        </p:par>
-                      </p:childTnLst>
-                    </p:cTn>
-                  </p:par>
-                  <p:par>
-                    <p:cTn id="7" fill="hold">
-                      <p:stCondLst>
-                        <p:cond delay="indefinite"/>
-                      </p:stCondLst>
-                      <p:childTnLst>
-                        <p:par>
-                          <p:cTn id="8" fill="hold">
-                            <p:stCondLst>
-                              <p:cond delay="0"/>
-                            </p:stCondLst>
-                            <p:childTnLst>
-                              <p:par>
-                                <p:cTn id="9" presetID="1" presetClass="entr" presetSubtype="0" fill="hold" grpId="0" nodeType="clickEffect">
-                                  <p:stCondLst>
-                                    <p:cond delay="0"/>
-                                  </p:stCondLst>
-                                  <p:childTnLst>
-                                    <p:set>
-                                      <p:cBhvr>
-                                        <p:cTn id="10" dur="1" fill="hold">
-                                          <p:stCondLst>
-                                            <p:cond delay="0"/>
-                                          </p:stCondLst>
-                                        </p:cTn>
-                                        <p:tgtEl>
-                                          <p:spTgt spid="3">
-                                            <p:txEl>
-                                              <p:pRg st="1" end="1"/>
-                                            </p:txEl>
-                                          </p:spTgt>
-                                        </p:tgtEl>
-                                        <p:attrNameLst>
-                                          <p:attrName>style.visibility</p:attrName>
-                                        </p:attrNameLst>
-                                      </p:cBhvr>
-                                      <p:to>
-                                        <p:strVal val="visible"/>
-                                      </p:to>
-                                    </p:set>
-                                  </p:childTnLst>
-                                </p:cTn>
-                              </p:par>
-                            </p:childTnLst>
-                          </p:cTn>
-                        </p:par>
-                      </p:childTnLst>
-                    </p:cTn>
-                  </p:par>
-                  <p:par>
-                    <p:cTn id="11" fill="hold">
-                      <p:stCondLst>
-                        <p:cond delay="indefinite"/>
-                      </p:stCondLst>
-                      <p:childTnLst>
-                        <p:par>
-                          <p:cTn id="12" fill="hold">
-                            <p:stCondLst>
-                              <p:cond delay="0"/>
-                            </p:stCondLst>
-                            <p:childTnLst>
-                              <p:par>
-                                <p:cTn id="13" presetID="1" presetClass="entr" presetSubtype="0" fill="hold" grpId="0" nodeType="clickEffect">
-                                  <p:stCondLst>
-                                    <p:cond delay="0"/>
-                                  </p:stCondLst>
-                                  <p:childTnLst>
-                                    <p:set>
-                                      <p:cBhvr>
-                                        <p:cTn id="14" dur="1" fill="hold">
-                                          <p:stCondLst>
-                                            <p:cond delay="0"/>
-                                          </p:stCondLst>
-                                        </p:cTn>
-                                        <p:tgtEl>
-                                          <p:spTgt spid="3">
-                                            <p:txEl>
-                                              <p:pRg st="2" end="2"/>
-                                            </p:txEl>
-                                          </p:spTgt>
-                                        </p:tgtEl>
-                                        <p:attrNameLst>
-                                          <p:attrName>style.visibility</p:attrName>
-                                        </p:attrNameLst>
-                                      </p:cBhvr>
-                                      <p:to>
-                                        <p:strVal val="visible"/>
-                                      </p:to>
-                                    </p:set>
-                                  </p:childTnLst>
-                                </p:cTn>
-                              </p:par>
-                            </p:childTnLst>
-                          </p:cTn>
-                        </p:par>
-                      </p:childTnLst>
-                    </p:cTn>
-                  </p:par>
-                  <p:par>
-                    <p:cTn id="15" fill="hold">
-                      <p:stCondLst>
-                        <p:cond delay="indefinite"/>
-                      </p:stCondLst>
-                      <p:childTnLst>
-                        <p:par>
-                          <p:cTn id="16" fill="hold">
-                            <p:stCondLst>
-                              <p:cond delay="0"/>
-                            </p:stCondLst>
-                            <p:childTnLst>
-                              <p:par>
-                                <p:cTn id="17" presetID="1" presetClass="entr" presetSubtype="0" fill="hold" grpId="0" nodeType="clickEffect">
-                                  <p:stCondLst>
-                                    <p:cond delay="0"/>
-                                  </p:stCondLst>
-                                  <p:childTnLst>
-                                    <p:set>
-                                      <p:cBhvr>
-                                        <p:cTn id="18" dur="1" fill="hold">
-                                          <p:stCondLst>
-                                            <p:cond delay="0"/>
-                                          </p:stCondLst>
-                                        </p:cTn>
-                                        <p:tgtEl>
-                                          <p:spTgt spid="3">
-                                            <p:txEl>
-                                              <p:pRg st="3" end="3"/>
-                                            </p:txEl>
-                                          </p:spTgt>
-                                        </p:tgtEl>
-                                        <p:attrNameLst>
-                                          <p:attrName>style.visibility</p:attrName>
-                                        </p:attrNameLst>
-                                      </p:cBhvr>
-                                      <p:to>
-                                        <p:strVal val="visible"/>
-                                      </p:to>
-                                    </p:set>
-                                  </p:childTnLst>
-                                </p:cTn>
-                              </p:par>
-                            </p:childTnLst>
-                          </p:cTn>
-                        </p:par>
-                      </p:childTnLst>
-                    </p:cTn>
-                  </p:par>
-                  <p:par>
-                    <p:cTn id="19" fill="hold">
-                      <p:stCondLst>
-                        <p:cond delay="indefinite"/>
-                      </p:stCondLst>
-                      <p:childTnLst>
-                        <p:par>
-                          <p:cTn id="20" fill="hold">
-                            <p:stCondLst>
-                              <p:cond delay="0"/>
-                            </p:stCondLst>
-                            <p:childTnLst>
-                              <p:par>
-                                <p:cTn id="21" presetID="1" presetClass="entr" presetSubtype="0" fill="hold" grpId="0" nodeType="clickEffect">
-                                  <p:stCondLst>
-                                    <p:cond delay="0"/>
-                                  </p:stCondLst>
-                                  <p:childTnLst>
-                                    <p:set>
-                                      <p:cBhvr>
-                                        <p:cTn id="22" dur="1" fill="hold">
-                                          <p:stCondLst>
-                                            <p:cond delay="0"/>
-                                          </p:stCondLst>
-                                        </p:cTn>
-                                        <p:tgtEl>
-                                          <p:spTgt spid="4">
-                                            <p:txEl>
-                                              <p:pRg st="0" end="0"/>
-                                            </p:txEl>
-                                          </p:spTgt>
-                                        </p:tgtEl>
-                                        <p:attrNameLst>
-                                          <p:attrName>style.visibility</p:attrName>
-                                        </p:attrNameLst>
-                                      </p:cBhvr>
-                                      <p:to>
-                                        <p:strVal val="visible"/>
-                                      </p:to>
-                                    </p:set>
-                                  </p:childTnLst>
-                                </p:cTn>
-                              </p:par>
-                            </p:childTnLst>
-                          </p:cTn>
-                        </p:par>
-                      </p:childTnLst>
-                    </p:cTn>
-                  </p:par>
-                  <p:par>
-                    <p:cTn id="23" fill="hold">
-                      <p:stCondLst>
-                        <p:cond delay="indefinite"/>
-                      </p:stCondLst>
-                      <p:childTnLst>
-                        <p:par>
-                          <p:cTn id="24" fill="hold">
-                            <p:stCondLst>
-                              <p:cond delay="0"/>
-                            </p:stCondLst>
-                            <p:childTnLst>
-                              <p:par>
-                                <p:cTn id="25" presetID="1" presetClass="entr" presetSubtype="0" fill="hold" grpId="0" nodeType="clickEffect">
-                                  <p:stCondLst>
-                                    <p:cond delay="0"/>
-                                  </p:stCondLst>
-                                  <p:childTnLst>
-                                    <p:set>
-                                      <p:cBhvr>
-                                        <p:cTn id="26" dur="1" fill="hold">
-                                          <p:stCondLst>
-                                            <p:cond delay="0"/>
-                                          </p:stCondLst>
-                                        </p:cTn>
-                                        <p:tgtEl>
-                                          <p:spTgt spid="4">
-                                            <p:txEl>
-                                              <p:pRg st="1" end="1"/>
-                                            </p:txEl>
-                                          </p:spTgt>
-                                        </p:tgtEl>
-                                        <p:attrNameLst>
-                                          <p:attrName>style.visibility</p:attrName>
-                                        </p:attrNameLst>
-                                      </p:cBhvr>
-                                      <p:to>
-                                        <p:strVal val="visible"/>
-                                      </p:to>
-                                    </p:set>
-                                  </p:childTnLst>
-                                </p:cTn>
-                              </p:par>
-                            </p:childTnLst>
-                          </p:cTn>
-                        </p:par>
-                      </p:childTnLst>
-                    </p:cTn>
-                  </p:par>
-                  <p:par>
-                    <p:cTn id="27" fill="hold">
-                      <p:stCondLst>
-                        <p:cond delay="indefinite"/>
-                      </p:stCondLst>
-                      <p:childTnLst>
-                        <p:par>
-                          <p:cTn id="28" fill="hold">
-                            <p:stCondLst>
-                              <p:cond delay="0"/>
-                            </p:stCondLst>
-                            <p:childTnLst>
-                              <p:par>
-                                <p:cTn id="29" presetID="1" presetClass="entr" presetSubtype="0" fill="hold" grpId="0" nodeType="clickEffect">
-                                  <p:stCondLst>
-                                    <p:cond delay="0"/>
-                                  </p:stCondLst>
-                                  <p:childTnLst>
-                                    <p:set>
-                                      <p:cBhvr>
-                                        <p:cTn id="30" dur="1" fill="hold">
-                                          <p:stCondLst>
-                                            <p:cond delay="0"/>
-                                          </p:stCondLst>
-                                        </p:cTn>
-                                        <p:tgtEl>
-                                          <p:spTgt spid="4">
-                                            <p:txEl>
-                                              <p:pRg st="2" end="2"/>
-                                            </p:txEl>
-                                          </p:spTgt>
-                                        </p:tgtEl>
-                                        <p:attrNameLst>
-                                          <p:attrName>style.visibility</p:attrName>
-                                        </p:attrNameLst>
-                                      </p:cBhvr>
-                                      <p:to>
-                                        <p:strVal val="visible"/>
-                                      </p:to>
-                                    </p:set>
-                                  </p:childTnLst>
-                                </p:cTn>
-                              </p:par>
-                            </p:childTnLst>
-                          </p:cTn>
-                        </p:par>
-                      </p:childTnLst>
-                    </p:cTn>
-                  </p:par>
-                  <p:par>
-                    <p:cTn id="31" fill="hold">
-                      <p:stCondLst>
-                        <p:cond delay="indefinite"/>
-                      </p:stCondLst>
-                      <p:childTnLst>
-                        <p:par>
-                          <p:cTn id="32" fill="hold">
-                            <p:stCondLst>
-                              <p:cond delay="0"/>
-                            </p:stCondLst>
-                            <p:childTnLst>
-                              <p:par>
-                                <p:cTn id="33" presetID="1" presetClass="entr" presetSubtype="0" fill="hold" grpId="0" nodeType="clickEffect">
-                                  <p:stCondLst>
-                                    <p:cond delay="0"/>
-                                  </p:stCondLst>
-                                  <p:childTnLst>
-                                    <p:set>
-                                      <p:cBhvr>
-                                        <p:cTn id="34" dur="1" fill="hold">
-                                          <p:stCondLst>
-                                            <p:cond delay="0"/>
-                                          </p:stCondLst>
-                                        </p:cTn>
-                                        <p:tgtEl>
-                                          <p:spTgt spid="4">
-                                            <p:txEl>
-                                              <p:pRg st="3" end="3"/>
-                                            </p:txEl>
-                                          </p:spTgt>
-                                        </p:tgtEl>
-                                        <p:attrNameLst>
-                                          <p:attrName>style.visibility</p:attrName>
-                                        </p:attrNameLst>
-                                      </p:cBhvr>
-                                      <p:to>
-                                        <p:strVal val="visible"/>
-                                      </p:to>
-                                    </p:set>
-                                  </p:childTnLst>
-                                </p:cTn>
-                              </p:par>
-                            </p:childTnLst>
-                          </p:cTn>
-                        </p:par>
-                      </p:childTnLst>
-                    </p:cTn>
-                  </p:par>
-                </p:childTnLst>
-              </p:cTn>
-              <p:prevCondLst>
-                <p:cond evt="onPrev" delay="0">
-                  <p:tgtEl>
-                    <p:sldTgt/>
-                  </p:tgtEl>
-                </p:cond>
-              </p:prevCondLst>
-              <p:nextCondLst>
-                <p:cond evt="onNext" delay="0">
-                  <p:tgtEl>
-                    <p:sldTgt/>
-                  </p:tgtEl>
-                </p:cond>
-              </p:nextCondLst>
-            </p:seq>
-          </p:childTnLst>
-        </p:cTn>
-      </p:par>
-    </p:tnLst>
-    <p:bldLst>
-      <p:bldP spid="3" grpId="0" uiExpand="1" build="p"/>
-      <p:bldP spid="4" grpId="0" uiExpand="1" build="p"/>
-    </p:bldLst>
-  </p:timing>
 </p:sld>
 </file>
 
@@ -5814,7 +7209,7 @@
             </a:pPr>
             <a:r>
               <a:rPr/>
-              <a:t>Summary of key findings</a:t>
+              <a:t>1.3 Summary of key findings</a:t>
             </a:r>
           </a:p>
         </p:txBody>
@@ -5839,7 +7234,7 @@
             </a:pPr>
             <a:r>
               <a:rPr/>
-              <a:t>Regardless of direction of impact, our results are not consistent across hospital sites. This suggests that there are a number of other factors in the hospital design, systems, policies and procedures that are important. Switching to single bedroom hospitals without considering the other factors would not necessarily have a positive effect on outcomes nor mitigate any likely risks. This inconsistency is reflective of the findings from published literature.</a:t>
+              <a:t>Our results are generally not consistent within indicators and across hospital sites. This suggests that there are a number of other factors in the hospital design, systems, policies and procedures that are important. Switching to single bedroom hospitals without considering the other factors would not necessarily have a positive effect on outcomes nor mitigate any likely risks. This inconsistency is reflective of the findings from published literature.</a:t>
             </a:r>
           </a:p>
         </p:txBody>
@@ -5873,13 +7268,13 @@
             <a:spLocks noGrp="1"/>
           </p:cNvSpPr>
           <p:nvPr>
-            <p:ph hasCustomPrompt="1" type="ctrTitle"/>
+            <p:ph hasCustomPrompt="1" type="title"/>
           </p:nvPr>
         </p:nvSpPr>
         <p:spPr>
           <a:xfrm>
-            <a:off x="457199" y="4755350"/>
-            <a:ext cx="7772400" cy="1218369"/>
+            <a:off x="909829" y="403765"/>
+            <a:ext cx="8434196" cy="976056"/>
           </a:xfrm>
         </p:spPr>
         <p:txBody>
@@ -5891,7 +7286,62 @@
             </a:pPr>
             <a:r>
               <a:rPr/>
-              <a:t>The impact framework</a:t>
+              <a:t>1.4 Limitations and Recommendations</a:t>
+            </a:r>
+          </a:p>
+        </p:txBody>
+      </p:sp>
+      <p:sp>
+        <p:nvSpPr>
+          <p:cNvPr id="3" name="Content Placeholder 2"/>
+          <p:cNvSpPr>
+            <a:spLocks noGrp="1"/>
+          </p:cNvSpPr>
+          <p:nvPr>
+            <p:ph idx="1"/>
+          </p:nvPr>
+        </p:nvSpPr>
+        <p:spPr/>
+        <p:txBody>
+          <a:bodyPr/>
+          <a:lstStyle/>
+          <a:p>
+            <a:pPr lvl="0" indent="0" marL="0">
+              <a:buNone/>
+            </a:pPr>
+            <a:r>
+              <a:rPr/>
+              <a:t>Placeholder….limitations</a:t>
+            </a:r>
+          </a:p>
+          <a:p>
+            <a:pPr lvl="0"/>
+            <a:r>
+              <a:rPr/>
+              <a:t>Data quality and robustness</a:t>
+            </a:r>
+          </a:p>
+          <a:p>
+            <a:pPr lvl="0"/>
+            <a:r>
+              <a:rPr/>
+              <a:t>Below site-level analysis</a:t>
+            </a:r>
+          </a:p>
+          <a:p>
+            <a:pPr lvl="0" indent="0" marL="0">
+              <a:buNone/>
+            </a:pPr>
+            <a:r>
+              <a:rPr/>
+              <a:t>Placeholder…recommendations</a:t>
+            </a:r>
+          </a:p>
+          <a:p>
+            <a:pPr lvl="0"/>
+            <a:r>
+              <a:rPr/>
+              <a:t>System dynamics for productivity scenario</a:t>
             </a:r>
           </a:p>
         </p:txBody>
@@ -5925,13 +7375,13 @@
             <a:spLocks noGrp="1"/>
           </p:cNvSpPr>
           <p:nvPr>
-            <p:ph hasCustomPrompt="1" type="title"/>
+            <p:ph hasCustomPrompt="1" type="ctrTitle"/>
           </p:nvPr>
         </p:nvSpPr>
         <p:spPr>
           <a:xfrm>
-            <a:off x="909829" y="403765"/>
-            <a:ext cx="8434196" cy="976056"/>
+            <a:off x="457199" y="4665306"/>
+            <a:ext cx="7772400" cy="1308413"/>
           </a:xfrm>
         </p:spPr>
         <p:txBody>
@@ -5943,41 +7393,11 @@
             </a:pPr>
             <a:r>
               <a:rPr/>
-              <a:t>Overview</a:t>
-            </a:r>
-          </a:p>
-        </p:txBody>
-      </p:sp>
-      <p:pic>
-        <p:nvPicPr>
-          <p:cNvPr descr="images/indicators.jpeg" id="0" name="Picture 1"/>
-          <p:cNvPicPr>
-            <a:picLocks noGrp="1" noChangeAspect="1"/>
-          </p:cNvPicPr>
-          <p:nvPr/>
-        </p:nvPicPr>
-        <p:blipFill>
-          <a:blip r:embed="rId2"/>
-          <a:stretch>
-            <a:fillRect/>
-          </a:stretch>
-        </p:blipFill>
-        <p:spPr bwMode="auto">
-          <a:xfrm>
-            <a:off x="901700" y="2032000"/>
-            <a:ext cx="10414000" cy="3467100"/>
-          </a:xfrm>
-          <a:prstGeom prst="rect">
-            <a:avLst/>
-          </a:prstGeom>
-          <a:noFill/>
-          <a:ln w="9525">
-            <a:noFill/>
-            <a:headEnd/>
-            <a:tailEnd/>
-          </a:ln>
-        </p:spPr>
-      </p:pic>
+              <a:t>2. The impact framework</a:t>
+            </a:r>
+          </a:p>
+        </p:txBody>
+      </p:sp>
     </p:spTree>
   </p:cSld>
 </p:sld>
@@ -6007,13 +7427,13 @@
             <a:spLocks noGrp="1"/>
           </p:cNvSpPr>
           <p:nvPr>
-            <p:ph hasCustomPrompt="1" type="ctrTitle"/>
+            <p:ph hasCustomPrompt="1" type="title"/>
           </p:nvPr>
         </p:nvSpPr>
         <p:spPr>
           <a:xfrm>
-            <a:off x="457199" y="4755350"/>
-            <a:ext cx="7772400" cy="1218369"/>
+            <a:off x="909829" y="403765"/>
+            <a:ext cx="8434196" cy="976056"/>
           </a:xfrm>
         </p:spPr>
         <p:txBody>
@@ -6025,11 +7445,41 @@
             </a:pPr>
             <a:r>
               <a:rPr/>
-              <a:t>The hospitals</a:t>
-            </a:r>
-          </a:p>
-        </p:txBody>
-      </p:sp>
+              <a:t>2.1 Overview</a:t>
+            </a:r>
+          </a:p>
+        </p:txBody>
+      </p:sp>
+      <p:pic>
+        <p:nvPicPr>
+          <p:cNvPr descr="images/indicators.jpeg" id="0" name="Picture 1"/>
+          <p:cNvPicPr>
+            <a:picLocks noGrp="1" noChangeAspect="1"/>
+          </p:cNvPicPr>
+          <p:nvPr/>
+        </p:nvPicPr>
+        <p:blipFill>
+          <a:blip r:embed="rId2"/>
+          <a:stretch>
+            <a:fillRect/>
+          </a:stretch>
+        </p:blipFill>
+        <p:spPr bwMode="auto">
+          <a:xfrm>
+            <a:off x="901700" y="2032000"/>
+            <a:ext cx="10414000" cy="3467100"/>
+          </a:xfrm>
+          <a:prstGeom prst="rect">
+            <a:avLst/>
+          </a:prstGeom>
+          <a:noFill/>
+          <a:ln w="9525">
+            <a:noFill/>
+            <a:headEnd/>
+            <a:tailEnd/>
+          </a:ln>
+        </p:spPr>
+      </p:pic>
     </p:spTree>
   </p:cSld>
 </p:sld>
@@ -6059,13 +7509,13 @@
             <a:spLocks noGrp="1"/>
           </p:cNvSpPr>
           <p:nvPr>
-            <p:ph type="title"/>
+            <p:ph hasCustomPrompt="1" type="title"/>
           </p:nvPr>
         </p:nvSpPr>
         <p:spPr>
           <a:xfrm>
-            <a:off x="919352" y="419100"/>
-            <a:ext cx="9720072" cy="933450"/>
+            <a:off x="909829" y="403765"/>
+            <a:ext cx="8434196" cy="976056"/>
           </a:xfrm>
         </p:spPr>
         <p:txBody>
@@ -6077,85 +7527,14 @@
             </a:pPr>
             <a:r>
               <a:rPr/>
-              <a:t>7 natural experiments</a:t>
-            </a:r>
-          </a:p>
-        </p:txBody>
-      </p:sp>
-      <p:sp>
-        <p:nvSpPr>
-          <p:cNvPr id="3" name="Content Placeholder 2">
-            <a:extLst>
-              <a:ext uri="{FF2B5EF4-FFF2-40B4-BE49-F238E27FC236}">
-                <a16:creationId xmlns:a16="http://schemas.microsoft.com/office/drawing/2014/main" id="{D2592819-5C80-B996-F823-F8B9F9EAD6C9}"/>
-              </a:ext>
-            </a:extLst>
-          </p:cNvPr>
-          <p:cNvSpPr>
-            <a:spLocks noGrp="1"/>
-          </p:cNvSpPr>
-          <p:nvPr>
-            <p:ph idx="10"/>
-          </p:nvPr>
-        </p:nvSpPr>
-        <p:spPr/>
-        <p:txBody>
-          <a:bodyPr/>
-          <a:lstStyle/>
-          <a:p>
-            <a:pPr lvl="0"/>
-            <a:r>
-              <a:rPr/>
-              <a:t>Royal Liverpool (Oct 2022)</a:t>
-            </a:r>
-          </a:p>
-          <a:p>
-            <a:pPr lvl="0"/>
-            <a:r>
-              <a:rPr/>
-              <a:t>Clatterbridge Cancer Centre (June 2020)</a:t>
-            </a:r>
-          </a:p>
-          <a:p>
-            <a:pPr lvl="0"/>
-            <a:r>
-              <a:rPr/>
-              <a:t>Royal Papworth Hospital (May 2019)</a:t>
-            </a:r>
-          </a:p>
-          <a:p>
-            <a:pPr lvl="0"/>
-            <a:r>
-              <a:rPr/>
-              <a:t>Chase Farm Hospital (Sept 2018)</a:t>
-            </a:r>
-          </a:p>
-          <a:p>
-            <a:pPr lvl="0"/>
-            <a:r>
-              <a:rPr/>
-              <a:t>Southmead Hospital (May 2014)</a:t>
-            </a:r>
-          </a:p>
-          <a:p>
-            <a:pPr lvl="0"/>
-            <a:r>
-              <a:rPr/>
-              <a:t>Tunbridge Wells (Jan/Sept 2011)</a:t>
-            </a:r>
-          </a:p>
-          <a:p>
-            <a:pPr lvl="0"/>
-            <a:r>
-              <a:rPr/>
-              <a:t>Peterborough Hospital (Nov 2010)</a:t>
+              <a:t>2.2 Indicator availability and time of SBR changes by site</a:t>
             </a:r>
           </a:p>
         </p:txBody>
       </p:sp>
       <p:pic>
         <p:nvPicPr>
-          <p:cNvPr descr="images/hospitals_map.png" id="0" name="Picture 1"/>
+          <p:cNvPr descr="NHP_SBR-impacts_2024_files/figure-pptx/ind_timeline-1.png" id="0" name="Picture 1"/>
           <p:cNvPicPr>
             <a:picLocks noGrp="1" noChangeAspect="1"/>
           </p:cNvPicPr>
@@ -6169,8 +7548,8 @@
         </p:blipFill>
         <p:spPr bwMode="auto">
           <a:xfrm>
-            <a:off x="6223000" y="2057400"/>
-            <a:ext cx="5041900" cy="3327400"/>
+            <a:off x="2032000" y="1727200"/>
+            <a:ext cx="8153400" cy="4076700"/>
           </a:xfrm>
           <a:prstGeom prst="rect">
             <a:avLst/>
@@ -6185,382 +7564,6 @@
       </p:pic>
     </p:spTree>
   </p:cSld>
-  <p:timing>
-    <p:tnLst>
-      <p:par>
-        <p:cTn id="1" dur="indefinite" restart="never" nodeType="tmRoot">
-          <p:childTnLst>
-            <p:seq concurrent="1" nextAc="seek">
-              <p:cTn id="2" dur="indefinite" nodeType="mainSeq">
-                <p:childTnLst>
-                  <p:par>
-                    <p:cTn id="3" fill="hold">
-                      <p:stCondLst>
-                        <p:cond delay="indefinite"/>
-                      </p:stCondLst>
-                      <p:childTnLst>
-                        <p:par>
-                          <p:cTn id="4" fill="hold">
-                            <p:stCondLst>
-                              <p:cond delay="0"/>
-                            </p:stCondLst>
-                            <p:childTnLst>
-                              <p:par>
-                                <p:cTn id="5" presetID="1" presetClass="entr" presetSubtype="0" fill="hold" grpId="0" nodeType="clickEffect">
-                                  <p:stCondLst>
-                                    <p:cond delay="0"/>
-                                  </p:stCondLst>
-                                  <p:childTnLst>
-                                    <p:set>
-                                      <p:cBhvr>
-                                        <p:cTn id="6" dur="1" fill="hold">
-                                          <p:stCondLst>
-                                            <p:cond delay="0"/>
-                                          </p:stCondLst>
-                                        </p:cTn>
-                                        <p:tgtEl>
-                                          <p:spTgt spid="3">
-                                            <p:txEl>
-                                              <p:pRg st="0" end="0"/>
-                                            </p:txEl>
-                                          </p:spTgt>
-                                        </p:tgtEl>
-                                        <p:attrNameLst>
-                                          <p:attrName>style.visibility</p:attrName>
-                                        </p:attrNameLst>
-                                      </p:cBhvr>
-                                      <p:to>
-                                        <p:strVal val="visible"/>
-                                      </p:to>
-                                    </p:set>
-                                  </p:childTnLst>
-                                </p:cTn>
-                              </p:par>
-                            </p:childTnLst>
-                          </p:cTn>
-                        </p:par>
-                      </p:childTnLst>
-                    </p:cTn>
-                  </p:par>
-                  <p:par>
-                    <p:cTn id="7" fill="hold">
-                      <p:stCondLst>
-                        <p:cond delay="indefinite"/>
-                      </p:stCondLst>
-                      <p:childTnLst>
-                        <p:par>
-                          <p:cTn id="8" fill="hold">
-                            <p:stCondLst>
-                              <p:cond delay="0"/>
-                            </p:stCondLst>
-                            <p:childTnLst>
-                              <p:par>
-                                <p:cTn id="9" presetID="1" presetClass="entr" presetSubtype="0" fill="hold" grpId="0" nodeType="clickEffect">
-                                  <p:stCondLst>
-                                    <p:cond delay="0"/>
-                                  </p:stCondLst>
-                                  <p:childTnLst>
-                                    <p:set>
-                                      <p:cBhvr>
-                                        <p:cTn id="10" dur="1" fill="hold">
-                                          <p:stCondLst>
-                                            <p:cond delay="0"/>
-                                          </p:stCondLst>
-                                        </p:cTn>
-                                        <p:tgtEl>
-                                          <p:spTgt spid="3">
-                                            <p:txEl>
-                                              <p:pRg st="1" end="1"/>
-                                            </p:txEl>
-                                          </p:spTgt>
-                                        </p:tgtEl>
-                                        <p:attrNameLst>
-                                          <p:attrName>style.visibility</p:attrName>
-                                        </p:attrNameLst>
-                                      </p:cBhvr>
-                                      <p:to>
-                                        <p:strVal val="visible"/>
-                                      </p:to>
-                                    </p:set>
-                                  </p:childTnLst>
-                                </p:cTn>
-                              </p:par>
-                            </p:childTnLst>
-                          </p:cTn>
-                        </p:par>
-                      </p:childTnLst>
-                    </p:cTn>
-                  </p:par>
-                  <p:par>
-                    <p:cTn id="11" fill="hold">
-                      <p:stCondLst>
-                        <p:cond delay="indefinite"/>
-                      </p:stCondLst>
-                      <p:childTnLst>
-                        <p:par>
-                          <p:cTn id="12" fill="hold">
-                            <p:stCondLst>
-                              <p:cond delay="0"/>
-                            </p:stCondLst>
-                            <p:childTnLst>
-                              <p:par>
-                                <p:cTn id="13" presetID="1" presetClass="entr" presetSubtype="0" fill="hold" grpId="0" nodeType="clickEffect">
-                                  <p:stCondLst>
-                                    <p:cond delay="0"/>
-                                  </p:stCondLst>
-                                  <p:childTnLst>
-                                    <p:set>
-                                      <p:cBhvr>
-                                        <p:cTn id="14" dur="1" fill="hold">
-                                          <p:stCondLst>
-                                            <p:cond delay="0"/>
-                                          </p:stCondLst>
-                                        </p:cTn>
-                                        <p:tgtEl>
-                                          <p:spTgt spid="3">
-                                            <p:txEl>
-                                              <p:pRg st="2" end="2"/>
-                                            </p:txEl>
-                                          </p:spTgt>
-                                        </p:tgtEl>
-                                        <p:attrNameLst>
-                                          <p:attrName>style.visibility</p:attrName>
-                                        </p:attrNameLst>
-                                      </p:cBhvr>
-                                      <p:to>
-                                        <p:strVal val="visible"/>
-                                      </p:to>
-                                    </p:set>
-                                  </p:childTnLst>
-                                </p:cTn>
-                              </p:par>
-                            </p:childTnLst>
-                          </p:cTn>
-                        </p:par>
-                      </p:childTnLst>
-                    </p:cTn>
-                  </p:par>
-                  <p:par>
-                    <p:cTn id="15" fill="hold">
-                      <p:stCondLst>
-                        <p:cond delay="indefinite"/>
-                      </p:stCondLst>
-                      <p:childTnLst>
-                        <p:par>
-                          <p:cTn id="16" fill="hold">
-                            <p:stCondLst>
-                              <p:cond delay="0"/>
-                            </p:stCondLst>
-                            <p:childTnLst>
-                              <p:par>
-                                <p:cTn id="17" presetID="1" presetClass="entr" presetSubtype="0" fill="hold" grpId="0" nodeType="clickEffect">
-                                  <p:stCondLst>
-                                    <p:cond delay="0"/>
-                                  </p:stCondLst>
-                                  <p:childTnLst>
-                                    <p:set>
-                                      <p:cBhvr>
-                                        <p:cTn id="18" dur="1" fill="hold">
-                                          <p:stCondLst>
-                                            <p:cond delay="0"/>
-                                          </p:stCondLst>
-                                        </p:cTn>
-                                        <p:tgtEl>
-                                          <p:spTgt spid="3">
-                                            <p:txEl>
-                                              <p:pRg st="3" end="3"/>
-                                            </p:txEl>
-                                          </p:spTgt>
-                                        </p:tgtEl>
-                                        <p:attrNameLst>
-                                          <p:attrName>style.visibility</p:attrName>
-                                        </p:attrNameLst>
-                                      </p:cBhvr>
-                                      <p:to>
-                                        <p:strVal val="visible"/>
-                                      </p:to>
-                                    </p:set>
-                                  </p:childTnLst>
-                                </p:cTn>
-                              </p:par>
-                            </p:childTnLst>
-                          </p:cTn>
-                        </p:par>
-                      </p:childTnLst>
-                    </p:cTn>
-                  </p:par>
-                  <p:par>
-                    <p:cTn id="19" fill="hold">
-                      <p:stCondLst>
-                        <p:cond delay="indefinite"/>
-                      </p:stCondLst>
-                      <p:childTnLst>
-                        <p:par>
-                          <p:cTn id="20" fill="hold">
-                            <p:stCondLst>
-                              <p:cond delay="0"/>
-                            </p:stCondLst>
-                            <p:childTnLst>
-                              <p:par>
-                                <p:cTn id="21" presetID="1" presetClass="entr" presetSubtype="0" fill="hold" grpId="0" nodeType="clickEffect">
-                                  <p:stCondLst>
-                                    <p:cond delay="0"/>
-                                  </p:stCondLst>
-                                  <p:childTnLst>
-                                    <p:set>
-                                      <p:cBhvr>
-                                        <p:cTn id="22" dur="1" fill="hold">
-                                          <p:stCondLst>
-                                            <p:cond delay="0"/>
-                                          </p:stCondLst>
-                                        </p:cTn>
-                                        <p:tgtEl>
-                                          <p:spTgt spid="3">
-                                            <p:txEl>
-                                              <p:pRg st="4" end="4"/>
-                                            </p:txEl>
-                                          </p:spTgt>
-                                        </p:tgtEl>
-                                        <p:attrNameLst>
-                                          <p:attrName>style.visibility</p:attrName>
-                                        </p:attrNameLst>
-                                      </p:cBhvr>
-                                      <p:to>
-                                        <p:strVal val="visible"/>
-                                      </p:to>
-                                    </p:set>
-                                  </p:childTnLst>
-                                </p:cTn>
-                              </p:par>
-                            </p:childTnLst>
-                          </p:cTn>
-                        </p:par>
-                      </p:childTnLst>
-                    </p:cTn>
-                  </p:par>
-                  <p:par>
-                    <p:cTn id="23" fill="hold">
-                      <p:stCondLst>
-                        <p:cond delay="indefinite"/>
-                      </p:stCondLst>
-                      <p:childTnLst>
-                        <p:par>
-                          <p:cTn id="24" fill="hold">
-                            <p:stCondLst>
-                              <p:cond delay="0"/>
-                            </p:stCondLst>
-                            <p:childTnLst>
-                              <p:par>
-                                <p:cTn id="25" presetID="1" presetClass="entr" presetSubtype="0" fill="hold" grpId="0" nodeType="clickEffect">
-                                  <p:stCondLst>
-                                    <p:cond delay="0"/>
-                                  </p:stCondLst>
-                                  <p:childTnLst>
-                                    <p:set>
-                                      <p:cBhvr>
-                                        <p:cTn id="26" dur="1" fill="hold">
-                                          <p:stCondLst>
-                                            <p:cond delay="0"/>
-                                          </p:stCondLst>
-                                        </p:cTn>
-                                        <p:tgtEl>
-                                          <p:spTgt spid="3">
-                                            <p:txEl>
-                                              <p:pRg st="5" end="5"/>
-                                            </p:txEl>
-                                          </p:spTgt>
-                                        </p:tgtEl>
-                                        <p:attrNameLst>
-                                          <p:attrName>style.visibility</p:attrName>
-                                        </p:attrNameLst>
-                                      </p:cBhvr>
-                                      <p:to>
-                                        <p:strVal val="visible"/>
-                                      </p:to>
-                                    </p:set>
-                                  </p:childTnLst>
-                                </p:cTn>
-                              </p:par>
-                            </p:childTnLst>
-                          </p:cTn>
-                        </p:par>
-                      </p:childTnLst>
-                    </p:cTn>
-                  </p:par>
-                  <p:par>
-                    <p:cTn id="27" fill="hold">
-                      <p:stCondLst>
-                        <p:cond delay="indefinite"/>
-                      </p:stCondLst>
-                      <p:childTnLst>
-                        <p:par>
-                          <p:cTn id="28" fill="hold">
-                            <p:stCondLst>
-                              <p:cond delay="0"/>
-                            </p:stCondLst>
-                            <p:childTnLst>
-                              <p:par>
-                                <p:cTn id="29" presetID="1" presetClass="entr" presetSubtype="0" fill="hold" grpId="0" nodeType="clickEffect">
-                                  <p:stCondLst>
-                                    <p:cond delay="0"/>
-                                  </p:stCondLst>
-                                  <p:childTnLst>
-                                    <p:set>
-                                      <p:cBhvr>
-                                        <p:cTn id="30" dur="1" fill="hold">
-                                          <p:stCondLst>
-                                            <p:cond delay="0"/>
-                                          </p:stCondLst>
-                                        </p:cTn>
-                                        <p:tgtEl>
-                                          <p:spTgt spid="3">
-                                            <p:txEl>
-                                              <p:pRg st="6" end="6"/>
-                                            </p:txEl>
-                                          </p:spTgt>
-                                        </p:tgtEl>
-                                        <p:attrNameLst>
-                                          <p:attrName>style.visibility</p:attrName>
-                                        </p:attrNameLst>
-                                      </p:cBhvr>
-                                      <p:to>
-                                        <p:strVal val="visible"/>
-                                      </p:to>
-                                    </p:set>
-                                  </p:childTnLst>
-                                </p:cTn>
-                              </p:par>
-                            </p:childTnLst>
-                          </p:cTn>
-                        </p:par>
-                      </p:childTnLst>
-                    </p:cTn>
-                  </p:par>
-                </p:childTnLst>
-              </p:cTn>
-              <p:prevCondLst>
-                <p:cond evt="onPrev" delay="0">
-                  <p:tgtEl>
-                    <p:sldTgt/>
-                  </p:tgtEl>
-                </p:cond>
-              </p:prevCondLst>
-              <p:nextCondLst>
-                <p:cond evt="onNext" delay="0">
-                  <p:tgtEl>
-                    <p:sldTgt/>
-                  </p:tgtEl>
-                </p:cond>
-              </p:nextCondLst>
-            </p:seq>
-          </p:childTnLst>
-        </p:cTn>
-      </p:par>
-    </p:tnLst>
-    <p:bldLst>
-      <p:bldP spid="3" grpId="0" uiExpand="1" build="p"/>
-    </p:bldLst>
-  </p:timing>
 </p:sld>
 </file>
 

</xml_diff>

<commit_message>
Add/changes images to use in ppt render. Updated all text for presentation and latest render output.
</commit_message>
<xml_diff>
--- a/NHP_SBR impacts_2024.pptx
+++ b/NHP_SBR impacts_2024.pptx
@@ -36,6 +36,16 @@
     <p:sldId id="284" r:id="rId33"/>
     <p:sldId id="285" r:id="rId34"/>
     <p:sldId id="286" r:id="rId35"/>
+    <p:sldId id="287" r:id="rId36"/>
+    <p:sldId id="288" r:id="rId37"/>
+    <p:sldId id="289" r:id="rId38"/>
+    <p:sldId id="290" r:id="rId39"/>
+    <p:sldId id="291" r:id="rId40"/>
+    <p:sldId id="292" r:id="rId41"/>
+    <p:sldId id="293" r:id="rId42"/>
+    <p:sldId id="294" r:id="rId43"/>
+    <p:sldId id="295" r:id="rId44"/>
+    <p:sldId id="296" r:id="rId45"/>
   </p:sldIdLst>
   <p:sldSz cx="12192000" cy="6858000"/>
   <p:notesSz cx="6858000" cy="9144000"/>
@@ -4210,7 +4220,7 @@
             <a:br/>
             <a:r>
               <a:rPr/>
-              <a:t>Andy Hood | Analytics Manager | Strategy Unit | 14th May 2024</a:t>
+              <a:t>Andy Hood | Analytics Manager | Strategy Unit | 10th June 2024</a:t>
             </a:r>
           </a:p>
         </p:txBody>
@@ -4244,13 +4254,13 @@
             <a:spLocks noGrp="1"/>
           </p:cNvSpPr>
           <p:nvPr>
-            <p:ph hasCustomPrompt="1" type="ctrTitle"/>
+            <p:ph hasCustomPrompt="1" type="title"/>
           </p:nvPr>
         </p:nvSpPr>
         <p:spPr>
           <a:xfrm>
-            <a:off x="457199" y="4665306"/>
-            <a:ext cx="7772400" cy="1308413"/>
+            <a:off x="909829" y="438150"/>
+            <a:ext cx="8434196" cy="914400"/>
           </a:xfrm>
         </p:spPr>
         <p:txBody>
@@ -4262,11 +4272,72 @@
             </a:pPr>
             <a:r>
               <a:rPr/>
-              <a:t>3. The hospitals</a:t>
-            </a:r>
-          </a:p>
-        </p:txBody>
-      </p:sp>
+              <a:t>2.4 Summary of key findings (2)</a:t>
+            </a:r>
+          </a:p>
+        </p:txBody>
+      </p:sp>
+      <p:sp>
+        <p:nvSpPr>
+          <p:cNvPr id="7" name="Text Placeholder 6">
+            <a:extLst>
+              <a:ext uri="{FF2B5EF4-FFF2-40B4-BE49-F238E27FC236}">
+                <a16:creationId xmlns:a16="http://schemas.microsoft.com/office/drawing/2014/main" id="{DE622849-4EA7-24AE-DD96-E693EAA81594}"/>
+              </a:ext>
+            </a:extLst>
+          </p:cNvPr>
+          <p:cNvSpPr>
+            <a:spLocks noGrp="1"/>
+          </p:cNvSpPr>
+          <p:nvPr>
+            <p:ph idx="13" sz="quarter" type="body"/>
+          </p:nvPr>
+        </p:nvSpPr>
+        <p:spPr/>
+        <p:txBody>
+          <a:bodyPr/>
+          <a:lstStyle/>
+          <a:p>
+            <a:pPr lvl="0" indent="0" marL="0">
+              <a:buNone/>
+            </a:pPr>
+            <a:r>
+              <a:rPr/>
+              <a:t>The table across demonstrates the range of impacts across all new hospital sites for each impact measure</a:t>
+            </a:r>
+          </a:p>
+        </p:txBody>
+      </p:sp>
+      <p:pic>
+        <p:nvPicPr>
+          <p:cNvPr descr="images/impact_range.jpeg" id="0" name="Picture 1"/>
+          <p:cNvPicPr>
+            <a:picLocks noGrp="1" noChangeAspect="1"/>
+          </p:cNvPicPr>
+          <p:nvPr/>
+        </p:nvPicPr>
+        <p:blipFill>
+          <a:blip r:embed="rId2"/>
+          <a:stretch>
+            <a:fillRect/>
+          </a:stretch>
+        </p:blipFill>
+        <p:spPr bwMode="auto">
+          <a:xfrm>
+            <a:off x="4127500" y="2374900"/>
+            <a:ext cx="7010400" cy="2616200"/>
+          </a:xfrm>
+          <a:prstGeom prst="rect">
+            <a:avLst/>
+          </a:prstGeom>
+          <a:noFill/>
+          <a:ln w="9525">
+            <a:noFill/>
+            <a:headEnd/>
+            <a:tailEnd/>
+          </a:ln>
+        </p:spPr>
+      </p:pic>
     </p:spTree>
   </p:cSld>
 </p:sld>
@@ -4301,8 +4372,8 @@
         </p:nvSpPr>
         <p:spPr>
           <a:xfrm>
-            <a:off x="909829" y="438150"/>
-            <a:ext cx="8434196" cy="914400"/>
+            <a:off x="909829" y="403765"/>
+            <a:ext cx="8434196" cy="976056"/>
           </a:xfrm>
         </p:spPr>
         <p:txBody>
@@ -4314,25 +4385,19 @@
             </a:pPr>
             <a:r>
               <a:rPr/>
-              <a:t>3.1 Seven natural experiments</a:t>
-            </a:r>
-          </a:p>
-        </p:txBody>
-      </p:sp>
-      <p:sp>
-        <p:nvSpPr>
-          <p:cNvPr id="7" name="Text Placeholder 6">
-            <a:extLst>
-              <a:ext uri="{FF2B5EF4-FFF2-40B4-BE49-F238E27FC236}">
-                <a16:creationId xmlns:a16="http://schemas.microsoft.com/office/drawing/2014/main" id="{DE622849-4EA7-24AE-DD96-E693EAA81594}"/>
-              </a:ext>
-            </a:extLst>
-          </p:cNvPr>
-          <p:cNvSpPr>
-            <a:spLocks noGrp="1"/>
-          </p:cNvSpPr>
-          <p:nvPr>
-            <p:ph idx="13" sz="quarter" type="body"/>
+              <a:t>2.5 Limitations</a:t>
+            </a:r>
+          </a:p>
+        </p:txBody>
+      </p:sp>
+      <p:sp>
+        <p:nvSpPr>
+          <p:cNvPr id="3" name="Content Placeholder 2"/>
+          <p:cNvSpPr>
+            <a:spLocks noGrp="1"/>
+          </p:cNvSpPr>
+          <p:nvPr>
+            <p:ph idx="1"/>
           </p:nvPr>
         </p:nvSpPr>
         <p:spPr/>
@@ -4343,83 +4408,53 @@
             <a:pPr lvl="0"/>
             <a:r>
               <a:rPr/>
-              <a:t>Royal Liverpool (Oct 2022)</a:t>
+              <a:t>Data quality and robustness</a:t>
             </a:r>
           </a:p>
           <a:p>
             <a:pPr lvl="0"/>
             <a:r>
               <a:rPr/>
-              <a:t>Clatterbridge Cancer Centre (June 2020)</a:t>
+              <a:t>No below site-level analysis</a:t>
             </a:r>
           </a:p>
           <a:p>
             <a:pPr lvl="0"/>
             <a:r>
               <a:rPr/>
-              <a:t>Royal Papworth Hospital (May 2019)</a:t>
+              <a:t>Sensitivity/Specificity of some of the measures</a:t>
             </a:r>
           </a:p>
           <a:p>
             <a:pPr lvl="0"/>
             <a:r>
               <a:rPr/>
-              <a:t>Chase Farm Hospital (Sept 2018)</a:t>
+              <a:t>Dose-response effects are not possible to ascertain (e.g. an x% change in SBR leads to a y% change in impact A)</a:t>
             </a:r>
           </a:p>
           <a:p>
             <a:pPr lvl="0"/>
             <a:r>
               <a:rPr/>
-              <a:t>Southmead Hospital (May 2014)</a:t>
+              <a:t>Covid 19 bias in some of the pre and post trends</a:t>
             </a:r>
           </a:p>
           <a:p>
             <a:pPr lvl="0"/>
             <a:r>
               <a:rPr/>
-              <a:t>Tunbridge Wells (Jan/Sept 2011)</a:t>
+              <a:t>Small pool of control sites and lack of similarity (specialist sites)</a:t>
             </a:r>
           </a:p>
           <a:p>
             <a:pPr lvl="0"/>
             <a:r>
               <a:rPr/>
-              <a:t>Peterborough Hospital (Nov 2010)</a:t>
-            </a:r>
-          </a:p>
-        </p:txBody>
-      </p:sp>
-      <p:pic>
-        <p:nvPicPr>
-          <p:cNvPr descr="images/hospitals_map.png" id="0" name="Picture 1"/>
-          <p:cNvPicPr>
-            <a:picLocks noGrp="1" noChangeAspect="1"/>
-          </p:cNvPicPr>
-          <p:nvPr/>
-        </p:nvPicPr>
-        <p:blipFill>
-          <a:blip r:embed="rId2"/>
-          <a:stretch>
-            <a:fillRect/>
-          </a:stretch>
-        </p:blipFill>
-        <p:spPr bwMode="auto">
-          <a:xfrm>
-            <a:off x="4406900" y="1549400"/>
-            <a:ext cx="6438900" cy="4254500"/>
-          </a:xfrm>
-          <a:prstGeom prst="rect">
-            <a:avLst/>
-          </a:prstGeom>
-          <a:noFill/>
-          <a:ln w="9525">
-            <a:noFill/>
-            <a:headEnd/>
-            <a:tailEnd/>
-          </a:ln>
-        </p:spPr>
-      </p:pic>
+              <a:t>Model fit and large credible intervals</a:t>
+            </a:r>
+          </a:p>
+        </p:txBody>
+      </p:sp>
     </p:spTree>
   </p:cSld>
 </p:sld>
@@ -4467,7 +4502,7 @@
             </a:pPr>
             <a:r>
               <a:rPr/>
-              <a:t>3.2 Heterogeneity</a:t>
+              <a:t>2.6 Recommendations</a:t>
             </a:r>
           </a:p>
         </p:txBody>
@@ -4487,21 +4522,52 @@
           <a:bodyPr/>
           <a:lstStyle/>
           <a:p>
-            <a:pPr lvl="0" indent="0" marL="0">
-              <a:buNone/>
-            </a:pPr>
-            <a:r>
-              <a:rPr/>
-              <a:t>No hospital site is the same as another. This is no more true than for our 7 natural experiments. The sites are a mixture of general acute hospitals and specialist ones. They vary in size and function and there are many possible confounding factors in the input-output logic model for our impacts that we can not identify nor account for.</a:t>
-            </a:r>
-          </a:p>
-          <a:p>
-            <a:pPr lvl="0" indent="0" marL="0">
-              <a:buNone/>
-            </a:pPr>
-            <a:r>
-              <a:rPr/>
-              <a:t>In aggregating some of the findings in this analysis, we have grouped the general acute sites together for indicative purposes. However; the nature of those hospital systems and the social and cultural circumstance should be considerations when both interpreting our findings and also in considering single-bed provision within hospital developments</a:t>
+            <a:pPr lvl="0"/>
+            <a:r>
+              <a:rPr/>
+              <a:t>Develop an evaluation framework from (some of) these measures, process indicators and wider evidence (logic model)</a:t>
+            </a:r>
+          </a:p>
+          <a:p>
+            <a:pPr lvl="0"/>
+            <a:r>
+              <a:rPr/>
+              <a:t>Include qualitative survey measures for patients and staff (free text for thematic analysis)</a:t>
+            </a:r>
+          </a:p>
+          <a:p>
+            <a:pPr lvl="0"/>
+            <a:r>
+              <a:rPr/>
+              <a:t>Capture information on design, systemic and cultural factors that may also have bearing on these impacts.</a:t>
+            </a:r>
+          </a:p>
+          <a:p>
+            <a:pPr lvl="0"/>
+            <a:r>
+              <a:rPr/>
+              <a:t>Start collecting data well before the change in bed provision and at least monthly!</a:t>
+            </a:r>
+          </a:p>
+          <a:p>
+            <a:pPr lvl="0"/>
+            <a:r>
+              <a:rPr/>
+              <a:t>System dynamics modelling would aid understanding of multi-factorial productivity impacts.</a:t>
+            </a:r>
+          </a:p>
+          <a:p>
+            <a:pPr lvl="0"/>
+            <a:r>
+              <a:rPr/>
+              <a:t>Length of Stay sub-group analysis i.e. by clinical and patient groups.</a:t>
+            </a:r>
+          </a:p>
+          <a:p>
+            <a:pPr lvl="0"/>
+            <a:r>
+              <a:rPr/>
+              <a:t>Mitigation strategy for staff wellbeing and retention.</a:t>
             </a:r>
           </a:p>
         </p:txBody>
@@ -4553,7 +4619,7 @@
             </a:pPr>
             <a:r>
               <a:rPr/>
-              <a:t>4. Summary of methods</a:t>
+              <a:t>3. The impact framework</a:t>
             </a:r>
           </a:p>
         </p:txBody>
@@ -4587,13 +4653,13 @@
             <a:spLocks noGrp="1"/>
           </p:cNvSpPr>
           <p:nvPr>
-            <p:ph type="title"/>
+            <p:ph hasCustomPrompt="1" type="title"/>
           </p:nvPr>
         </p:nvSpPr>
         <p:spPr>
           <a:xfrm>
-            <a:off x="919352" y="419100"/>
-            <a:ext cx="9720072" cy="933450"/>
+            <a:off x="909829" y="403765"/>
+            <a:ext cx="8434196" cy="976056"/>
           </a:xfrm>
         </p:spPr>
         <p:txBody>
@@ -4605,93 +4671,14 @@
             </a:pPr>
             <a:r>
               <a:rPr/>
-              <a:t>4.1 Selecting control sites</a:t>
-            </a:r>
-          </a:p>
-        </p:txBody>
-      </p:sp>
-      <p:sp>
-        <p:nvSpPr>
-          <p:cNvPr id="3" name="Content Placeholder 2">
-            <a:extLst>
-              <a:ext uri="{FF2B5EF4-FFF2-40B4-BE49-F238E27FC236}">
-                <a16:creationId xmlns:a16="http://schemas.microsoft.com/office/drawing/2014/main" id="{D2592819-5C80-B996-F823-F8B9F9EAD6C9}"/>
-              </a:ext>
-            </a:extLst>
-          </p:cNvPr>
-          <p:cNvSpPr>
-            <a:spLocks noGrp="1"/>
-          </p:cNvSpPr>
-          <p:nvPr>
-            <p:ph idx="10"/>
-          </p:nvPr>
-        </p:nvSpPr>
-        <p:spPr/>
-        <p:txBody>
-          <a:bodyPr/>
-          <a:lstStyle/>
-          <a:p>
-            <a:pPr lvl="0" indent="0" marL="0">
-              <a:buNone/>
-            </a:pPr>
-            <a:r>
-              <a:rPr/>
-              <a:t>Before including control sites into the calculation of the post-intervention counterfactual, we must ensure they’re similar to the site under study. We do this in several consecutive steps:</a:t>
-            </a:r>
-          </a:p>
-          <a:p>
-            <a:pPr lvl="0" indent="-457200" marL="457200">
-              <a:buAutoNum type="arabicPeriod"/>
-            </a:pPr>
-            <a:r>
-              <a:rPr/>
-              <a:t>Filter on similar site types e.g. General Acute, Tertiary Centre</a:t>
-            </a:r>
-          </a:p>
-          <a:p>
-            <a:pPr lvl="0" indent="-457200" marL="457200">
-              <a:buAutoNum type="arabicPeriod"/>
-            </a:pPr>
-            <a:r>
-              <a:rPr/>
-              <a:t>Exclude those with dissimilar single bed %’s at the point of intervention</a:t>
-            </a:r>
-          </a:p>
-          <a:p>
-            <a:pPr lvl="0" indent="-457200" marL="457200">
-              <a:buAutoNum type="arabicPeriod"/>
-            </a:pPr>
-            <a:r>
-              <a:rPr/>
-              <a:t>Match on (the closest 20) according to the following variables:</a:t>
-            </a:r>
-          </a:p>
-          <a:p>
-            <a:pPr lvl="0"/>
-            <a:r>
-              <a:rPr/>
-              <a:t>Hospital size (m2)</a:t>
-            </a:r>
-          </a:p>
-          <a:p>
-            <a:pPr lvl="0"/>
-            <a:r>
-              <a:rPr/>
-              <a:t>Patient case-mix (median age)</a:t>
-            </a:r>
-          </a:p>
-          <a:p>
-            <a:pPr lvl="0"/>
-            <a:r>
-              <a:rPr/>
-              <a:t>Elective:Non-elective spell ratio</a:t>
+              <a:t>3.1 Overview</a:t>
             </a:r>
           </a:p>
         </p:txBody>
       </p:sp>
       <p:pic>
         <p:nvPicPr>
-          <p:cNvPr descr="images/control_flowchart.png" id="0" name="Picture 1"/>
+          <p:cNvPr descr="images/indicators.jpeg" id="0" name="Picture 1"/>
           <p:cNvPicPr>
             <a:picLocks noGrp="1" noChangeAspect="1"/>
           </p:cNvPicPr>
@@ -4705,8 +4692,8 @@
         </p:blipFill>
         <p:spPr bwMode="auto">
           <a:xfrm>
-            <a:off x="6223000" y="1993900"/>
-            <a:ext cx="5041900" cy="3467100"/>
+            <a:off x="901700" y="2032000"/>
+            <a:ext cx="10414000" cy="3454400"/>
           </a:xfrm>
           <a:prstGeom prst="rect">
             <a:avLst/>
@@ -4748,13 +4735,13 @@
             <a:spLocks noGrp="1"/>
           </p:cNvSpPr>
           <p:nvPr>
-            <p:ph type="title"/>
+            <p:ph hasCustomPrompt="1" type="title"/>
           </p:nvPr>
         </p:nvSpPr>
         <p:spPr>
           <a:xfrm>
-            <a:off x="919352" y="419100"/>
-            <a:ext cx="9720072" cy="933450"/>
+            <a:off x="909829" y="403765"/>
+            <a:ext cx="8434196" cy="976056"/>
           </a:xfrm>
         </p:spPr>
         <p:txBody>
@@ -4766,54 +4753,14 @@
             </a:pPr>
             <a:r>
               <a:rPr/>
-              <a:t>4.2 Causal Impact Analysis</a:t>
-            </a:r>
-          </a:p>
-        </p:txBody>
-      </p:sp>
-      <p:sp>
-        <p:nvSpPr>
-          <p:cNvPr id="3" name="Content Placeholder 2">
-            <a:extLst>
-              <a:ext uri="{FF2B5EF4-FFF2-40B4-BE49-F238E27FC236}">
-                <a16:creationId xmlns:a16="http://schemas.microsoft.com/office/drawing/2014/main" id="{D2592819-5C80-B996-F823-F8B9F9EAD6C9}"/>
-              </a:ext>
-            </a:extLst>
-          </p:cNvPr>
-          <p:cNvSpPr>
-            <a:spLocks noGrp="1"/>
-          </p:cNvSpPr>
-          <p:nvPr>
-            <p:ph idx="10"/>
-          </p:nvPr>
-        </p:nvSpPr>
-        <p:spPr/>
-        <p:txBody>
-          <a:bodyPr/>
-          <a:lstStyle/>
-          <a:p>
-            <a:pPr lvl="0" indent="0" marL="0">
-              <a:buNone/>
-            </a:pPr>
-            <a:r>
-              <a:rPr/>
-              <a:t>Causal Impact Analysis (CIA), developed by K. Broderson in 2014, explicitly uses prior trends and ‘market-matched’ control analysis to predict a time series. The observed values for the study site are compared to this to determine the direction, magnitude and significance of impacts as a result of the intervention.</a:t>
-            </a:r>
-          </a:p>
-          <a:p>
-            <a:pPr lvl="0" indent="0" marL="0">
-              <a:buNone/>
-            </a:pPr>
-            <a:r>
-              <a:rPr/>
-              <a:t>All analysis has been performed in R software (v4.3.2+) with the following packages - CausalImpact, MarketMatching, dtw, metafor.</a:t>
+              <a:t>3.2 Indicator availability and time of SBR changes by site</a:t>
             </a:r>
           </a:p>
         </p:txBody>
       </p:sp>
       <p:pic>
         <p:nvPicPr>
-          <p:cNvPr descr="fig:  images/cia_example.png" id="0" name="Picture 1"/>
+          <p:cNvPr descr="NHP_SBR-impacts_2024_files/figure-pptx/ind_timeline-1.png" id="0" name="Picture 1"/>
           <p:cNvPicPr>
             <a:picLocks noGrp="1" noChangeAspect="1"/>
           </p:cNvPicPr>
@@ -4827,8 +4774,8 @@
         </p:blipFill>
         <p:spPr bwMode="auto">
           <a:xfrm>
-            <a:off x="7188200" y="1612900"/>
-            <a:ext cx="3098800" cy="3721100"/>
+            <a:off x="2032000" y="1727200"/>
+            <a:ext cx="8153400" cy="4076700"/>
           </a:xfrm>
           <a:prstGeom prst="rect">
             <a:avLst/>
@@ -4841,36 +4788,6 @@
           </a:ln>
         </p:spPr>
       </p:pic>
-      <p:sp>
-        <p:nvSpPr>
-          <p:cNvPr id="1" name="TextBox 3"/>
-          <p:cNvSpPr txBox="1"/>
-          <p:nvPr/>
-        </p:nvSpPr>
-        <p:spPr>
-          <a:xfrm>
-            <a:off x="6223000" y="5334000"/>
-            <a:ext cx="5041900" cy="508000"/>
-          </a:xfrm>
-          <a:prstGeom prst="rect">
-            <a:avLst/>
-          </a:prstGeom>
-          <a:noFill/>
-        </p:spPr>
-        <p:txBody>
-          <a:bodyPr/>
-          <a:lstStyle/>
-          <a:p>
-            <a:pPr lvl="0" indent="0" marL="0" algn="ctr">
-              <a:buNone/>
-            </a:pPr>
-            <a:r>
-              <a:rPr/>
-              <a:t>Example of CIA analysis</a:t>
-            </a:r>
-          </a:p>
-        </p:txBody>
-      </p:sp>
     </p:spTree>
   </p:cSld>
 </p:sld>
@@ -4900,13 +4817,13 @@
             <a:spLocks noGrp="1"/>
           </p:cNvSpPr>
           <p:nvPr>
-            <p:ph type="title"/>
+            <p:ph hasCustomPrompt="1" type="ctrTitle"/>
           </p:nvPr>
         </p:nvSpPr>
         <p:spPr>
           <a:xfrm>
-            <a:off x="919352" y="419100"/>
-            <a:ext cx="9720072" cy="933450"/>
+            <a:off x="457199" y="4665306"/>
+            <a:ext cx="7772400" cy="1308413"/>
           </a:xfrm>
         </p:spPr>
         <p:txBody>
@@ -4918,107 +4835,7 @@
             </a:pPr>
             <a:r>
               <a:rPr/>
-              <a:t>4.3 Aggregating impacts</a:t>
-            </a:r>
-          </a:p>
-        </p:txBody>
-      </p:sp>
-      <p:sp>
-        <p:nvSpPr>
-          <p:cNvPr id="3" name="Content Placeholder 2">
-            <a:extLst>
-              <a:ext uri="{FF2B5EF4-FFF2-40B4-BE49-F238E27FC236}">
-                <a16:creationId xmlns:a16="http://schemas.microsoft.com/office/drawing/2014/main" id="{D2592819-5C80-B996-F823-F8B9F9EAD6C9}"/>
-              </a:ext>
-            </a:extLst>
-          </p:cNvPr>
-          <p:cNvSpPr>
-            <a:spLocks noGrp="1"/>
-          </p:cNvSpPr>
-          <p:nvPr>
-            <p:ph idx="10"/>
-          </p:nvPr>
-        </p:nvSpPr>
-        <p:spPr/>
-        <p:txBody>
-          <a:bodyPr/>
-          <a:lstStyle/>
-          <a:p>
-            <a:pPr lvl="0" indent="0" marL="0">
-              <a:buNone/>
-            </a:pPr>
-            <a:r>
-              <a:rPr/>
-              <a:t>Where for each impact measure there were 2 or more general and acute hospitals, a meta-analysis was conducted. The specialist hospital sites were excluded from this analysis as it is felt the effects at these sites may not be generalisable when considering future building of general acute hospitals.</a:t>
-            </a:r>
-          </a:p>
-          <a:p>
-            <a:pPr lvl="0" indent="0" marL="0">
-              <a:buNone/>
-            </a:pPr>
-            <a:r>
-              <a:rPr/>
-              <a:t>A random-effects meta-analysis was conducted using the metafor R package (Viechtbauer 2024) and with the relative effects for each site weighted using the inverse variance, as used for meta-analysis of causal impact models by Schmitt et al. (Schmitt, Tull, and Atwater 2017).</a:t>
-            </a:r>
-          </a:p>
-        </p:txBody>
-      </p:sp>
-      <p:pic>
-        <p:nvPicPr>
-          <p:cNvPr descr="fig:  images/meta_example.png" id="0" name="Picture 1"/>
-          <p:cNvPicPr>
-            <a:picLocks noGrp="1" noChangeAspect="1"/>
-          </p:cNvPicPr>
-          <p:nvPr/>
-        </p:nvPicPr>
-        <p:blipFill>
-          <a:blip r:embed="rId2"/>
-          <a:stretch>
-            <a:fillRect/>
-          </a:stretch>
-        </p:blipFill>
-        <p:spPr bwMode="auto">
-          <a:xfrm>
-            <a:off x="6223000" y="2743200"/>
-            <a:ext cx="5041900" cy="1447800"/>
-          </a:xfrm>
-          <a:prstGeom prst="rect">
-            <a:avLst/>
-          </a:prstGeom>
-          <a:noFill/>
-          <a:ln w="9525">
-            <a:noFill/>
-            <a:headEnd/>
-            <a:tailEnd/>
-          </a:ln>
-        </p:spPr>
-      </p:pic>
-      <p:sp>
-        <p:nvSpPr>
-          <p:cNvPr id="1" name="TextBox 3"/>
-          <p:cNvSpPr txBox="1"/>
-          <p:nvPr/>
-        </p:nvSpPr>
-        <p:spPr>
-          <a:xfrm>
-            <a:off x="6223000" y="5334000"/>
-            <a:ext cx="5041900" cy="508000"/>
-          </a:xfrm>
-          <a:prstGeom prst="rect">
-            <a:avLst/>
-          </a:prstGeom>
-          <a:noFill/>
-        </p:spPr>
-        <p:txBody>
-          <a:bodyPr/>
-          <a:lstStyle/>
-          <a:p>
-            <a:pPr lvl="0" indent="0" marL="0" algn="ctr">
-              <a:buNone/>
-            </a:pPr>
-            <a:r>
-              <a:rPr/>
-              <a:t>Example of meta-analysis</a:t>
+              <a:t>4. The hospitals</a:t>
             </a:r>
           </a:p>
         </p:txBody>
@@ -5052,13 +4869,13 @@
             <a:spLocks noGrp="1"/>
           </p:cNvSpPr>
           <p:nvPr>
-            <p:ph hasCustomPrompt="1" type="ctrTitle"/>
+            <p:ph hasCustomPrompt="1" type="title"/>
           </p:nvPr>
         </p:nvSpPr>
         <p:spPr>
           <a:xfrm>
-            <a:off x="457199" y="4665306"/>
-            <a:ext cx="7772400" cy="1308413"/>
+            <a:off x="909829" y="438150"/>
+            <a:ext cx="8434196" cy="914400"/>
           </a:xfrm>
         </p:spPr>
         <p:txBody>
@@ -5070,11 +4887,112 @@
             </a:pPr>
             <a:r>
               <a:rPr/>
-              <a:t>5. Main results - Productivity and Efficiency</a:t>
-            </a:r>
-          </a:p>
-        </p:txBody>
-      </p:sp>
+              <a:t>4.1 Seven natural experiments</a:t>
+            </a:r>
+          </a:p>
+        </p:txBody>
+      </p:sp>
+      <p:sp>
+        <p:nvSpPr>
+          <p:cNvPr id="7" name="Text Placeholder 6">
+            <a:extLst>
+              <a:ext uri="{FF2B5EF4-FFF2-40B4-BE49-F238E27FC236}">
+                <a16:creationId xmlns:a16="http://schemas.microsoft.com/office/drawing/2014/main" id="{DE622849-4EA7-24AE-DD96-E693EAA81594}"/>
+              </a:ext>
+            </a:extLst>
+          </p:cNvPr>
+          <p:cNvSpPr>
+            <a:spLocks noGrp="1"/>
+          </p:cNvSpPr>
+          <p:nvPr>
+            <p:ph idx="13" sz="quarter" type="body"/>
+          </p:nvPr>
+        </p:nvSpPr>
+        <p:spPr/>
+        <p:txBody>
+          <a:bodyPr/>
+          <a:lstStyle/>
+          <a:p>
+            <a:pPr lvl="0"/>
+            <a:r>
+              <a:rPr/>
+              <a:t>Royal Liverpool (Oct 2022)</a:t>
+            </a:r>
+          </a:p>
+          <a:p>
+            <a:pPr lvl="0"/>
+            <a:r>
+              <a:rPr/>
+              <a:t>Clatterbridge Cancer Centre (June 2020)</a:t>
+            </a:r>
+          </a:p>
+          <a:p>
+            <a:pPr lvl="0"/>
+            <a:r>
+              <a:rPr/>
+              <a:t>Royal Papworth Hospital (May 2019)</a:t>
+            </a:r>
+          </a:p>
+          <a:p>
+            <a:pPr lvl="0"/>
+            <a:r>
+              <a:rPr/>
+              <a:t>Chase Farm Hospital (Sept 2018)</a:t>
+            </a:r>
+          </a:p>
+          <a:p>
+            <a:pPr lvl="0"/>
+            <a:r>
+              <a:rPr/>
+              <a:t>Southmead Hospital (May 2014)</a:t>
+            </a:r>
+          </a:p>
+          <a:p>
+            <a:pPr lvl="0"/>
+            <a:r>
+              <a:rPr/>
+              <a:t>Tunbridge Wells (Jan/Sept 2011)</a:t>
+            </a:r>
+          </a:p>
+          <a:p>
+            <a:pPr lvl="0"/>
+            <a:r>
+              <a:rPr/>
+              <a:t>Peterborough Hospital (Nov 2010)</a:t>
+            </a:r>
+          </a:p>
+        </p:txBody>
+      </p:sp>
+      <p:pic>
+        <p:nvPicPr>
+          <p:cNvPr descr="images/hospitals_map.png" id="0" name="Picture 1"/>
+          <p:cNvPicPr>
+            <a:picLocks noGrp="1" noChangeAspect="1"/>
+          </p:cNvPicPr>
+          <p:nvPr/>
+        </p:nvPicPr>
+        <p:blipFill>
+          <a:blip r:embed="rId2"/>
+          <a:stretch>
+            <a:fillRect/>
+          </a:stretch>
+        </p:blipFill>
+        <p:spPr bwMode="auto">
+          <a:xfrm>
+            <a:off x="4406900" y="1549400"/>
+            <a:ext cx="6438900" cy="4254500"/>
+          </a:xfrm>
+          <a:prstGeom prst="rect">
+            <a:avLst/>
+          </a:prstGeom>
+          <a:noFill/>
+          <a:ln w="9525">
+            <a:noFill/>
+            <a:headEnd/>
+            <a:tailEnd/>
+          </a:ln>
+        </p:spPr>
+      </p:pic>
     </p:spTree>
   </p:cSld>
 </p:sld>
@@ -5109,8 +5027,8 @@
         </p:nvSpPr>
         <p:spPr>
           <a:xfrm>
-            <a:off x="909829" y="438150"/>
-            <a:ext cx="8434196" cy="914400"/>
+            <a:off x="909829" y="403765"/>
+            <a:ext cx="8434196" cy="976056"/>
           </a:xfrm>
         </p:spPr>
         <p:txBody>
@@ -5122,25 +5040,19 @@
             </a:pPr>
             <a:r>
               <a:rPr/>
-              <a:t>5.1 Length of stay</a:t>
-            </a:r>
-          </a:p>
-        </p:txBody>
-      </p:sp>
-      <p:sp>
-        <p:nvSpPr>
-          <p:cNvPr id="7" name="Text Placeholder 6">
-            <a:extLst>
-              <a:ext uri="{FF2B5EF4-FFF2-40B4-BE49-F238E27FC236}">
-                <a16:creationId xmlns:a16="http://schemas.microsoft.com/office/drawing/2014/main" id="{DE622849-4EA7-24AE-DD96-E693EAA81594}"/>
-              </a:ext>
-            </a:extLst>
-          </p:cNvPr>
-          <p:cNvSpPr>
-            <a:spLocks noGrp="1"/>
-          </p:cNvSpPr>
-          <p:nvPr>
-            <p:ph idx="13" sz="quarter" type="body"/>
+              <a:t>4.2 Heterogeneity</a:t>
+            </a:r>
+          </a:p>
+        </p:txBody>
+      </p:sp>
+      <p:sp>
+        <p:nvSpPr>
+          <p:cNvPr id="3" name="Content Placeholder 2"/>
+          <p:cNvSpPr>
+            <a:spLocks noGrp="1"/>
+          </p:cNvSpPr>
+          <p:nvPr>
+            <p:ph idx="1"/>
           </p:nvPr>
         </p:nvSpPr>
         <p:spPr/>
@@ -5153,23 +5065,7 @@
             </a:pPr>
             <a:r>
               <a:rPr/>
-              <a:t>This </a:t>
-            </a:r>
-            <a:r>
-              <a:rPr b="1"/>
-              <a:t>monthly</a:t>
-            </a:r>
-            <a:r>
-              <a:rPr/>
-              <a:t> data at </a:t>
-            </a:r>
-            <a:r>
-              <a:rPr b="1"/>
-              <a:t>site level</a:t>
-            </a:r>
-            <a:r>
-              <a:rPr/>
-              <a:t> is derived from the Secondary Uses Service (SUS) admitted patients care spells.</a:t>
+              <a:t>No hospital site is the same as another. This is no more true than for our 7 natural experiments. The sites are a mixture of general acute hospitals and specialist ones. They vary in size and function and there are many possible confounding factors in the input-output logic model for our impacts that we can not identify nor account for.</a:t>
             </a:r>
           </a:p>
           <a:p>
@@ -5178,41 +5074,11 @@
             </a:pPr>
             <a:r>
               <a:rPr/>
-              <a:t>Mean length of stay (in days) significantly decreased at 3/6 sites (Southmead, Peterborough and Chase Farm), was unchanged at 2/6 sites (Royal Liverpool and Tunbridge Wells), but significantly increased at Clatterbridge.</a:t>
-            </a:r>
-          </a:p>
-        </p:txBody>
-      </p:sp>
-      <p:pic>
-        <p:nvPicPr>
-          <p:cNvPr descr="NHP_SBR-impacts_2024_files/figure-pptx/cia_los-1.png" id="0" name="Picture 1"/>
-          <p:cNvPicPr>
-            <a:picLocks noGrp="1" noChangeAspect="1"/>
-          </p:cNvPicPr>
-          <p:nvPr/>
-        </p:nvPicPr>
-        <p:blipFill>
-          <a:blip r:embed="rId2"/>
-          <a:stretch>
-            <a:fillRect/>
-          </a:stretch>
-        </p:blipFill>
-        <p:spPr bwMode="auto">
-          <a:xfrm>
-            <a:off x="4127500" y="1930400"/>
-            <a:ext cx="7010400" cy="3505200"/>
-          </a:xfrm>
-          <a:prstGeom prst="rect">
-            <a:avLst/>
-          </a:prstGeom>
-          <a:noFill/>
-          <a:ln w="9525">
-            <a:noFill/>
-            <a:headEnd/>
-            <a:tailEnd/>
-          </a:ln>
-        </p:spPr>
-      </p:pic>
+              <a:t>In aggregating some of the findings in this analysis, we have grouped the general acute sites together for indicative purposes. However; the nature of those hospital systems and the social and cultural circumstance should be considerations when both interpreting our findings and also in considering single-bed provision within hospital developments</a:t>
+            </a:r>
+          </a:p>
+        </p:txBody>
+      </p:sp>
     </p:spTree>
   </p:cSld>
 </p:sld>
@@ -5242,13 +5108,13 @@
             <a:spLocks noGrp="1"/>
           </p:cNvSpPr>
           <p:nvPr>
-            <p:ph hasCustomPrompt="1" type="title"/>
+            <p:ph hasCustomPrompt="1" type="ctrTitle"/>
           </p:nvPr>
         </p:nvSpPr>
         <p:spPr>
           <a:xfrm>
-            <a:off x="909829" y="438150"/>
-            <a:ext cx="8434196" cy="914400"/>
+            <a:off x="457199" y="4665306"/>
+            <a:ext cx="7772400" cy="1308413"/>
           </a:xfrm>
         </p:spPr>
         <p:txBody>
@@ -5260,97 +5126,11 @@
             </a:pPr>
             <a:r>
               <a:rPr/>
-              <a:t>5.2 Waiting time (median)</a:t>
-            </a:r>
-          </a:p>
-        </p:txBody>
-      </p:sp>
-      <p:sp>
-        <p:nvSpPr>
-          <p:cNvPr id="7" name="Text Placeholder 6">
-            <a:extLst>
-              <a:ext uri="{FF2B5EF4-FFF2-40B4-BE49-F238E27FC236}">
-                <a16:creationId xmlns:a16="http://schemas.microsoft.com/office/drawing/2014/main" id="{DE622849-4EA7-24AE-DD96-E693EAA81594}"/>
-              </a:ext>
-            </a:extLst>
-          </p:cNvPr>
-          <p:cNvSpPr>
-            <a:spLocks noGrp="1"/>
-          </p:cNvSpPr>
-          <p:nvPr>
-            <p:ph idx="13" sz="quarter" type="body"/>
-          </p:nvPr>
-        </p:nvSpPr>
-        <p:spPr/>
-        <p:txBody>
-          <a:bodyPr/>
-          <a:lstStyle/>
-          <a:p>
-            <a:pPr lvl="0" indent="0" marL="0">
-              <a:buNone/>
-            </a:pPr>
-            <a:r>
-              <a:rPr/>
-              <a:t>This </a:t>
-            </a:r>
-            <a:r>
-              <a:rPr b="1"/>
-              <a:t>monthly</a:t>
-            </a:r>
-            <a:r>
-              <a:rPr/>
-              <a:t> data at </a:t>
-            </a:r>
-            <a:r>
-              <a:rPr b="1"/>
-              <a:t>provider level</a:t>
-            </a:r>
-            <a:r>
-              <a:rPr/>
-              <a:t> is from published RTT waiting times dataset (via UDAL).</a:t>
-            </a:r>
-          </a:p>
-          <a:p>
-            <a:pPr lvl="0" indent="0" marL="0">
-              <a:buNone/>
-            </a:pPr>
-            <a:r>
-              <a:rPr/>
-              <a:t>The median referral to treatment waiting time (in weeks) significantly decreased at 2/5 sites (Royal Liverpool and Peterborough) and was unchanged at 2/5 sites (Papworth and Clatterbridge) and increased at Tunbridge Wells.</a:t>
-            </a:r>
-          </a:p>
-        </p:txBody>
-      </p:sp>
-      <p:pic>
-        <p:nvPicPr>
-          <p:cNvPr descr="NHP_SBR-impacts_2024_files/figure-pptx/cia_wait-1.png" id="0" name="Picture 1"/>
-          <p:cNvPicPr>
-            <a:picLocks noGrp="1" noChangeAspect="1"/>
-          </p:cNvPicPr>
-          <p:nvPr/>
-        </p:nvPicPr>
-        <p:blipFill>
-          <a:blip r:embed="rId2"/>
-          <a:stretch>
-            <a:fillRect/>
-          </a:stretch>
-        </p:blipFill>
-        <p:spPr bwMode="auto">
-          <a:xfrm>
-            <a:off x="4127500" y="1930400"/>
-            <a:ext cx="7010400" cy="3505200"/>
-          </a:xfrm>
-          <a:prstGeom prst="rect">
-            <a:avLst/>
-          </a:prstGeom>
-          <a:noFill/>
-          <a:ln w="9525">
-            <a:noFill/>
-            <a:headEnd/>
-            <a:tailEnd/>
-          </a:ln>
-        </p:spPr>
-      </p:pic>
+              <a:t>5. Summary of methods</a:t>
+            </a:r>
+          </a:p>
+        </p:txBody>
+      </p:sp>
     </p:spTree>
   </p:cSld>
 </p:sld>
@@ -5380,13 +5160,13 @@
             <a:spLocks noGrp="1"/>
           </p:cNvSpPr>
           <p:nvPr>
-            <p:ph hasCustomPrompt="1" type="ctrTitle"/>
+            <p:ph hasCustomPrompt="1" type="title"/>
           </p:nvPr>
         </p:nvSpPr>
         <p:spPr>
           <a:xfrm>
-            <a:off x="457199" y="4665306"/>
-            <a:ext cx="7772400" cy="1308413"/>
+            <a:off x="909829" y="403765"/>
+            <a:ext cx="8434196" cy="976056"/>
           </a:xfrm>
         </p:spPr>
         <p:txBody>
@@ -5398,7 +5178,44 @@
             </a:pPr>
             <a:r>
               <a:rPr/>
-              <a:t>1. Introduction, approach, summary and recommendations</a:t>
+              <a:t>0.1 Expectations for this session</a:t>
+            </a:r>
+          </a:p>
+        </p:txBody>
+      </p:sp>
+      <p:sp>
+        <p:nvSpPr>
+          <p:cNvPr id="3" name="Content Placeholder 2"/>
+          <p:cNvSpPr>
+            <a:spLocks noGrp="1"/>
+          </p:cNvSpPr>
+          <p:nvPr>
+            <p:ph idx="1"/>
+          </p:nvPr>
+        </p:nvSpPr>
+        <p:spPr/>
+        <p:txBody>
+          <a:bodyPr/>
+          <a:lstStyle/>
+          <a:p>
+            <a:pPr lvl="0"/>
+            <a:r>
+              <a:rPr/>
+              <a:t>Share progress and key findings to date</a:t>
+            </a:r>
+          </a:p>
+          <a:p>
+            <a:pPr lvl="0"/>
+            <a:r>
+              <a:rPr/>
+              <a:t>Gain insights and perspectives from wider stakeholders</a:t>
+            </a:r>
+          </a:p>
+          <a:p>
+            <a:pPr lvl="0"/>
+            <a:r>
+              <a:rPr/>
+              <a:t>Improve messaging and narratives</a:t>
             </a:r>
           </a:p>
         </p:txBody>
@@ -5432,13 +5249,13 @@
             <a:spLocks noGrp="1"/>
           </p:cNvSpPr>
           <p:nvPr>
-            <p:ph hasCustomPrompt="1" type="title"/>
+            <p:ph type="title"/>
           </p:nvPr>
         </p:nvSpPr>
         <p:spPr>
           <a:xfrm>
-            <a:off x="909829" y="438150"/>
-            <a:ext cx="8434196" cy="914400"/>
+            <a:off x="919352" y="419100"/>
+            <a:ext cx="9720072" cy="933450"/>
           </a:xfrm>
         </p:spPr>
         <p:txBody>
@@ -5450,17 +5267,17 @@
             </a:pPr>
             <a:r>
               <a:rPr/>
-              <a:t>5.3 Bed Occupancy</a:t>
-            </a:r>
-          </a:p>
-        </p:txBody>
-      </p:sp>
-      <p:sp>
-        <p:nvSpPr>
-          <p:cNvPr id="7" name="Text Placeholder 6">
+              <a:t>5.1 Selecting control sites</a:t>
+            </a:r>
+          </a:p>
+        </p:txBody>
+      </p:sp>
+      <p:sp>
+        <p:nvSpPr>
+          <p:cNvPr id="3" name="Content Placeholder 2">
             <a:extLst>
               <a:ext uri="{FF2B5EF4-FFF2-40B4-BE49-F238E27FC236}">
-                <a16:creationId xmlns:a16="http://schemas.microsoft.com/office/drawing/2014/main" id="{DE622849-4EA7-24AE-DD96-E693EAA81594}"/>
+                <a16:creationId xmlns:a16="http://schemas.microsoft.com/office/drawing/2014/main" id="{D2592819-5C80-B996-F823-F8B9F9EAD6C9}"/>
               </a:ext>
             </a:extLst>
           </p:cNvPr>
@@ -5468,7 +5285,7 @@
             <a:spLocks noGrp="1"/>
           </p:cNvSpPr>
           <p:nvPr>
-            <p:ph idx="13" sz="quarter" type="body"/>
+            <p:ph idx="10"/>
           </p:nvPr>
         </p:nvSpPr>
         <p:spPr/>
@@ -5481,39 +5298,62 @@
             </a:pPr>
             <a:r>
               <a:rPr/>
-              <a:t>This </a:t>
-            </a:r>
-            <a:r>
-              <a:rPr b="1"/>
-              <a:t>quarterly</a:t>
-            </a:r>
-            <a:r>
-              <a:rPr/>
-              <a:t> data at </a:t>
-            </a:r>
-            <a:r>
-              <a:rPr b="1"/>
-              <a:t>provider level</a:t>
-            </a:r>
-            <a:r>
-              <a:rPr/>
-              <a:t> is from published KH03 bed returns (via UDAL).</a:t>
-            </a:r>
-          </a:p>
-          <a:p>
-            <a:pPr lvl="0" indent="0" marL="0">
-              <a:buNone/>
+              <a:t>Before including control sites into the calculation of the post-intervention counterfactual, we must ensure they’re similar to the site under study. We do this in several consecutive steps:</a:t>
+            </a:r>
+          </a:p>
+          <a:p>
+            <a:pPr lvl="0" indent="-457200" marL="457200">
+              <a:buAutoNum type="arabicPeriod"/>
             </a:pPr>
             <a:r>
               <a:rPr/>
-              <a:t>Bed occupancy is measured quarterly and is only available at a Provider level. The percentage of available beds occupied significantly increased at 2/4 sites (Clatterbridge and Southmead) and was unchanged at 2/4 (Royal Liverpool and and Chase Farm).</a:t>
+              <a:t>Filter on similar site types e.g. General Acute, Tertiary Centre</a:t>
+            </a:r>
+          </a:p>
+          <a:p>
+            <a:pPr lvl="0" indent="-457200" marL="457200">
+              <a:buAutoNum type="arabicPeriod"/>
+            </a:pPr>
+            <a:r>
+              <a:rPr/>
+              <a:t>Exclude those with dissimilar single bed %’s at the point of intervention</a:t>
+            </a:r>
+          </a:p>
+          <a:p>
+            <a:pPr lvl="0" indent="-457200" marL="457200">
+              <a:buAutoNum type="arabicPeriod"/>
+            </a:pPr>
+            <a:r>
+              <a:rPr/>
+              <a:t>Match on (the closest 20) according to the following variables:</a:t>
+            </a:r>
+          </a:p>
+          <a:p>
+            <a:pPr lvl="0"/>
+            <a:r>
+              <a:rPr/>
+              <a:t>Hospital size (m2)</a:t>
+            </a:r>
+          </a:p>
+          <a:p>
+            <a:pPr lvl="0"/>
+            <a:r>
+              <a:rPr/>
+              <a:t>Patient case-mix (median age)</a:t>
+            </a:r>
+          </a:p>
+          <a:p>
+            <a:pPr lvl="0"/>
+            <a:r>
+              <a:rPr/>
+              <a:t>Elective:Non-elective spell ratio</a:t>
             </a:r>
           </a:p>
         </p:txBody>
       </p:sp>
       <p:pic>
         <p:nvPicPr>
-          <p:cNvPr descr="NHP_SBR-impacts_2024_files/figure-pptx/cia_bedocc-1.png" id="0" name="Picture 1"/>
+          <p:cNvPr descr="images/control_flowchart.png" id="0" name="Picture 1"/>
           <p:cNvPicPr>
             <a:picLocks noGrp="1" noChangeAspect="1"/>
           </p:cNvPicPr>
@@ -5527,8 +5367,8 @@
         </p:blipFill>
         <p:spPr bwMode="auto">
           <a:xfrm>
-            <a:off x="4127500" y="1930400"/>
-            <a:ext cx="7010400" cy="3505200"/>
+            <a:off x="6223000" y="1993900"/>
+            <a:ext cx="5041900" cy="3467100"/>
           </a:xfrm>
           <a:prstGeom prst="rect">
             <a:avLst/>
@@ -5570,13 +5410,13 @@
             <a:spLocks noGrp="1"/>
           </p:cNvSpPr>
           <p:nvPr>
-            <p:ph hasCustomPrompt="1" type="title"/>
+            <p:ph type="title"/>
           </p:nvPr>
         </p:nvSpPr>
         <p:spPr>
           <a:xfrm>
-            <a:off x="909829" y="438150"/>
-            <a:ext cx="8434196" cy="914400"/>
+            <a:off x="919352" y="419100"/>
+            <a:ext cx="9720072" cy="933450"/>
           </a:xfrm>
         </p:spPr>
         <p:txBody>
@@ -5588,17 +5428,17 @@
             </a:pPr>
             <a:r>
               <a:rPr/>
-              <a:t>5.4 Emergency readmissions</a:t>
-            </a:r>
-          </a:p>
-        </p:txBody>
-      </p:sp>
-      <p:sp>
-        <p:nvSpPr>
-          <p:cNvPr id="7" name="Text Placeholder 6">
+              <a:t>5.2 Causal Impact Analysis</a:t>
+            </a:r>
+          </a:p>
+        </p:txBody>
+      </p:sp>
+      <p:sp>
+        <p:nvSpPr>
+          <p:cNvPr id="3" name="Content Placeholder 2">
             <a:extLst>
               <a:ext uri="{FF2B5EF4-FFF2-40B4-BE49-F238E27FC236}">
-                <a16:creationId xmlns:a16="http://schemas.microsoft.com/office/drawing/2014/main" id="{DE622849-4EA7-24AE-DD96-E693EAA81594}"/>
+                <a16:creationId xmlns:a16="http://schemas.microsoft.com/office/drawing/2014/main" id="{D2592819-5C80-B996-F823-F8B9F9EAD6C9}"/>
               </a:ext>
             </a:extLst>
           </p:cNvPr>
@@ -5606,7 +5446,7 @@
             <a:spLocks noGrp="1"/>
           </p:cNvSpPr>
           <p:nvPr>
-            <p:ph idx="13" sz="quarter" type="body"/>
+            <p:ph idx="10"/>
           </p:nvPr>
         </p:nvSpPr>
         <p:spPr/>
@@ -5619,23 +5459,7 @@
             </a:pPr>
             <a:r>
               <a:rPr/>
-              <a:t>This </a:t>
-            </a:r>
-            <a:r>
-              <a:rPr b="1"/>
-              <a:t>monthly</a:t>
-            </a:r>
-            <a:r>
-              <a:rPr/>
-              <a:t> data at </a:t>
-            </a:r>
-            <a:r>
-              <a:rPr b="1"/>
-              <a:t>site level</a:t>
-            </a:r>
-            <a:r>
-              <a:rPr/>
-              <a:t> is derived from SUS admitted patient care records.</a:t>
+              <a:t>Causal Impact Analysis (CIA), developed by K. Broderson in 2014, explicitly uses prior trends and ‘market-matched’ control analysis to predict a time series. The observed values for the study site are compared to this to determine the direction, magnitude and significance of impacts as a result of the intervention.</a:t>
             </a:r>
           </a:p>
           <a:p>
@@ -5644,14 +5468,14 @@
             </a:pPr>
             <a:r>
               <a:rPr/>
-              <a:t>The percentage of admissions that are emergency readmissions &lt; 30 days of discharge significantly decreased at 3/7 sites (Tunbridge Wells, Peterborough and Clatterbridge) and was unchanged at the remaining 4/7 sites.</a:t>
+              <a:t>All analysis has been performed in R software (v4.3.2+) with the following packages - CausalImpact, MarketMatching, dtw, metafor.</a:t>
             </a:r>
           </a:p>
         </p:txBody>
       </p:sp>
       <p:pic>
         <p:nvPicPr>
-          <p:cNvPr descr="NHP_SBR-impacts_2024_files/figure-pptx/cia_emergreadm-1.png" id="0" name="Picture 1"/>
+          <p:cNvPr descr="fig:  images/cia_example.png" id="0" name="Picture 1"/>
           <p:cNvPicPr>
             <a:picLocks noGrp="1" noChangeAspect="1"/>
           </p:cNvPicPr>
@@ -5665,8 +5489,8 @@
         </p:blipFill>
         <p:spPr bwMode="auto">
           <a:xfrm>
-            <a:off x="4127500" y="1930400"/>
-            <a:ext cx="7010400" cy="3505200"/>
+            <a:off x="7188200" y="1612900"/>
+            <a:ext cx="3098800" cy="3721100"/>
           </a:xfrm>
           <a:prstGeom prst="rect">
             <a:avLst/>
@@ -5679,6 +5503,36 @@
           </a:ln>
         </p:spPr>
       </p:pic>
+      <p:sp>
+        <p:nvSpPr>
+          <p:cNvPr id="1" name="TextBox 3"/>
+          <p:cNvSpPr txBox="1"/>
+          <p:nvPr/>
+        </p:nvSpPr>
+        <p:spPr>
+          <a:xfrm>
+            <a:off x="6223000" y="5334000"/>
+            <a:ext cx="5041900" cy="508000"/>
+          </a:xfrm>
+          <a:prstGeom prst="rect">
+            <a:avLst/>
+          </a:prstGeom>
+          <a:noFill/>
+        </p:spPr>
+        <p:txBody>
+          <a:bodyPr/>
+          <a:lstStyle/>
+          <a:p>
+            <a:pPr lvl="0" indent="0" marL="0" algn="ctr">
+              <a:buNone/>
+            </a:pPr>
+            <a:r>
+              <a:rPr/>
+              <a:t>Example of CIA analysis</a:t>
+            </a:r>
+          </a:p>
+        </p:txBody>
+      </p:sp>
     </p:spTree>
   </p:cSld>
 </p:sld>
@@ -5708,13 +5562,13 @@
             <a:spLocks noGrp="1"/>
           </p:cNvSpPr>
           <p:nvPr>
-            <p:ph hasCustomPrompt="1" type="title"/>
+            <p:ph type="title"/>
           </p:nvPr>
         </p:nvSpPr>
         <p:spPr>
           <a:xfrm>
-            <a:off x="909829" y="438150"/>
-            <a:ext cx="8434196" cy="914400"/>
+            <a:off x="919352" y="419100"/>
+            <a:ext cx="9720072" cy="933450"/>
           </a:xfrm>
         </p:spPr>
         <p:txBody>
@@ -5726,17 +5580,17 @@
             </a:pPr>
             <a:r>
               <a:rPr/>
-              <a:t>5.5 Cleaning costs</a:t>
-            </a:r>
-          </a:p>
-        </p:txBody>
-      </p:sp>
-      <p:sp>
-        <p:nvSpPr>
-          <p:cNvPr id="7" name="Text Placeholder 6">
+              <a:t>5.3 Aggregating impacts</a:t>
+            </a:r>
+          </a:p>
+        </p:txBody>
+      </p:sp>
+      <p:sp>
+        <p:nvSpPr>
+          <p:cNvPr id="3" name="Content Placeholder 2">
             <a:extLst>
               <a:ext uri="{FF2B5EF4-FFF2-40B4-BE49-F238E27FC236}">
-                <a16:creationId xmlns:a16="http://schemas.microsoft.com/office/drawing/2014/main" id="{DE622849-4EA7-24AE-DD96-E693EAA81594}"/>
+                <a16:creationId xmlns:a16="http://schemas.microsoft.com/office/drawing/2014/main" id="{D2592819-5C80-B996-F823-F8B9F9EAD6C9}"/>
               </a:ext>
             </a:extLst>
           </p:cNvPr>
@@ -5744,7 +5598,7 @@
             <a:spLocks noGrp="1"/>
           </p:cNvSpPr>
           <p:nvPr>
-            <p:ph idx="13" sz="quarter" type="body"/>
+            <p:ph idx="10"/>
           </p:nvPr>
         </p:nvSpPr>
         <p:spPr/>
@@ -5757,23 +5611,7 @@
             </a:pPr>
             <a:r>
               <a:rPr/>
-              <a:t>This </a:t>
-            </a:r>
-            <a:r>
-              <a:rPr b="1"/>
-              <a:t>annual</a:t>
-            </a:r>
-            <a:r>
-              <a:rPr/>
-              <a:t> data at </a:t>
-            </a:r>
-            <a:r>
-              <a:rPr b="1"/>
-              <a:t>site level</a:t>
-            </a:r>
-            <a:r>
-              <a:rPr/>
-              <a:t> is taken from published Estates Return Information Collection (ERIC) datasets.</a:t>
+              <a:t>Where for each impact measure there were 2 or more general and acute hospitals, a meta-analysis was conducted. The specialist hospital sites were excluded from this analysis as it is felt the effects at these sites may not be generalisable when considering future building of general acute hospitals.</a:t>
             </a:r>
           </a:p>
           <a:p>
@@ -5782,14 +5620,14 @@
             </a:pPr>
             <a:r>
               <a:rPr/>
-              <a:t>The cleaning costs (in £) per square metre of occupied floor space significantly increased at 1/3 sites (Royal Liverpool) but decreased at 2/3 sites (Clatterbridge and Papworth).</a:t>
+              <a:t>A random-effects meta-analysis was conducted using the metafor R package (Viechtbauer 2024) and with the relative effects for each site weighted using the inverse variance, as used for meta-analysis of causal impact models by Schmitt et al. (Schmitt, Tull, and Atwater 2017).</a:t>
             </a:r>
           </a:p>
         </p:txBody>
       </p:sp>
       <p:pic>
         <p:nvPicPr>
-          <p:cNvPr descr="NHP_SBR-impacts_2024_files/figure-pptx/cia_cleaning-1.png" id="0" name="Picture 1"/>
+          <p:cNvPr descr="fig:  images/meta_example.png" id="0" name="Picture 1"/>
           <p:cNvPicPr>
             <a:picLocks noGrp="1" noChangeAspect="1"/>
           </p:cNvPicPr>
@@ -5803,8 +5641,8 @@
         </p:blipFill>
         <p:spPr bwMode="auto">
           <a:xfrm>
-            <a:off x="4127500" y="1930400"/>
-            <a:ext cx="7010400" cy="3505200"/>
+            <a:off x="6223000" y="2743200"/>
+            <a:ext cx="5041900" cy="1447800"/>
           </a:xfrm>
           <a:prstGeom prst="rect">
             <a:avLst/>
@@ -5817,6 +5655,36 @@
           </a:ln>
         </p:spPr>
       </p:pic>
+      <p:sp>
+        <p:nvSpPr>
+          <p:cNvPr id="1" name="TextBox 3"/>
+          <p:cNvSpPr txBox="1"/>
+          <p:nvPr/>
+        </p:nvSpPr>
+        <p:spPr>
+          <a:xfrm>
+            <a:off x="6223000" y="5334000"/>
+            <a:ext cx="5041900" cy="508000"/>
+          </a:xfrm>
+          <a:prstGeom prst="rect">
+            <a:avLst/>
+          </a:prstGeom>
+          <a:noFill/>
+        </p:spPr>
+        <p:txBody>
+          <a:bodyPr/>
+          <a:lstStyle/>
+          <a:p>
+            <a:pPr lvl="0" indent="0" marL="0" algn="ctr">
+              <a:buNone/>
+            </a:pPr>
+            <a:r>
+              <a:rPr/>
+              <a:t>Example of meta-analysis</a:t>
+            </a:r>
+          </a:p>
+        </p:txBody>
+      </p:sp>
     </p:spTree>
   </p:cSld>
 </p:sld>
@@ -5864,7 +5732,7 @@
             </a:pPr>
             <a:r>
               <a:rPr/>
-              <a:t>6. Main results - Health and Safety</a:t>
+              <a:t>6. Main results - Productivity and Efficiency</a:t>
             </a:r>
           </a:p>
         </p:txBody>
@@ -5916,7 +5784,7 @@
             </a:pPr>
             <a:r>
               <a:rPr/>
-              <a:t>6.1 In-hospital deaths</a:t>
+              <a:t>6.1 Length of stay</a:t>
             </a:r>
           </a:p>
         </p:txBody>
@@ -5963,7 +5831,7 @@
             </a:r>
             <a:r>
               <a:rPr/>
-              <a:t> is derived from SUS admitted patient care records.</a:t>
+              <a:t> is derived from the Secondary Uses Service (SUS) admitted patients care spells.</a:t>
             </a:r>
           </a:p>
           <a:p>
@@ -5972,14 +5840,14 @@
             </a:pPr>
             <a:r>
               <a:rPr/>
-              <a:t>The rate of in-hospital deaths (number per 1,000 discharges) significantly decreased at 1/5 sites (Peterborough), and was unchanged at 4/5 sites (Royal Liverpool, Tunbridge Wells, Clatterbridge and Southmead).</a:t>
+              <a:t>Mean length of stay (in days) significantly decreased at 3/6 sites (Southmead, Peterborough and Chase Farm), was unchanged at 2/6 sites (Royal Liverpool and Tunbridge Wells), but significantly increased at Clatterbridge.</a:t>
             </a:r>
           </a:p>
         </p:txBody>
       </p:sp>
       <p:pic>
         <p:nvPicPr>
-          <p:cNvPr descr="NHP_SBR-impacts_2024_files/figure-pptx/cia_mort-1.png" id="0" name="Picture 1"/>
+          <p:cNvPr descr="NHP_SBR-impacts_2024_files/figure-pptx/cia_los-1.png" id="0" name="Picture 1"/>
           <p:cNvPicPr>
             <a:picLocks noGrp="1" noChangeAspect="1"/>
           </p:cNvPicPr>
@@ -6054,7 +5922,7 @@
             </a:pPr>
             <a:r>
               <a:rPr/>
-              <a:t>6.2 In-hospital falls and injuries</a:t>
+              <a:t>6.2 Waiting time (median)</a:t>
             </a:r>
           </a:p>
         </p:txBody>
@@ -6097,11 +5965,11 @@
             </a:r>
             <a:r>
               <a:rPr b="1"/>
-              <a:t>site level</a:t>
-            </a:r>
-            <a:r>
-              <a:rPr/>
-              <a:t> is derived from SUS admitted patient care records.</a:t>
+              <a:t>provider level</a:t>
+            </a:r>
+            <a:r>
+              <a:rPr/>
+              <a:t> is from published RTT waiting times dataset (via UDAL).</a:t>
             </a:r>
           </a:p>
           <a:p>
@@ -6110,14 +5978,14 @@
             </a:pPr>
             <a:r>
               <a:rPr/>
-              <a:t>The rate of in-hospital falls and injuries (% of spells) significantly decreased at 1/4 sites (Peterborough), and was unchanged at 3/4 sites (Royal Liverpool, Tunbridge Wells and Southmead).</a:t>
+              <a:t>The median referral to treatment waiting time (in weeks) significantly decreased at 2/5 sites (Royal Liverpool and Peterborough) and was unchanged at 2/5 sites (Papworth and Clatterbridge) and increased at Tunbridge Wells.</a:t>
             </a:r>
           </a:p>
         </p:txBody>
       </p:sp>
       <p:pic>
         <p:nvPicPr>
-          <p:cNvPr descr="NHP_SBR-impacts_2024_files/figure-pptx/cia_falls-1.png" id="0" name="Picture 1"/>
+          <p:cNvPr descr="NHP_SBR-impacts_2024_files/figure-pptx/cia_wait-1.png" id="0" name="Picture 1"/>
           <p:cNvPicPr>
             <a:picLocks noGrp="1" noChangeAspect="1"/>
           </p:cNvPicPr>
@@ -6192,7 +6060,7 @@
             </a:pPr>
             <a:r>
               <a:rPr/>
-              <a:t>6.3 Healthcare Acquired Infections (HCAI) - clostridium dificile</a:t>
+              <a:t>6.3 Bed Occupancy</a:t>
             </a:r>
           </a:p>
         </p:txBody>
@@ -6227,7 +6095,7 @@
             </a:r>
             <a:r>
               <a:rPr b="1"/>
-              <a:t>monthly</a:t>
+              <a:t>quarterly</a:t>
             </a:r>
             <a:r>
               <a:rPr/>
@@ -6239,7 +6107,7 @@
             </a:r>
             <a:r>
               <a:rPr/>
-              <a:t> is taken from published UKHSA surveillance data (via UDAL).</a:t>
+              <a:t> is from published KH03 bed returns (via UDAL).</a:t>
             </a:r>
           </a:p>
           <a:p>
@@ -6248,14 +6116,14 @@
             </a:pPr>
             <a:r>
               <a:rPr/>
-              <a:t>The rate of healthcare acquired C. difficile infections (cases per 10,000 bed days) decreased at 2/3 sites (Chase Farm and Southmead) but was unchanged at Royal Liverpool.</a:t>
+              <a:t>Bed occupancy is measured quarterly and is only available at a Provider level. The percentage of available beds occupied significantly increased at 2/4 sites (Clatterbridge and Southmead) and was unchanged at 2/4 (Royal Liverpool and and Chase Farm).</a:t>
             </a:r>
           </a:p>
         </p:txBody>
       </p:sp>
       <p:pic>
         <p:nvPicPr>
-          <p:cNvPr descr="NHP_SBR-impacts_2024_files/figure-pptx/cia_hcai-1.png" id="0" name="Picture 1"/>
+          <p:cNvPr descr="NHP_SBR-impacts_2024_files/figure-pptx/cia_bedocc-1.png" id="0" name="Picture 1"/>
           <p:cNvPicPr>
             <a:picLocks noGrp="1" noChangeAspect="1"/>
           </p:cNvPicPr>
@@ -6312,13 +6180,13 @@
             <a:spLocks noGrp="1"/>
           </p:cNvSpPr>
           <p:nvPr>
-            <p:ph hasCustomPrompt="1" type="ctrTitle"/>
+            <p:ph hasCustomPrompt="1" type="title"/>
           </p:nvPr>
         </p:nvSpPr>
         <p:spPr>
           <a:xfrm>
-            <a:off x="457199" y="4665306"/>
-            <a:ext cx="7772400" cy="1308413"/>
+            <a:off x="909829" y="438150"/>
+            <a:ext cx="8434196" cy="914400"/>
           </a:xfrm>
         </p:spPr>
         <p:txBody>
@@ -6330,11 +6198,97 @@
             </a:pPr>
             <a:r>
               <a:rPr/>
-              <a:t>7. Main results - Patient and Staff Experience</a:t>
-            </a:r>
-          </a:p>
-        </p:txBody>
-      </p:sp>
+              <a:t>6.4 Emergency readmissions</a:t>
+            </a:r>
+          </a:p>
+        </p:txBody>
+      </p:sp>
+      <p:sp>
+        <p:nvSpPr>
+          <p:cNvPr id="7" name="Text Placeholder 6">
+            <a:extLst>
+              <a:ext uri="{FF2B5EF4-FFF2-40B4-BE49-F238E27FC236}">
+                <a16:creationId xmlns:a16="http://schemas.microsoft.com/office/drawing/2014/main" id="{DE622849-4EA7-24AE-DD96-E693EAA81594}"/>
+              </a:ext>
+            </a:extLst>
+          </p:cNvPr>
+          <p:cNvSpPr>
+            <a:spLocks noGrp="1"/>
+          </p:cNvSpPr>
+          <p:nvPr>
+            <p:ph idx="13" sz="quarter" type="body"/>
+          </p:nvPr>
+        </p:nvSpPr>
+        <p:spPr/>
+        <p:txBody>
+          <a:bodyPr/>
+          <a:lstStyle/>
+          <a:p>
+            <a:pPr lvl="0" indent="0" marL="0">
+              <a:buNone/>
+            </a:pPr>
+            <a:r>
+              <a:rPr/>
+              <a:t>This </a:t>
+            </a:r>
+            <a:r>
+              <a:rPr b="1"/>
+              <a:t>monthly</a:t>
+            </a:r>
+            <a:r>
+              <a:rPr/>
+              <a:t> data at </a:t>
+            </a:r>
+            <a:r>
+              <a:rPr b="1"/>
+              <a:t>site level</a:t>
+            </a:r>
+            <a:r>
+              <a:rPr/>
+              <a:t> is derived from SUS admitted patient care records.</a:t>
+            </a:r>
+          </a:p>
+          <a:p>
+            <a:pPr lvl="0" indent="0" marL="0">
+              <a:buNone/>
+            </a:pPr>
+            <a:r>
+              <a:rPr/>
+              <a:t>The percentage of admissions that are emergency readmissions &lt; 30 days of discharge significantly decreased at 3/7 sites (Tunbridge Wells, Peterborough and Clatterbridge) and was unchanged at the remaining 4/7 sites.</a:t>
+            </a:r>
+          </a:p>
+        </p:txBody>
+      </p:sp>
+      <p:pic>
+        <p:nvPicPr>
+          <p:cNvPr descr="NHP_SBR-impacts_2024_files/figure-pptx/cia_emergreadm-1.png" id="0" name="Picture 1"/>
+          <p:cNvPicPr>
+            <a:picLocks noGrp="1" noChangeAspect="1"/>
+          </p:cNvPicPr>
+          <p:nvPr/>
+        </p:nvPicPr>
+        <p:blipFill>
+          <a:blip r:embed="rId2"/>
+          <a:stretch>
+            <a:fillRect/>
+          </a:stretch>
+        </p:blipFill>
+        <p:spPr bwMode="auto">
+          <a:xfrm>
+            <a:off x="4127500" y="1930400"/>
+            <a:ext cx="7010400" cy="3505200"/>
+          </a:xfrm>
+          <a:prstGeom prst="rect">
+            <a:avLst/>
+          </a:prstGeom>
+          <a:noFill/>
+          <a:ln w="9525">
+            <a:noFill/>
+            <a:headEnd/>
+            <a:tailEnd/>
+          </a:ln>
+        </p:spPr>
+      </p:pic>
     </p:spTree>
   </p:cSld>
 </p:sld>
@@ -6382,7 +6336,7 @@
             </a:pPr>
             <a:r>
               <a:rPr/>
-              <a:t>7.1 Family and Friends test</a:t>
+              <a:t>6.5 Cleaning costs</a:t>
             </a:r>
           </a:p>
         </p:txBody>
@@ -6417,7 +6371,7 @@
             </a:r>
             <a:r>
               <a:rPr b="1"/>
-              <a:t>monthly</a:t>
+              <a:t>annual</a:t>
             </a:r>
             <a:r>
               <a:rPr/>
@@ -6429,7 +6383,7 @@
             </a:r>
             <a:r>
               <a:rPr/>
-              <a:t> is taken from published NHS England data (via UDAL).</a:t>
+              <a:t> is taken from published Estates Return Information Collection (ERIC) datasets.</a:t>
             </a:r>
           </a:p>
           <a:p>
@@ -6438,14 +6392,14 @@
             </a:pPr>
             <a:r>
               <a:rPr/>
-              <a:t>The percentage of positive responses significantly decreased at 1/5 sites (Clatterbridge), increased at 1/5 sites (Papworth) and was unchanged at the other 3/5 sites (Royal Liverpool, Southmead and Chase Farm).</a:t>
+              <a:t>The cleaning costs (in £) per square metre of occupied floor space significantly increased at 1/3 sites (Royal Liverpool) but decreased at 2/3 sites (Clatterbridge and Papworth).</a:t>
             </a:r>
           </a:p>
         </p:txBody>
       </p:sp>
       <p:pic>
         <p:nvPicPr>
-          <p:cNvPr descr="NHP_SBR-impacts_2024_files/figure-pptx/cia_famfriend-1.png" id="0" name="Picture 1"/>
+          <p:cNvPr descr="NHP_SBR-impacts_2024_files/figure-pptx/cia_cleaning-1.png" id="0" name="Picture 1"/>
           <p:cNvPicPr>
             <a:picLocks noGrp="1" noChangeAspect="1"/>
           </p:cNvPicPr>
@@ -6502,13 +6456,13 @@
             <a:spLocks noGrp="1"/>
           </p:cNvSpPr>
           <p:nvPr>
-            <p:ph hasCustomPrompt="1" type="title"/>
+            <p:ph hasCustomPrompt="1" type="ctrTitle"/>
           </p:nvPr>
         </p:nvSpPr>
         <p:spPr>
           <a:xfrm>
-            <a:off x="909829" y="438150"/>
-            <a:ext cx="8434196" cy="914400"/>
+            <a:off x="457199" y="4665306"/>
+            <a:ext cx="7772400" cy="1308413"/>
           </a:xfrm>
         </p:spPr>
         <p:txBody>
@@ -6520,97 +6474,11 @@
             </a:pPr>
             <a:r>
               <a:rPr/>
-              <a:t>7.2 Staff sickness absence</a:t>
-            </a:r>
-          </a:p>
-        </p:txBody>
-      </p:sp>
-      <p:sp>
-        <p:nvSpPr>
-          <p:cNvPr id="7" name="Text Placeholder 6">
-            <a:extLst>
-              <a:ext uri="{FF2B5EF4-FFF2-40B4-BE49-F238E27FC236}">
-                <a16:creationId xmlns:a16="http://schemas.microsoft.com/office/drawing/2014/main" id="{DE622849-4EA7-24AE-DD96-E693EAA81594}"/>
-              </a:ext>
-            </a:extLst>
-          </p:cNvPr>
-          <p:cNvSpPr>
-            <a:spLocks noGrp="1"/>
-          </p:cNvSpPr>
-          <p:nvPr>
-            <p:ph idx="13" sz="quarter" type="body"/>
-          </p:nvPr>
-        </p:nvSpPr>
-        <p:spPr/>
-        <p:txBody>
-          <a:bodyPr/>
-          <a:lstStyle/>
-          <a:p>
-            <a:pPr lvl="0" indent="0" marL="0">
-              <a:buNone/>
-            </a:pPr>
-            <a:r>
-              <a:rPr/>
-              <a:t>This </a:t>
-            </a:r>
-            <a:r>
-              <a:rPr b="1"/>
-              <a:t>monthly</a:t>
-            </a:r>
-            <a:r>
-              <a:rPr/>
-              <a:t> data at </a:t>
-            </a:r>
-            <a:r>
-              <a:rPr b="1"/>
-              <a:t>provider level</a:t>
-            </a:r>
-            <a:r>
-              <a:rPr/>
-              <a:t> is taken from published NHS England data (via UDAL).</a:t>
-            </a:r>
-          </a:p>
-          <a:p>
-            <a:pPr lvl="0" indent="0" marL="0">
-              <a:buNone/>
-            </a:pPr>
-            <a:r>
-              <a:rPr/>
-              <a:t>The percentage of available days taken off sick by staff significantly increased at 2/7 sites (Southmead and Tunbridge Wells) and was unchanged at the remaining 5 sites.</a:t>
-            </a:r>
-          </a:p>
-        </p:txBody>
-      </p:sp>
-      <p:pic>
-        <p:nvPicPr>
-          <p:cNvPr descr="NHP_SBR-impacts_2024_files/figure-pptx/cia_sick-1.png" id="0" name="Picture 1"/>
-          <p:cNvPicPr>
-            <a:picLocks noGrp="1" noChangeAspect="1"/>
-          </p:cNvPicPr>
-          <p:nvPr/>
-        </p:nvPicPr>
-        <p:blipFill>
-          <a:blip r:embed="rId2"/>
-          <a:stretch>
-            <a:fillRect/>
-          </a:stretch>
-        </p:blipFill>
-        <p:spPr bwMode="auto">
-          <a:xfrm>
-            <a:off x="4127500" y="1930400"/>
-            <a:ext cx="7010400" cy="3505200"/>
-          </a:xfrm>
-          <a:prstGeom prst="rect">
-            <a:avLst/>
-          </a:prstGeom>
-          <a:noFill/>
-          <a:ln w="9525">
-            <a:noFill/>
-            <a:headEnd/>
-            <a:tailEnd/>
-          </a:ln>
-        </p:spPr>
-      </p:pic>
+              <a:t>7. Main results - Health and Safety</a:t>
+            </a:r>
+          </a:p>
+        </p:txBody>
+      </p:sp>
     </p:spTree>
   </p:cSld>
 </p:sld>
@@ -6640,13 +6508,13 @@
             <a:spLocks noGrp="1"/>
           </p:cNvSpPr>
           <p:nvPr>
-            <p:ph type="title"/>
+            <p:ph hasCustomPrompt="1" type="ctrTitle"/>
           </p:nvPr>
         </p:nvSpPr>
         <p:spPr>
           <a:xfrm>
-            <a:off x="919352" y="419100"/>
-            <a:ext cx="9720072" cy="933450"/>
+            <a:off x="457199" y="4665306"/>
+            <a:ext cx="7772400" cy="1308413"/>
           </a:xfrm>
         </p:spPr>
         <p:txBody>
@@ -6658,78 +6526,7 @@
             </a:pPr>
             <a:r>
               <a:rPr/>
-              <a:t>1.1 Introduction</a:t>
-            </a:r>
-          </a:p>
-        </p:txBody>
-      </p:sp>
-      <p:sp>
-        <p:nvSpPr>
-          <p:cNvPr id="3" name="Content Placeholder 2">
-            <a:extLst>
-              <a:ext uri="{FF2B5EF4-FFF2-40B4-BE49-F238E27FC236}">
-                <a16:creationId xmlns:a16="http://schemas.microsoft.com/office/drawing/2014/main" id="{D2592819-5C80-B996-F823-F8B9F9EAD6C9}"/>
-              </a:ext>
-            </a:extLst>
-          </p:cNvPr>
-          <p:cNvSpPr>
-            <a:spLocks noGrp="1"/>
-          </p:cNvSpPr>
-          <p:nvPr>
-            <p:ph idx="10"/>
-          </p:nvPr>
-        </p:nvSpPr>
-        <p:spPr/>
-        <p:txBody>
-          <a:bodyPr/>
-          <a:lstStyle/>
-          <a:p>
-            <a:pPr lvl="0" indent="0" marL="0">
-              <a:buNone/>
-            </a:pPr>
-            <a:r>
-              <a:rPr/>
-              <a:t>Since it’s inception, the New Hospital Programme (NHP) has advocated for single bed rooms (SBR). The grounds for this are based on a range of guidance, evidence and previous policy statements of intent. Whilst that position is unequivocal, there is uncertainty around the quantification of impacts of such a change and thus the assumptions that feed into demand and capacity models and economic business cases for current and future new hospital developments.</a:t>
-            </a:r>
-          </a:p>
-        </p:txBody>
-      </p:sp>
-      <p:sp>
-        <p:nvSpPr>
-          <p:cNvPr id="4" name="Content Placeholder 2">
-            <a:extLst>
-              <a:ext uri="{FF2B5EF4-FFF2-40B4-BE49-F238E27FC236}">
-                <a16:creationId xmlns:a16="http://schemas.microsoft.com/office/drawing/2014/main" id="{D1BAB7DA-EC53-0103-E362-83F86BDB6BC4}"/>
-              </a:ext>
-            </a:extLst>
-          </p:cNvPr>
-          <p:cNvSpPr>
-            <a:spLocks noGrp="1"/>
-          </p:cNvSpPr>
-          <p:nvPr>
-            <p:ph idx="11"/>
-          </p:nvPr>
-        </p:nvSpPr>
-        <p:spPr/>
-        <p:txBody>
-          <a:bodyPr/>
-          <a:lstStyle/>
-          <a:p>
-            <a:pPr lvl="0" indent="0" marL="0">
-              <a:buNone/>
-            </a:pPr>
-            <a:r>
-              <a:rPr/>
-              <a:t>Specifically, a starting assumption was that a length of stay reduction of 12% was likely for all new SBR facilities compared to prior trends. This assumption was criticised by the national audit office (NAO) (Office 2023) in the face of a mixed evidence base.</a:t>
-            </a:r>
-          </a:p>
-          <a:p>
-            <a:pPr lvl="0" indent="0" marL="0">
-              <a:buNone/>
-            </a:pPr>
-            <a:r>
-              <a:rPr/>
-              <a:t>It is the express aim of this analysis therefore to quantify the range of likely impacts for length of stay and a basket of other measures across patient &amp; staff experience, productivity and health &amp; safety.</a:t>
+              <a:t>1. Headlines and Highlights</a:t>
             </a:r>
           </a:p>
         </p:txBody>
@@ -6781,7 +6578,7 @@
             </a:pPr>
             <a:r>
               <a:rPr/>
-              <a:t>7.3 Staff turnover</a:t>
+              <a:t>7.1 In-hospital deaths</a:t>
             </a:r>
           </a:p>
         </p:txBody>
@@ -6824,11 +6621,11 @@
             </a:r>
             <a:r>
               <a:rPr b="1"/>
-              <a:t>provider level</a:t>
-            </a:r>
-            <a:r>
-              <a:rPr/>
-              <a:t> is taken from published NHS England data (via UDAL).</a:t>
+              <a:t>site level</a:t>
+            </a:r>
+            <a:r>
+              <a:rPr/>
+              <a:t> is derived from SUS admitted patient care records.</a:t>
             </a:r>
           </a:p>
           <a:p>
@@ -6837,14 +6634,14 @@
             </a:pPr>
             <a:r>
               <a:rPr/>
-              <a:t>Staff turnover measured as percentage of staff leaving was not significantly changed at any of the 3 sites where data was available.</a:t>
+              <a:t>The rate of in-hospital deaths (number per 1,000 discharges) significantly decreased at 1/5 sites (Peterborough), and was unchanged at 4/5 sites (Royal Liverpool, Tunbridge Wells, Clatterbridge and Southmead).</a:t>
             </a:r>
           </a:p>
         </p:txBody>
       </p:sp>
       <p:pic>
         <p:nvPicPr>
-          <p:cNvPr descr="NHP_SBR-impacts_2024_files/figure-pptx/cia_turnover-1.png" id="0" name="Picture 1"/>
+          <p:cNvPr descr="NHP_SBR-impacts_2024_files/figure-pptx/cia_mort-1.png" id="0" name="Picture 1"/>
           <p:cNvPicPr>
             <a:picLocks noGrp="1" noChangeAspect="1"/>
           </p:cNvPicPr>
@@ -6919,7 +6716,749 @@
             </a:pPr>
             <a:r>
               <a:rPr/>
-              <a:t>7.4 Staff survey - recommending place to work</a:t>
+              <a:t>7.2 In-hospital falls and injuries</a:t>
+            </a:r>
+          </a:p>
+        </p:txBody>
+      </p:sp>
+      <p:sp>
+        <p:nvSpPr>
+          <p:cNvPr id="7" name="Text Placeholder 6">
+            <a:extLst>
+              <a:ext uri="{FF2B5EF4-FFF2-40B4-BE49-F238E27FC236}">
+                <a16:creationId xmlns:a16="http://schemas.microsoft.com/office/drawing/2014/main" id="{DE622849-4EA7-24AE-DD96-E693EAA81594}"/>
+              </a:ext>
+            </a:extLst>
+          </p:cNvPr>
+          <p:cNvSpPr>
+            <a:spLocks noGrp="1"/>
+          </p:cNvSpPr>
+          <p:nvPr>
+            <p:ph idx="13" sz="quarter" type="body"/>
+          </p:nvPr>
+        </p:nvSpPr>
+        <p:spPr/>
+        <p:txBody>
+          <a:bodyPr/>
+          <a:lstStyle/>
+          <a:p>
+            <a:pPr lvl="0" indent="0" marL="0">
+              <a:buNone/>
+            </a:pPr>
+            <a:r>
+              <a:rPr/>
+              <a:t>This </a:t>
+            </a:r>
+            <a:r>
+              <a:rPr b="1"/>
+              <a:t>monthly</a:t>
+            </a:r>
+            <a:r>
+              <a:rPr/>
+              <a:t> data at </a:t>
+            </a:r>
+            <a:r>
+              <a:rPr b="1"/>
+              <a:t>site level</a:t>
+            </a:r>
+            <a:r>
+              <a:rPr/>
+              <a:t> is derived from SUS admitted patient care records.</a:t>
+            </a:r>
+          </a:p>
+          <a:p>
+            <a:pPr lvl="0" indent="0" marL="0">
+              <a:buNone/>
+            </a:pPr>
+            <a:r>
+              <a:rPr/>
+              <a:t>The rate of in-hospital falls and injuries (% of spells) significantly decreased at 1/4 sites (Peterborough), and was unchanged at 3/4 sites (Royal Liverpool, Tunbridge Wells and Southmead).</a:t>
+            </a:r>
+          </a:p>
+        </p:txBody>
+      </p:sp>
+      <p:pic>
+        <p:nvPicPr>
+          <p:cNvPr descr="NHP_SBR-impacts_2024_files/figure-pptx/cia_falls-1.png" id="0" name="Picture 1"/>
+          <p:cNvPicPr>
+            <a:picLocks noGrp="1" noChangeAspect="1"/>
+          </p:cNvPicPr>
+          <p:nvPr/>
+        </p:nvPicPr>
+        <p:blipFill>
+          <a:blip r:embed="rId2"/>
+          <a:stretch>
+            <a:fillRect/>
+          </a:stretch>
+        </p:blipFill>
+        <p:spPr bwMode="auto">
+          <a:xfrm>
+            <a:off x="4127500" y="1930400"/>
+            <a:ext cx="7010400" cy="3505200"/>
+          </a:xfrm>
+          <a:prstGeom prst="rect">
+            <a:avLst/>
+          </a:prstGeom>
+          <a:noFill/>
+          <a:ln w="9525">
+            <a:noFill/>
+            <a:headEnd/>
+            <a:tailEnd/>
+          </a:ln>
+        </p:spPr>
+      </p:pic>
+    </p:spTree>
+  </p:cSld>
+</p:sld>
+</file>
+
+<file path=ppt/slides/slide32.xml><?xml version="1.0" encoding="utf-8"?>
+<p:sld xmlns:a="http://schemas.openxmlformats.org/drawingml/2006/main" xmlns:r="http://schemas.openxmlformats.org/officeDocument/2006/relationships" xmlns:p="http://schemas.openxmlformats.org/presentationml/2006/main">
+  <p:cSld>
+    <p:spTree>
+      <p:nvGrpSpPr>
+        <p:cNvPr id="1" name=""/>
+        <p:cNvGrpSpPr/>
+        <p:nvPr/>
+      </p:nvGrpSpPr>
+      <p:grpSpPr>
+        <a:xfrm>
+          <a:off x="0" y="0"/>
+          <a:ext cx="0" cy="0"/>
+          <a:chOff x="0" y="0"/>
+          <a:chExt cx="0" cy="0"/>
+        </a:xfrm>
+      </p:grpSpPr>
+      <p:sp>
+        <p:nvSpPr>
+          <p:cNvPr id="2" name="Title 1"/>
+          <p:cNvSpPr>
+            <a:spLocks noGrp="1"/>
+          </p:cNvSpPr>
+          <p:nvPr>
+            <p:ph hasCustomPrompt="1" type="title"/>
+          </p:nvPr>
+        </p:nvSpPr>
+        <p:spPr>
+          <a:xfrm>
+            <a:off x="909829" y="438150"/>
+            <a:ext cx="8434196" cy="914400"/>
+          </a:xfrm>
+        </p:spPr>
+        <p:txBody>
+          <a:bodyPr/>
+          <a:lstStyle/>
+          <a:p>
+            <a:pPr lvl="0" indent="0" marL="0">
+              <a:buNone/>
+            </a:pPr>
+            <a:r>
+              <a:rPr/>
+              <a:t>7.3 Healthcare Acquired Infections (HCAI) - clostridium dificile</a:t>
+            </a:r>
+          </a:p>
+        </p:txBody>
+      </p:sp>
+      <p:sp>
+        <p:nvSpPr>
+          <p:cNvPr id="7" name="Text Placeholder 6">
+            <a:extLst>
+              <a:ext uri="{FF2B5EF4-FFF2-40B4-BE49-F238E27FC236}">
+                <a16:creationId xmlns:a16="http://schemas.microsoft.com/office/drawing/2014/main" id="{DE622849-4EA7-24AE-DD96-E693EAA81594}"/>
+              </a:ext>
+            </a:extLst>
+          </p:cNvPr>
+          <p:cNvSpPr>
+            <a:spLocks noGrp="1"/>
+          </p:cNvSpPr>
+          <p:nvPr>
+            <p:ph idx="13" sz="quarter" type="body"/>
+          </p:nvPr>
+        </p:nvSpPr>
+        <p:spPr/>
+        <p:txBody>
+          <a:bodyPr/>
+          <a:lstStyle/>
+          <a:p>
+            <a:pPr lvl="0" indent="0" marL="0">
+              <a:buNone/>
+            </a:pPr>
+            <a:r>
+              <a:rPr/>
+              <a:t>This </a:t>
+            </a:r>
+            <a:r>
+              <a:rPr b="1"/>
+              <a:t>monthly</a:t>
+            </a:r>
+            <a:r>
+              <a:rPr/>
+              <a:t> data at </a:t>
+            </a:r>
+            <a:r>
+              <a:rPr b="1"/>
+              <a:t>provider level</a:t>
+            </a:r>
+            <a:r>
+              <a:rPr/>
+              <a:t> is taken from published UKHSA surveillance data (via UDAL).</a:t>
+            </a:r>
+          </a:p>
+          <a:p>
+            <a:pPr lvl="0" indent="0" marL="0">
+              <a:buNone/>
+            </a:pPr>
+            <a:r>
+              <a:rPr/>
+              <a:t>The rate of healthcare acquired C. difficile infections (cases per 10,000 bed days) decreased at 2/3 sites (Chase Farm and Southmead) but was unchanged at Royal Liverpool.</a:t>
+            </a:r>
+          </a:p>
+        </p:txBody>
+      </p:sp>
+      <p:pic>
+        <p:nvPicPr>
+          <p:cNvPr descr="NHP_SBR-impacts_2024_files/figure-pptx/cia_hcai-1.png" id="0" name="Picture 1"/>
+          <p:cNvPicPr>
+            <a:picLocks noGrp="1" noChangeAspect="1"/>
+          </p:cNvPicPr>
+          <p:nvPr/>
+        </p:nvPicPr>
+        <p:blipFill>
+          <a:blip r:embed="rId2"/>
+          <a:stretch>
+            <a:fillRect/>
+          </a:stretch>
+        </p:blipFill>
+        <p:spPr bwMode="auto">
+          <a:xfrm>
+            <a:off x="4127500" y="1930400"/>
+            <a:ext cx="7010400" cy="3505200"/>
+          </a:xfrm>
+          <a:prstGeom prst="rect">
+            <a:avLst/>
+          </a:prstGeom>
+          <a:noFill/>
+          <a:ln w="9525">
+            <a:noFill/>
+            <a:headEnd/>
+            <a:tailEnd/>
+          </a:ln>
+        </p:spPr>
+      </p:pic>
+    </p:spTree>
+  </p:cSld>
+</p:sld>
+</file>
+
+<file path=ppt/slides/slide33.xml><?xml version="1.0" encoding="utf-8"?>
+<p:sld xmlns:a="http://schemas.openxmlformats.org/drawingml/2006/main" xmlns:r="http://schemas.openxmlformats.org/officeDocument/2006/relationships" xmlns:p="http://schemas.openxmlformats.org/presentationml/2006/main">
+  <p:cSld>
+    <p:spTree>
+      <p:nvGrpSpPr>
+        <p:cNvPr id="1" name=""/>
+        <p:cNvGrpSpPr/>
+        <p:nvPr/>
+      </p:nvGrpSpPr>
+      <p:grpSpPr>
+        <a:xfrm>
+          <a:off x="0" y="0"/>
+          <a:ext cx="0" cy="0"/>
+          <a:chOff x="0" y="0"/>
+          <a:chExt cx="0" cy="0"/>
+        </a:xfrm>
+      </p:grpSpPr>
+      <p:sp>
+        <p:nvSpPr>
+          <p:cNvPr id="2" name="Title 1"/>
+          <p:cNvSpPr>
+            <a:spLocks noGrp="1"/>
+          </p:cNvSpPr>
+          <p:nvPr>
+            <p:ph hasCustomPrompt="1" type="ctrTitle"/>
+          </p:nvPr>
+        </p:nvSpPr>
+        <p:spPr>
+          <a:xfrm>
+            <a:off x="457199" y="4665306"/>
+            <a:ext cx="7772400" cy="1308413"/>
+          </a:xfrm>
+        </p:spPr>
+        <p:txBody>
+          <a:bodyPr/>
+          <a:lstStyle/>
+          <a:p>
+            <a:pPr lvl="0" indent="0" marL="0">
+              <a:buNone/>
+            </a:pPr>
+            <a:r>
+              <a:rPr/>
+              <a:t>8. Main results - Patient and Staff Experience</a:t>
+            </a:r>
+          </a:p>
+        </p:txBody>
+      </p:sp>
+    </p:spTree>
+  </p:cSld>
+</p:sld>
+</file>
+
+<file path=ppt/slides/slide34.xml><?xml version="1.0" encoding="utf-8"?>
+<p:sld xmlns:a="http://schemas.openxmlformats.org/drawingml/2006/main" xmlns:r="http://schemas.openxmlformats.org/officeDocument/2006/relationships" xmlns:p="http://schemas.openxmlformats.org/presentationml/2006/main">
+  <p:cSld>
+    <p:spTree>
+      <p:nvGrpSpPr>
+        <p:cNvPr id="1" name=""/>
+        <p:cNvGrpSpPr/>
+        <p:nvPr/>
+      </p:nvGrpSpPr>
+      <p:grpSpPr>
+        <a:xfrm>
+          <a:off x="0" y="0"/>
+          <a:ext cx="0" cy="0"/>
+          <a:chOff x="0" y="0"/>
+          <a:chExt cx="0" cy="0"/>
+        </a:xfrm>
+      </p:grpSpPr>
+      <p:sp>
+        <p:nvSpPr>
+          <p:cNvPr id="2" name="Title 1"/>
+          <p:cNvSpPr>
+            <a:spLocks noGrp="1"/>
+          </p:cNvSpPr>
+          <p:nvPr>
+            <p:ph hasCustomPrompt="1" type="title"/>
+          </p:nvPr>
+        </p:nvSpPr>
+        <p:spPr>
+          <a:xfrm>
+            <a:off x="909829" y="438150"/>
+            <a:ext cx="8434196" cy="914400"/>
+          </a:xfrm>
+        </p:spPr>
+        <p:txBody>
+          <a:bodyPr/>
+          <a:lstStyle/>
+          <a:p>
+            <a:pPr lvl="0" indent="0" marL="0">
+              <a:buNone/>
+            </a:pPr>
+            <a:r>
+              <a:rPr/>
+              <a:t>8.1 Family and Friends test</a:t>
+            </a:r>
+          </a:p>
+        </p:txBody>
+      </p:sp>
+      <p:sp>
+        <p:nvSpPr>
+          <p:cNvPr id="7" name="Text Placeholder 6">
+            <a:extLst>
+              <a:ext uri="{FF2B5EF4-FFF2-40B4-BE49-F238E27FC236}">
+                <a16:creationId xmlns:a16="http://schemas.microsoft.com/office/drawing/2014/main" id="{DE622849-4EA7-24AE-DD96-E693EAA81594}"/>
+              </a:ext>
+            </a:extLst>
+          </p:cNvPr>
+          <p:cNvSpPr>
+            <a:spLocks noGrp="1"/>
+          </p:cNvSpPr>
+          <p:nvPr>
+            <p:ph idx="13" sz="quarter" type="body"/>
+          </p:nvPr>
+        </p:nvSpPr>
+        <p:spPr/>
+        <p:txBody>
+          <a:bodyPr/>
+          <a:lstStyle/>
+          <a:p>
+            <a:pPr lvl="0" indent="0" marL="0">
+              <a:buNone/>
+            </a:pPr>
+            <a:r>
+              <a:rPr/>
+              <a:t>This </a:t>
+            </a:r>
+            <a:r>
+              <a:rPr b="1"/>
+              <a:t>monthly</a:t>
+            </a:r>
+            <a:r>
+              <a:rPr/>
+              <a:t> data at </a:t>
+            </a:r>
+            <a:r>
+              <a:rPr b="1"/>
+              <a:t>site level</a:t>
+            </a:r>
+            <a:r>
+              <a:rPr/>
+              <a:t> is taken from published NHS England data (via UDAL).</a:t>
+            </a:r>
+          </a:p>
+          <a:p>
+            <a:pPr lvl="0" indent="0" marL="0">
+              <a:buNone/>
+            </a:pPr>
+            <a:r>
+              <a:rPr/>
+              <a:t>The percentage of positive responses significantly decreased at 1/5 sites (Clatterbridge), increased at 1/5 sites (Papworth) and was unchanged at the other 3/5 sites (Royal Liverpool, Southmead and Chase Farm).</a:t>
+            </a:r>
+          </a:p>
+        </p:txBody>
+      </p:sp>
+      <p:pic>
+        <p:nvPicPr>
+          <p:cNvPr descr="NHP_SBR-impacts_2024_files/figure-pptx/cia_famfriend-1.png" id="0" name="Picture 1"/>
+          <p:cNvPicPr>
+            <a:picLocks noGrp="1" noChangeAspect="1"/>
+          </p:cNvPicPr>
+          <p:nvPr/>
+        </p:nvPicPr>
+        <p:blipFill>
+          <a:blip r:embed="rId2"/>
+          <a:stretch>
+            <a:fillRect/>
+          </a:stretch>
+        </p:blipFill>
+        <p:spPr bwMode="auto">
+          <a:xfrm>
+            <a:off x="4127500" y="1930400"/>
+            <a:ext cx="7010400" cy="3505200"/>
+          </a:xfrm>
+          <a:prstGeom prst="rect">
+            <a:avLst/>
+          </a:prstGeom>
+          <a:noFill/>
+          <a:ln w="9525">
+            <a:noFill/>
+            <a:headEnd/>
+            <a:tailEnd/>
+          </a:ln>
+        </p:spPr>
+      </p:pic>
+    </p:spTree>
+  </p:cSld>
+</p:sld>
+</file>
+
+<file path=ppt/slides/slide35.xml><?xml version="1.0" encoding="utf-8"?>
+<p:sld xmlns:a="http://schemas.openxmlformats.org/drawingml/2006/main" xmlns:r="http://schemas.openxmlformats.org/officeDocument/2006/relationships" xmlns:p="http://schemas.openxmlformats.org/presentationml/2006/main">
+  <p:cSld>
+    <p:spTree>
+      <p:nvGrpSpPr>
+        <p:cNvPr id="1" name=""/>
+        <p:cNvGrpSpPr/>
+        <p:nvPr/>
+      </p:nvGrpSpPr>
+      <p:grpSpPr>
+        <a:xfrm>
+          <a:off x="0" y="0"/>
+          <a:ext cx="0" cy="0"/>
+          <a:chOff x="0" y="0"/>
+          <a:chExt cx="0" cy="0"/>
+        </a:xfrm>
+      </p:grpSpPr>
+      <p:sp>
+        <p:nvSpPr>
+          <p:cNvPr id="2" name="Title 1"/>
+          <p:cNvSpPr>
+            <a:spLocks noGrp="1"/>
+          </p:cNvSpPr>
+          <p:nvPr>
+            <p:ph hasCustomPrompt="1" type="title"/>
+          </p:nvPr>
+        </p:nvSpPr>
+        <p:spPr>
+          <a:xfrm>
+            <a:off x="909829" y="438150"/>
+            <a:ext cx="8434196" cy="914400"/>
+          </a:xfrm>
+        </p:spPr>
+        <p:txBody>
+          <a:bodyPr/>
+          <a:lstStyle/>
+          <a:p>
+            <a:pPr lvl="0" indent="0" marL="0">
+              <a:buNone/>
+            </a:pPr>
+            <a:r>
+              <a:rPr/>
+              <a:t>8.2 Staff sickness absence</a:t>
+            </a:r>
+          </a:p>
+        </p:txBody>
+      </p:sp>
+      <p:sp>
+        <p:nvSpPr>
+          <p:cNvPr id="7" name="Text Placeholder 6">
+            <a:extLst>
+              <a:ext uri="{FF2B5EF4-FFF2-40B4-BE49-F238E27FC236}">
+                <a16:creationId xmlns:a16="http://schemas.microsoft.com/office/drawing/2014/main" id="{DE622849-4EA7-24AE-DD96-E693EAA81594}"/>
+              </a:ext>
+            </a:extLst>
+          </p:cNvPr>
+          <p:cNvSpPr>
+            <a:spLocks noGrp="1"/>
+          </p:cNvSpPr>
+          <p:nvPr>
+            <p:ph idx="13" sz="quarter" type="body"/>
+          </p:nvPr>
+        </p:nvSpPr>
+        <p:spPr/>
+        <p:txBody>
+          <a:bodyPr/>
+          <a:lstStyle/>
+          <a:p>
+            <a:pPr lvl="0" indent="0" marL="0">
+              <a:buNone/>
+            </a:pPr>
+            <a:r>
+              <a:rPr/>
+              <a:t>This </a:t>
+            </a:r>
+            <a:r>
+              <a:rPr b="1"/>
+              <a:t>monthly</a:t>
+            </a:r>
+            <a:r>
+              <a:rPr/>
+              <a:t> data at </a:t>
+            </a:r>
+            <a:r>
+              <a:rPr b="1"/>
+              <a:t>provider level</a:t>
+            </a:r>
+            <a:r>
+              <a:rPr/>
+              <a:t> is taken from published NHS England data (via UDAL).</a:t>
+            </a:r>
+          </a:p>
+          <a:p>
+            <a:pPr lvl="0" indent="0" marL="0">
+              <a:buNone/>
+            </a:pPr>
+            <a:r>
+              <a:rPr/>
+              <a:t>The percentage of available days taken off sick by staff significantly increased at 2/7 sites (Southmead and Tunbridge Wells) and was unchanged at the remaining 5 sites.</a:t>
+            </a:r>
+          </a:p>
+        </p:txBody>
+      </p:sp>
+      <p:pic>
+        <p:nvPicPr>
+          <p:cNvPr descr="NHP_SBR-impacts_2024_files/figure-pptx/cia_sick-1.png" id="0" name="Picture 1"/>
+          <p:cNvPicPr>
+            <a:picLocks noGrp="1" noChangeAspect="1"/>
+          </p:cNvPicPr>
+          <p:nvPr/>
+        </p:nvPicPr>
+        <p:blipFill>
+          <a:blip r:embed="rId2"/>
+          <a:stretch>
+            <a:fillRect/>
+          </a:stretch>
+        </p:blipFill>
+        <p:spPr bwMode="auto">
+          <a:xfrm>
+            <a:off x="4127500" y="1930400"/>
+            <a:ext cx="7010400" cy="3505200"/>
+          </a:xfrm>
+          <a:prstGeom prst="rect">
+            <a:avLst/>
+          </a:prstGeom>
+          <a:noFill/>
+          <a:ln w="9525">
+            <a:noFill/>
+            <a:headEnd/>
+            <a:tailEnd/>
+          </a:ln>
+        </p:spPr>
+      </p:pic>
+    </p:spTree>
+  </p:cSld>
+</p:sld>
+</file>
+
+<file path=ppt/slides/slide36.xml><?xml version="1.0" encoding="utf-8"?>
+<p:sld xmlns:a="http://schemas.openxmlformats.org/drawingml/2006/main" xmlns:r="http://schemas.openxmlformats.org/officeDocument/2006/relationships" xmlns:p="http://schemas.openxmlformats.org/presentationml/2006/main">
+  <p:cSld>
+    <p:spTree>
+      <p:nvGrpSpPr>
+        <p:cNvPr id="1" name=""/>
+        <p:cNvGrpSpPr/>
+        <p:nvPr/>
+      </p:nvGrpSpPr>
+      <p:grpSpPr>
+        <a:xfrm>
+          <a:off x="0" y="0"/>
+          <a:ext cx="0" cy="0"/>
+          <a:chOff x="0" y="0"/>
+          <a:chExt cx="0" cy="0"/>
+        </a:xfrm>
+      </p:grpSpPr>
+      <p:sp>
+        <p:nvSpPr>
+          <p:cNvPr id="2" name="Title 1"/>
+          <p:cNvSpPr>
+            <a:spLocks noGrp="1"/>
+          </p:cNvSpPr>
+          <p:nvPr>
+            <p:ph hasCustomPrompt="1" type="title"/>
+          </p:nvPr>
+        </p:nvSpPr>
+        <p:spPr>
+          <a:xfrm>
+            <a:off x="909829" y="438150"/>
+            <a:ext cx="8434196" cy="914400"/>
+          </a:xfrm>
+        </p:spPr>
+        <p:txBody>
+          <a:bodyPr/>
+          <a:lstStyle/>
+          <a:p>
+            <a:pPr lvl="0" indent="0" marL="0">
+              <a:buNone/>
+            </a:pPr>
+            <a:r>
+              <a:rPr/>
+              <a:t>8.3 Staff turnover</a:t>
+            </a:r>
+          </a:p>
+        </p:txBody>
+      </p:sp>
+      <p:sp>
+        <p:nvSpPr>
+          <p:cNvPr id="7" name="Text Placeholder 6">
+            <a:extLst>
+              <a:ext uri="{FF2B5EF4-FFF2-40B4-BE49-F238E27FC236}">
+                <a16:creationId xmlns:a16="http://schemas.microsoft.com/office/drawing/2014/main" id="{DE622849-4EA7-24AE-DD96-E693EAA81594}"/>
+              </a:ext>
+            </a:extLst>
+          </p:cNvPr>
+          <p:cNvSpPr>
+            <a:spLocks noGrp="1"/>
+          </p:cNvSpPr>
+          <p:nvPr>
+            <p:ph idx="13" sz="quarter" type="body"/>
+          </p:nvPr>
+        </p:nvSpPr>
+        <p:spPr/>
+        <p:txBody>
+          <a:bodyPr/>
+          <a:lstStyle/>
+          <a:p>
+            <a:pPr lvl="0" indent="0" marL="0">
+              <a:buNone/>
+            </a:pPr>
+            <a:r>
+              <a:rPr/>
+              <a:t>This </a:t>
+            </a:r>
+            <a:r>
+              <a:rPr b="1"/>
+              <a:t>monthly</a:t>
+            </a:r>
+            <a:r>
+              <a:rPr/>
+              <a:t> data at </a:t>
+            </a:r>
+            <a:r>
+              <a:rPr b="1"/>
+              <a:t>provider level</a:t>
+            </a:r>
+            <a:r>
+              <a:rPr/>
+              <a:t> is taken from published NHS England data (via UDAL).</a:t>
+            </a:r>
+          </a:p>
+          <a:p>
+            <a:pPr lvl="0" indent="0" marL="0">
+              <a:buNone/>
+            </a:pPr>
+            <a:r>
+              <a:rPr/>
+              <a:t>Staff turnover measured as percentage of staff leaving was not significantly changed at any of the 3 sites where data was available.</a:t>
+            </a:r>
+          </a:p>
+        </p:txBody>
+      </p:sp>
+      <p:pic>
+        <p:nvPicPr>
+          <p:cNvPr descr="NHP_SBR-impacts_2024_files/figure-pptx/cia_turnover-1.png" id="0" name="Picture 1"/>
+          <p:cNvPicPr>
+            <a:picLocks noGrp="1" noChangeAspect="1"/>
+          </p:cNvPicPr>
+          <p:nvPr/>
+        </p:nvPicPr>
+        <p:blipFill>
+          <a:blip r:embed="rId2"/>
+          <a:stretch>
+            <a:fillRect/>
+          </a:stretch>
+        </p:blipFill>
+        <p:spPr bwMode="auto">
+          <a:xfrm>
+            <a:off x="4127500" y="1930400"/>
+            <a:ext cx="7010400" cy="3505200"/>
+          </a:xfrm>
+          <a:prstGeom prst="rect">
+            <a:avLst/>
+          </a:prstGeom>
+          <a:noFill/>
+          <a:ln w="9525">
+            <a:noFill/>
+            <a:headEnd/>
+            <a:tailEnd/>
+          </a:ln>
+        </p:spPr>
+      </p:pic>
+    </p:spTree>
+  </p:cSld>
+</p:sld>
+</file>
+
+<file path=ppt/slides/slide37.xml><?xml version="1.0" encoding="utf-8"?>
+<p:sld xmlns:a="http://schemas.openxmlformats.org/drawingml/2006/main" xmlns:r="http://schemas.openxmlformats.org/officeDocument/2006/relationships" xmlns:p="http://schemas.openxmlformats.org/presentationml/2006/main">
+  <p:cSld>
+    <p:spTree>
+      <p:nvGrpSpPr>
+        <p:cNvPr id="1" name=""/>
+        <p:cNvGrpSpPr/>
+        <p:nvPr/>
+      </p:nvGrpSpPr>
+      <p:grpSpPr>
+        <a:xfrm>
+          <a:off x="0" y="0"/>
+          <a:ext cx="0" cy="0"/>
+          <a:chOff x="0" y="0"/>
+          <a:chExt cx="0" cy="0"/>
+        </a:xfrm>
+      </p:grpSpPr>
+      <p:sp>
+        <p:nvSpPr>
+          <p:cNvPr id="2" name="Title 1"/>
+          <p:cNvSpPr>
+            <a:spLocks noGrp="1"/>
+          </p:cNvSpPr>
+          <p:nvPr>
+            <p:ph hasCustomPrompt="1" type="title"/>
+          </p:nvPr>
+        </p:nvSpPr>
+        <p:spPr>
+          <a:xfrm>
+            <a:off x="909829" y="438150"/>
+            <a:ext cx="8434196" cy="914400"/>
+          </a:xfrm>
+        </p:spPr>
+        <p:txBody>
+          <a:bodyPr/>
+          <a:lstStyle/>
+          <a:p>
+            <a:pPr lvl="0" indent="0" marL="0">
+              <a:buNone/>
+            </a:pPr>
+            <a:r>
+              <a:rPr/>
+              <a:t>8.4 Staff survey - recommending place to work</a:t>
             </a:r>
           </a:p>
         </p:txBody>
@@ -7010,6 +7549,161 @@
           </a:ln>
         </p:spPr>
       </p:pic>
+    </p:spTree>
+  </p:cSld>
+</p:sld>
+</file>
+
+<file path=ppt/slides/slide38.xml><?xml version="1.0" encoding="utf-8"?>
+<p:sld xmlns:a="http://schemas.openxmlformats.org/drawingml/2006/main" xmlns:r="http://schemas.openxmlformats.org/officeDocument/2006/relationships" xmlns:p="http://schemas.openxmlformats.org/presentationml/2006/main">
+  <p:cSld>
+    <p:spTree>
+      <p:nvGrpSpPr>
+        <p:cNvPr id="1" name=""/>
+        <p:cNvGrpSpPr/>
+        <p:nvPr/>
+      </p:nvGrpSpPr>
+      <p:grpSpPr>
+        <a:xfrm>
+          <a:off x="0" y="0"/>
+          <a:ext cx="0" cy="0"/>
+          <a:chOff x="0" y="0"/>
+          <a:chExt cx="0" cy="0"/>
+        </a:xfrm>
+      </p:grpSpPr>
+      <p:sp>
+        <p:nvSpPr>
+          <p:cNvPr id="2" name="Title 1"/>
+          <p:cNvSpPr>
+            <a:spLocks noGrp="1"/>
+          </p:cNvSpPr>
+          <p:nvPr>
+            <p:ph hasCustomPrompt="1" type="ctrTitle"/>
+          </p:nvPr>
+        </p:nvSpPr>
+        <p:spPr>
+          <a:xfrm>
+            <a:off x="457199" y="4665306"/>
+            <a:ext cx="7772400" cy="1308413"/>
+          </a:xfrm>
+        </p:spPr>
+        <p:txBody>
+          <a:bodyPr/>
+          <a:lstStyle/>
+          <a:p>
+            <a:pPr lvl="0" indent="0" marL="0">
+              <a:buNone/>
+            </a:pPr>
+            <a:r>
+              <a:rPr/>
+              <a:t>9. Next steps</a:t>
+            </a:r>
+          </a:p>
+        </p:txBody>
+      </p:sp>
+    </p:spTree>
+  </p:cSld>
+</p:sld>
+</file>
+
+<file path=ppt/slides/slide39.xml><?xml version="1.0" encoding="utf-8"?>
+<p:sld xmlns:a="http://schemas.openxmlformats.org/drawingml/2006/main" xmlns:r="http://schemas.openxmlformats.org/officeDocument/2006/relationships" xmlns:p="http://schemas.openxmlformats.org/presentationml/2006/main">
+  <p:cSld>
+    <p:spTree>
+      <p:nvGrpSpPr>
+        <p:cNvPr id="1" name=""/>
+        <p:cNvGrpSpPr/>
+        <p:nvPr/>
+      </p:nvGrpSpPr>
+      <p:grpSpPr>
+        <a:xfrm>
+          <a:off x="0" y="0"/>
+          <a:ext cx="0" cy="0"/>
+          <a:chOff x="0" y="0"/>
+          <a:chExt cx="0" cy="0"/>
+        </a:xfrm>
+      </p:grpSpPr>
+      <p:sp>
+        <p:nvSpPr>
+          <p:cNvPr id="2" name="Title 1"/>
+          <p:cNvSpPr>
+            <a:spLocks noGrp="1"/>
+          </p:cNvSpPr>
+          <p:nvPr>
+            <p:ph hasCustomPrompt="1" type="title"/>
+          </p:nvPr>
+        </p:nvSpPr>
+        <p:spPr>
+          <a:xfrm>
+            <a:off x="909829" y="403765"/>
+            <a:ext cx="8434196" cy="976056"/>
+          </a:xfrm>
+        </p:spPr>
+        <p:txBody>
+          <a:bodyPr/>
+          <a:lstStyle/>
+          <a:p>
+            <a:pPr lvl="0" indent="0" marL="0">
+              <a:buNone/>
+            </a:pPr>
+            <a:r>
+              <a:rPr/>
+              <a:t>9.1 Still on the to-do list…</a:t>
+            </a:r>
+          </a:p>
+        </p:txBody>
+      </p:sp>
+      <p:sp>
+        <p:nvSpPr>
+          <p:cNvPr id="3" name="Content Placeholder 2"/>
+          <p:cNvSpPr>
+            <a:spLocks noGrp="1"/>
+          </p:cNvSpPr>
+          <p:nvPr>
+            <p:ph idx="1"/>
+          </p:nvPr>
+        </p:nvSpPr>
+        <p:spPr/>
+        <p:txBody>
+          <a:bodyPr/>
+          <a:lstStyle/>
+          <a:p>
+            <a:pPr lvl="0"/>
+            <a:r>
+              <a:rPr/>
+              <a:t>Triangulate with qualitative look-back exercise</a:t>
+            </a:r>
+          </a:p>
+          <a:p>
+            <a:pPr lvl="0"/>
+            <a:r>
+              <a:rPr/>
+              <a:t>Finish technical report and polish this summary and recommendations</a:t>
+            </a:r>
+          </a:p>
+          <a:p>
+            <a:pPr lvl="0"/>
+            <a:r>
+              <a:rPr/>
+              <a:t>Pass impact parameters to the NHP model team for inclusion</a:t>
+            </a:r>
+          </a:p>
+          <a:p>
+            <a:pPr lvl="0"/>
+            <a:r>
+              <a:rPr/>
+              <a:t>Engage with 7 providers over the results and sharing them</a:t>
+            </a:r>
+          </a:p>
+          <a:p>
+            <a:pPr lvl="0"/>
+            <a:r>
+              <a:rPr/>
+              <a:t>Pursue journal publication</a:t>
+            </a:r>
+          </a:p>
+        </p:txBody>
+      </p:sp>
     </p:spTree>
   </p:cSld>
 </p:sld>
@@ -7039,13 +7733,13 @@
             <a:spLocks noGrp="1"/>
           </p:cNvSpPr>
           <p:nvPr>
-            <p:ph type="title"/>
+            <p:ph hasCustomPrompt="1" type="title"/>
           </p:nvPr>
         </p:nvSpPr>
         <p:spPr>
           <a:xfrm>
-            <a:off x="919352" y="419100"/>
-            <a:ext cx="9720072" cy="933450"/>
+            <a:off x="909829" y="403765"/>
+            <a:ext cx="8434196" cy="976056"/>
           </a:xfrm>
         </p:spPr>
         <p:txBody>
@@ -7057,25 +7751,19 @@
             </a:pPr>
             <a:r>
               <a:rPr/>
-              <a:t>1.2 Approach</a:t>
-            </a:r>
-          </a:p>
-        </p:txBody>
-      </p:sp>
-      <p:sp>
-        <p:nvSpPr>
-          <p:cNvPr id="3" name="Content Placeholder 2">
-            <a:extLst>
-              <a:ext uri="{FF2B5EF4-FFF2-40B4-BE49-F238E27FC236}">
-                <a16:creationId xmlns:a16="http://schemas.microsoft.com/office/drawing/2014/main" id="{D2592819-5C80-B996-F823-F8B9F9EAD6C9}"/>
-              </a:ext>
-            </a:extLst>
-          </p:cNvPr>
-          <p:cNvSpPr>
-            <a:spLocks noGrp="1"/>
-          </p:cNvSpPr>
-          <p:nvPr>
-            <p:ph idx="10"/>
+              <a:t>1.1 Headlines and Highlights (1)</a:t>
+            </a:r>
+          </a:p>
+        </p:txBody>
+      </p:sp>
+      <p:sp>
+        <p:nvSpPr>
+          <p:cNvPr id="3" name="Content Placeholder 2"/>
+          <p:cNvSpPr>
+            <a:spLocks noGrp="1"/>
+          </p:cNvSpPr>
+          <p:nvPr>
+            <p:ph idx="1"/>
           </p:nvPr>
         </p:nvSpPr>
         <p:spPr/>
@@ -7086,46 +7774,158 @@
             <a:pPr lvl="0"/>
             <a:r>
               <a:rPr/>
-              <a:t>Previous literature reviews and general searches were undertaken to identify potential impact factors.</a:t>
+              <a:t>The NHP program advocates for SBR design for new hospitals</a:t>
             </a:r>
           </a:p>
           <a:p>
             <a:pPr lvl="0"/>
             <a:r>
               <a:rPr/>
-              <a:t>Identified relevant measures or proxy measures from publicly available data and routine data sources.</a:t>
+              <a:t>Assumption that doing so will reduce inpatient length of stay (circa 12%)</a:t>
             </a:r>
           </a:p>
           <a:p>
             <a:pPr lvl="0"/>
             <a:r>
               <a:rPr/>
-              <a:t>Included only those with sufficient time series and of acceptable data quality into final impact framework.</a:t>
+              <a:t>The challenge, therefore, is to quantify changes in LoS and a range of other potential impacts for 7 natural experiments between 2010 and 2022</a:t>
             </a:r>
           </a:p>
           <a:p>
             <a:pPr lvl="0"/>
             <a:r>
               <a:rPr/>
-              <a:t>Cleansed and compiled all the data into time series format.</a:t>
-            </a:r>
-          </a:p>
-        </p:txBody>
-      </p:sp>
-      <p:sp>
-        <p:nvSpPr>
-          <p:cNvPr id="4" name="Content Placeholder 2">
-            <a:extLst>
-              <a:ext uri="{FF2B5EF4-FFF2-40B4-BE49-F238E27FC236}">
-                <a16:creationId xmlns:a16="http://schemas.microsoft.com/office/drawing/2014/main" id="{D1BAB7DA-EC53-0103-E362-83F86BDB6BC4}"/>
-              </a:ext>
-            </a:extLst>
-          </p:cNvPr>
-          <p:cNvSpPr>
-            <a:spLocks noGrp="1"/>
-          </p:cNvSpPr>
-          <p:nvPr>
-            <p:ph idx="11"/>
+              <a:t>Identified 12 impact measures</a:t>
+            </a:r>
+          </a:p>
+          <a:p>
+            <a:pPr lvl="0"/>
+            <a:r>
+              <a:rPr/>
+              <a:t>Used an approach called Causal Impact Analysis to detect pre-post changes in trend</a:t>
+            </a:r>
+          </a:p>
+          <a:p>
+            <a:pPr lvl="0"/>
+            <a:r>
+              <a:rPr/>
+              <a:t>Results (much like the published literature) are mixed…</a:t>
+            </a:r>
+          </a:p>
+        </p:txBody>
+      </p:sp>
+    </p:spTree>
+  </p:cSld>
+</p:sld>
+</file>
+
+<file path=ppt/slides/slide40.xml><?xml version="1.0" encoding="utf-8"?>
+<p:sld xmlns:a="http://schemas.openxmlformats.org/drawingml/2006/main" xmlns:r="http://schemas.openxmlformats.org/officeDocument/2006/relationships" xmlns:p="http://schemas.openxmlformats.org/presentationml/2006/main">
+  <p:cSld>
+    <p:spTree>
+      <p:nvGrpSpPr>
+        <p:cNvPr id="1" name=""/>
+        <p:cNvGrpSpPr/>
+        <p:nvPr/>
+      </p:nvGrpSpPr>
+      <p:grpSpPr>
+        <a:xfrm>
+          <a:off x="0" y="0"/>
+          <a:ext cx="0" cy="0"/>
+          <a:chOff x="0" y="0"/>
+          <a:chExt cx="0" cy="0"/>
+        </a:xfrm>
+      </p:grpSpPr>
+      <p:sp>
+        <p:nvSpPr>
+          <p:cNvPr id="2" name="Title 1"/>
+          <p:cNvSpPr>
+            <a:spLocks noGrp="1"/>
+          </p:cNvSpPr>
+          <p:nvPr>
+            <p:ph hasCustomPrompt="1" type="ctrTitle"/>
+          </p:nvPr>
+        </p:nvSpPr>
+        <p:spPr>
+          <a:xfrm>
+            <a:off x="457199" y="4665306"/>
+            <a:ext cx="7772400" cy="1308413"/>
+          </a:xfrm>
+        </p:spPr>
+        <p:txBody>
+          <a:bodyPr/>
+          <a:lstStyle/>
+          <a:p>
+            <a:pPr lvl="0" indent="0" marL="0">
+              <a:buNone/>
+            </a:pPr>
+            <a:r>
+              <a:rPr/>
+              <a:t>10. Acknowledgements</a:t>
+            </a:r>
+          </a:p>
+        </p:txBody>
+      </p:sp>
+    </p:spTree>
+  </p:cSld>
+</p:sld>
+</file>
+
+<file path=ppt/slides/slide41.xml><?xml version="1.0" encoding="utf-8"?>
+<p:sld xmlns:a="http://schemas.openxmlformats.org/drawingml/2006/main" xmlns:r="http://schemas.openxmlformats.org/officeDocument/2006/relationships" xmlns:p="http://schemas.openxmlformats.org/presentationml/2006/main">
+  <p:cSld>
+    <p:spTree>
+      <p:nvGrpSpPr>
+        <p:cNvPr id="1" name=""/>
+        <p:cNvGrpSpPr/>
+        <p:nvPr/>
+      </p:nvGrpSpPr>
+      <p:grpSpPr>
+        <a:xfrm>
+          <a:off x="0" y="0"/>
+          <a:ext cx="0" cy="0"/>
+          <a:chOff x="0" y="0"/>
+          <a:chExt cx="0" cy="0"/>
+        </a:xfrm>
+      </p:grpSpPr>
+      <p:sp>
+        <p:nvSpPr>
+          <p:cNvPr id="2" name="Title 1"/>
+          <p:cNvSpPr>
+            <a:spLocks noGrp="1"/>
+          </p:cNvSpPr>
+          <p:nvPr>
+            <p:ph hasCustomPrompt="1" type="title"/>
+          </p:nvPr>
+        </p:nvSpPr>
+        <p:spPr>
+          <a:xfrm>
+            <a:off x="909829" y="403765"/>
+            <a:ext cx="8434196" cy="976056"/>
+          </a:xfrm>
+        </p:spPr>
+        <p:txBody>
+          <a:bodyPr/>
+          <a:lstStyle/>
+          <a:p>
+            <a:pPr lvl="0" indent="0" marL="0">
+              <a:buNone/>
+            </a:pPr>
+            <a:r>
+              <a:rPr/>
+              <a:t>10.1 Acknowledgements</a:t>
+            </a:r>
+          </a:p>
+        </p:txBody>
+      </p:sp>
+      <p:sp>
+        <p:nvSpPr>
+          <p:cNvPr id="3" name="Content Placeholder 2"/>
+          <p:cNvSpPr>
+            <a:spLocks noGrp="1"/>
+          </p:cNvSpPr>
+          <p:nvPr>
+            <p:ph idx="1"/>
           </p:nvPr>
         </p:nvSpPr>
         <p:spPr/>
@@ -7133,31 +7933,42 @@
           <a:bodyPr/>
           <a:lstStyle/>
           <a:p>
-            <a:pPr lvl="0"/>
-            <a:r>
-              <a:rPr/>
-              <a:t>Identified ‘control’ sites and providers to compare to our natural experiment sites.</a:t>
-            </a:r>
-          </a:p>
-          <a:p>
-            <a:pPr lvl="0"/>
-            <a:r>
-              <a:rPr/>
-              <a:t>Several stages of this matching according to hospital function, size, case-mix and admission ratio’s.</a:t>
-            </a:r>
-          </a:p>
-          <a:p>
-            <a:pPr lvl="0"/>
-            <a:r>
-              <a:rPr/>
-              <a:t>Performed causal impact analysis on the pre and post intervention periods to detect the nature and scale of impacts for each natural experiment.</a:t>
-            </a:r>
-          </a:p>
-          <a:p>
-            <a:pPr lvl="0"/>
-            <a:r>
-              <a:rPr/>
-              <a:t>Aggregated findings for the non-specialist hospitals.</a:t>
+            <a:pPr lvl="0" indent="0" marL="0">
+              <a:buNone/>
+            </a:pPr>
+            <a:r>
+              <a:rPr b="1"/>
+              <a:t>NHP programme</a:t>
+            </a:r>
+            <a:r>
+              <a:rPr/>
+              <a:t>: Cheryl Riotto, Anne White, Joanna Wood, Carolyn Akyil, Michael Weinbren</a:t>
+            </a:r>
+          </a:p>
+          <a:p>
+            <a:pPr lvl="0" indent="0" marL="0">
+              <a:buNone/>
+            </a:pPr>
+            <a:r>
+              <a:rPr b="1"/>
+              <a:t>NHS England</a:t>
+            </a:r>
+            <a:r>
+              <a:rPr/>
+              <a:t>: Joshua Igbineweka, Paul Smith</a:t>
+            </a:r>
+          </a:p>
+          <a:p>
+            <a:pPr lvl="0" indent="0" marL="0">
+              <a:buNone/>
+            </a:pPr>
+            <a:r>
+              <a:rPr b="1"/>
+              <a:t>Strategy Unit</a:t>
+            </a:r>
+            <a:r>
+              <a:rPr/>
+              <a:t>: Sarah Lucas, Anya Ferguson, Peter Spilsbury, Simon Bourne, Jennifer Wood</a:t>
             </a:r>
           </a:p>
         </p:txBody>
@@ -7209,7 +8020,7 @@
             </a:pPr>
             <a:r>
               <a:rPr/>
-              <a:t>1.3 Summary of key findings</a:t>
+              <a:t>1.2 Headlines and Highlights (2)</a:t>
             </a:r>
           </a:p>
         </p:txBody>
@@ -7229,12 +8040,48 @@
           <a:bodyPr/>
           <a:lstStyle/>
           <a:p>
-            <a:pPr lvl="0" indent="0" marL="0">
-              <a:buNone/>
-            </a:pPr>
-            <a:r>
-              <a:rPr/>
-              <a:t>Our results are generally not consistent within indicators and across hospital sites. This suggests that there are a number of other factors in the hospital design, systems, policies and procedures that are important. Switching to single bedroom hospitals without considering the other factors would not necessarily have a positive effect on outcomes nor mitigate any likely risks. This inconsistency is reflective of the findings from published literature.</a:t>
+            <a:pPr lvl="0"/>
+            <a:r>
+              <a:rPr/>
+              <a:t>For </a:t>
+            </a:r>
+            <a:r>
+              <a:rPr b="1"/>
+              <a:t>productivity and Efficiency</a:t>
+            </a:r>
+            <a:r>
+              <a:rPr/>
+              <a:t> measures, length of stay generally improved (4/6), waiting times reduced (3/5), Bed Occupancy increased (3/4), Emergency readmissions fell (4/7), cleaning costs reduced (2/3)</a:t>
+            </a:r>
+          </a:p>
+          <a:p>
+            <a:pPr lvl="0"/>
+            <a:r>
+              <a:rPr/>
+              <a:t>For </a:t>
+            </a:r>
+            <a:r>
+              <a:rPr b="1"/>
+              <a:t>health and safety</a:t>
+            </a:r>
+            <a:r>
+              <a:rPr/>
+              <a:t> measures, in-hospital deaths fell (3/5), falls and injuries increased (3/4), HCAI reduced (3/3)</a:t>
+            </a:r>
+          </a:p>
+          <a:p>
+            <a:pPr lvl="0"/>
+            <a:r>
+              <a:rPr/>
+              <a:t>For </a:t>
+            </a:r>
+            <a:r>
+              <a:rPr b="1"/>
+              <a:t>patient &amp; staff experiences</a:t>
+            </a:r>
+            <a:r>
+              <a:rPr/>
+              <a:t>, friends and family scores increased (3/5), staff sickness increased (4/7), staff turnover fell (3/3), staff satisfaction reduced (4/6).</a:t>
             </a:r>
           </a:p>
         </p:txBody>
@@ -7268,13 +8115,13 @@
             <a:spLocks noGrp="1"/>
           </p:cNvSpPr>
           <p:nvPr>
-            <p:ph hasCustomPrompt="1" type="title"/>
+            <p:ph hasCustomPrompt="1" type="ctrTitle"/>
           </p:nvPr>
         </p:nvSpPr>
         <p:spPr>
           <a:xfrm>
-            <a:off x="909829" y="403765"/>
-            <a:ext cx="8434196" cy="976056"/>
+            <a:off x="457199" y="4665306"/>
+            <a:ext cx="7772400" cy="1308413"/>
           </a:xfrm>
         </p:spPr>
         <p:txBody>
@@ -7286,62 +8133,7 @@
             </a:pPr>
             <a:r>
               <a:rPr/>
-              <a:t>1.4 Limitations and Recommendations</a:t>
-            </a:r>
-          </a:p>
-        </p:txBody>
-      </p:sp>
-      <p:sp>
-        <p:nvSpPr>
-          <p:cNvPr id="3" name="Content Placeholder 2"/>
-          <p:cNvSpPr>
-            <a:spLocks noGrp="1"/>
-          </p:cNvSpPr>
-          <p:nvPr>
-            <p:ph idx="1"/>
-          </p:nvPr>
-        </p:nvSpPr>
-        <p:spPr/>
-        <p:txBody>
-          <a:bodyPr/>
-          <a:lstStyle/>
-          <a:p>
-            <a:pPr lvl="0" indent="0" marL="0">
-              <a:buNone/>
-            </a:pPr>
-            <a:r>
-              <a:rPr/>
-              <a:t>Placeholder….limitations</a:t>
-            </a:r>
-          </a:p>
-          <a:p>
-            <a:pPr lvl="0"/>
-            <a:r>
-              <a:rPr/>
-              <a:t>Data quality and robustness</a:t>
-            </a:r>
-          </a:p>
-          <a:p>
-            <a:pPr lvl="0"/>
-            <a:r>
-              <a:rPr/>
-              <a:t>Below site-level analysis</a:t>
-            </a:r>
-          </a:p>
-          <a:p>
-            <a:pPr lvl="0" indent="0" marL="0">
-              <a:buNone/>
-            </a:pPr>
-            <a:r>
-              <a:rPr/>
-              <a:t>Placeholder…recommendations</a:t>
-            </a:r>
-          </a:p>
-          <a:p>
-            <a:pPr lvl="0"/>
-            <a:r>
-              <a:rPr/>
-              <a:t>System dynamics for productivity scenario</a:t>
+              <a:t>2. Introduction, approach, summary and recommendations</a:t>
             </a:r>
           </a:p>
         </p:txBody>
@@ -7375,13 +8167,13 @@
             <a:spLocks noGrp="1"/>
           </p:cNvSpPr>
           <p:nvPr>
-            <p:ph hasCustomPrompt="1" type="ctrTitle"/>
+            <p:ph type="title"/>
           </p:nvPr>
         </p:nvSpPr>
         <p:spPr>
           <a:xfrm>
-            <a:off x="457199" y="4665306"/>
-            <a:ext cx="7772400" cy="1308413"/>
+            <a:off x="919352" y="419100"/>
+            <a:ext cx="9720072" cy="933450"/>
           </a:xfrm>
         </p:spPr>
         <p:txBody>
@@ -7393,7 +8185,78 @@
             </a:pPr>
             <a:r>
               <a:rPr/>
-              <a:t>2. The impact framework</a:t>
+              <a:t>2.1 Introduction</a:t>
+            </a:r>
+          </a:p>
+        </p:txBody>
+      </p:sp>
+      <p:sp>
+        <p:nvSpPr>
+          <p:cNvPr id="3" name="Content Placeholder 2">
+            <a:extLst>
+              <a:ext uri="{FF2B5EF4-FFF2-40B4-BE49-F238E27FC236}">
+                <a16:creationId xmlns:a16="http://schemas.microsoft.com/office/drawing/2014/main" id="{D2592819-5C80-B996-F823-F8B9F9EAD6C9}"/>
+              </a:ext>
+            </a:extLst>
+          </p:cNvPr>
+          <p:cNvSpPr>
+            <a:spLocks noGrp="1"/>
+          </p:cNvSpPr>
+          <p:nvPr>
+            <p:ph idx="10"/>
+          </p:nvPr>
+        </p:nvSpPr>
+        <p:spPr/>
+        <p:txBody>
+          <a:bodyPr/>
+          <a:lstStyle/>
+          <a:p>
+            <a:pPr lvl="0" indent="0" marL="0">
+              <a:buNone/>
+            </a:pPr>
+            <a:r>
+              <a:rPr/>
+              <a:t>Since it’s inception, the New Hospital Programme (NHP) has advocated for single bed rooms (SBR). The grounds for this are based on a range of guidance, evidence and previous policy statements of intent. Whilst that position is unequivocal, there is uncertainty around the quantification of impacts of such a change and thus the assumptions that feed into demand and capacity models and economic business cases for current and future new hospital developments.</a:t>
+            </a:r>
+          </a:p>
+        </p:txBody>
+      </p:sp>
+      <p:sp>
+        <p:nvSpPr>
+          <p:cNvPr id="4" name="Content Placeholder 2">
+            <a:extLst>
+              <a:ext uri="{FF2B5EF4-FFF2-40B4-BE49-F238E27FC236}">
+                <a16:creationId xmlns:a16="http://schemas.microsoft.com/office/drawing/2014/main" id="{D1BAB7DA-EC53-0103-E362-83F86BDB6BC4}"/>
+              </a:ext>
+            </a:extLst>
+          </p:cNvPr>
+          <p:cNvSpPr>
+            <a:spLocks noGrp="1"/>
+          </p:cNvSpPr>
+          <p:nvPr>
+            <p:ph idx="11"/>
+          </p:nvPr>
+        </p:nvSpPr>
+        <p:spPr/>
+        <p:txBody>
+          <a:bodyPr/>
+          <a:lstStyle/>
+          <a:p>
+            <a:pPr lvl="0" indent="0" marL="0">
+              <a:buNone/>
+            </a:pPr>
+            <a:r>
+              <a:rPr/>
+              <a:t>Specifically, a starting assumption was that a length of stay reduction of 12% was likely for all new SBR facilities compared to prior trends. This assumption was criticised by the national audit office (NAO) (Office 2023) in the face of a mixed evidence base.</a:t>
+            </a:r>
+          </a:p>
+          <a:p>
+            <a:pPr lvl="0" indent="0" marL="0">
+              <a:buNone/>
+            </a:pPr>
+            <a:r>
+              <a:rPr/>
+              <a:t>It is the express aim of this analysis therefore to quantify the range of likely impacts for length of stay and a basket of other measures across patient &amp; staff experience, productivity and health &amp; safety.</a:t>
             </a:r>
           </a:p>
         </p:txBody>
@@ -7427,13 +8290,13 @@
             <a:spLocks noGrp="1"/>
           </p:cNvSpPr>
           <p:nvPr>
-            <p:ph hasCustomPrompt="1" type="title"/>
+            <p:ph type="title"/>
           </p:nvPr>
         </p:nvSpPr>
         <p:spPr>
           <a:xfrm>
-            <a:off x="909829" y="403765"/>
-            <a:ext cx="8434196" cy="976056"/>
+            <a:off x="919352" y="419100"/>
+            <a:ext cx="9720072" cy="933450"/>
           </a:xfrm>
         </p:spPr>
         <p:txBody>
@@ -7445,41 +8308,111 @@
             </a:pPr>
             <a:r>
               <a:rPr/>
-              <a:t>2.1 Overview</a:t>
-            </a:r>
-          </a:p>
-        </p:txBody>
-      </p:sp>
-      <p:pic>
-        <p:nvPicPr>
-          <p:cNvPr descr="images/indicators.jpeg" id="0" name="Picture 1"/>
-          <p:cNvPicPr>
-            <a:picLocks noGrp="1" noChangeAspect="1"/>
-          </p:cNvPicPr>
-          <p:nvPr/>
-        </p:nvPicPr>
-        <p:blipFill>
-          <a:blip r:embed="rId2"/>
-          <a:stretch>
-            <a:fillRect/>
-          </a:stretch>
-        </p:blipFill>
-        <p:spPr bwMode="auto">
-          <a:xfrm>
-            <a:off x="901700" y="2032000"/>
-            <a:ext cx="10414000" cy="3467100"/>
-          </a:xfrm>
-          <a:prstGeom prst="rect">
-            <a:avLst/>
-          </a:prstGeom>
-          <a:noFill/>
-          <a:ln w="9525">
-            <a:noFill/>
-            <a:headEnd/>
-            <a:tailEnd/>
-          </a:ln>
-        </p:spPr>
-      </p:pic>
+              <a:t>2.2 Approach</a:t>
+            </a:r>
+          </a:p>
+        </p:txBody>
+      </p:sp>
+      <p:sp>
+        <p:nvSpPr>
+          <p:cNvPr id="3" name="Content Placeholder 2">
+            <a:extLst>
+              <a:ext uri="{FF2B5EF4-FFF2-40B4-BE49-F238E27FC236}">
+                <a16:creationId xmlns:a16="http://schemas.microsoft.com/office/drawing/2014/main" id="{D2592819-5C80-B996-F823-F8B9F9EAD6C9}"/>
+              </a:ext>
+            </a:extLst>
+          </p:cNvPr>
+          <p:cNvSpPr>
+            <a:spLocks noGrp="1"/>
+          </p:cNvSpPr>
+          <p:nvPr>
+            <p:ph idx="10"/>
+          </p:nvPr>
+        </p:nvSpPr>
+        <p:spPr/>
+        <p:txBody>
+          <a:bodyPr/>
+          <a:lstStyle/>
+          <a:p>
+            <a:pPr lvl="0"/>
+            <a:r>
+              <a:rPr/>
+              <a:t>Previous literature reviews and general searches were undertaken to identify potential impact factors.</a:t>
+            </a:r>
+          </a:p>
+          <a:p>
+            <a:pPr lvl="0"/>
+            <a:r>
+              <a:rPr/>
+              <a:t>Identified relevant measures or proxy measures from publicly available data and routine data sources.</a:t>
+            </a:r>
+          </a:p>
+          <a:p>
+            <a:pPr lvl="0"/>
+            <a:r>
+              <a:rPr/>
+              <a:t>Included only those with sufficient time series and of acceptable data quality into final impact framework.</a:t>
+            </a:r>
+          </a:p>
+          <a:p>
+            <a:pPr lvl="0"/>
+            <a:r>
+              <a:rPr/>
+              <a:t>Cleansed and compiled all the data into time series format.</a:t>
+            </a:r>
+          </a:p>
+        </p:txBody>
+      </p:sp>
+      <p:sp>
+        <p:nvSpPr>
+          <p:cNvPr id="4" name="Content Placeholder 2">
+            <a:extLst>
+              <a:ext uri="{FF2B5EF4-FFF2-40B4-BE49-F238E27FC236}">
+                <a16:creationId xmlns:a16="http://schemas.microsoft.com/office/drawing/2014/main" id="{D1BAB7DA-EC53-0103-E362-83F86BDB6BC4}"/>
+              </a:ext>
+            </a:extLst>
+          </p:cNvPr>
+          <p:cNvSpPr>
+            <a:spLocks noGrp="1"/>
+          </p:cNvSpPr>
+          <p:nvPr>
+            <p:ph idx="11"/>
+          </p:nvPr>
+        </p:nvSpPr>
+        <p:spPr/>
+        <p:txBody>
+          <a:bodyPr/>
+          <a:lstStyle/>
+          <a:p>
+            <a:pPr lvl="0"/>
+            <a:r>
+              <a:rPr/>
+              <a:t>Identified ‘control’ sites and providers to compare to our natural experiment sites.</a:t>
+            </a:r>
+          </a:p>
+          <a:p>
+            <a:pPr lvl="0"/>
+            <a:r>
+              <a:rPr/>
+              <a:t>Several stages of this matching according to hospital function, size, case-mix and admission ratio’s.</a:t>
+            </a:r>
+          </a:p>
+          <a:p>
+            <a:pPr lvl="0"/>
+            <a:r>
+              <a:rPr/>
+              <a:t>Performed causal impact analysis on the pre and post intervention periods to detect the nature and scale of impacts for each natural experiment.</a:t>
+            </a:r>
+          </a:p>
+          <a:p>
+            <a:pPr lvl="0"/>
+            <a:r>
+              <a:rPr/>
+              <a:t>Aggregated findings for the non-specialist hospitals.</a:t>
+            </a:r>
+          </a:p>
+        </p:txBody>
+      </p:sp>
     </p:spTree>
   </p:cSld>
 </p:sld>
@@ -7527,41 +8460,78 @@
             </a:pPr>
             <a:r>
               <a:rPr/>
-              <a:t>2.2 Indicator availability and time of SBR changes by site</a:t>
-            </a:r>
-          </a:p>
-        </p:txBody>
-      </p:sp>
-      <p:pic>
-        <p:nvPicPr>
-          <p:cNvPr descr="NHP_SBR-impacts_2024_files/figure-pptx/ind_timeline-1.png" id="0" name="Picture 1"/>
-          <p:cNvPicPr>
-            <a:picLocks noGrp="1" noChangeAspect="1"/>
-          </p:cNvPicPr>
-          <p:nvPr/>
-        </p:nvPicPr>
-        <p:blipFill>
-          <a:blip r:embed="rId2"/>
-          <a:stretch>
-            <a:fillRect/>
-          </a:stretch>
-        </p:blipFill>
-        <p:spPr bwMode="auto">
-          <a:xfrm>
-            <a:off x="2032000" y="1727200"/>
-            <a:ext cx="8153400" cy="4076700"/>
-          </a:xfrm>
-          <a:prstGeom prst="rect">
-            <a:avLst/>
-          </a:prstGeom>
-          <a:noFill/>
-          <a:ln w="9525">
-            <a:noFill/>
-            <a:headEnd/>
-            <a:tailEnd/>
-          </a:ln>
-        </p:spPr>
-      </p:pic>
+              <a:t>2.3 Summary of key findings (1)</a:t>
+            </a:r>
+          </a:p>
+        </p:txBody>
+      </p:sp>
+      <p:sp>
+        <p:nvSpPr>
+          <p:cNvPr id="3" name="Content Placeholder 2"/>
+          <p:cNvSpPr>
+            <a:spLocks noGrp="1"/>
+          </p:cNvSpPr>
+          <p:nvPr>
+            <p:ph idx="1"/>
+          </p:nvPr>
+        </p:nvSpPr>
+        <p:spPr/>
+        <p:txBody>
+          <a:bodyPr/>
+          <a:lstStyle/>
+          <a:p>
+            <a:pPr lvl="0" indent="0" marL="0">
+              <a:buNone/>
+            </a:pPr>
+            <a:r>
+              <a:rPr/>
+              <a:t>Our results are generally not consistent within indicators and across hospital sites. This inconsistency is reflective of the findings from published literature. Two impact measures moved in the same direction across all (eligible) sites - </a:t>
+            </a:r>
+            <a:r>
+              <a:rPr b="1"/>
+              <a:t>C-diff decreasing</a:t>
+            </a:r>
+            <a:r>
+              <a:rPr/>
+              <a:t> and </a:t>
+            </a:r>
+            <a:r>
+              <a:rPr b="1"/>
+              <a:t>staff turnover decreasing</a:t>
+            </a:r>
+            <a:r>
+              <a:rPr/>
+              <a:t>.</a:t>
+            </a:r>
+          </a:p>
+          <a:p>
+            <a:pPr lvl="0" indent="0" marL="0">
+              <a:buNone/>
+            </a:pPr>
+            <a:r>
+              <a:rPr/>
+              <a:t>This suggests that there are other factors in the hospital design, systems, policies and cultures that are important. </a:t>
+            </a:r>
+            <a:r>
+              <a:rPr i="1"/>
+              <a:t>Responses to a qualitative look-back exercise are currently being explored to identify those critical factors that are likely to have exacerbated success or failure</a:t>
+            </a:r>
+            <a:r>
+              <a:rPr/>
+              <a:t>.</a:t>
+            </a:r>
+          </a:p>
+          <a:p>
+            <a:pPr lvl="0" indent="0" marL="0">
+              <a:buNone/>
+            </a:pPr>
+            <a:r>
+              <a:rPr/>
+              <a:t>Switching to single bedroom hospitals without considering these other factors would not necessarily have a positive effect on outcomes nor mitigate any likely risks.</a:t>
+            </a:r>
+          </a:p>
+        </p:txBody>
+      </p:sp>
     </p:spTree>
   </p:cSld>
 </p:sld>

</xml_diff>